<commit_message>
Deep-dive (knob + cross-model agreement) + deck v2 with interactive explorer
- exp3e knob confound: colour LOWEST (not a colour artifact), bias scales with
  perceptual difficulty; wealth>morality within every knob.
- exp3f cross-model item agreement: per-item error r=0.68 across families ->
  prototype trap is item-intrinsic.
- ProgressReport_2.pptx (22 slides): + knob/agreement findings, two-factor
  takeaway, interactive model-explorer (hyperlink slide-jumps).
- DEEPDIVE_outline.md + v3 README updates.

Co-Authored-By: Claude Opus 4.8 <noreply@anthropic.com>
</commit_message>
<xml_diff>
--- a/v3/paper/ProgressReport_2.pptx
+++ b/v3/paper/ProgressReport_2.pptx
@@ -22,9 +22,14 @@
     <p:sldId id="270" r:id="rId16"/>
     <p:sldId id="271" r:id="rId17"/>
     <p:sldId id="272" r:id="rId18"/>
+    <p:sldId id="273" r:id="rId19"/>
+    <p:sldId id="274" r:id="rId20"/>
+    <p:sldId id="275" r:id="rId21"/>
+    <p:sldId id="276" r:id="rId22"/>
+    <p:sldId id="277" r:id="rId23"/>
   </p:sldIdLst>
   <p:notesMasterIdLst>
-    <p:notesMasterId r:id="rId19"/>
+    <p:notesMasterId r:id="rId24"/>
   </p:notesMasterIdLst>
   <p:sldSz cx="12191695" cy="6858000"/>
   <p:notesSz cx="6858000" cy="12191695"/>
@@ -2068,6 +2073,182 @@
 </p:notes>
 </file>
 
+<file path=ppt/notesSlides/notesSlide18.xml><?xml version="1.0" encoding="utf-8"?>
+<p:notes xmlns:a="http://schemas.openxmlformats.org/drawingml/2006/main" xmlns:r="http://schemas.openxmlformats.org/officeDocument/2006/relationships" xmlns:p="http://schemas.openxmlformats.org/presentationml/2006/main">
+  <p:cSld>
+    <p:spTree>
+      <p:nvGrpSpPr>
+        <p:cNvPr id="1" name=""/>
+        <p:cNvGrpSpPr/>
+        <p:nvPr/>
+      </p:nvGrpSpPr>
+      <p:grpSpPr>
+        <a:xfrm>
+          <a:off x="0" y="0"/>
+          <a:ext cx="0" cy="0"/>
+          <a:chOff x="0" y="0"/>
+          <a:chExt cx="0" cy="0"/>
+        </a:xfrm>
+      </p:grpSpPr>
+      <p:sp>
+        <p:nvSpPr>
+          <p:cNvPr id="2" name="Slide Image Placeholder 1"/>
+          <p:cNvSpPr>
+            <a:spLocks noGrp="1" noRot="1" noChangeAspect="1"/>
+          </p:cNvSpPr>
+          <p:nvPr>
+            <p:ph type="sldImg"/>
+          </p:nvPr>
+        </p:nvSpPr>
+        <p:spPr/>
+      </p:sp>
+      <p:sp>
+        <p:nvSpPr>
+          <p:cNvPr id="3" name="Notes Placeholder 2"/>
+          <p:cNvSpPr>
+            <a:spLocks noGrp="1"/>
+          </p:cNvSpPr>
+          <p:nvPr>
+            <p:ph type="body" idx="1"/>
+          </p:nvPr>
+        </p:nvSpPr>
+        <p:spPr/>
+        <p:txBody>
+          <a:bodyPr/>
+          <a:lstStyle/>
+          <a:p>
+            <a:r>
+              <a:rPr lang="en-US" dirty="0"/>
+              <a:t/>
+            </a:r>
+            <a:endParaRPr lang="en-US" dirty="0"/>
+          </a:p>
+        </p:txBody>
+      </p:sp>
+      <p:sp>
+        <p:nvSpPr>
+          <p:cNvPr id="4" name="Slide Number Placeholder 3"/>
+          <p:cNvSpPr>
+            <a:spLocks noGrp="1"/>
+          </p:cNvSpPr>
+          <p:nvPr>
+            <p:ph type="sldNum" sz="quarter" idx="10"/>
+          </p:nvPr>
+        </p:nvSpPr>
+        <p:spPr/>
+        <p:txBody>
+          <a:bodyPr/>
+          <a:lstStyle/>
+          <a:p>
+            <a:fld id="{F7021451-1387-4CA6-816F-3879F97B5CBC}" type="slidenum">
+              <a:rPr lang="en-US"/>
+              <a:t>18</a:t>
+            </a:fld>
+            <a:endParaRPr lang="en-US"/>
+          </a:p>
+        </p:txBody>
+      </p:sp>
+    </p:spTree>
+    <p:extLst>
+      <p:ext uri="{BB962C8B-B14F-4D97-AF65-F5344CB8AC3E}">
+        <p14:creationId xmlns:p14="http://schemas.microsoft.com/office/powerpoint/2010/main" val="1024086991"/>
+      </p:ext>
+    </p:extLst>
+  </p:cSld>
+  <p:clrMapOvr>
+    <a:masterClrMapping/>
+  </p:clrMapOvr>
+</p:notes>
+</file>
+
+<file path=ppt/notesSlides/notesSlide19.xml><?xml version="1.0" encoding="utf-8"?>
+<p:notes xmlns:a="http://schemas.openxmlformats.org/drawingml/2006/main" xmlns:r="http://schemas.openxmlformats.org/officeDocument/2006/relationships" xmlns:p="http://schemas.openxmlformats.org/presentationml/2006/main">
+  <p:cSld>
+    <p:spTree>
+      <p:nvGrpSpPr>
+        <p:cNvPr id="1" name=""/>
+        <p:cNvGrpSpPr/>
+        <p:nvPr/>
+      </p:nvGrpSpPr>
+      <p:grpSpPr>
+        <a:xfrm>
+          <a:off x="0" y="0"/>
+          <a:ext cx="0" cy="0"/>
+          <a:chOff x="0" y="0"/>
+          <a:chExt cx="0" cy="0"/>
+        </a:xfrm>
+      </p:grpSpPr>
+      <p:sp>
+        <p:nvSpPr>
+          <p:cNvPr id="2" name="Slide Image Placeholder 1"/>
+          <p:cNvSpPr>
+            <a:spLocks noGrp="1" noRot="1" noChangeAspect="1"/>
+          </p:cNvSpPr>
+          <p:nvPr>
+            <p:ph type="sldImg"/>
+          </p:nvPr>
+        </p:nvSpPr>
+        <p:spPr/>
+      </p:sp>
+      <p:sp>
+        <p:nvSpPr>
+          <p:cNvPr id="3" name="Notes Placeholder 2"/>
+          <p:cNvSpPr>
+            <a:spLocks noGrp="1"/>
+          </p:cNvSpPr>
+          <p:nvPr>
+            <p:ph type="body" idx="1"/>
+          </p:nvPr>
+        </p:nvSpPr>
+        <p:spPr/>
+        <p:txBody>
+          <a:bodyPr/>
+          <a:lstStyle/>
+          <a:p>
+            <a:r>
+              <a:rPr lang="en-US" dirty="0"/>
+              <a:t/>
+            </a:r>
+            <a:endParaRPr lang="en-US" dirty="0"/>
+          </a:p>
+        </p:txBody>
+      </p:sp>
+      <p:sp>
+        <p:nvSpPr>
+          <p:cNvPr id="4" name="Slide Number Placeholder 3"/>
+          <p:cNvSpPr>
+            <a:spLocks noGrp="1"/>
+          </p:cNvSpPr>
+          <p:nvPr>
+            <p:ph type="sldNum" sz="quarter" idx="10"/>
+          </p:nvPr>
+        </p:nvSpPr>
+        <p:spPr/>
+        <p:txBody>
+          <a:bodyPr/>
+          <a:lstStyle/>
+          <a:p>
+            <a:fld id="{F7021451-1387-4CA6-816F-3879F97B5CBC}" type="slidenum">
+              <a:rPr lang="en-US"/>
+              <a:t>19</a:t>
+            </a:fld>
+            <a:endParaRPr lang="en-US"/>
+          </a:p>
+        </p:txBody>
+      </p:sp>
+    </p:spTree>
+    <p:extLst>
+      <p:ext uri="{BB962C8B-B14F-4D97-AF65-F5344CB8AC3E}">
+        <p14:creationId xmlns:p14="http://schemas.microsoft.com/office/powerpoint/2010/main" val="1024086991"/>
+      </p:ext>
+    </p:extLst>
+  </p:cSld>
+  <p:clrMapOvr>
+    <a:masterClrMapping/>
+  </p:clrMapOvr>
+</p:notes>
+</file>
+
 <file path=ppt/notesSlides/notesSlide2.xml><?xml version="1.0" encoding="utf-8"?>
 <p:notes xmlns:a="http://schemas.openxmlformats.org/drawingml/2006/main" xmlns:r="http://schemas.openxmlformats.org/officeDocument/2006/relationships" xmlns:p="http://schemas.openxmlformats.org/presentationml/2006/main">
   <p:cSld>
@@ -2138,6 +2319,270 @@
             <a:fld id="{F7021451-1387-4CA6-816F-3879F97B5CBC}" type="slidenum">
               <a:rPr lang="en-US"/>
               <a:t>2</a:t>
+            </a:fld>
+            <a:endParaRPr lang="en-US"/>
+          </a:p>
+        </p:txBody>
+      </p:sp>
+    </p:spTree>
+    <p:extLst>
+      <p:ext uri="{BB962C8B-B14F-4D97-AF65-F5344CB8AC3E}">
+        <p14:creationId xmlns:p14="http://schemas.microsoft.com/office/powerpoint/2010/main" val="1024086991"/>
+      </p:ext>
+    </p:extLst>
+  </p:cSld>
+  <p:clrMapOvr>
+    <a:masterClrMapping/>
+  </p:clrMapOvr>
+</p:notes>
+</file>
+
+<file path=ppt/notesSlides/notesSlide20.xml><?xml version="1.0" encoding="utf-8"?>
+<p:notes xmlns:a="http://schemas.openxmlformats.org/drawingml/2006/main" xmlns:r="http://schemas.openxmlformats.org/officeDocument/2006/relationships" xmlns:p="http://schemas.openxmlformats.org/presentationml/2006/main">
+  <p:cSld>
+    <p:spTree>
+      <p:nvGrpSpPr>
+        <p:cNvPr id="1" name=""/>
+        <p:cNvGrpSpPr/>
+        <p:nvPr/>
+      </p:nvGrpSpPr>
+      <p:grpSpPr>
+        <a:xfrm>
+          <a:off x="0" y="0"/>
+          <a:ext cx="0" cy="0"/>
+          <a:chOff x="0" y="0"/>
+          <a:chExt cx="0" cy="0"/>
+        </a:xfrm>
+      </p:grpSpPr>
+      <p:sp>
+        <p:nvSpPr>
+          <p:cNvPr id="2" name="Slide Image Placeholder 1"/>
+          <p:cNvSpPr>
+            <a:spLocks noGrp="1" noRot="1" noChangeAspect="1"/>
+          </p:cNvSpPr>
+          <p:nvPr>
+            <p:ph type="sldImg"/>
+          </p:nvPr>
+        </p:nvSpPr>
+        <p:spPr/>
+      </p:sp>
+      <p:sp>
+        <p:nvSpPr>
+          <p:cNvPr id="3" name="Notes Placeholder 2"/>
+          <p:cNvSpPr>
+            <a:spLocks noGrp="1"/>
+          </p:cNvSpPr>
+          <p:nvPr>
+            <p:ph type="body" idx="1"/>
+          </p:nvPr>
+        </p:nvSpPr>
+        <p:spPr/>
+        <p:txBody>
+          <a:bodyPr/>
+          <a:lstStyle/>
+          <a:p>
+            <a:r>
+              <a:rPr lang="en-US" dirty="0"/>
+              <a:t/>
+            </a:r>
+            <a:endParaRPr lang="en-US" dirty="0"/>
+          </a:p>
+        </p:txBody>
+      </p:sp>
+      <p:sp>
+        <p:nvSpPr>
+          <p:cNvPr id="4" name="Slide Number Placeholder 3"/>
+          <p:cNvSpPr>
+            <a:spLocks noGrp="1"/>
+          </p:cNvSpPr>
+          <p:nvPr>
+            <p:ph type="sldNum" sz="quarter" idx="10"/>
+          </p:nvPr>
+        </p:nvSpPr>
+        <p:spPr/>
+        <p:txBody>
+          <a:bodyPr/>
+          <a:lstStyle/>
+          <a:p>
+            <a:fld id="{F7021451-1387-4CA6-816F-3879F97B5CBC}" type="slidenum">
+              <a:rPr lang="en-US"/>
+              <a:t>20</a:t>
+            </a:fld>
+            <a:endParaRPr lang="en-US"/>
+          </a:p>
+        </p:txBody>
+      </p:sp>
+    </p:spTree>
+    <p:extLst>
+      <p:ext uri="{BB962C8B-B14F-4D97-AF65-F5344CB8AC3E}">
+        <p14:creationId xmlns:p14="http://schemas.microsoft.com/office/powerpoint/2010/main" val="1024086991"/>
+      </p:ext>
+    </p:extLst>
+  </p:cSld>
+  <p:clrMapOvr>
+    <a:masterClrMapping/>
+  </p:clrMapOvr>
+</p:notes>
+</file>
+
+<file path=ppt/notesSlides/notesSlide21.xml><?xml version="1.0" encoding="utf-8"?>
+<p:notes xmlns:a="http://schemas.openxmlformats.org/drawingml/2006/main" xmlns:r="http://schemas.openxmlformats.org/officeDocument/2006/relationships" xmlns:p="http://schemas.openxmlformats.org/presentationml/2006/main">
+  <p:cSld>
+    <p:spTree>
+      <p:nvGrpSpPr>
+        <p:cNvPr id="1" name=""/>
+        <p:cNvGrpSpPr/>
+        <p:nvPr/>
+      </p:nvGrpSpPr>
+      <p:grpSpPr>
+        <a:xfrm>
+          <a:off x="0" y="0"/>
+          <a:ext cx="0" cy="0"/>
+          <a:chOff x="0" y="0"/>
+          <a:chExt cx="0" cy="0"/>
+        </a:xfrm>
+      </p:grpSpPr>
+      <p:sp>
+        <p:nvSpPr>
+          <p:cNvPr id="2" name="Slide Image Placeholder 1"/>
+          <p:cNvSpPr>
+            <a:spLocks noGrp="1" noRot="1" noChangeAspect="1"/>
+          </p:cNvSpPr>
+          <p:nvPr>
+            <p:ph type="sldImg"/>
+          </p:nvPr>
+        </p:nvSpPr>
+        <p:spPr/>
+      </p:sp>
+      <p:sp>
+        <p:nvSpPr>
+          <p:cNvPr id="3" name="Notes Placeholder 2"/>
+          <p:cNvSpPr>
+            <a:spLocks noGrp="1"/>
+          </p:cNvSpPr>
+          <p:nvPr>
+            <p:ph type="body" idx="1"/>
+          </p:nvPr>
+        </p:nvSpPr>
+        <p:spPr/>
+        <p:txBody>
+          <a:bodyPr/>
+          <a:lstStyle/>
+          <a:p>
+            <a:r>
+              <a:rPr lang="en-US" dirty="0"/>
+              <a:t/>
+            </a:r>
+            <a:endParaRPr lang="en-US" dirty="0"/>
+          </a:p>
+        </p:txBody>
+      </p:sp>
+      <p:sp>
+        <p:nvSpPr>
+          <p:cNvPr id="4" name="Slide Number Placeholder 3"/>
+          <p:cNvSpPr>
+            <a:spLocks noGrp="1"/>
+          </p:cNvSpPr>
+          <p:nvPr>
+            <p:ph type="sldNum" sz="quarter" idx="10"/>
+          </p:nvPr>
+        </p:nvSpPr>
+        <p:spPr/>
+        <p:txBody>
+          <a:bodyPr/>
+          <a:lstStyle/>
+          <a:p>
+            <a:fld id="{F7021451-1387-4CA6-816F-3879F97B5CBC}" type="slidenum">
+              <a:rPr lang="en-US"/>
+              <a:t>21</a:t>
+            </a:fld>
+            <a:endParaRPr lang="en-US"/>
+          </a:p>
+        </p:txBody>
+      </p:sp>
+    </p:spTree>
+    <p:extLst>
+      <p:ext uri="{BB962C8B-B14F-4D97-AF65-F5344CB8AC3E}">
+        <p14:creationId xmlns:p14="http://schemas.microsoft.com/office/powerpoint/2010/main" val="1024086991"/>
+      </p:ext>
+    </p:extLst>
+  </p:cSld>
+  <p:clrMapOvr>
+    <a:masterClrMapping/>
+  </p:clrMapOvr>
+</p:notes>
+</file>
+
+<file path=ppt/notesSlides/notesSlide22.xml><?xml version="1.0" encoding="utf-8"?>
+<p:notes xmlns:a="http://schemas.openxmlformats.org/drawingml/2006/main" xmlns:r="http://schemas.openxmlformats.org/officeDocument/2006/relationships" xmlns:p="http://schemas.openxmlformats.org/presentationml/2006/main">
+  <p:cSld>
+    <p:spTree>
+      <p:nvGrpSpPr>
+        <p:cNvPr id="1" name=""/>
+        <p:cNvGrpSpPr/>
+        <p:nvPr/>
+      </p:nvGrpSpPr>
+      <p:grpSpPr>
+        <a:xfrm>
+          <a:off x="0" y="0"/>
+          <a:ext cx="0" cy="0"/>
+          <a:chOff x="0" y="0"/>
+          <a:chExt cx="0" cy="0"/>
+        </a:xfrm>
+      </p:grpSpPr>
+      <p:sp>
+        <p:nvSpPr>
+          <p:cNvPr id="2" name="Slide Image Placeholder 1"/>
+          <p:cNvSpPr>
+            <a:spLocks noGrp="1" noRot="1" noChangeAspect="1"/>
+          </p:cNvSpPr>
+          <p:nvPr>
+            <p:ph type="sldImg"/>
+          </p:nvPr>
+        </p:nvSpPr>
+        <p:spPr/>
+      </p:sp>
+      <p:sp>
+        <p:nvSpPr>
+          <p:cNvPr id="3" name="Notes Placeholder 2"/>
+          <p:cNvSpPr>
+            <a:spLocks noGrp="1"/>
+          </p:cNvSpPr>
+          <p:nvPr>
+            <p:ph type="body" idx="1"/>
+          </p:nvPr>
+        </p:nvSpPr>
+        <p:spPr/>
+        <p:txBody>
+          <a:bodyPr/>
+          <a:lstStyle/>
+          <a:p>
+            <a:r>
+              <a:rPr lang="en-US" dirty="0"/>
+              <a:t/>
+            </a:r>
+            <a:endParaRPr lang="en-US" dirty="0"/>
+          </a:p>
+        </p:txBody>
+      </p:sp>
+      <p:sp>
+        <p:nvSpPr>
+          <p:cNvPr id="4" name="Slide Number Placeholder 3"/>
+          <p:cNvSpPr>
+            <a:spLocks noGrp="1"/>
+          </p:cNvSpPr>
+          <p:nvPr>
+            <p:ph type="sldNum" sz="quarter" idx="10"/>
+          </p:nvPr>
+        </p:nvSpPr>
+        <p:spPr/>
+        <p:txBody>
+          <a:bodyPr/>
+          <a:lstStyle/>
+          <a:p>
+            <a:fld id="{F7021451-1387-4CA6-816F-3879F97B5CBC}" type="slidenum">
+              <a:rPr lang="en-US"/>
+              <a:t>22</a:t>
             </a:fld>
             <a:endParaRPr lang="en-US"/>
           </a:p>
@@ -5562,7 +6007,7 @@
     <p:bg>
       <p:bgPr>
         <a:solidFill>
-          <a:srgbClr val="1B1F3B"/>
+          <a:srgbClr val="FFFFFF"/>
         </a:solidFill>
       </p:bgPr>
     </p:bg>
@@ -5613,7 +6058,7 @@
                 <a:ea typeface="Calibri" pitchFamily="34" charset="-122"/>
                 <a:cs typeface="Calibri" pitchFamily="34" charset="-120"/>
               </a:rPr>
-              <a:t>WHAT WE FOUND</a:t>
+              <a:t>GOING DEEPER · THE CONFOUND</a:t>
             </a:r>
             <a:endParaRPr lang="en-US" sz="1200" dirty="0"/>
           </a:p>
@@ -5627,8 +6072,8 @@
         </p:nvSpPr>
         <p:spPr>
           <a:xfrm>
-            <a:off x="685800" y="868680"/>
-            <a:ext cx="10789920" cy="822960"/>
+            <a:off x="685800" y="841248"/>
+            <a:ext cx="10820095" cy="868680"/>
           </a:xfrm>
           <a:prstGeom prst="rect">
             <a:avLst/>
@@ -5641,20 +6086,23 @@
           <a:lstStyle/>
           <a:p>
             <a:pPr indent="0" marL="0">
+              <a:lnSpc>
+                <a:spcPts val="3456"/>
+              </a:lnSpc>
               <a:buNone/>
             </a:pPr>
             <a:r>
-              <a:rPr lang="en-US" sz="3000" b="1" dirty="0">
-                <a:solidFill>
-                  <a:srgbClr val="FFFFFF"/>
+              <a:rPr lang="en-US" sz="3200" b="1" dirty="0">
+                <a:solidFill>
+                  <a:srgbClr val="23262F"/>
                 </a:solidFill>
                 <a:latin typeface="Georgia" pitchFamily="34" charset="0"/>
                 <a:ea typeface="Georgia" pitchFamily="34" charset="-122"/>
                 <a:cs typeface="Georgia" pitchFamily="34" charset="-120"/>
               </a:rPr>
-              <a:t>Two results, both robust across model families</a:t>
-            </a:r>
-            <a:endParaRPr lang="en-US" sz="3000" dirty="0"/>
+              <a:t>Is it just a low-level visual cue? No.</a:t>
+            </a:r>
+            <a:endParaRPr lang="en-US" sz="3200" dirty="0"/>
           </a:p>
         </p:txBody>
       </p:sp>
@@ -5666,8 +6114,8 @@
         </p:nvSpPr>
         <p:spPr>
           <a:xfrm>
-            <a:off x="685800" y="2057400"/>
-            <a:ext cx="731520" cy="1005840"/>
+            <a:off x="685800" y="1920240"/>
+            <a:ext cx="5120640" cy="4206240"/>
           </a:xfrm>
           <a:prstGeom prst="rect">
             <a:avLst/>
@@ -5676,264 +6124,133 @@
           <a:ln/>
         </p:spPr>
         <p:txBody>
-          <a:bodyPr wrap="square" lIns="0" tIns="0" rIns="0" bIns="0" rtlCol="0" anchor="ctr"/>
-          <a:lstStyle/>
-          <a:p>
-            <a:pPr indent="0" marL="0">
-              <a:buNone/>
-            </a:pPr>
-            <a:r>
-              <a:rPr lang="en-US" sz="4600" b="1" dirty="0">
-                <a:solidFill>
-                  <a:srgbClr val="C44E52"/>
-                </a:solidFill>
-                <a:latin typeface="Georgia" pitchFamily="34" charset="0"/>
-                <a:ea typeface="Georgia" pitchFamily="34" charset="-122"/>
-                <a:cs typeface="Georgia" pitchFamily="34" charset="-120"/>
-              </a:rPr>
-              <a:t>1</a:t>
-            </a:r>
-            <a:endParaRPr lang="en-US" sz="4600" dirty="0"/>
-          </a:p>
-        </p:txBody>
-      </p:sp>
-      <p:sp>
-        <p:nvSpPr>
-          <p:cNvPr id="5" name="Text 3"/>
-          <p:cNvSpPr/>
-          <p:nvPr/>
-        </p:nvSpPr>
-        <p:spPr>
-          <a:xfrm>
-            <a:off x="1600200" y="2103120"/>
-            <a:ext cx="10058400" cy="502920"/>
-          </a:xfrm>
-          <a:prstGeom prst="rect">
-            <a:avLst/>
-          </a:prstGeom>
-          <a:noFill/>
-          <a:ln/>
-        </p:spPr>
-        <p:txBody>
-          <a:bodyPr wrap="square" lIns="0" tIns="0" rIns="0" bIns="0" rtlCol="0" anchor="ctr"/>
-          <a:lstStyle/>
-          <a:p>
-            <a:pPr indent="0" marL="0">
-              <a:buNone/>
-            </a:pPr>
-            <a:r>
-              <a:rPr lang="en-US" sz="2000" b="1" dirty="0">
-                <a:solidFill>
-                  <a:srgbClr val="FFFFFF"/>
-                </a:solidFill>
-                <a:latin typeface="Georgia" pitchFamily="34" charset="0"/>
-                <a:ea typeface="Georgia" pitchFamily="34" charset="-122"/>
-                <a:cs typeface="Georgia" pitchFamily="34" charset="-120"/>
-              </a:rPr>
-              <a:t>The bias is attribute-specific</a:t>
-            </a:r>
-            <a:endParaRPr lang="en-US" sz="2000" dirty="0"/>
-          </a:p>
-        </p:txBody>
-      </p:sp>
-      <p:sp>
-        <p:nvSpPr>
-          <p:cNvPr id="6" name="Text 4"/>
-          <p:cNvSpPr/>
-          <p:nvPr/>
-        </p:nvSpPr>
-        <p:spPr>
-          <a:xfrm>
-            <a:off x="1600200" y="2624328"/>
-            <a:ext cx="10241280" cy="822960"/>
-          </a:xfrm>
-          <a:prstGeom prst="rect">
-            <a:avLst/>
-          </a:prstGeom>
-          <a:noFill/>
-          <a:ln/>
-        </p:spPr>
-        <p:txBody>
-          <a:bodyPr wrap="square" lIns="0" tIns="0" rIns="0" bIns="0" rtlCol="0" anchor="ctr"/>
-          <a:lstStyle/>
-          <a:p>
-            <a:pPr indent="0" marL="0">
-              <a:buNone/>
-            </a:pPr>
-            <a:r>
-              <a:rPr lang="en-US" sz="1550" dirty="0">
-                <a:solidFill>
-                  <a:srgbClr val="C9D2EC"/>
+          <a:bodyPr wrap="square" lIns="0" tIns="0" rIns="0" bIns="0" rtlCol="0" anchor="t"/>
+          <a:lstStyle/>
+          <a:p>
+            <a:pPr marL="203200" indent="-203200">
+              <a:lnSpc>
+                <a:spcPct val="100000"/>
+              </a:lnSpc>
+              <a:spcAft>
+                <a:spcPts val="1100"/>
+              </a:spcAft>
+              <a:buSzPct val="100000"/>
+              <a:buChar char="•"/>
+            </a:pPr>
+            <a:r>
+              <a:rPr lang="en-US" sz="1600" dirty="0">
+                <a:solidFill>
+                  <a:srgbClr val="23262F"/>
                 </a:solidFill>
                 <a:latin typeface="Calibri" pitchFamily="34" charset="0"/>
                 <a:ea typeface="Calibri" pitchFamily="34" charset="-122"/>
                 <a:cs typeface="Calibri" pitchFamily="34" charset="-120"/>
               </a:rPr>
-              <a:t>Concentrated on wealth and social status, near-chance for morality and intellect — and the same in Qwen2.5-VL-7B and InternVL3-8B.</a:t>
-            </a:r>
-            <a:endParaRPr lang="en-US" sz="1550" dirty="0"/>
-          </a:p>
-        </p:txBody>
-      </p:sp>
-      <p:sp>
-        <p:nvSpPr>
-          <p:cNvPr id="7" name="Text 5"/>
-          <p:cNvSpPr/>
-          <p:nvPr/>
-        </p:nvSpPr>
-        <p:spPr>
-          <a:xfrm>
-            <a:off x="685800" y="3794760"/>
-            <a:ext cx="731520" cy="1005840"/>
-          </a:xfrm>
-          <a:prstGeom prst="rect">
-            <a:avLst/>
-          </a:prstGeom>
-          <a:noFill/>
-          <a:ln/>
-        </p:spPr>
-        <p:txBody>
-          <a:bodyPr wrap="square" lIns="0" tIns="0" rIns="0" bIns="0" rtlCol="0" anchor="ctr"/>
-          <a:lstStyle/>
-          <a:p>
-            <a:pPr indent="0" marL="0">
-              <a:buNone/>
-            </a:pPr>
-            <a:r>
-              <a:rPr lang="en-US" sz="4600" b="1" dirty="0">
-                <a:solidFill>
-                  <a:srgbClr val="4C72B0"/>
-                </a:solidFill>
-                <a:latin typeface="Georgia" pitchFamily="34" charset="0"/>
-                <a:ea typeface="Georgia" pitchFamily="34" charset="-122"/>
-                <a:cs typeface="Georgia" pitchFamily="34" charset="-120"/>
-              </a:rPr>
-              <a:t>2</a:t>
-            </a:r>
-            <a:endParaRPr lang="en-US" sz="4600" dirty="0"/>
-          </a:p>
-        </p:txBody>
-      </p:sp>
-      <p:sp>
-        <p:nvSpPr>
-          <p:cNvPr id="8" name="Text 6"/>
-          <p:cNvSpPr/>
-          <p:nvPr/>
-        </p:nvSpPr>
-        <p:spPr>
-          <a:xfrm>
-            <a:off x="1600200" y="3840480"/>
-            <a:ext cx="10058400" cy="502920"/>
-          </a:xfrm>
-          <a:prstGeom prst="rect">
-            <a:avLst/>
-          </a:prstGeom>
-          <a:noFill/>
-          <a:ln/>
-        </p:spPr>
-        <p:txBody>
-          <a:bodyPr wrap="square" lIns="0" tIns="0" rIns="0" bIns="0" rtlCol="0" anchor="ctr"/>
-          <a:lstStyle/>
-          <a:p>
-            <a:pPr indent="0" marL="0">
-              <a:buNone/>
-            </a:pPr>
-            <a:r>
-              <a:rPr lang="en-US" sz="2000" b="1" dirty="0">
-                <a:solidFill>
-                  <a:srgbClr val="FFFFFF"/>
-                </a:solidFill>
-                <a:latin typeface="Georgia" pitchFamily="34" charset="0"/>
-                <a:ea typeface="Georgia" pitchFamily="34" charset="-122"/>
-                <a:cs typeface="Georgia" pitchFamily="34" charset="-120"/>
-              </a:rPr>
-              <a:t>The bias is language-modulated</a:t>
-            </a:r>
-            <a:endParaRPr lang="en-US" sz="2000" dirty="0"/>
-          </a:p>
-        </p:txBody>
-      </p:sp>
-      <p:sp>
-        <p:nvSpPr>
-          <p:cNvPr id="9" name="Text 7"/>
-          <p:cNvSpPr/>
-          <p:nvPr/>
-        </p:nvSpPr>
-        <p:spPr>
-          <a:xfrm>
-            <a:off x="1600200" y="4361688"/>
-            <a:ext cx="10241280" cy="822960"/>
-          </a:xfrm>
-          <a:prstGeom prst="rect">
-            <a:avLst/>
-          </a:prstGeom>
-          <a:noFill/>
-          <a:ln/>
-        </p:spPr>
-        <p:txBody>
-          <a:bodyPr wrap="square" lIns="0" tIns="0" rIns="0" bIns="0" rtlCol="0" anchor="ctr"/>
-          <a:lstStyle/>
-          <a:p>
-            <a:pPr indent="0" marL="0">
-              <a:buNone/>
-            </a:pPr>
-            <a:r>
-              <a:rPr lang="en-US" sz="1550" dirty="0">
-                <a:solidFill>
-                  <a:srgbClr val="C9D2EC"/>
+              <a:t>Every adversarial image also tweaks one visual knob — count / colour / scale / layout / spatial.</a:t>
+            </a:r>
+            <a:endParaRPr lang="en-US" sz="1600" dirty="0"/>
+          </a:p>
+          <a:p>
+            <a:pPr marL="203200" indent="-203200">
+              <a:lnSpc>
+                <a:spcPct val="100000"/>
+              </a:lnSpc>
+              <a:spcAft>
+                <a:spcPts val="1100"/>
+              </a:spcAft>
+              <a:buSzPct val="100000"/>
+              <a:buChar char="•"/>
+            </a:pPr>
+            <a:r>
+              <a:rPr lang="en-US" sz="1600" dirty="0">
+                <a:solidFill>
+                  <a:srgbClr val="23262F"/>
                 </a:solidFill>
                 <a:latin typeface="Calibri" pitchFamily="34" charset="0"/>
                 <a:ea typeface="Calibri" pitchFamily="34" charset="-122"/>
                 <a:cs typeface="Calibri" pitchFamily="34" charset="-120"/>
               </a:rPr>
-              <a:t>Lower-resource and distinct-script prompts (Bengali, Greek) elicit more bias — replicated across both families, and not a translation artifact.</a:t>
-            </a:r>
-            <a:endParaRPr lang="en-US" sz="1550" dirty="0"/>
-          </a:p>
-        </p:txBody>
-      </p:sp>
-      <p:sp>
-        <p:nvSpPr>
-          <p:cNvPr id="10" name="Text 8"/>
-          <p:cNvSpPr/>
-          <p:nvPr/>
-        </p:nvSpPr>
-        <p:spPr>
-          <a:xfrm>
-            <a:off x="685800" y="5806440"/>
-            <a:ext cx="10789920" cy="548640"/>
+              <a:t>If the bias were a colour artifact, colour would spike. Instead colour is the LOWEST (≈0.40).</a:t>
+            </a:r>
+            <a:endParaRPr lang="en-US" sz="1600" dirty="0"/>
+          </a:p>
+          <a:p>
+            <a:pPr marL="203200" indent="-203200">
+              <a:lnSpc>
+                <a:spcPct val="100000"/>
+              </a:lnSpc>
+              <a:spcAft>
+                <a:spcPts val="1100"/>
+              </a:spcAft>
+              <a:buSzPct val="100000"/>
+              <a:buChar char="•"/>
+            </a:pPr>
+            <a:r>
+              <a:rPr lang="en-US" sz="1600" dirty="0">
+                <a:solidFill>
+                  <a:srgbClr val="23262F"/>
+                </a:solidFill>
+                <a:latin typeface="Calibri" pitchFamily="34" charset="0"/>
+                <a:ea typeface="Calibri" pitchFamily="34" charset="-122"/>
+                <a:cs typeface="Calibri" pitchFamily="34" charset="-120"/>
+              </a:rPr>
+              <a:t>Bias is highest when the cue is hard to perceive (count, scale) — a fallback when the detail can't be grounded.</a:t>
+            </a:r>
+            <a:endParaRPr lang="en-US" sz="1600" dirty="0"/>
+          </a:p>
+          <a:p>
+            <a:pPr marL="203200" indent="-203200">
+              <a:lnSpc>
+                <a:spcPct val="100000"/>
+              </a:lnSpc>
+              <a:spcAft>
+                <a:spcPts val="1100"/>
+              </a:spcAft>
+              <a:buSzPct val="100000"/>
+              <a:buChar char="•"/>
+            </a:pPr>
+            <a:r>
+              <a:rPr lang="en-US" sz="1600" dirty="0">
+                <a:solidFill>
+                  <a:srgbClr val="23262F"/>
+                </a:solidFill>
+                <a:latin typeface="Calibri" pitchFamily="34" charset="0"/>
+                <a:ea typeface="Calibri" pitchFamily="34" charset="-122"/>
+                <a:cs typeface="Calibri" pitchFamily="34" charset="-120"/>
+              </a:rPr>
+              <a:t>Wealth &gt; morality holds within every knob — the attribute effect is not a knob artifact.</a:t>
+            </a:r>
+            <a:endParaRPr lang="en-US" sz="1600" dirty="0"/>
+          </a:p>
+        </p:txBody>
+      </p:sp>
+      <p:pic>
+        <p:nvPicPr>
+          <p:cNvPr id="5" name="Image 0" descr="/Users/xiaochuan/Desktop/Projects/P5_Multi_linguistic_histoBias/v3/experiments/exp3e_knob_confound/figures/figF_error_by_knob.png">    </p:cNvPr>
+          <p:cNvPicPr>
+            <a:picLocks noChangeAspect="1"/>
+          </p:cNvPicPr>
+          <p:nvPr/>
+        </p:nvPicPr>
+        <p:blipFill>
+          <a:blip r:embed="rId1"/>
+          <a:stretch>
+            <a:fillRect/>
+          </a:stretch>
+        </p:blipFill>
+        <p:spPr>
+          <a:xfrm>
+            <a:off x="6126480" y="2377440"/>
+            <a:ext cx="5532120" cy="2993571"/>
           </a:xfrm>
           <a:prstGeom prst="rect">
             <a:avLst/>
           </a:prstGeom>
-          <a:noFill/>
-          <a:ln/>
-        </p:spPr>
-        <p:txBody>
-          <a:bodyPr wrap="square" lIns="0" tIns="0" rIns="0" bIns="0" rtlCol="0" anchor="ctr"/>
-          <a:lstStyle/>
-          <a:p>
-            <a:pPr indent="0" marL="0">
-              <a:buNone/>
-            </a:pPr>
-            <a:r>
-              <a:rPr lang="en-US" sz="1600" i="1" dirty="0">
-                <a:solidFill>
-                  <a:srgbClr val="C44E52"/>
-                </a:solidFill>
-                <a:latin typeface="Georgia" pitchFamily="34" charset="0"/>
-                <a:ea typeface="Georgia" pitchFamily="34" charset="-122"/>
-                <a:cs typeface="Georgia" pitchFamily="34" charset="-120"/>
-              </a:rPr>
-              <a:t>The which-attribute structure is universal; the overall susceptibility scales with language.</a:t>
-            </a:r>
-            <a:endParaRPr lang="en-US" sz="1600" dirty="0"/>
-          </a:p>
-        </p:txBody>
-      </p:sp>
-      <p:sp>
-        <p:nvSpPr>
-          <p:cNvPr id="11" name="Text 9"/>
+        </p:spPr>
+      </p:pic>
+      <p:sp>
+        <p:nvSpPr>
+          <p:cNvPr id="6" name="Text 3"/>
           <p:cNvSpPr/>
           <p:nvPr/>
         </p:nvSpPr>
@@ -6035,7 +6352,7 @@
                 <a:ea typeface="Calibri" pitchFamily="34" charset="-122"/>
                 <a:cs typeface="Calibri" pitchFamily="34" charset="-120"/>
               </a:rPr>
-              <a:t>LIMITATIONS</a:t>
+              <a:t>GOING DEEPER · IS THE TRAP OBJECTIVE?</a:t>
             </a:r>
             <a:endParaRPr lang="en-US" sz="1200" dirty="0"/>
           </a:p>
@@ -6077,7 +6394,7 @@
                 <a:ea typeface="Georgia" pitchFamily="34" charset="-122"/>
                 <a:cs typeface="Georgia" pitchFamily="34" charset="-120"/>
               </a:rPr>
-              <a:t>What we are not yet claiming</a:t>
+              <a:t>The same items fool both model families</a:t>
             </a:r>
             <a:endParaRPr lang="en-US" sz="3200" dirty="0"/>
           </a:p>
@@ -6091,8 +6408,8 @@
         </p:nvSpPr>
         <p:spPr>
           <a:xfrm>
-            <a:off x="685800" y="1965960"/>
-            <a:ext cx="10607040" cy="4023360"/>
+            <a:off x="685800" y="1920240"/>
+            <a:ext cx="5486400" cy="4206240"/>
           </a:xfrm>
           <a:prstGeom prst="rect">
             <a:avLst/>
@@ -6115,7 +6432,7 @@
               <a:buChar char="•"/>
             </a:pPr>
             <a:r>
-              <a:rPr lang="en-US" sz="1700" dirty="0">
+              <a:rPr lang="en-US" sz="1600" dirty="0">
                 <a:solidFill>
                   <a:srgbClr val="23262F"/>
                 </a:solidFill>
@@ -6123,9 +6440,9 @@
                 <a:ea typeface="Calibri" pitchFamily="34" charset="-122"/>
                 <a:cs typeface="Calibri" pitchFamily="34" charset="-120"/>
               </a:rPr>
-              <a:t>Single seed, single translation backend; the adversarial “knob” (color / scale) is a co-varying confound.</a:t>
-            </a:r>
-            <a:endParaRPr lang="en-US" sz="1700" dirty="0"/>
+              <a:t>Two families judge the same 900 image pairs — do they err on the SAME ones?</a:t>
+            </a:r>
+            <a:endParaRPr lang="en-US" sz="1600" dirty="0"/>
           </a:p>
           <a:p>
             <a:pPr marL="203200" indent="-203200">
@@ -6139,7 +6456,7 @@
               <a:buChar char="•"/>
             </a:pPr>
             <a:r>
-              <a:rPr lang="en-US" sz="1700" dirty="0">
+              <a:rPr lang="en-US" sz="1600" dirty="0">
                 <a:solidFill>
                   <a:srgbClr val="23262F"/>
                 </a:solidFill>
@@ -6147,9 +6464,9 @@
                 <a:ea typeface="Calibri" pitchFamily="34" charset="-122"/>
                 <a:cs typeface="Calibri" pitchFamily="34" charset="-120"/>
               </a:rPr>
-              <a:t>Demography cells are small (Wealth ≈ 31 / language) — mixed-effects pools, but power is limited.</a:t>
-            </a:r>
-            <a:endParaRPr lang="en-US" sz="1700" dirty="0"/>
+              <a:t>Per-item error rates correlate at r = 0.68 (Cohen's κ = 0.39).</a:t>
+            </a:r>
+            <a:endParaRPr lang="en-US" sz="1600" dirty="0"/>
           </a:p>
           <a:p>
             <a:pPr marL="203200" indent="-203200">
@@ -6163,7 +6480,7 @@
               <a:buChar char="•"/>
             </a:pPr>
             <a:r>
-              <a:rPr lang="en-US" sz="1700" dirty="0">
+              <a:rPr lang="en-US" sz="1600" dirty="0">
                 <a:solidFill>
                   <a:srgbClr val="23262F"/>
                 </a:solidFill>
@@ -6171,9 +6488,9 @@
                 <a:ea typeface="Calibri" pitchFamily="34" charset="-122"/>
                 <a:cs typeface="Calibri" pitchFamily="34" charset="-120"/>
               </a:rPr>
-              <a:t>Qwen-32B was dropped — infeasible runtime (≈280 s/item) on the available 2×A40 sharding.</a:t>
-            </a:r>
-            <a:endParaRPr lang="en-US" sz="1700" dirty="0"/>
+              <a:t>So the prototype trap is largely item-intrinsic — an objective property of the image pair, not a model quirk.</a:t>
+            </a:r>
+            <a:endParaRPr lang="en-US" sz="1600" dirty="0"/>
           </a:p>
           <a:p>
             <a:pPr marL="203200" indent="-203200">
@@ -6187,7 +6504,7 @@
               <a:buChar char="•"/>
             </a:pPr>
             <a:r>
-              <a:rPr lang="en-US" sz="1700" dirty="0">
+              <a:rPr lang="en-US" sz="1600" dirty="0">
                 <a:solidFill>
                   <a:srgbClr val="23262F"/>
                 </a:solidFill>
@@ -6195,15 +6512,39 @@
                 <a:ea typeface="Calibri" pitchFamily="34" charset="-122"/>
                 <a:cs typeface="Calibri" pitchFamily="34" charset="-120"/>
               </a:rPr>
-              <a:t>Why ar / bn / el specifically — not a clean resource gradient (Russian is non-Latin yet flat) — is open.</a:t>
-            </a:r>
-            <a:endParaRPr lang="en-US" sz="1700" dirty="0"/>
-          </a:p>
-        </p:txBody>
-      </p:sp>
-      <p:sp>
-        <p:nvSpPr>
-          <p:cNvPr id="5" name="Text 3"/>
+              <a:t>(r is not 1.0: about half is still model-specific — strongest agreement on demography, weakest on objects.)</a:t>
+            </a:r>
+            <a:endParaRPr lang="en-US" sz="1600" dirty="0"/>
+          </a:p>
+        </p:txBody>
+      </p:sp>
+      <p:pic>
+        <p:nvPicPr>
+          <p:cNvPr id="5" name="Image 0" descr="/Users/xiaochuan/Desktop/Projects/P5_Multi_linguistic_histoBias/v3/experiments/exp3f_cross_model_agreement/figures/figG_item_agreement.png">    </p:cNvPr>
+          <p:cNvPicPr>
+            <a:picLocks noChangeAspect="1"/>
+          </p:cNvPicPr>
+          <p:nvPr/>
+        </p:nvPicPr>
+        <p:blipFill>
+          <a:blip r:embed="rId1"/>
+          <a:stretch>
+            <a:fillRect/>
+          </a:stretch>
+        </p:blipFill>
+        <p:spPr>
+          <a:xfrm>
+            <a:off x="7315200" y="1874520"/>
+            <a:ext cx="4114800" cy="3964162"/>
+          </a:xfrm>
+          <a:prstGeom prst="rect">
+            <a:avLst/>
+          </a:prstGeom>
+        </p:spPr>
+      </p:pic>
+      <p:sp>
+        <p:nvSpPr>
+          <p:cNvPr id="6" name="Text 3"/>
           <p:cNvSpPr/>
           <p:nvPr/>
         </p:nvSpPr>
@@ -6251,6 +6592,428 @@
 <file path=ppt/slides/slide15.xml><?xml version="1.0" encoding="utf-8"?>
 <p:sld xmlns:a="http://schemas.openxmlformats.org/drawingml/2006/main" xmlns:r="http://schemas.openxmlformats.org/officeDocument/2006/relationships" xmlns:p="http://schemas.openxmlformats.org/presentationml/2006/main">
   <p:cSld name="Slide 15">
+    <p:bg>
+      <p:bgPr>
+        <a:solidFill>
+          <a:srgbClr val="1B1F3B"/>
+        </a:solidFill>
+      </p:bgPr>
+    </p:bg>
+    <p:spTree>
+      <p:nvGrpSpPr>
+        <p:cNvPr id="1" name=""/>
+        <p:cNvGrpSpPr/>
+        <p:nvPr/>
+      </p:nvGrpSpPr>
+      <p:grpSpPr>
+        <a:xfrm>
+          <a:off x="0" y="0"/>
+          <a:ext cx="0" cy="0"/>
+          <a:chOff x="0" y="0"/>
+          <a:chExt cx="0" cy="0"/>
+        </a:xfrm>
+      </p:grpSpPr>
+      <p:sp>
+        <p:nvSpPr>
+          <p:cNvPr id="2" name="Text 0"/>
+          <p:cNvSpPr/>
+          <p:nvPr/>
+        </p:nvSpPr>
+        <p:spPr>
+          <a:xfrm>
+            <a:off x="685800" y="502920"/>
+            <a:ext cx="10820095" cy="274320"/>
+          </a:xfrm>
+          <a:prstGeom prst="rect">
+            <a:avLst/>
+          </a:prstGeom>
+          <a:noFill/>
+          <a:ln/>
+        </p:spPr>
+        <p:txBody>
+          <a:bodyPr wrap="square" lIns="0" tIns="0" rIns="0" bIns="0" rtlCol="0" anchor="ctr"/>
+          <a:lstStyle/>
+          <a:p>
+            <a:pPr indent="0" marL="0">
+              <a:buNone/>
+            </a:pPr>
+            <a:r>
+              <a:rPr lang="en-US" sz="1200" b="1" spc="300" kern="0" dirty="0">
+                <a:solidFill>
+                  <a:srgbClr val="C44E52"/>
+                </a:solidFill>
+                <a:latin typeface="Calibri" pitchFamily="34" charset="0"/>
+                <a:ea typeface="Calibri" pitchFamily="34" charset="-122"/>
+                <a:cs typeface="Calibri" pitchFamily="34" charset="-120"/>
+              </a:rPr>
+              <a:t>WHAT WE FOUND</a:t>
+            </a:r>
+            <a:endParaRPr lang="en-US" sz="1200" dirty="0"/>
+          </a:p>
+        </p:txBody>
+      </p:sp>
+      <p:sp>
+        <p:nvSpPr>
+          <p:cNvPr id="3" name="Text 1"/>
+          <p:cNvSpPr/>
+          <p:nvPr/>
+        </p:nvSpPr>
+        <p:spPr>
+          <a:xfrm>
+            <a:off x="685800" y="868680"/>
+            <a:ext cx="10789920" cy="822960"/>
+          </a:xfrm>
+          <a:prstGeom prst="rect">
+            <a:avLst/>
+          </a:prstGeom>
+          <a:noFill/>
+          <a:ln/>
+        </p:spPr>
+        <p:txBody>
+          <a:bodyPr wrap="square" lIns="0" tIns="0" rIns="0" bIns="0" rtlCol="0" anchor="ctr"/>
+          <a:lstStyle/>
+          <a:p>
+            <a:pPr indent="0" marL="0">
+              <a:buNone/>
+            </a:pPr>
+            <a:r>
+              <a:rPr lang="en-US" sz="3000" b="1" dirty="0">
+                <a:solidFill>
+                  <a:srgbClr val="FFFFFF"/>
+                </a:solidFill>
+                <a:latin typeface="Georgia" pitchFamily="34" charset="0"/>
+                <a:ea typeface="Georgia" pitchFamily="34" charset="-122"/>
+                <a:cs typeface="Georgia" pitchFamily="34" charset="-120"/>
+              </a:rPr>
+              <a:t>One picture: a fallback with two factors</a:t>
+            </a:r>
+            <a:endParaRPr lang="en-US" sz="3000" dirty="0"/>
+          </a:p>
+        </p:txBody>
+      </p:sp>
+      <p:sp>
+        <p:nvSpPr>
+          <p:cNvPr id="4" name="Text 2"/>
+          <p:cNvSpPr/>
+          <p:nvPr/>
+        </p:nvSpPr>
+        <p:spPr>
+          <a:xfrm>
+            <a:off x="685800" y="2011680"/>
+            <a:ext cx="731520" cy="1005840"/>
+          </a:xfrm>
+          <a:prstGeom prst="rect">
+            <a:avLst/>
+          </a:prstGeom>
+          <a:noFill/>
+          <a:ln/>
+        </p:spPr>
+        <p:txBody>
+          <a:bodyPr wrap="square" lIns="0" tIns="0" rIns="0" bIns="0" rtlCol="0" anchor="ctr"/>
+          <a:lstStyle/>
+          <a:p>
+            <a:pPr indent="0" marL="0">
+              <a:buNone/>
+            </a:pPr>
+            <a:r>
+              <a:rPr lang="en-US" sz="4600" b="1" dirty="0">
+                <a:solidFill>
+                  <a:srgbClr val="C44E52"/>
+                </a:solidFill>
+                <a:latin typeface="Georgia" pitchFamily="34" charset="0"/>
+                <a:ea typeface="Georgia" pitchFamily="34" charset="-122"/>
+                <a:cs typeface="Georgia" pitchFamily="34" charset="-120"/>
+              </a:rPr>
+              <a:t>1</a:t>
+            </a:r>
+            <a:endParaRPr lang="en-US" sz="4600" dirty="0"/>
+          </a:p>
+        </p:txBody>
+      </p:sp>
+      <p:sp>
+        <p:nvSpPr>
+          <p:cNvPr id="5" name="Text 3"/>
+          <p:cNvSpPr/>
+          <p:nvPr/>
+        </p:nvSpPr>
+        <p:spPr>
+          <a:xfrm>
+            <a:off x="1600200" y="2057400"/>
+            <a:ext cx="10424160" cy="502920"/>
+          </a:xfrm>
+          <a:prstGeom prst="rect">
+            <a:avLst/>
+          </a:prstGeom>
+          <a:noFill/>
+          <a:ln/>
+        </p:spPr>
+        <p:txBody>
+          <a:bodyPr wrap="square" lIns="0" tIns="0" rIns="0" bIns="0" rtlCol="0" anchor="ctr"/>
+          <a:lstStyle/>
+          <a:p>
+            <a:pPr indent="0" marL="0">
+              <a:buNone/>
+            </a:pPr>
+            <a:r>
+              <a:rPr lang="en-US" sz="2000" b="1" dirty="0">
+                <a:solidFill>
+                  <a:srgbClr val="FFFFFF"/>
+                </a:solidFill>
+                <a:latin typeface="Georgia" pitchFamily="34" charset="0"/>
+                <a:ea typeface="Georgia" pitchFamily="34" charset="-122"/>
+                <a:cs typeface="Georgia" pitchFamily="34" charset="-120"/>
+              </a:rPr>
+              <a:t>Is there a prototype to take?  →  the attribute</a:t>
+            </a:r>
+            <a:endParaRPr lang="en-US" sz="2000" dirty="0"/>
+          </a:p>
+        </p:txBody>
+      </p:sp>
+      <p:sp>
+        <p:nvSpPr>
+          <p:cNvPr id="6" name="Text 4"/>
+          <p:cNvSpPr/>
+          <p:nvPr/>
+        </p:nvSpPr>
+        <p:spPr>
+          <a:xfrm>
+            <a:off x="1600200" y="2578608"/>
+            <a:ext cx="10424160" cy="868680"/>
+          </a:xfrm>
+          <a:prstGeom prst="rect">
+            <a:avLst/>
+          </a:prstGeom>
+          <a:noFill/>
+          <a:ln/>
+        </p:spPr>
+        <p:txBody>
+          <a:bodyPr wrap="square" lIns="0" tIns="0" rIns="0" bIns="0" rtlCol="0" anchor="ctr"/>
+          <a:lstStyle/>
+          <a:p>
+            <a:pPr indent="0" marL="0">
+              <a:buNone/>
+            </a:pPr>
+            <a:r>
+              <a:rPr lang="en-US" sz="1500" dirty="0">
+                <a:solidFill>
+                  <a:srgbClr val="C9D2EC"/>
+                </a:solidFill>
+                <a:latin typeface="Calibri" pitchFamily="34" charset="0"/>
+                <a:ea typeface="Calibri" pitchFamily="34" charset="-122"/>
+                <a:cs typeface="Calibri" pitchFamily="34" charset="-120"/>
+              </a:rPr>
+              <a:t>A visual prototype exists for wealth and status, not for morality or intellect. That map replicates across both families, and the trap is largely item-intrinsic (the same items fool both, r = 0.68).</a:t>
+            </a:r>
+            <a:endParaRPr lang="en-US" sz="1500" dirty="0"/>
+          </a:p>
+        </p:txBody>
+      </p:sp>
+      <p:sp>
+        <p:nvSpPr>
+          <p:cNvPr id="7" name="Text 5"/>
+          <p:cNvSpPr/>
+          <p:nvPr/>
+        </p:nvSpPr>
+        <p:spPr>
+          <a:xfrm>
+            <a:off x="685800" y="3794760"/>
+            <a:ext cx="731520" cy="1005840"/>
+          </a:xfrm>
+          <a:prstGeom prst="rect">
+            <a:avLst/>
+          </a:prstGeom>
+          <a:noFill/>
+          <a:ln/>
+        </p:spPr>
+        <p:txBody>
+          <a:bodyPr wrap="square" lIns="0" tIns="0" rIns="0" bIns="0" rtlCol="0" anchor="ctr"/>
+          <a:lstStyle/>
+          <a:p>
+            <a:pPr indent="0" marL="0">
+              <a:buNone/>
+            </a:pPr>
+            <a:r>
+              <a:rPr lang="en-US" sz="4600" b="1" dirty="0">
+                <a:solidFill>
+                  <a:srgbClr val="4C72B0"/>
+                </a:solidFill>
+                <a:latin typeface="Georgia" pitchFamily="34" charset="0"/>
+                <a:ea typeface="Georgia" pitchFamily="34" charset="-122"/>
+                <a:cs typeface="Georgia" pitchFamily="34" charset="-120"/>
+              </a:rPr>
+              <a:t>2</a:t>
+            </a:r>
+            <a:endParaRPr lang="en-US" sz="4600" dirty="0"/>
+          </a:p>
+        </p:txBody>
+      </p:sp>
+      <p:sp>
+        <p:nvSpPr>
+          <p:cNvPr id="8" name="Text 6"/>
+          <p:cNvSpPr/>
+          <p:nvPr/>
+        </p:nvSpPr>
+        <p:spPr>
+          <a:xfrm>
+            <a:off x="1600200" y="3840480"/>
+            <a:ext cx="10424160" cy="502920"/>
+          </a:xfrm>
+          <a:prstGeom prst="rect">
+            <a:avLst/>
+          </a:prstGeom>
+          <a:noFill/>
+          <a:ln/>
+        </p:spPr>
+        <p:txBody>
+          <a:bodyPr wrap="square" lIns="0" tIns="0" rIns="0" bIns="0" rtlCol="0" anchor="ctr"/>
+          <a:lstStyle/>
+          <a:p>
+            <a:pPr indent="0" marL="0">
+              <a:buNone/>
+            </a:pPr>
+            <a:r>
+              <a:rPr lang="en-US" sz="2000" b="1" dirty="0">
+                <a:solidFill>
+                  <a:srgbClr val="FFFFFF"/>
+                </a:solidFill>
+                <a:latin typeface="Georgia" pitchFamily="34" charset="0"/>
+                <a:ea typeface="Georgia" pitchFamily="34" charset="-122"/>
+                <a:cs typeface="Georgia" pitchFamily="34" charset="-120"/>
+              </a:rPr>
+              <a:t>How weak is the signal?  →  perception &amp; language</a:t>
+            </a:r>
+            <a:endParaRPr lang="en-US" sz="2000" dirty="0"/>
+          </a:p>
+        </p:txBody>
+      </p:sp>
+      <p:sp>
+        <p:nvSpPr>
+          <p:cNvPr id="9" name="Text 7"/>
+          <p:cNvSpPr/>
+          <p:nvPr/>
+        </p:nvSpPr>
+        <p:spPr>
+          <a:xfrm>
+            <a:off x="1600200" y="4361688"/>
+            <a:ext cx="10424160" cy="868680"/>
+          </a:xfrm>
+          <a:prstGeom prst="rect">
+            <a:avLst/>
+          </a:prstGeom>
+          <a:noFill/>
+          <a:ln/>
+        </p:spPr>
+        <p:txBody>
+          <a:bodyPr wrap="square" lIns="0" tIns="0" rIns="0" bIns="0" rtlCol="0" anchor="ctr"/>
+          <a:lstStyle/>
+          <a:p>
+            <a:pPr indent="0" marL="0">
+              <a:buNone/>
+            </a:pPr>
+            <a:r>
+              <a:rPr lang="en-US" sz="1500" dirty="0">
+                <a:solidFill>
+                  <a:srgbClr val="C9D2EC"/>
+                </a:solidFill>
+                <a:latin typeface="Calibri" pitchFamily="34" charset="0"/>
+                <a:ea typeface="Calibri" pitchFamily="34" charset="-122"/>
+                <a:cs typeface="Calibri" pitchFamily="34" charset="-120"/>
+              </a:rPr>
+              <a:t>The model falls back on the prototype when the discriminating cue is hard to perceive (count, scale) OR the prompt language is unfamiliar (Bengali, Greek). Two routes, one mechanism.</a:t>
+            </a:r>
+            <a:endParaRPr lang="en-US" sz="1500" dirty="0"/>
+          </a:p>
+        </p:txBody>
+      </p:sp>
+      <p:sp>
+        <p:nvSpPr>
+          <p:cNvPr id="10" name="Text 8"/>
+          <p:cNvSpPr/>
+          <p:nvPr/>
+        </p:nvSpPr>
+        <p:spPr>
+          <a:xfrm>
+            <a:off x="685800" y="5852160"/>
+            <a:ext cx="10789920" cy="548640"/>
+          </a:xfrm>
+          <a:prstGeom prst="rect">
+            <a:avLst/>
+          </a:prstGeom>
+          <a:noFill/>
+          <a:ln/>
+        </p:spPr>
+        <p:txBody>
+          <a:bodyPr wrap="square" lIns="0" tIns="0" rIns="0" bIns="0" rtlCol="0" anchor="ctr"/>
+          <a:lstStyle/>
+          <a:p>
+            <a:pPr indent="0" marL="0">
+              <a:buNone/>
+            </a:pPr>
+            <a:r>
+              <a:rPr lang="en-US" sz="1600" i="1" dirty="0">
+                <a:solidFill>
+                  <a:srgbClr val="C44E52"/>
+                </a:solidFill>
+                <a:latin typeface="Georgia" pitchFamily="34" charset="0"/>
+                <a:ea typeface="Georgia" pitchFamily="34" charset="-122"/>
+                <a:cs typeface="Georgia" pitchFamily="34" charset="-120"/>
+              </a:rPr>
+              <a:t>Attribute sets whether a shortcut exists; signal-weakness sets how much the model takes it.</a:t>
+            </a:r>
+            <a:endParaRPr lang="en-US" sz="1600" dirty="0"/>
+          </a:p>
+        </p:txBody>
+      </p:sp>
+      <p:sp>
+        <p:nvSpPr>
+          <p:cNvPr id="11" name="Text 9"/>
+          <p:cNvSpPr/>
+          <p:nvPr/>
+        </p:nvSpPr>
+        <p:spPr>
+          <a:xfrm>
+            <a:off x="11551615" y="6400800"/>
+            <a:ext cx="365760" cy="274320"/>
+          </a:xfrm>
+          <a:prstGeom prst="rect">
+            <a:avLst/>
+          </a:prstGeom>
+          <a:noFill/>
+          <a:ln/>
+        </p:spPr>
+        <p:txBody>
+          <a:bodyPr wrap="square" lIns="0" tIns="0" rIns="0" bIns="0" rtlCol="0" anchor="ctr"/>
+          <a:lstStyle/>
+          <a:p>
+            <a:pPr algn="r" indent="0" marL="0">
+              <a:buNone/>
+            </a:pPr>
+            <a:r>
+              <a:rPr lang="en-US" sz="1000" dirty="0">
+                <a:solidFill>
+                  <a:srgbClr val="9AA0B0"/>
+                </a:solidFill>
+                <a:latin typeface="Calibri" pitchFamily="34" charset="0"/>
+                <a:ea typeface="Calibri" pitchFamily="34" charset="-122"/>
+                <a:cs typeface="Calibri" pitchFamily="34" charset="-120"/>
+              </a:rPr>
+              <a:t>15</a:t>
+            </a:r>
+            <a:endParaRPr lang="en-US" sz="1000" dirty="0"/>
+          </a:p>
+        </p:txBody>
+      </p:sp>
+    </p:spTree>
+  </p:cSld>
+  <p:clrMapOvr>
+    <a:masterClrMapping/>
+  </p:clrMapOvr>
+</p:sld>
+</file>
+
+<file path=ppt/slides/slide16.xml><?xml version="1.0" encoding="utf-8"?>
+<p:sld xmlns:a="http://schemas.openxmlformats.org/drawingml/2006/main" xmlns:r="http://schemas.openxmlformats.org/officeDocument/2006/relationships" xmlns:p="http://schemas.openxmlformats.org/presentationml/2006/main">
+  <p:cSld name="Slide 16">
     <p:bg>
       <p:bgPr>
         <a:solidFill>
@@ -6305,7 +7068,7 @@
                 <a:ea typeface="Calibri" pitchFamily="34" charset="-122"/>
                 <a:cs typeface="Calibri" pitchFamily="34" charset="-120"/>
               </a:rPr>
-              <a:t>OUTLOOK</a:t>
+              <a:t>LIMITATIONS</a:t>
             </a:r>
             <a:endParaRPr lang="en-US" sz="1200" dirty="0"/>
           </a:p>
@@ -6347,7 +7110,7 @@
                 <a:ea typeface="Georgia" pitchFamily="34" charset="-122"/>
                 <a:cs typeface="Georgia" pitchFamily="34" charset="-120"/>
               </a:rPr>
-              <a:t>Next steps</a:t>
+              <a:t>What we are not yet claiming</a:t>
             </a:r>
             <a:endParaRPr lang="en-US" sz="3200" dirty="0"/>
           </a:p>
@@ -6355,34 +7118,14 @@
       </p:sp>
       <p:sp>
         <p:nvSpPr>
-          <p:cNvPr id="4" name="Shape 2"/>
+          <p:cNvPr id="4" name="Text 2"/>
           <p:cNvSpPr/>
           <p:nvPr/>
         </p:nvSpPr>
         <p:spPr>
           <a:xfrm>
-            <a:off x="685800" y="2103120"/>
-            <a:ext cx="384048" cy="384048"/>
-          </a:xfrm>
-          <a:prstGeom prst="ellipse">
-            <a:avLst/>
-          </a:prstGeom>
-          <a:solidFill>
-            <a:srgbClr val="1B1F3B"/>
-          </a:solidFill>
-          <a:ln/>
-        </p:spPr>
-      </p:sp>
-      <p:sp>
-        <p:nvSpPr>
-          <p:cNvPr id="5" name="Text 3"/>
-          <p:cNvSpPr/>
-          <p:nvPr/>
-        </p:nvSpPr>
-        <p:spPr>
-          <a:xfrm>
-            <a:off x="685800" y="2103120"/>
-            <a:ext cx="384048" cy="384048"/>
+            <a:off x="685800" y="1965960"/>
+            <a:ext cx="10607040" cy="4023360"/>
           </a:xfrm>
           <a:prstGeom prst="rect">
             <a:avLst/>
@@ -6391,92 +7134,21 @@
           <a:ln/>
         </p:spPr>
         <p:txBody>
-          <a:bodyPr wrap="square" lIns="0" tIns="0" rIns="0" bIns="0" rtlCol="0" anchor="ctr"/>
-          <a:lstStyle/>
-          <a:p>
-            <a:pPr algn="ctr" indent="0" marL="0">
-              <a:buNone/>
-            </a:pPr>
-            <a:r>
-              <a:rPr lang="en-US" sz="1600" b="1" dirty="0">
-                <a:solidFill>
-                  <a:srgbClr val="FFFFFF"/>
-                </a:solidFill>
-                <a:latin typeface="Georgia" pitchFamily="34" charset="0"/>
-                <a:ea typeface="Georgia" pitchFamily="34" charset="-122"/>
-                <a:cs typeface="Georgia" pitchFamily="34" charset="-120"/>
-              </a:rPr>
-              <a:t>1</a:t>
-            </a:r>
-            <a:endParaRPr lang="en-US" sz="1600" dirty="0"/>
-          </a:p>
-        </p:txBody>
-      </p:sp>
-      <p:sp>
-        <p:nvSpPr>
-          <p:cNvPr id="6" name="Text 4"/>
-          <p:cNvSpPr/>
-          <p:nvPr/>
-        </p:nvSpPr>
-        <p:spPr>
-          <a:xfrm>
-            <a:off x="1325880" y="2039112"/>
-            <a:ext cx="2926080" cy="457200"/>
-          </a:xfrm>
-          <a:prstGeom prst="rect">
-            <a:avLst/>
-          </a:prstGeom>
-          <a:noFill/>
-          <a:ln/>
-        </p:spPr>
-        <p:txBody>
-          <a:bodyPr wrap="square" lIns="0" tIns="0" rIns="0" bIns="0" rtlCol="0" anchor="ctr"/>
-          <a:lstStyle/>
-          <a:p>
-            <a:pPr indent="0" marL="0">
-              <a:buNone/>
-            </a:pPr>
-            <a:r>
-              <a:rPr lang="en-US" sz="1700" b="1" dirty="0">
-                <a:solidFill>
-                  <a:srgbClr val="C44E52"/>
-                </a:solidFill>
-                <a:latin typeface="Georgia" pitchFamily="34" charset="0"/>
-                <a:ea typeface="Georgia" pitchFamily="34" charset="-122"/>
-                <a:cs typeface="Georgia" pitchFamily="34" charset="-120"/>
-              </a:rPr>
-              <a:t>Scale axis</a:t>
-            </a:r>
-            <a:endParaRPr lang="en-US" sz="1700" dirty="0"/>
-          </a:p>
-        </p:txBody>
-      </p:sp>
-      <p:sp>
-        <p:nvSpPr>
-          <p:cNvPr id="7" name="Text 5"/>
-          <p:cNvSpPr/>
-          <p:nvPr/>
-        </p:nvSpPr>
-        <p:spPr>
-          <a:xfrm>
-            <a:off x="4343400" y="2039112"/>
-            <a:ext cx="7772400" cy="640080"/>
-          </a:xfrm>
-          <a:prstGeom prst="rect">
-            <a:avLst/>
-          </a:prstGeom>
-          <a:noFill/>
-          <a:ln/>
-        </p:spPr>
-        <p:txBody>
           <a:bodyPr wrap="square" lIns="0" tIns="0" rIns="0" bIns="0" rtlCol="0" anchor="t"/>
           <a:lstStyle/>
           <a:p>
-            <a:pPr indent="0" marL="0">
-              <a:buNone/>
-            </a:pPr>
-            <a:r>
-              <a:rPr lang="en-US" sz="1500" dirty="0">
+            <a:pPr marL="203200" indent="-203200">
+              <a:lnSpc>
+                <a:spcPct val="100000"/>
+              </a:lnSpc>
+              <a:spcAft>
+                <a:spcPts val="1100"/>
+              </a:spcAft>
+              <a:buSzPct val="100000"/>
+              <a:buChar char="•"/>
+            </a:pPr>
+            <a:r>
+              <a:rPr lang="en-US" sz="1700" dirty="0">
                 <a:solidFill>
                   <a:srgbClr val="23262F"/>
                 </a:solidFill>
@@ -6484,136 +7156,23 @@
                 <a:ea typeface="Calibri" pitchFamily="34" charset="-122"/>
                 <a:cs typeface="Calibri" pitchFamily="34" charset="-120"/>
               </a:rPr>
-              <a:t>Qwen-32B in 4-bit on a single GPU — does the bias shrink with model size?</a:t>
-            </a:r>
-            <a:endParaRPr lang="en-US" sz="1500" dirty="0"/>
-          </a:p>
-        </p:txBody>
-      </p:sp>
-      <p:sp>
-        <p:nvSpPr>
-          <p:cNvPr id="8" name="Shape 6"/>
-          <p:cNvSpPr/>
-          <p:nvPr/>
-        </p:nvSpPr>
-        <p:spPr>
-          <a:xfrm>
-            <a:off x="685800" y="3127248"/>
-            <a:ext cx="384048" cy="384048"/>
-          </a:xfrm>
-          <a:prstGeom prst="ellipse">
-            <a:avLst/>
-          </a:prstGeom>
-          <a:solidFill>
-            <a:srgbClr val="1B1F3B"/>
-          </a:solidFill>
-          <a:ln/>
-        </p:spPr>
-      </p:sp>
-      <p:sp>
-        <p:nvSpPr>
-          <p:cNvPr id="9" name="Text 7"/>
-          <p:cNvSpPr/>
-          <p:nvPr/>
-        </p:nvSpPr>
-        <p:spPr>
-          <a:xfrm>
-            <a:off x="685800" y="3127248"/>
-            <a:ext cx="384048" cy="384048"/>
-          </a:xfrm>
-          <a:prstGeom prst="rect">
-            <a:avLst/>
-          </a:prstGeom>
-          <a:noFill/>
-          <a:ln/>
-        </p:spPr>
-        <p:txBody>
-          <a:bodyPr wrap="square" lIns="0" tIns="0" rIns="0" bIns="0" rtlCol="0" anchor="ctr"/>
-          <a:lstStyle/>
-          <a:p>
-            <a:pPr algn="ctr" indent="0" marL="0">
-              <a:buNone/>
-            </a:pPr>
-            <a:r>
-              <a:rPr lang="en-US" sz="1600" b="1" dirty="0">
-                <a:solidFill>
-                  <a:srgbClr val="FFFFFF"/>
-                </a:solidFill>
-                <a:latin typeface="Georgia" pitchFamily="34" charset="0"/>
-                <a:ea typeface="Georgia" pitchFamily="34" charset="-122"/>
-                <a:cs typeface="Georgia" pitchFamily="34" charset="-120"/>
-              </a:rPr>
-              <a:t>2</a:t>
-            </a:r>
-            <a:endParaRPr lang="en-US" sz="1600" dirty="0"/>
-          </a:p>
-        </p:txBody>
-      </p:sp>
-      <p:sp>
-        <p:nvSpPr>
-          <p:cNvPr id="10" name="Text 8"/>
-          <p:cNvSpPr/>
-          <p:nvPr/>
-        </p:nvSpPr>
-        <p:spPr>
-          <a:xfrm>
-            <a:off x="1325880" y="3063240"/>
-            <a:ext cx="2926080" cy="457200"/>
-          </a:xfrm>
-          <a:prstGeom prst="rect">
-            <a:avLst/>
-          </a:prstGeom>
-          <a:noFill/>
-          <a:ln/>
-        </p:spPr>
-        <p:txBody>
-          <a:bodyPr wrap="square" lIns="0" tIns="0" rIns="0" bIns="0" rtlCol="0" anchor="ctr"/>
-          <a:lstStyle/>
-          <a:p>
-            <a:pPr indent="0" marL="0">
-              <a:buNone/>
-            </a:pPr>
-            <a:r>
-              <a:rPr lang="en-US" sz="1700" b="1" dirty="0">
-                <a:solidFill>
-                  <a:srgbClr val="C44E52"/>
-                </a:solidFill>
-                <a:latin typeface="Georgia" pitchFamily="34" charset="0"/>
-                <a:ea typeface="Georgia" pitchFamily="34" charset="-122"/>
-                <a:cs typeface="Georgia" pitchFamily="34" charset="-120"/>
-              </a:rPr>
-              <a:t>More families</a:t>
+              <a:t>Single seed, single translation backend; the adversarial “knob” (color / scale) is a co-varying confound.</a:t>
             </a:r>
             <a:endParaRPr lang="en-US" sz="1700" dirty="0"/>
           </a:p>
-        </p:txBody>
-      </p:sp>
-      <p:sp>
-        <p:nvSpPr>
-          <p:cNvPr id="11" name="Text 9"/>
-          <p:cNvSpPr/>
-          <p:nvPr/>
-        </p:nvSpPr>
-        <p:spPr>
-          <a:xfrm>
-            <a:off x="4343400" y="3063240"/>
-            <a:ext cx="7772400" cy="640080"/>
-          </a:xfrm>
-          <a:prstGeom prst="rect">
-            <a:avLst/>
-          </a:prstGeom>
-          <a:noFill/>
-          <a:ln/>
-        </p:spPr>
-        <p:txBody>
-          <a:bodyPr wrap="square" lIns="0" tIns="0" rIns="0" bIns="0" rtlCol="0" anchor="t"/>
-          <a:lstStyle/>
-          <a:p>
-            <a:pPr indent="0" marL="0">
-              <a:buNone/>
-            </a:pPr>
-            <a:r>
-              <a:rPr lang="en-US" sz="1500" dirty="0">
+          <a:p>
+            <a:pPr marL="203200" indent="-203200">
+              <a:lnSpc>
+                <a:spcPct val="100000"/>
+              </a:lnSpc>
+              <a:spcAft>
+                <a:spcPts val="1100"/>
+              </a:spcAft>
+              <a:buSzPct val="100000"/>
+              <a:buChar char="•"/>
+            </a:pPr>
+            <a:r>
+              <a:rPr lang="en-US" sz="1700" dirty="0">
                 <a:solidFill>
                   <a:srgbClr val="23262F"/>
                 </a:solidFill>
@@ -6621,136 +7180,23 @@
                 <a:ea typeface="Calibri" pitchFamily="34" charset="-122"/>
                 <a:cs typeface="Calibri" pitchFamily="34" charset="-120"/>
               </a:rPr>
-              <a:t>Gemma-3, LLaVA-OneVision — map how general the language effect is.</a:t>
-            </a:r>
-            <a:endParaRPr lang="en-US" sz="1500" dirty="0"/>
-          </a:p>
-        </p:txBody>
-      </p:sp>
-      <p:sp>
-        <p:nvSpPr>
-          <p:cNvPr id="12" name="Shape 10"/>
-          <p:cNvSpPr/>
-          <p:nvPr/>
-        </p:nvSpPr>
-        <p:spPr>
-          <a:xfrm>
-            <a:off x="685800" y="4151376"/>
-            <a:ext cx="384048" cy="384048"/>
-          </a:xfrm>
-          <a:prstGeom prst="ellipse">
-            <a:avLst/>
-          </a:prstGeom>
-          <a:solidFill>
-            <a:srgbClr val="1B1F3B"/>
-          </a:solidFill>
-          <a:ln/>
-        </p:spPr>
-      </p:sp>
-      <p:sp>
-        <p:nvSpPr>
-          <p:cNvPr id="13" name="Text 11"/>
-          <p:cNvSpPr/>
-          <p:nvPr/>
-        </p:nvSpPr>
-        <p:spPr>
-          <a:xfrm>
-            <a:off x="685800" y="4151376"/>
-            <a:ext cx="384048" cy="384048"/>
-          </a:xfrm>
-          <a:prstGeom prst="rect">
-            <a:avLst/>
-          </a:prstGeom>
-          <a:noFill/>
-          <a:ln/>
-        </p:spPr>
-        <p:txBody>
-          <a:bodyPr wrap="square" lIns="0" tIns="0" rIns="0" bIns="0" rtlCol="0" anchor="ctr"/>
-          <a:lstStyle/>
-          <a:p>
-            <a:pPr algn="ctr" indent="0" marL="0">
-              <a:buNone/>
-            </a:pPr>
-            <a:r>
-              <a:rPr lang="en-US" sz="1600" b="1" dirty="0">
-                <a:solidFill>
-                  <a:srgbClr val="FFFFFF"/>
-                </a:solidFill>
-                <a:latin typeface="Georgia" pitchFamily="34" charset="0"/>
-                <a:ea typeface="Georgia" pitchFamily="34" charset="-122"/>
-                <a:cs typeface="Georgia" pitchFamily="34" charset="-120"/>
-              </a:rPr>
-              <a:t>3</a:t>
-            </a:r>
-            <a:endParaRPr lang="en-US" sz="1600" dirty="0"/>
-          </a:p>
-        </p:txBody>
-      </p:sp>
-      <p:sp>
-        <p:nvSpPr>
-          <p:cNvPr id="14" name="Text 12"/>
-          <p:cNvSpPr/>
-          <p:nvPr/>
-        </p:nvSpPr>
-        <p:spPr>
-          <a:xfrm>
-            <a:off x="1325880" y="4087368"/>
-            <a:ext cx="2926080" cy="457200"/>
-          </a:xfrm>
-          <a:prstGeom prst="rect">
-            <a:avLst/>
-          </a:prstGeom>
-          <a:noFill/>
-          <a:ln/>
-        </p:spPr>
-        <p:txBody>
-          <a:bodyPr wrap="square" lIns="0" tIns="0" rIns="0" bIns="0" rtlCol="0" anchor="ctr"/>
-          <a:lstStyle/>
-          <a:p>
-            <a:pPr indent="0" marL="0">
-              <a:buNone/>
-            </a:pPr>
-            <a:r>
-              <a:rPr lang="en-US" sz="1700" b="1" dirty="0">
-                <a:solidFill>
-                  <a:srgbClr val="C44E52"/>
-                </a:solidFill>
-                <a:latin typeface="Georgia" pitchFamily="34" charset="0"/>
-                <a:ea typeface="Georgia" pitchFamily="34" charset="-122"/>
-                <a:cs typeface="Georgia" pitchFamily="34" charset="-120"/>
-              </a:rPr>
-              <a:t>Shortcut-severing</a:t>
+              <a:t>Demography cells are small (Wealth ≈ 31 / language) — mixed-effects pools, but power is limited.</a:t>
             </a:r>
             <a:endParaRPr lang="en-US" sz="1700" dirty="0"/>
           </a:p>
-        </p:txBody>
-      </p:sp>
-      <p:sp>
-        <p:nvSpPr>
-          <p:cNvPr id="15" name="Text 13"/>
-          <p:cNvSpPr/>
-          <p:nvPr/>
-        </p:nvSpPr>
-        <p:spPr>
-          <a:xfrm>
-            <a:off x="4343400" y="4087368"/>
-            <a:ext cx="7772400" cy="640080"/>
-          </a:xfrm>
-          <a:prstGeom prst="rect">
-            <a:avLst/>
-          </a:prstGeom>
-          <a:noFill/>
-          <a:ln/>
-        </p:spPr>
-        <p:txBody>
-          <a:bodyPr wrap="square" lIns="0" tIns="0" rIns="0" bIns="0" rtlCol="0" anchor="t"/>
-          <a:lstStyle/>
-          <a:p>
-            <a:pPr indent="0" marL="0">
-              <a:buNone/>
-            </a:pPr>
-            <a:r>
-              <a:rPr lang="en-US" sz="1500" dirty="0">
+          <a:p>
+            <a:pPr marL="203200" indent="-203200">
+              <a:lnSpc>
+                <a:spcPct val="100000"/>
+              </a:lnSpc>
+              <a:spcAft>
+                <a:spcPts val="1100"/>
+              </a:spcAft>
+              <a:buSzPct val="100000"/>
+              <a:buChar char="•"/>
+            </a:pPr>
+            <a:r>
+              <a:rPr lang="en-US" sz="1700" dirty="0">
                 <a:solidFill>
                   <a:srgbClr val="23262F"/>
                 </a:solidFill>
@@ -6758,136 +7204,23 @@
                 <a:ea typeface="Calibri" pitchFamily="34" charset="-122"/>
                 <a:cs typeface="Calibri" pitchFamily="34" charset="-120"/>
               </a:rPr>
-              <a:t>Remove prototype cues — is stable correctness actually grounded?</a:t>
-            </a:r>
-            <a:endParaRPr lang="en-US" sz="1500" dirty="0"/>
-          </a:p>
-        </p:txBody>
-      </p:sp>
-      <p:sp>
-        <p:nvSpPr>
-          <p:cNvPr id="16" name="Shape 14"/>
-          <p:cNvSpPr/>
-          <p:nvPr/>
-        </p:nvSpPr>
-        <p:spPr>
-          <a:xfrm>
-            <a:off x="685800" y="5175504"/>
-            <a:ext cx="384048" cy="384048"/>
-          </a:xfrm>
-          <a:prstGeom prst="ellipse">
-            <a:avLst/>
-          </a:prstGeom>
-          <a:solidFill>
-            <a:srgbClr val="1B1F3B"/>
-          </a:solidFill>
-          <a:ln/>
-        </p:spPr>
-      </p:sp>
-      <p:sp>
-        <p:nvSpPr>
-          <p:cNvPr id="17" name="Text 15"/>
-          <p:cNvSpPr/>
-          <p:nvPr/>
-        </p:nvSpPr>
-        <p:spPr>
-          <a:xfrm>
-            <a:off x="685800" y="5175504"/>
-            <a:ext cx="384048" cy="384048"/>
-          </a:xfrm>
-          <a:prstGeom prst="rect">
-            <a:avLst/>
-          </a:prstGeom>
-          <a:noFill/>
-          <a:ln/>
-        </p:spPr>
-        <p:txBody>
-          <a:bodyPr wrap="square" lIns="0" tIns="0" rIns="0" bIns="0" rtlCol="0" anchor="ctr"/>
-          <a:lstStyle/>
-          <a:p>
-            <a:pPr algn="ctr" indent="0" marL="0">
-              <a:buNone/>
-            </a:pPr>
-            <a:r>
-              <a:rPr lang="en-US" sz="1600" b="1" dirty="0">
-                <a:solidFill>
-                  <a:srgbClr val="FFFFFF"/>
-                </a:solidFill>
-                <a:latin typeface="Georgia" pitchFamily="34" charset="0"/>
-                <a:ea typeface="Georgia" pitchFamily="34" charset="-122"/>
-                <a:cs typeface="Georgia" pitchFamily="34" charset="-120"/>
-              </a:rPr>
-              <a:t>4</a:t>
-            </a:r>
-            <a:endParaRPr lang="en-US" sz="1600" dirty="0"/>
-          </a:p>
-        </p:txBody>
-      </p:sp>
-      <p:sp>
-        <p:nvSpPr>
-          <p:cNvPr id="18" name="Text 16"/>
-          <p:cNvSpPr/>
-          <p:nvPr/>
-        </p:nvSpPr>
-        <p:spPr>
-          <a:xfrm>
-            <a:off x="1325880" y="5111496"/>
-            <a:ext cx="2926080" cy="457200"/>
-          </a:xfrm>
-          <a:prstGeom prst="rect">
-            <a:avLst/>
-          </a:prstGeom>
-          <a:noFill/>
-          <a:ln/>
-        </p:spPr>
-        <p:txBody>
-          <a:bodyPr wrap="square" lIns="0" tIns="0" rIns="0" bIns="0" rtlCol="0" anchor="ctr"/>
-          <a:lstStyle/>
-          <a:p>
-            <a:pPr indent="0" marL="0">
-              <a:buNone/>
-            </a:pPr>
-            <a:r>
-              <a:rPr lang="en-US" sz="1700" b="1" dirty="0">
-                <a:solidFill>
-                  <a:srgbClr val="C44E52"/>
-                </a:solidFill>
-                <a:latin typeface="Georgia" pitchFamily="34" charset="0"/>
-                <a:ea typeface="Georgia" pitchFamily="34" charset="-122"/>
-                <a:cs typeface="Georgia" pitchFamily="34" charset="-120"/>
-              </a:rPr>
-              <a:t>Pin down language</a:t>
+              <a:t>Qwen-32B was dropped — infeasible runtime (≈280 s/item) on the available 2×A40 sharding.</a:t>
             </a:r>
             <a:endParaRPr lang="en-US" sz="1700" dirty="0"/>
           </a:p>
-        </p:txBody>
-      </p:sp>
-      <p:sp>
-        <p:nvSpPr>
-          <p:cNvPr id="19" name="Text 17"/>
-          <p:cNvSpPr/>
-          <p:nvPr/>
-        </p:nvSpPr>
-        <p:spPr>
-          <a:xfrm>
-            <a:off x="4343400" y="5111496"/>
-            <a:ext cx="7772400" cy="640080"/>
-          </a:xfrm>
-          <a:prstGeom prst="rect">
-            <a:avLst/>
-          </a:prstGeom>
-          <a:noFill/>
-          <a:ln/>
-        </p:spPr>
-        <p:txBody>
-          <a:bodyPr wrap="square" lIns="0" tIns="0" rIns="0" bIns="0" rtlCol="0" anchor="t"/>
-          <a:lstStyle/>
-          <a:p>
-            <a:pPr indent="0" marL="0">
-              <a:buNone/>
-            </a:pPr>
-            <a:r>
-              <a:rPr lang="en-US" sz="1500" dirty="0">
+          <a:p>
+            <a:pPr marL="203200" indent="-203200">
+              <a:lnSpc>
+                <a:spcPct val="100000"/>
+              </a:lnSpc>
+              <a:spcAft>
+                <a:spcPts val="1100"/>
+              </a:spcAft>
+              <a:buSzPct val="100000"/>
+              <a:buChar char="•"/>
+            </a:pPr>
+            <a:r>
+              <a:rPr lang="en-US" sz="1700" dirty="0">
                 <a:solidFill>
                   <a:srgbClr val="23262F"/>
                 </a:solidFill>
@@ -6895,247 +7228,15 @@
                 <a:ea typeface="Calibri" pitchFamily="34" charset="-122"/>
                 <a:cs typeface="Calibri" pitchFamily="34" charset="-120"/>
               </a:rPr>
-              <a:t>Disentangle resource vs script vs cultural loading behind the ar / bn / el spike.</a:t>
-            </a:r>
-            <a:endParaRPr lang="en-US" sz="1500" dirty="0"/>
-          </a:p>
-        </p:txBody>
-      </p:sp>
-      <p:sp>
-        <p:nvSpPr>
-          <p:cNvPr id="20" name="Text 18"/>
-          <p:cNvSpPr/>
-          <p:nvPr/>
-        </p:nvSpPr>
-        <p:spPr>
-          <a:xfrm>
-            <a:off x="11551615" y="6400800"/>
-            <a:ext cx="365760" cy="274320"/>
-          </a:xfrm>
-          <a:prstGeom prst="rect">
-            <a:avLst/>
-          </a:prstGeom>
-          <a:noFill/>
-          <a:ln/>
-        </p:spPr>
-        <p:txBody>
-          <a:bodyPr wrap="square" lIns="0" tIns="0" rIns="0" bIns="0" rtlCol="0" anchor="ctr"/>
-          <a:lstStyle/>
-          <a:p>
-            <a:pPr algn="r" indent="0" marL="0">
-              <a:buNone/>
-            </a:pPr>
-            <a:r>
-              <a:rPr lang="en-US" sz="1000" dirty="0">
-                <a:solidFill>
-                  <a:srgbClr val="9AA0B0"/>
-                </a:solidFill>
-                <a:latin typeface="Calibri" pitchFamily="34" charset="0"/>
-                <a:ea typeface="Calibri" pitchFamily="34" charset="-122"/>
-                <a:cs typeface="Calibri" pitchFamily="34" charset="-120"/>
-              </a:rPr>
-              <a:t>15</a:t>
-            </a:r>
-            <a:endParaRPr lang="en-US" sz="1000" dirty="0"/>
-          </a:p>
-        </p:txBody>
-      </p:sp>
-    </p:spTree>
-  </p:cSld>
-  <p:clrMapOvr>
-    <a:masterClrMapping/>
-  </p:clrMapOvr>
-</p:sld>
-</file>
-
-<file path=ppt/slides/slide16.xml><?xml version="1.0" encoding="utf-8"?>
-<p:sld xmlns:a="http://schemas.openxmlformats.org/drawingml/2006/main" xmlns:r="http://schemas.openxmlformats.org/officeDocument/2006/relationships" xmlns:p="http://schemas.openxmlformats.org/presentationml/2006/main">
-  <p:cSld name="Slide 16">
-    <p:bg>
-      <p:bgPr>
-        <a:solidFill>
-          <a:srgbClr val="1B1F3B"/>
-        </a:solidFill>
-      </p:bgPr>
-    </p:bg>
-    <p:spTree>
-      <p:nvGrpSpPr>
-        <p:cNvPr id="1" name=""/>
-        <p:cNvGrpSpPr/>
-        <p:nvPr/>
-      </p:nvGrpSpPr>
-      <p:grpSpPr>
-        <a:xfrm>
-          <a:off x="0" y="0"/>
-          <a:ext cx="0" cy="0"/>
-          <a:chOff x="0" y="0"/>
-          <a:chExt cx="0" cy="0"/>
-        </a:xfrm>
-      </p:grpSpPr>
-      <p:sp>
-        <p:nvSpPr>
-          <p:cNvPr id="2" name="Shape 0"/>
-          <p:cNvSpPr/>
-          <p:nvPr/>
-        </p:nvSpPr>
-        <p:spPr>
-          <a:xfrm>
-            <a:off x="685800" y="2286000"/>
-            <a:ext cx="109728" cy="109728"/>
-          </a:xfrm>
-          <a:prstGeom prst="ellipse">
-            <a:avLst/>
-          </a:prstGeom>
-          <a:solidFill>
-            <a:srgbClr val="C44E52"/>
-          </a:solidFill>
-          <a:ln/>
-        </p:spPr>
-      </p:sp>
-      <p:sp>
-        <p:nvSpPr>
-          <p:cNvPr id="3" name="Shape 1"/>
-          <p:cNvSpPr/>
-          <p:nvPr/>
-        </p:nvSpPr>
-        <p:spPr>
-          <a:xfrm>
-            <a:off x="886968" y="2286000"/>
-            <a:ext cx="109728" cy="109728"/>
-          </a:xfrm>
-          <a:prstGeom prst="ellipse">
-            <a:avLst/>
-          </a:prstGeom>
-          <a:solidFill>
-            <a:srgbClr val="4C72B0"/>
-          </a:solidFill>
-          <a:ln/>
-        </p:spPr>
-      </p:sp>
-      <p:sp>
-        <p:nvSpPr>
-          <p:cNvPr id="4" name="Shape 2"/>
-          <p:cNvSpPr/>
-          <p:nvPr/>
-        </p:nvSpPr>
-        <p:spPr>
-          <a:xfrm>
-            <a:off x="1088136" y="2286000"/>
-            <a:ext cx="109728" cy="109728"/>
-          </a:xfrm>
-          <a:prstGeom prst="ellipse">
-            <a:avLst/>
-          </a:prstGeom>
-          <a:solidFill>
-            <a:srgbClr val="55A868"/>
-          </a:solidFill>
-          <a:ln/>
-        </p:spPr>
+              <a:t>Why ar / bn / el specifically — not a clean resource gradient (Russian is non-Latin yet flat) — is open.</a:t>
+            </a:r>
+            <a:endParaRPr lang="en-US" sz="1700" dirty="0"/>
+          </a:p>
+        </p:txBody>
       </p:sp>
       <p:sp>
         <p:nvSpPr>
           <p:cNvPr id="5" name="Text 3"/>
-          <p:cNvSpPr/>
-          <p:nvPr/>
-        </p:nvSpPr>
-        <p:spPr>
-          <a:xfrm>
-            <a:off x="685800" y="2651760"/>
-            <a:ext cx="10789920" cy="1097280"/>
-          </a:xfrm>
-          <a:prstGeom prst="rect">
-            <a:avLst/>
-          </a:prstGeom>
-          <a:noFill/>
-          <a:ln/>
-        </p:spPr>
-        <p:txBody>
-          <a:bodyPr wrap="square" lIns="0" tIns="0" rIns="0" bIns="0" rtlCol="0" anchor="ctr"/>
-          <a:lstStyle/>
-          <a:p>
-            <a:pPr indent="0" marL="0">
-              <a:buNone/>
-            </a:pPr>
-            <a:r>
-              <a:rPr lang="en-US" sz="4000" b="1" dirty="0">
-                <a:solidFill>
-                  <a:srgbClr val="FFFFFF"/>
-                </a:solidFill>
-                <a:latin typeface="Georgia" pitchFamily="34" charset="0"/>
-                <a:ea typeface="Georgia" pitchFamily="34" charset="-122"/>
-                <a:cs typeface="Georgia" pitchFamily="34" charset="-120"/>
-              </a:rPr>
-              <a:t>Thank you — questions?</a:t>
-            </a:r>
-            <a:endParaRPr lang="en-US" sz="4000" dirty="0"/>
-          </a:p>
-        </p:txBody>
-      </p:sp>
-      <p:sp>
-        <p:nvSpPr>
-          <p:cNvPr id="6" name="Text 4"/>
-          <p:cNvSpPr/>
-          <p:nvPr/>
-        </p:nvSpPr>
-        <p:spPr>
-          <a:xfrm>
-            <a:off x="685800" y="4114800"/>
-            <a:ext cx="10789920" cy="914400"/>
-          </a:xfrm>
-          <a:prstGeom prst="rect">
-            <a:avLst/>
-          </a:prstGeom>
-          <a:noFill/>
-          <a:ln/>
-        </p:spPr>
-        <p:txBody>
-          <a:bodyPr wrap="square" lIns="0" tIns="0" rIns="0" bIns="0" rtlCol="0" anchor="ctr"/>
-          <a:lstStyle/>
-          <a:p>
-            <a:pPr indent="0" marL="0">
-              <a:spcAft>
-                <a:spcPts val="800"/>
-              </a:spcAft>
-              <a:buNone/>
-            </a:pPr>
-            <a:r>
-              <a:rPr lang="en-US" sz="1500" dirty="0">
-                <a:solidFill>
-                  <a:srgbClr val="C9D2EC"/>
-                </a:solidFill>
-                <a:latin typeface="Calibri" pitchFamily="34" charset="0"/>
-                <a:ea typeface="Calibri" pitchFamily="34" charset="-122"/>
-                <a:cs typeface="Calibri" pitchFamily="34" charset="-120"/>
-              </a:rPr>
-              <a:t>Built &amp; ran the first multilingual, multi-model ProtoBias pipeline — 7 languages, 2 model families.</a:t>
-            </a:r>
-            <a:endParaRPr lang="en-US" sz="1500" dirty="0"/>
-          </a:p>
-          <a:p>
-            <a:pPr indent="0" marL="0">
-              <a:spcAft>
-                <a:spcPts val="800"/>
-              </a:spcAft>
-              <a:buNone/>
-            </a:pPr>
-            <a:r>
-              <a:rPr lang="en-US" sz="1500" b="1" dirty="0">
-                <a:solidFill>
-                  <a:srgbClr val="C44E52"/>
-                </a:solidFill>
-                <a:latin typeface="Calibri" pitchFamily="34" charset="0"/>
-                <a:ea typeface="Calibri" pitchFamily="34" charset="-122"/>
-                <a:cs typeface="Calibri" pitchFamily="34" charset="-120"/>
-              </a:rPr>
-              <a:t>github.com/xchuan-li/cross_lingual_protobias</a:t>
-            </a:r>
-            <a:endParaRPr lang="en-US" sz="1500" dirty="0"/>
-          </a:p>
-        </p:txBody>
-      </p:sp>
-      <p:sp>
-        <p:nvSpPr>
-          <p:cNvPr id="7" name="Text 5"/>
           <p:cNvSpPr/>
           <p:nvPr/>
         </p:nvSpPr>
@@ -7231,6 +7332,938 @@
             <a:r>
               <a:rPr lang="en-US" sz="1200" b="1" spc="300" kern="0" dirty="0">
                 <a:solidFill>
+                  <a:srgbClr val="C44E52"/>
+                </a:solidFill>
+                <a:latin typeface="Calibri" pitchFamily="34" charset="0"/>
+                <a:ea typeface="Calibri" pitchFamily="34" charset="-122"/>
+                <a:cs typeface="Calibri" pitchFamily="34" charset="-120"/>
+              </a:rPr>
+              <a:t>OUTLOOK</a:t>
+            </a:r>
+            <a:endParaRPr lang="en-US" sz="1200" dirty="0"/>
+          </a:p>
+        </p:txBody>
+      </p:sp>
+      <p:sp>
+        <p:nvSpPr>
+          <p:cNvPr id="3" name="Text 1"/>
+          <p:cNvSpPr/>
+          <p:nvPr/>
+        </p:nvSpPr>
+        <p:spPr>
+          <a:xfrm>
+            <a:off x="685800" y="841248"/>
+            <a:ext cx="10820095" cy="868680"/>
+          </a:xfrm>
+          <a:prstGeom prst="rect">
+            <a:avLst/>
+          </a:prstGeom>
+          <a:noFill/>
+          <a:ln/>
+        </p:spPr>
+        <p:txBody>
+          <a:bodyPr wrap="square" lIns="0" tIns="0" rIns="0" bIns="0" rtlCol="0" anchor="ctr"/>
+          <a:lstStyle/>
+          <a:p>
+            <a:pPr indent="0" marL="0">
+              <a:lnSpc>
+                <a:spcPts val="3456"/>
+              </a:lnSpc>
+              <a:buNone/>
+            </a:pPr>
+            <a:r>
+              <a:rPr lang="en-US" sz="3200" b="1" dirty="0">
+                <a:solidFill>
+                  <a:srgbClr val="23262F"/>
+                </a:solidFill>
+                <a:latin typeface="Georgia" pitchFamily="34" charset="0"/>
+                <a:ea typeface="Georgia" pitchFamily="34" charset="-122"/>
+                <a:cs typeface="Georgia" pitchFamily="34" charset="-120"/>
+              </a:rPr>
+              <a:t>Next steps</a:t>
+            </a:r>
+            <a:endParaRPr lang="en-US" sz="3200" dirty="0"/>
+          </a:p>
+        </p:txBody>
+      </p:sp>
+      <p:sp>
+        <p:nvSpPr>
+          <p:cNvPr id="4" name="Shape 2"/>
+          <p:cNvSpPr/>
+          <p:nvPr/>
+        </p:nvSpPr>
+        <p:spPr>
+          <a:xfrm>
+            <a:off x="685800" y="2103120"/>
+            <a:ext cx="384048" cy="384048"/>
+          </a:xfrm>
+          <a:prstGeom prst="ellipse">
+            <a:avLst/>
+          </a:prstGeom>
+          <a:solidFill>
+            <a:srgbClr val="1B1F3B"/>
+          </a:solidFill>
+          <a:ln/>
+        </p:spPr>
+      </p:sp>
+      <p:sp>
+        <p:nvSpPr>
+          <p:cNvPr id="5" name="Text 3"/>
+          <p:cNvSpPr/>
+          <p:nvPr/>
+        </p:nvSpPr>
+        <p:spPr>
+          <a:xfrm>
+            <a:off x="685800" y="2103120"/>
+            <a:ext cx="384048" cy="384048"/>
+          </a:xfrm>
+          <a:prstGeom prst="rect">
+            <a:avLst/>
+          </a:prstGeom>
+          <a:noFill/>
+          <a:ln/>
+        </p:spPr>
+        <p:txBody>
+          <a:bodyPr wrap="square" lIns="0" tIns="0" rIns="0" bIns="0" rtlCol="0" anchor="ctr"/>
+          <a:lstStyle/>
+          <a:p>
+            <a:pPr algn="ctr" indent="0" marL="0">
+              <a:buNone/>
+            </a:pPr>
+            <a:r>
+              <a:rPr lang="en-US" sz="1600" b="1" dirty="0">
+                <a:solidFill>
+                  <a:srgbClr val="FFFFFF"/>
+                </a:solidFill>
+                <a:latin typeface="Georgia" pitchFamily="34" charset="0"/>
+                <a:ea typeface="Georgia" pitchFamily="34" charset="-122"/>
+                <a:cs typeface="Georgia" pitchFamily="34" charset="-120"/>
+              </a:rPr>
+              <a:t>1</a:t>
+            </a:r>
+            <a:endParaRPr lang="en-US" sz="1600" dirty="0"/>
+          </a:p>
+        </p:txBody>
+      </p:sp>
+      <p:sp>
+        <p:nvSpPr>
+          <p:cNvPr id="6" name="Text 4"/>
+          <p:cNvSpPr/>
+          <p:nvPr/>
+        </p:nvSpPr>
+        <p:spPr>
+          <a:xfrm>
+            <a:off x="1325880" y="2039112"/>
+            <a:ext cx="2926080" cy="457200"/>
+          </a:xfrm>
+          <a:prstGeom prst="rect">
+            <a:avLst/>
+          </a:prstGeom>
+          <a:noFill/>
+          <a:ln/>
+        </p:spPr>
+        <p:txBody>
+          <a:bodyPr wrap="square" lIns="0" tIns="0" rIns="0" bIns="0" rtlCol="0" anchor="ctr"/>
+          <a:lstStyle/>
+          <a:p>
+            <a:pPr indent="0" marL="0">
+              <a:buNone/>
+            </a:pPr>
+            <a:r>
+              <a:rPr lang="en-US" sz="1700" b="1" dirty="0">
+                <a:solidFill>
+                  <a:srgbClr val="C44E52"/>
+                </a:solidFill>
+                <a:latin typeface="Georgia" pitchFamily="34" charset="0"/>
+                <a:ea typeface="Georgia" pitchFamily="34" charset="-122"/>
+                <a:cs typeface="Georgia" pitchFamily="34" charset="-120"/>
+              </a:rPr>
+              <a:t>Scale axis</a:t>
+            </a:r>
+            <a:endParaRPr lang="en-US" sz="1700" dirty="0"/>
+          </a:p>
+        </p:txBody>
+      </p:sp>
+      <p:sp>
+        <p:nvSpPr>
+          <p:cNvPr id="7" name="Text 5"/>
+          <p:cNvSpPr/>
+          <p:nvPr/>
+        </p:nvSpPr>
+        <p:spPr>
+          <a:xfrm>
+            <a:off x="4343400" y="2039112"/>
+            <a:ext cx="7772400" cy="640080"/>
+          </a:xfrm>
+          <a:prstGeom prst="rect">
+            <a:avLst/>
+          </a:prstGeom>
+          <a:noFill/>
+          <a:ln/>
+        </p:spPr>
+        <p:txBody>
+          <a:bodyPr wrap="square" lIns="0" tIns="0" rIns="0" bIns="0" rtlCol="0" anchor="t"/>
+          <a:lstStyle/>
+          <a:p>
+            <a:pPr indent="0" marL="0">
+              <a:buNone/>
+            </a:pPr>
+            <a:r>
+              <a:rPr lang="en-US" sz="1500" dirty="0">
+                <a:solidFill>
+                  <a:srgbClr val="23262F"/>
+                </a:solidFill>
+                <a:latin typeface="Calibri" pitchFamily="34" charset="0"/>
+                <a:ea typeface="Calibri" pitchFamily="34" charset="-122"/>
+                <a:cs typeface="Calibri" pitchFamily="34" charset="-120"/>
+              </a:rPr>
+              <a:t>Qwen-32B in 4-bit on a single GPU — does the bias shrink with model size?</a:t>
+            </a:r>
+            <a:endParaRPr lang="en-US" sz="1500" dirty="0"/>
+          </a:p>
+        </p:txBody>
+      </p:sp>
+      <p:sp>
+        <p:nvSpPr>
+          <p:cNvPr id="8" name="Shape 6"/>
+          <p:cNvSpPr/>
+          <p:nvPr/>
+        </p:nvSpPr>
+        <p:spPr>
+          <a:xfrm>
+            <a:off x="685800" y="3127248"/>
+            <a:ext cx="384048" cy="384048"/>
+          </a:xfrm>
+          <a:prstGeom prst="ellipse">
+            <a:avLst/>
+          </a:prstGeom>
+          <a:solidFill>
+            <a:srgbClr val="1B1F3B"/>
+          </a:solidFill>
+          <a:ln/>
+        </p:spPr>
+      </p:sp>
+      <p:sp>
+        <p:nvSpPr>
+          <p:cNvPr id="9" name="Text 7"/>
+          <p:cNvSpPr/>
+          <p:nvPr/>
+        </p:nvSpPr>
+        <p:spPr>
+          <a:xfrm>
+            <a:off x="685800" y="3127248"/>
+            <a:ext cx="384048" cy="384048"/>
+          </a:xfrm>
+          <a:prstGeom prst="rect">
+            <a:avLst/>
+          </a:prstGeom>
+          <a:noFill/>
+          <a:ln/>
+        </p:spPr>
+        <p:txBody>
+          <a:bodyPr wrap="square" lIns="0" tIns="0" rIns="0" bIns="0" rtlCol="0" anchor="ctr"/>
+          <a:lstStyle/>
+          <a:p>
+            <a:pPr algn="ctr" indent="0" marL="0">
+              <a:buNone/>
+            </a:pPr>
+            <a:r>
+              <a:rPr lang="en-US" sz="1600" b="1" dirty="0">
+                <a:solidFill>
+                  <a:srgbClr val="FFFFFF"/>
+                </a:solidFill>
+                <a:latin typeface="Georgia" pitchFamily="34" charset="0"/>
+                <a:ea typeface="Georgia" pitchFamily="34" charset="-122"/>
+                <a:cs typeface="Georgia" pitchFamily="34" charset="-120"/>
+              </a:rPr>
+              <a:t>2</a:t>
+            </a:r>
+            <a:endParaRPr lang="en-US" sz="1600" dirty="0"/>
+          </a:p>
+        </p:txBody>
+      </p:sp>
+      <p:sp>
+        <p:nvSpPr>
+          <p:cNvPr id="10" name="Text 8"/>
+          <p:cNvSpPr/>
+          <p:nvPr/>
+        </p:nvSpPr>
+        <p:spPr>
+          <a:xfrm>
+            <a:off x="1325880" y="3063240"/>
+            <a:ext cx="2926080" cy="457200"/>
+          </a:xfrm>
+          <a:prstGeom prst="rect">
+            <a:avLst/>
+          </a:prstGeom>
+          <a:noFill/>
+          <a:ln/>
+        </p:spPr>
+        <p:txBody>
+          <a:bodyPr wrap="square" lIns="0" tIns="0" rIns="0" bIns="0" rtlCol="0" anchor="ctr"/>
+          <a:lstStyle/>
+          <a:p>
+            <a:pPr indent="0" marL="0">
+              <a:buNone/>
+            </a:pPr>
+            <a:r>
+              <a:rPr lang="en-US" sz="1700" b="1" dirty="0">
+                <a:solidFill>
+                  <a:srgbClr val="C44E52"/>
+                </a:solidFill>
+                <a:latin typeface="Georgia" pitchFamily="34" charset="0"/>
+                <a:ea typeface="Georgia" pitchFamily="34" charset="-122"/>
+                <a:cs typeface="Georgia" pitchFamily="34" charset="-120"/>
+              </a:rPr>
+              <a:t>More families</a:t>
+            </a:r>
+            <a:endParaRPr lang="en-US" sz="1700" dirty="0"/>
+          </a:p>
+        </p:txBody>
+      </p:sp>
+      <p:sp>
+        <p:nvSpPr>
+          <p:cNvPr id="11" name="Text 9"/>
+          <p:cNvSpPr/>
+          <p:nvPr/>
+        </p:nvSpPr>
+        <p:spPr>
+          <a:xfrm>
+            <a:off x="4343400" y="3063240"/>
+            <a:ext cx="7772400" cy="640080"/>
+          </a:xfrm>
+          <a:prstGeom prst="rect">
+            <a:avLst/>
+          </a:prstGeom>
+          <a:noFill/>
+          <a:ln/>
+        </p:spPr>
+        <p:txBody>
+          <a:bodyPr wrap="square" lIns="0" tIns="0" rIns="0" bIns="0" rtlCol="0" anchor="t"/>
+          <a:lstStyle/>
+          <a:p>
+            <a:pPr indent="0" marL="0">
+              <a:buNone/>
+            </a:pPr>
+            <a:r>
+              <a:rPr lang="en-US" sz="1500" dirty="0">
+                <a:solidFill>
+                  <a:srgbClr val="23262F"/>
+                </a:solidFill>
+                <a:latin typeface="Calibri" pitchFamily="34" charset="0"/>
+                <a:ea typeface="Calibri" pitchFamily="34" charset="-122"/>
+                <a:cs typeface="Calibri" pitchFamily="34" charset="-120"/>
+              </a:rPr>
+              <a:t>Gemma-3, LLaVA-OneVision — map how general the language effect is.</a:t>
+            </a:r>
+            <a:endParaRPr lang="en-US" sz="1500" dirty="0"/>
+          </a:p>
+        </p:txBody>
+      </p:sp>
+      <p:sp>
+        <p:nvSpPr>
+          <p:cNvPr id="12" name="Shape 10"/>
+          <p:cNvSpPr/>
+          <p:nvPr/>
+        </p:nvSpPr>
+        <p:spPr>
+          <a:xfrm>
+            <a:off x="685800" y="4151376"/>
+            <a:ext cx="384048" cy="384048"/>
+          </a:xfrm>
+          <a:prstGeom prst="ellipse">
+            <a:avLst/>
+          </a:prstGeom>
+          <a:solidFill>
+            <a:srgbClr val="1B1F3B"/>
+          </a:solidFill>
+          <a:ln/>
+        </p:spPr>
+      </p:sp>
+      <p:sp>
+        <p:nvSpPr>
+          <p:cNvPr id="13" name="Text 11"/>
+          <p:cNvSpPr/>
+          <p:nvPr/>
+        </p:nvSpPr>
+        <p:spPr>
+          <a:xfrm>
+            <a:off x="685800" y="4151376"/>
+            <a:ext cx="384048" cy="384048"/>
+          </a:xfrm>
+          <a:prstGeom prst="rect">
+            <a:avLst/>
+          </a:prstGeom>
+          <a:noFill/>
+          <a:ln/>
+        </p:spPr>
+        <p:txBody>
+          <a:bodyPr wrap="square" lIns="0" tIns="0" rIns="0" bIns="0" rtlCol="0" anchor="ctr"/>
+          <a:lstStyle/>
+          <a:p>
+            <a:pPr algn="ctr" indent="0" marL="0">
+              <a:buNone/>
+            </a:pPr>
+            <a:r>
+              <a:rPr lang="en-US" sz="1600" b="1" dirty="0">
+                <a:solidFill>
+                  <a:srgbClr val="FFFFFF"/>
+                </a:solidFill>
+                <a:latin typeface="Georgia" pitchFamily="34" charset="0"/>
+                <a:ea typeface="Georgia" pitchFamily="34" charset="-122"/>
+                <a:cs typeface="Georgia" pitchFamily="34" charset="-120"/>
+              </a:rPr>
+              <a:t>3</a:t>
+            </a:r>
+            <a:endParaRPr lang="en-US" sz="1600" dirty="0"/>
+          </a:p>
+        </p:txBody>
+      </p:sp>
+      <p:sp>
+        <p:nvSpPr>
+          <p:cNvPr id="14" name="Text 12"/>
+          <p:cNvSpPr/>
+          <p:nvPr/>
+        </p:nvSpPr>
+        <p:spPr>
+          <a:xfrm>
+            <a:off x="1325880" y="4087368"/>
+            <a:ext cx="2926080" cy="457200"/>
+          </a:xfrm>
+          <a:prstGeom prst="rect">
+            <a:avLst/>
+          </a:prstGeom>
+          <a:noFill/>
+          <a:ln/>
+        </p:spPr>
+        <p:txBody>
+          <a:bodyPr wrap="square" lIns="0" tIns="0" rIns="0" bIns="0" rtlCol="0" anchor="ctr"/>
+          <a:lstStyle/>
+          <a:p>
+            <a:pPr indent="0" marL="0">
+              <a:buNone/>
+            </a:pPr>
+            <a:r>
+              <a:rPr lang="en-US" sz="1700" b="1" dirty="0">
+                <a:solidFill>
+                  <a:srgbClr val="C44E52"/>
+                </a:solidFill>
+                <a:latin typeface="Georgia" pitchFamily="34" charset="0"/>
+                <a:ea typeface="Georgia" pitchFamily="34" charset="-122"/>
+                <a:cs typeface="Georgia" pitchFamily="34" charset="-120"/>
+              </a:rPr>
+              <a:t>Shortcut-severing</a:t>
+            </a:r>
+            <a:endParaRPr lang="en-US" sz="1700" dirty="0"/>
+          </a:p>
+        </p:txBody>
+      </p:sp>
+      <p:sp>
+        <p:nvSpPr>
+          <p:cNvPr id="15" name="Text 13"/>
+          <p:cNvSpPr/>
+          <p:nvPr/>
+        </p:nvSpPr>
+        <p:spPr>
+          <a:xfrm>
+            <a:off x="4343400" y="4087368"/>
+            <a:ext cx="7772400" cy="640080"/>
+          </a:xfrm>
+          <a:prstGeom prst="rect">
+            <a:avLst/>
+          </a:prstGeom>
+          <a:noFill/>
+          <a:ln/>
+        </p:spPr>
+        <p:txBody>
+          <a:bodyPr wrap="square" lIns="0" tIns="0" rIns="0" bIns="0" rtlCol="0" anchor="t"/>
+          <a:lstStyle/>
+          <a:p>
+            <a:pPr indent="0" marL="0">
+              <a:buNone/>
+            </a:pPr>
+            <a:r>
+              <a:rPr lang="en-US" sz="1500" dirty="0">
+                <a:solidFill>
+                  <a:srgbClr val="23262F"/>
+                </a:solidFill>
+                <a:latin typeface="Calibri" pitchFamily="34" charset="0"/>
+                <a:ea typeface="Calibri" pitchFamily="34" charset="-122"/>
+                <a:cs typeface="Calibri" pitchFamily="34" charset="-120"/>
+              </a:rPr>
+              <a:t>Remove prototype cues — is stable correctness actually grounded?</a:t>
+            </a:r>
+            <a:endParaRPr lang="en-US" sz="1500" dirty="0"/>
+          </a:p>
+        </p:txBody>
+      </p:sp>
+      <p:sp>
+        <p:nvSpPr>
+          <p:cNvPr id="16" name="Shape 14"/>
+          <p:cNvSpPr/>
+          <p:nvPr/>
+        </p:nvSpPr>
+        <p:spPr>
+          <a:xfrm>
+            <a:off x="685800" y="5175504"/>
+            <a:ext cx="384048" cy="384048"/>
+          </a:xfrm>
+          <a:prstGeom prst="ellipse">
+            <a:avLst/>
+          </a:prstGeom>
+          <a:solidFill>
+            <a:srgbClr val="1B1F3B"/>
+          </a:solidFill>
+          <a:ln/>
+        </p:spPr>
+      </p:sp>
+      <p:sp>
+        <p:nvSpPr>
+          <p:cNvPr id="17" name="Text 15"/>
+          <p:cNvSpPr/>
+          <p:nvPr/>
+        </p:nvSpPr>
+        <p:spPr>
+          <a:xfrm>
+            <a:off x="685800" y="5175504"/>
+            <a:ext cx="384048" cy="384048"/>
+          </a:xfrm>
+          <a:prstGeom prst="rect">
+            <a:avLst/>
+          </a:prstGeom>
+          <a:noFill/>
+          <a:ln/>
+        </p:spPr>
+        <p:txBody>
+          <a:bodyPr wrap="square" lIns="0" tIns="0" rIns="0" bIns="0" rtlCol="0" anchor="ctr"/>
+          <a:lstStyle/>
+          <a:p>
+            <a:pPr algn="ctr" indent="0" marL="0">
+              <a:buNone/>
+            </a:pPr>
+            <a:r>
+              <a:rPr lang="en-US" sz="1600" b="1" dirty="0">
+                <a:solidFill>
+                  <a:srgbClr val="FFFFFF"/>
+                </a:solidFill>
+                <a:latin typeface="Georgia" pitchFamily="34" charset="0"/>
+                <a:ea typeface="Georgia" pitchFamily="34" charset="-122"/>
+                <a:cs typeface="Georgia" pitchFamily="34" charset="-120"/>
+              </a:rPr>
+              <a:t>4</a:t>
+            </a:r>
+            <a:endParaRPr lang="en-US" sz="1600" dirty="0"/>
+          </a:p>
+        </p:txBody>
+      </p:sp>
+      <p:sp>
+        <p:nvSpPr>
+          <p:cNvPr id="18" name="Text 16"/>
+          <p:cNvSpPr/>
+          <p:nvPr/>
+        </p:nvSpPr>
+        <p:spPr>
+          <a:xfrm>
+            <a:off x="1325880" y="5111496"/>
+            <a:ext cx="2926080" cy="457200"/>
+          </a:xfrm>
+          <a:prstGeom prst="rect">
+            <a:avLst/>
+          </a:prstGeom>
+          <a:noFill/>
+          <a:ln/>
+        </p:spPr>
+        <p:txBody>
+          <a:bodyPr wrap="square" lIns="0" tIns="0" rIns="0" bIns="0" rtlCol="0" anchor="ctr"/>
+          <a:lstStyle/>
+          <a:p>
+            <a:pPr indent="0" marL="0">
+              <a:buNone/>
+            </a:pPr>
+            <a:r>
+              <a:rPr lang="en-US" sz="1700" b="1" dirty="0">
+                <a:solidFill>
+                  <a:srgbClr val="C44E52"/>
+                </a:solidFill>
+                <a:latin typeface="Georgia" pitchFamily="34" charset="0"/>
+                <a:ea typeface="Georgia" pitchFamily="34" charset="-122"/>
+                <a:cs typeface="Georgia" pitchFamily="34" charset="-120"/>
+              </a:rPr>
+              <a:t>Pin down language</a:t>
+            </a:r>
+            <a:endParaRPr lang="en-US" sz="1700" dirty="0"/>
+          </a:p>
+        </p:txBody>
+      </p:sp>
+      <p:sp>
+        <p:nvSpPr>
+          <p:cNvPr id="19" name="Text 17"/>
+          <p:cNvSpPr/>
+          <p:nvPr/>
+        </p:nvSpPr>
+        <p:spPr>
+          <a:xfrm>
+            <a:off x="4343400" y="5111496"/>
+            <a:ext cx="7772400" cy="640080"/>
+          </a:xfrm>
+          <a:prstGeom prst="rect">
+            <a:avLst/>
+          </a:prstGeom>
+          <a:noFill/>
+          <a:ln/>
+        </p:spPr>
+        <p:txBody>
+          <a:bodyPr wrap="square" lIns="0" tIns="0" rIns="0" bIns="0" rtlCol="0" anchor="t"/>
+          <a:lstStyle/>
+          <a:p>
+            <a:pPr indent="0" marL="0">
+              <a:buNone/>
+            </a:pPr>
+            <a:r>
+              <a:rPr lang="en-US" sz="1500" dirty="0">
+                <a:solidFill>
+                  <a:srgbClr val="23262F"/>
+                </a:solidFill>
+                <a:latin typeface="Calibri" pitchFamily="34" charset="0"/>
+                <a:ea typeface="Calibri" pitchFamily="34" charset="-122"/>
+                <a:cs typeface="Calibri" pitchFamily="34" charset="-120"/>
+              </a:rPr>
+              <a:t>Disentangle resource vs script vs cultural loading behind the ar / bn / el spike.</a:t>
+            </a:r>
+            <a:endParaRPr lang="en-US" sz="1500" dirty="0"/>
+          </a:p>
+        </p:txBody>
+      </p:sp>
+      <p:sp>
+        <p:nvSpPr>
+          <p:cNvPr id="20" name="Text 18"/>
+          <p:cNvSpPr/>
+          <p:nvPr/>
+        </p:nvSpPr>
+        <p:spPr>
+          <a:xfrm>
+            <a:off x="11551615" y="6400800"/>
+            <a:ext cx="365760" cy="274320"/>
+          </a:xfrm>
+          <a:prstGeom prst="rect">
+            <a:avLst/>
+          </a:prstGeom>
+          <a:noFill/>
+          <a:ln/>
+        </p:spPr>
+        <p:txBody>
+          <a:bodyPr wrap="square" lIns="0" tIns="0" rIns="0" bIns="0" rtlCol="0" anchor="ctr"/>
+          <a:lstStyle/>
+          <a:p>
+            <a:pPr algn="r" indent="0" marL="0">
+              <a:buNone/>
+            </a:pPr>
+            <a:r>
+              <a:rPr lang="en-US" sz="1000" dirty="0">
+                <a:solidFill>
+                  <a:srgbClr val="9AA0B0"/>
+                </a:solidFill>
+                <a:latin typeface="Calibri" pitchFamily="34" charset="0"/>
+                <a:ea typeface="Calibri" pitchFamily="34" charset="-122"/>
+                <a:cs typeface="Calibri" pitchFamily="34" charset="-120"/>
+              </a:rPr>
+              <a:t>17</a:t>
+            </a:r>
+            <a:endParaRPr lang="en-US" sz="1000" dirty="0"/>
+          </a:p>
+        </p:txBody>
+      </p:sp>
+    </p:spTree>
+  </p:cSld>
+  <p:clrMapOvr>
+    <a:masterClrMapping/>
+  </p:clrMapOvr>
+</p:sld>
+</file>
+
+<file path=ppt/slides/slide18.xml><?xml version="1.0" encoding="utf-8"?>
+<p:sld xmlns:a="http://schemas.openxmlformats.org/drawingml/2006/main" xmlns:r="http://schemas.openxmlformats.org/officeDocument/2006/relationships" xmlns:p="http://schemas.openxmlformats.org/presentationml/2006/main">
+  <p:cSld name="Slide 18">
+    <p:bg>
+      <p:bgPr>
+        <a:solidFill>
+          <a:srgbClr val="1B1F3B"/>
+        </a:solidFill>
+      </p:bgPr>
+    </p:bg>
+    <p:spTree>
+      <p:nvGrpSpPr>
+        <p:cNvPr id="1" name=""/>
+        <p:cNvGrpSpPr/>
+        <p:nvPr/>
+      </p:nvGrpSpPr>
+      <p:grpSpPr>
+        <a:xfrm>
+          <a:off x="0" y="0"/>
+          <a:ext cx="0" cy="0"/>
+          <a:chOff x="0" y="0"/>
+          <a:chExt cx="0" cy="0"/>
+        </a:xfrm>
+      </p:grpSpPr>
+      <p:sp>
+        <p:nvSpPr>
+          <p:cNvPr id="2" name="Shape 0"/>
+          <p:cNvSpPr/>
+          <p:nvPr/>
+        </p:nvSpPr>
+        <p:spPr>
+          <a:xfrm>
+            <a:off x="685800" y="2286000"/>
+            <a:ext cx="109728" cy="109728"/>
+          </a:xfrm>
+          <a:prstGeom prst="ellipse">
+            <a:avLst/>
+          </a:prstGeom>
+          <a:solidFill>
+            <a:srgbClr val="C44E52"/>
+          </a:solidFill>
+          <a:ln/>
+        </p:spPr>
+      </p:sp>
+      <p:sp>
+        <p:nvSpPr>
+          <p:cNvPr id="3" name="Shape 1"/>
+          <p:cNvSpPr/>
+          <p:nvPr/>
+        </p:nvSpPr>
+        <p:spPr>
+          <a:xfrm>
+            <a:off x="886968" y="2286000"/>
+            <a:ext cx="109728" cy="109728"/>
+          </a:xfrm>
+          <a:prstGeom prst="ellipse">
+            <a:avLst/>
+          </a:prstGeom>
+          <a:solidFill>
+            <a:srgbClr val="4C72B0"/>
+          </a:solidFill>
+          <a:ln/>
+        </p:spPr>
+      </p:sp>
+      <p:sp>
+        <p:nvSpPr>
+          <p:cNvPr id="4" name="Shape 2"/>
+          <p:cNvSpPr/>
+          <p:nvPr/>
+        </p:nvSpPr>
+        <p:spPr>
+          <a:xfrm>
+            <a:off x="1088136" y="2286000"/>
+            <a:ext cx="109728" cy="109728"/>
+          </a:xfrm>
+          <a:prstGeom prst="ellipse">
+            <a:avLst/>
+          </a:prstGeom>
+          <a:solidFill>
+            <a:srgbClr val="55A868"/>
+          </a:solidFill>
+          <a:ln/>
+        </p:spPr>
+      </p:sp>
+      <p:sp>
+        <p:nvSpPr>
+          <p:cNvPr id="5" name="Text 3"/>
+          <p:cNvSpPr/>
+          <p:nvPr/>
+        </p:nvSpPr>
+        <p:spPr>
+          <a:xfrm>
+            <a:off x="685800" y="2651760"/>
+            <a:ext cx="10789920" cy="1097280"/>
+          </a:xfrm>
+          <a:prstGeom prst="rect">
+            <a:avLst/>
+          </a:prstGeom>
+          <a:noFill/>
+          <a:ln/>
+        </p:spPr>
+        <p:txBody>
+          <a:bodyPr wrap="square" lIns="0" tIns="0" rIns="0" bIns="0" rtlCol="0" anchor="ctr"/>
+          <a:lstStyle/>
+          <a:p>
+            <a:pPr indent="0" marL="0">
+              <a:buNone/>
+            </a:pPr>
+            <a:r>
+              <a:rPr lang="en-US" sz="4000" b="1" dirty="0">
+                <a:solidFill>
+                  <a:srgbClr val="FFFFFF"/>
+                </a:solidFill>
+                <a:latin typeface="Georgia" pitchFamily="34" charset="0"/>
+                <a:ea typeface="Georgia" pitchFamily="34" charset="-122"/>
+                <a:cs typeface="Georgia" pitchFamily="34" charset="-120"/>
+              </a:rPr>
+              <a:t>Thank you — questions?</a:t>
+            </a:r>
+            <a:endParaRPr lang="en-US" sz="4000" dirty="0"/>
+          </a:p>
+        </p:txBody>
+      </p:sp>
+      <p:sp>
+        <p:nvSpPr>
+          <p:cNvPr id="6" name="Text 4"/>
+          <p:cNvSpPr/>
+          <p:nvPr/>
+        </p:nvSpPr>
+        <p:spPr>
+          <a:xfrm>
+            <a:off x="685800" y="4114800"/>
+            <a:ext cx="10789920" cy="914400"/>
+          </a:xfrm>
+          <a:prstGeom prst="rect">
+            <a:avLst/>
+          </a:prstGeom>
+          <a:noFill/>
+          <a:ln/>
+        </p:spPr>
+        <p:txBody>
+          <a:bodyPr wrap="square" lIns="0" tIns="0" rIns="0" bIns="0" rtlCol="0" anchor="ctr"/>
+          <a:lstStyle/>
+          <a:p>
+            <a:pPr indent="0" marL="0">
+              <a:spcAft>
+                <a:spcPts val="800"/>
+              </a:spcAft>
+              <a:buNone/>
+            </a:pPr>
+            <a:r>
+              <a:rPr lang="en-US" sz="1500" dirty="0">
+                <a:solidFill>
+                  <a:srgbClr val="C9D2EC"/>
+                </a:solidFill>
+                <a:latin typeface="Calibri" pitchFamily="34" charset="0"/>
+                <a:ea typeface="Calibri" pitchFamily="34" charset="-122"/>
+                <a:cs typeface="Calibri" pitchFamily="34" charset="-120"/>
+              </a:rPr>
+              <a:t>Built &amp; ran the first multilingual, multi-model ProtoBias pipeline — 7 languages, 2 model families.</a:t>
+            </a:r>
+            <a:endParaRPr lang="en-US" sz="1500" dirty="0"/>
+          </a:p>
+          <a:p>
+            <a:pPr indent="0" marL="0">
+              <a:spcAft>
+                <a:spcPts val="800"/>
+              </a:spcAft>
+              <a:buNone/>
+            </a:pPr>
+            <a:r>
+              <a:rPr lang="en-US" sz="1500" b="1" dirty="0">
+                <a:solidFill>
+                  <a:srgbClr val="C44E52"/>
+                </a:solidFill>
+                <a:latin typeface="Calibri" pitchFamily="34" charset="0"/>
+                <a:ea typeface="Calibri" pitchFamily="34" charset="-122"/>
+                <a:cs typeface="Calibri" pitchFamily="34" charset="-120"/>
+              </a:rPr>
+              <a:t>github.com/xchuan-li/cross_lingual_protobias</a:t>
+            </a:r>
+            <a:endParaRPr lang="en-US" sz="1500" dirty="0"/>
+          </a:p>
+        </p:txBody>
+      </p:sp>
+      <p:sp>
+        <p:nvSpPr>
+          <p:cNvPr id="7" name="Text 5"/>
+          <p:cNvSpPr/>
+          <p:nvPr/>
+        </p:nvSpPr>
+        <p:spPr>
+          <a:xfrm>
+            <a:off x="11551615" y="6400800"/>
+            <a:ext cx="365760" cy="274320"/>
+          </a:xfrm>
+          <a:prstGeom prst="rect">
+            <a:avLst/>
+          </a:prstGeom>
+          <a:noFill/>
+          <a:ln/>
+        </p:spPr>
+        <p:txBody>
+          <a:bodyPr wrap="square" lIns="0" tIns="0" rIns="0" bIns="0" rtlCol="0" anchor="ctr"/>
+          <a:lstStyle/>
+          <a:p>
+            <a:pPr algn="r" indent="0" marL="0">
+              <a:buNone/>
+            </a:pPr>
+            <a:r>
+              <a:rPr lang="en-US" sz="1000" dirty="0">
+                <a:solidFill>
+                  <a:srgbClr val="9AA0B0"/>
+                </a:solidFill>
+                <a:latin typeface="Calibri" pitchFamily="34" charset="0"/>
+                <a:ea typeface="Calibri" pitchFamily="34" charset="-122"/>
+                <a:cs typeface="Calibri" pitchFamily="34" charset="-120"/>
+              </a:rPr>
+              <a:t>18</a:t>
+            </a:r>
+            <a:endParaRPr lang="en-US" sz="1000" dirty="0"/>
+          </a:p>
+        </p:txBody>
+      </p:sp>
+    </p:spTree>
+  </p:cSld>
+  <p:clrMapOvr>
+    <a:masterClrMapping/>
+  </p:clrMapOvr>
+</p:sld>
+</file>
+
+<file path=ppt/slides/slide19.xml><?xml version="1.0" encoding="utf-8"?>
+<p:sld xmlns:a="http://schemas.openxmlformats.org/drawingml/2006/main" xmlns:r="http://schemas.openxmlformats.org/officeDocument/2006/relationships" xmlns:p="http://schemas.openxmlformats.org/presentationml/2006/main">
+  <p:cSld name="Slide 19">
+    <p:bg>
+      <p:bgPr>
+        <a:solidFill>
+          <a:srgbClr val="FFFFFF"/>
+        </a:solidFill>
+      </p:bgPr>
+    </p:bg>
+    <p:spTree>
+      <p:nvGrpSpPr>
+        <p:cNvPr id="1" name=""/>
+        <p:cNvGrpSpPr/>
+        <p:nvPr/>
+      </p:nvGrpSpPr>
+      <p:grpSpPr>
+        <a:xfrm>
+          <a:off x="0" y="0"/>
+          <a:ext cx="0" cy="0"/>
+          <a:chOff x="0" y="0"/>
+          <a:chExt cx="0" cy="0"/>
+        </a:xfrm>
+      </p:grpSpPr>
+      <p:sp>
+        <p:nvSpPr>
+          <p:cNvPr id="2" name="Text 0"/>
+          <p:cNvSpPr/>
+          <p:nvPr/>
+        </p:nvSpPr>
+        <p:spPr>
+          <a:xfrm>
+            <a:off x="685800" y="502920"/>
+            <a:ext cx="10820095" cy="274320"/>
+          </a:xfrm>
+          <a:prstGeom prst="rect">
+            <a:avLst/>
+          </a:prstGeom>
+          <a:noFill/>
+          <a:ln/>
+        </p:spPr>
+        <p:txBody>
+          <a:bodyPr wrap="square" lIns="0" tIns="0" rIns="0" bIns="0" rtlCol="0" anchor="ctr"/>
+          <a:lstStyle/>
+          <a:p>
+            <a:pPr indent="0" marL="0">
+              <a:buNone/>
+            </a:pPr>
+            <a:r>
+              <a:rPr lang="en-US" sz="1200" b="1" spc="300" kern="0" dirty="0">
+                <a:solidFill>
                   <a:srgbClr val="9AA0B0"/>
                 </a:solidFill>
                 <a:latin typeface="Calibri" pitchFamily="34" charset="0"/>
@@ -7287,7 +8320,7 @@
       </p:sp>
       <p:graphicFrame>
         <p:nvGraphicFramePr>
-          <p:cNvPr id="18" name="Table 0"/>
+          <p:cNvPr id="20" name="Table 0"/>
           <p:cNvGraphicFramePr>
             <a:graphicFrameLocks noGrp="1"/>
           </p:cNvGraphicFramePr>
@@ -8962,7 +9995,7 @@
                 <a:ea typeface="Calibri" pitchFamily="34" charset="-122"/>
                 <a:cs typeface="Calibri" pitchFamily="34" charset="-120"/>
               </a:rPr>
-              <a:t>17</a:t>
+              <a:t>19</a:t>
             </a:r>
             <a:endParaRPr lang="en-US" sz="1000" dirty="0"/>
           </a:p>
@@ -9296,6 +10329,1182 @@
                 <a:cs typeface="Calibri" pitchFamily="34" charset="-120"/>
               </a:rPr>
               <a:t>2</a:t>
+            </a:r>
+            <a:endParaRPr lang="en-US" sz="1000" dirty="0"/>
+          </a:p>
+        </p:txBody>
+      </p:sp>
+    </p:spTree>
+  </p:cSld>
+  <p:clrMapOvr>
+    <a:masterClrMapping/>
+  </p:clrMapOvr>
+</p:sld>
+</file>
+
+<file path=ppt/slides/slide20.xml><?xml version="1.0" encoding="utf-8"?>
+<p:sld xmlns:a="http://schemas.openxmlformats.org/drawingml/2006/main" xmlns:r="http://schemas.openxmlformats.org/officeDocument/2006/relationships" xmlns:p="http://schemas.openxmlformats.org/presentationml/2006/main">
+  <p:cSld name="Slide 20">
+    <p:bg>
+      <p:bgPr>
+        <a:solidFill>
+          <a:srgbClr val="FFFFFF"/>
+        </a:solidFill>
+      </p:bgPr>
+    </p:bg>
+    <p:spTree>
+      <p:nvGrpSpPr>
+        <p:cNvPr id="1" name=""/>
+        <p:cNvGrpSpPr/>
+        <p:nvPr/>
+      </p:nvGrpSpPr>
+      <p:grpSpPr>
+        <a:xfrm>
+          <a:off x="0" y="0"/>
+          <a:ext cx="0" cy="0"/>
+          <a:chOff x="0" y="0"/>
+          <a:chExt cx="0" cy="0"/>
+        </a:xfrm>
+      </p:grpSpPr>
+      <p:sp>
+        <p:nvSpPr>
+          <p:cNvPr id="2" name="Text 0"/>
+          <p:cNvSpPr/>
+          <p:nvPr/>
+        </p:nvSpPr>
+        <p:spPr>
+          <a:xfrm>
+            <a:off x="685800" y="502920"/>
+            <a:ext cx="10820095" cy="274320"/>
+          </a:xfrm>
+          <a:prstGeom prst="rect">
+            <a:avLst/>
+          </a:prstGeom>
+          <a:noFill/>
+          <a:ln/>
+        </p:spPr>
+        <p:txBody>
+          <a:bodyPr wrap="square" lIns="0" tIns="0" rIns="0" bIns="0" rtlCol="0" anchor="ctr"/>
+          <a:lstStyle/>
+          <a:p>
+            <a:pPr indent="0" marL="0">
+              <a:buNone/>
+            </a:pPr>
+            <a:r>
+              <a:rPr lang="en-US" sz="1200" b="1" spc="300" kern="0" dirty="0">
+                <a:solidFill>
+                  <a:srgbClr val="C44E52"/>
+                </a:solidFill>
+                <a:latin typeface="Calibri" pitchFamily="34" charset="0"/>
+                <a:ea typeface="Calibri" pitchFamily="34" charset="-122"/>
+                <a:cs typeface="Calibri" pitchFamily="34" charset="-120"/>
+              </a:rPr>
+              <a:t>INTERACTIVE · MODEL EXPLORER</a:t>
+            </a:r>
+            <a:endParaRPr lang="en-US" sz="1200" dirty="0"/>
+          </a:p>
+        </p:txBody>
+      </p:sp>
+      <p:sp>
+        <p:nvSpPr>
+          <p:cNvPr id="3" name="Text 1"/>
+          <p:cNvSpPr/>
+          <p:nvPr/>
+        </p:nvSpPr>
+        <p:spPr>
+          <a:xfrm>
+            <a:off x="685800" y="841248"/>
+            <a:ext cx="10820095" cy="868680"/>
+          </a:xfrm>
+          <a:prstGeom prst="rect">
+            <a:avLst/>
+          </a:prstGeom>
+          <a:noFill/>
+          <a:ln/>
+        </p:spPr>
+        <p:txBody>
+          <a:bodyPr wrap="square" lIns="0" tIns="0" rIns="0" bIns="0" rtlCol="0" anchor="ctr"/>
+          <a:lstStyle/>
+          <a:p>
+            <a:pPr indent="0" marL="0">
+              <a:lnSpc>
+                <a:spcPts val="2700"/>
+              </a:lnSpc>
+              <a:buNone/>
+            </a:pPr>
+            <a:r>
+              <a:rPr lang="en-US" sz="2500" b="1" dirty="0">
+                <a:solidFill>
+                  <a:srgbClr val="23262F"/>
+                </a:solidFill>
+                <a:latin typeface="Georgia" pitchFamily="34" charset="0"/>
+                <a:ea typeface="Georgia" pitchFamily="34" charset="-122"/>
+                <a:cs typeface="Georgia" pitchFamily="34" charset="-120"/>
+              </a:rPr>
+              <a:t>Does it hold across models?  ▸ click a button</a:t>
+            </a:r>
+            <a:endParaRPr lang="en-US" sz="2500" dirty="0"/>
+          </a:p>
+        </p:txBody>
+      </p:sp>
+      <p:pic>
+        <p:nvPicPr>
+          <p:cNvPr id="4" name="Image 0" descr="/Users/xiaochuan/Desktop/Projects/P5_Multi_linguistic_histoBias/v3/experiments/exp3a_mixed_effects/figures/figC_attribute_OR_qwen7b.png">    </p:cNvPr>
+          <p:cNvPicPr>
+            <a:picLocks noChangeAspect="1"/>
+          </p:cNvPicPr>
+          <p:nvPr/>
+        </p:nvPicPr>
+        <p:blipFill>
+          <a:blip r:embed="rId1"/>
+          <a:stretch>
+            <a:fillRect/>
+          </a:stretch>
+        </p:blipFill>
+        <p:spPr>
+          <a:xfrm>
+            <a:off x="1709928" y="1737360"/>
+            <a:ext cx="8778240" cy="3351753"/>
+          </a:xfrm>
+          <a:prstGeom prst="rect">
+            <a:avLst/>
+          </a:prstGeom>
+        </p:spPr>
+      </p:pic>
+      <p:sp>
+        <p:nvSpPr>
+          <p:cNvPr id="5" name="Shape 2"/>
+          <p:cNvSpPr/>
+          <p:nvPr/>
+        </p:nvSpPr>
+        <p:spPr>
+          <a:xfrm>
+            <a:off x="1325880" y="5943600"/>
+            <a:ext cx="3108960" cy="603504"/>
+          </a:xfrm>
+          <a:prstGeom prst="roundRect">
+            <a:avLst>
+              <a:gd name="adj" fmla="val 12121"/>
+            </a:avLst>
+          </a:prstGeom>
+          <a:solidFill>
+            <a:srgbClr val="1B1F3B"/>
+          </a:solidFill>
+          <a:ln w="12700">
+            <a:solidFill>
+              <a:srgbClr val="1B1F3B"/>
+            </a:solidFill>
+            <a:prstDash val="solid"/>
+          </a:ln>
+        </p:spPr>
+      </p:sp>
+      <p:sp>
+        <p:nvSpPr>
+          <p:cNvPr id="6" name="Text 3"/>
+          <p:cNvSpPr/>
+          <p:nvPr/>
+        </p:nvSpPr>
+        <p:spPr>
+          <a:xfrm>
+            <a:off x="1325880" y="5943600"/>
+            <a:ext cx="3108960" cy="603504"/>
+          </a:xfrm>
+          <a:prstGeom prst="rect">
+            <a:avLst/>
+          </a:prstGeom>
+          <a:noFill/>
+          <a:ln/>
+        </p:spPr>
+        <p:txBody>
+          <a:bodyPr wrap="square" lIns="0" tIns="0" rIns="0" bIns="0" rtlCol="0" anchor="ctr"/>
+          <a:lstStyle/>
+          <a:p>
+            <a:pPr algn="ctr" indent="0" marL="0">
+              <a:buNone/>
+            </a:pPr>
+            <a:r>
+              <a:rPr lang="en-US" sz="1400" b="1" dirty="0">
+                <a:solidFill>
+                  <a:srgbClr val="FFFFFF"/>
+                </a:solidFill>
+                <a:latin typeface="Calibri" pitchFamily="34" charset="0"/>
+                <a:ea typeface="Calibri" pitchFamily="34" charset="-122"/>
+                <a:cs typeface="Calibri" pitchFamily="34" charset="-120"/>
+              </a:rPr>
+              <a:t>Qwen-7B</a:t>
+            </a:r>
+            <a:endParaRPr lang="en-US" sz="1400" dirty="0"/>
+          </a:p>
+        </p:txBody>
+      </p:sp>
+      <p:sp>
+        <p:nvSpPr>
+          <p:cNvPr id="7" name="Shape 4"/>
+          <p:cNvSpPr/>
+          <p:nvPr/>
+        </p:nvSpPr>
+        <p:spPr>
+          <a:xfrm>
+            <a:off x="4544568" y="5943600"/>
+            <a:ext cx="3108960" cy="603504"/>
+          </a:xfrm>
+          <a:prstGeom prst="roundRect">
+            <a:avLst>
+              <a:gd name="adj" fmla="val 12121"/>
+            </a:avLst>
+          </a:prstGeom>
+          <a:solidFill>
+            <a:srgbClr val="F5F6FA"/>
+          </a:solidFill>
+          <a:ln w="12700">
+            <a:solidFill>
+              <a:srgbClr val="E4E6EF"/>
+            </a:solidFill>
+            <a:prstDash val="solid"/>
+          </a:ln>
+        </p:spPr>
+      </p:sp>
+      <p:sp>
+        <p:nvSpPr>
+          <p:cNvPr id="8" name="Text 5">
+            <a:hlinkClick r:id="rId2" tooltip="" action="ppaction://hlinksldjump"/>
+          </p:cNvPr>
+          <p:cNvSpPr/>
+          <p:nvPr/>
+        </p:nvSpPr>
+        <p:spPr>
+          <a:xfrm>
+            <a:off x="4544568" y="5943600"/>
+            <a:ext cx="3108960" cy="603504"/>
+          </a:xfrm>
+          <a:prstGeom prst="rect">
+            <a:avLst/>
+          </a:prstGeom>
+          <a:noFill/>
+          <a:ln/>
+        </p:spPr>
+        <p:txBody>
+          <a:bodyPr wrap="square" lIns="0" tIns="0" rIns="0" bIns="0" rtlCol="0" anchor="ctr"/>
+          <a:lstStyle/>
+          <a:p>
+            <a:pPr algn="ctr" indent="0" marL="0">
+              <a:buNone/>
+            </a:pPr>
+            <a:r>
+              <a:rPr lang="en-US" sz="1400" b="1" u="sng" dirty="0">
+                <a:solidFill>
+                  <a:srgbClr val="1B1F3B"/>
+                </a:solidFill>
+                <a:latin typeface="Calibri" pitchFamily="34" charset="0"/>
+                <a:ea typeface="Calibri" pitchFamily="34" charset="-122"/>
+                <a:cs typeface="Calibri" pitchFamily="34" charset="-120"/>
+                <a:hlinkClick r:id="rId2" action="ppaction://hlinksldjump" tooltip="">
+                  <a:extLst>
+                    <a:ext uri="{A12FA001-AC4F-418D-AE19-62706E023703}">
+                      <ahyp:hlinkClr xmlns:ahyp="http://schemas.microsoft.com/office/drawing/2018/hyperlinkcolor" val="tx"/>
+                    </a:ext>
+                  </a:extLst>
+                </a:hlinkClick>
+              </a:rPr>
+              <a:t>InternVL3-8B</a:t>
+            </a:r>
+            <a:endParaRPr lang="en-US" sz="1400" dirty="0"/>
+          </a:p>
+        </p:txBody>
+      </p:sp>
+      <p:sp>
+        <p:nvSpPr>
+          <p:cNvPr id="9" name="Shape 6"/>
+          <p:cNvSpPr/>
+          <p:nvPr/>
+        </p:nvSpPr>
+        <p:spPr>
+          <a:xfrm>
+            <a:off x="7763256" y="5943600"/>
+            <a:ext cx="3108960" cy="603504"/>
+          </a:xfrm>
+          <a:prstGeom prst="roundRect">
+            <a:avLst>
+              <a:gd name="adj" fmla="val 12121"/>
+            </a:avLst>
+          </a:prstGeom>
+          <a:solidFill>
+            <a:srgbClr val="F5F6FA"/>
+          </a:solidFill>
+          <a:ln w="12700">
+            <a:solidFill>
+              <a:srgbClr val="E4E6EF"/>
+            </a:solidFill>
+            <a:prstDash val="solid"/>
+          </a:ln>
+        </p:spPr>
+      </p:sp>
+      <p:sp>
+        <p:nvSpPr>
+          <p:cNvPr id="10" name="Text 7">
+            <a:hlinkClick r:id="rId3" tooltip="" action="ppaction://hlinksldjump"/>
+          </p:cNvPr>
+          <p:cNvSpPr/>
+          <p:nvPr/>
+        </p:nvSpPr>
+        <p:spPr>
+          <a:xfrm>
+            <a:off x="7763256" y="5943600"/>
+            <a:ext cx="3108960" cy="603504"/>
+          </a:xfrm>
+          <a:prstGeom prst="rect">
+            <a:avLst/>
+          </a:prstGeom>
+          <a:noFill/>
+          <a:ln/>
+        </p:spPr>
+        <p:txBody>
+          <a:bodyPr wrap="square" lIns="0" tIns="0" rIns="0" bIns="0" rtlCol="0" anchor="ctr"/>
+          <a:lstStyle/>
+          <a:p>
+            <a:pPr algn="ctr" indent="0" marL="0">
+              <a:buNone/>
+            </a:pPr>
+            <a:r>
+              <a:rPr lang="en-US" sz="1400" b="1" u="sng" dirty="0">
+                <a:solidFill>
+                  <a:srgbClr val="1B1F3B"/>
+                </a:solidFill>
+                <a:latin typeface="Calibri" pitchFamily="34" charset="0"/>
+                <a:ea typeface="Calibri" pitchFamily="34" charset="-122"/>
+                <a:cs typeface="Calibri" pitchFamily="34" charset="-120"/>
+                <a:hlinkClick r:id="rId3" action="ppaction://hlinksldjump" tooltip="">
+                  <a:extLst>
+                    <a:ext uri="{A12FA001-AC4F-418D-AE19-62706E023703}">
+                      <ahyp:hlinkClr xmlns:ahyp="http://schemas.microsoft.com/office/drawing/2018/hyperlinkcolor" val="tx"/>
+                    </a:ext>
+                  </a:extLst>
+                </a:hlinkClick>
+              </a:rPr>
+              <a:t>Both overlaid</a:t>
+            </a:r>
+            <a:endParaRPr lang="en-US" sz="1400" dirty="0"/>
+          </a:p>
+        </p:txBody>
+      </p:sp>
+      <p:sp>
+        <p:nvSpPr>
+          <p:cNvPr id="11" name="Text 8"/>
+          <p:cNvSpPr/>
+          <p:nvPr/>
+        </p:nvSpPr>
+        <p:spPr>
+          <a:xfrm>
+            <a:off x="11551615" y="6400800"/>
+            <a:ext cx="365760" cy="274320"/>
+          </a:xfrm>
+          <a:prstGeom prst="rect">
+            <a:avLst/>
+          </a:prstGeom>
+          <a:noFill/>
+          <a:ln/>
+        </p:spPr>
+        <p:txBody>
+          <a:bodyPr wrap="square" lIns="0" tIns="0" rIns="0" bIns="0" rtlCol="0" anchor="ctr"/>
+          <a:lstStyle/>
+          <a:p>
+            <a:pPr algn="r" indent="0" marL="0">
+              <a:buNone/>
+            </a:pPr>
+            <a:r>
+              <a:rPr lang="en-US" sz="1000" dirty="0">
+                <a:solidFill>
+                  <a:srgbClr val="9AA0B0"/>
+                </a:solidFill>
+                <a:latin typeface="Calibri" pitchFamily="34" charset="0"/>
+                <a:ea typeface="Calibri" pitchFamily="34" charset="-122"/>
+                <a:cs typeface="Calibri" pitchFamily="34" charset="-120"/>
+              </a:rPr>
+              <a:t>20</a:t>
+            </a:r>
+            <a:endParaRPr lang="en-US" sz="1000" dirty="0"/>
+          </a:p>
+        </p:txBody>
+      </p:sp>
+    </p:spTree>
+  </p:cSld>
+  <p:clrMapOvr>
+    <a:masterClrMapping/>
+  </p:clrMapOvr>
+</p:sld>
+</file>
+
+<file path=ppt/slides/slide21.xml><?xml version="1.0" encoding="utf-8"?>
+<p:sld xmlns:a="http://schemas.openxmlformats.org/drawingml/2006/main" xmlns:r="http://schemas.openxmlformats.org/officeDocument/2006/relationships" xmlns:p="http://schemas.openxmlformats.org/presentationml/2006/main">
+  <p:cSld name="Slide 21">
+    <p:bg>
+      <p:bgPr>
+        <a:solidFill>
+          <a:srgbClr val="FFFFFF"/>
+        </a:solidFill>
+      </p:bgPr>
+    </p:bg>
+    <p:spTree>
+      <p:nvGrpSpPr>
+        <p:cNvPr id="1" name=""/>
+        <p:cNvGrpSpPr/>
+        <p:nvPr/>
+      </p:nvGrpSpPr>
+      <p:grpSpPr>
+        <a:xfrm>
+          <a:off x="0" y="0"/>
+          <a:ext cx="0" cy="0"/>
+          <a:chOff x="0" y="0"/>
+          <a:chExt cx="0" cy="0"/>
+        </a:xfrm>
+      </p:grpSpPr>
+      <p:sp>
+        <p:nvSpPr>
+          <p:cNvPr id="2" name="Text 0"/>
+          <p:cNvSpPr/>
+          <p:nvPr/>
+        </p:nvSpPr>
+        <p:spPr>
+          <a:xfrm>
+            <a:off x="685800" y="502920"/>
+            <a:ext cx="10820095" cy="274320"/>
+          </a:xfrm>
+          <a:prstGeom prst="rect">
+            <a:avLst/>
+          </a:prstGeom>
+          <a:noFill/>
+          <a:ln/>
+        </p:spPr>
+        <p:txBody>
+          <a:bodyPr wrap="square" lIns="0" tIns="0" rIns="0" bIns="0" rtlCol="0" anchor="ctr"/>
+          <a:lstStyle/>
+          <a:p>
+            <a:pPr indent="0" marL="0">
+              <a:buNone/>
+            </a:pPr>
+            <a:r>
+              <a:rPr lang="en-US" sz="1200" b="1" spc="300" kern="0" dirty="0">
+                <a:solidFill>
+                  <a:srgbClr val="C44E52"/>
+                </a:solidFill>
+                <a:latin typeface="Calibri" pitchFamily="34" charset="0"/>
+                <a:ea typeface="Calibri" pitchFamily="34" charset="-122"/>
+                <a:cs typeface="Calibri" pitchFamily="34" charset="-120"/>
+              </a:rPr>
+              <a:t>INTERACTIVE · MODEL EXPLORER</a:t>
+            </a:r>
+            <a:endParaRPr lang="en-US" sz="1200" dirty="0"/>
+          </a:p>
+        </p:txBody>
+      </p:sp>
+      <p:sp>
+        <p:nvSpPr>
+          <p:cNvPr id="3" name="Text 1"/>
+          <p:cNvSpPr/>
+          <p:nvPr/>
+        </p:nvSpPr>
+        <p:spPr>
+          <a:xfrm>
+            <a:off x="685800" y="841248"/>
+            <a:ext cx="10820095" cy="868680"/>
+          </a:xfrm>
+          <a:prstGeom prst="rect">
+            <a:avLst/>
+          </a:prstGeom>
+          <a:noFill/>
+          <a:ln/>
+        </p:spPr>
+        <p:txBody>
+          <a:bodyPr wrap="square" lIns="0" tIns="0" rIns="0" bIns="0" rtlCol="0" anchor="ctr"/>
+          <a:lstStyle/>
+          <a:p>
+            <a:pPr indent="0" marL="0">
+              <a:lnSpc>
+                <a:spcPts val="2700"/>
+              </a:lnSpc>
+              <a:buNone/>
+            </a:pPr>
+            <a:r>
+              <a:rPr lang="en-US" sz="2500" b="1" dirty="0">
+                <a:solidFill>
+                  <a:srgbClr val="23262F"/>
+                </a:solidFill>
+                <a:latin typeface="Georgia" pitchFamily="34" charset="0"/>
+                <a:ea typeface="Georgia" pitchFamily="34" charset="-122"/>
+                <a:cs typeface="Georgia" pitchFamily="34" charset="-120"/>
+              </a:rPr>
+              <a:t>Does it hold across models?  ▸ click a button</a:t>
+            </a:r>
+            <a:endParaRPr lang="en-US" sz="2500" dirty="0"/>
+          </a:p>
+        </p:txBody>
+      </p:sp>
+      <p:pic>
+        <p:nvPicPr>
+          <p:cNvPr id="4" name="Image 0" descr="/Users/xiaochuan/Desktop/Projects/P5_Multi_linguistic_histoBias/v3/experiments/exp3a_mixed_effects/figures/figC_attribute_OR_internvl8b.png">    </p:cNvPr>
+          <p:cNvPicPr>
+            <a:picLocks noChangeAspect="1"/>
+          </p:cNvPicPr>
+          <p:nvPr/>
+        </p:nvPicPr>
+        <p:blipFill>
+          <a:blip r:embed="rId1"/>
+          <a:stretch>
+            <a:fillRect/>
+          </a:stretch>
+        </p:blipFill>
+        <p:spPr>
+          <a:xfrm>
+            <a:off x="1709928" y="1737360"/>
+            <a:ext cx="8778240" cy="3351753"/>
+          </a:xfrm>
+          <a:prstGeom prst="rect">
+            <a:avLst/>
+          </a:prstGeom>
+        </p:spPr>
+      </p:pic>
+      <p:sp>
+        <p:nvSpPr>
+          <p:cNvPr id="5" name="Shape 2"/>
+          <p:cNvSpPr/>
+          <p:nvPr/>
+        </p:nvSpPr>
+        <p:spPr>
+          <a:xfrm>
+            <a:off x="1325880" y="5943600"/>
+            <a:ext cx="3108960" cy="603504"/>
+          </a:xfrm>
+          <a:prstGeom prst="roundRect">
+            <a:avLst>
+              <a:gd name="adj" fmla="val 12121"/>
+            </a:avLst>
+          </a:prstGeom>
+          <a:solidFill>
+            <a:srgbClr val="F5F6FA"/>
+          </a:solidFill>
+          <a:ln w="12700">
+            <a:solidFill>
+              <a:srgbClr val="E4E6EF"/>
+            </a:solidFill>
+            <a:prstDash val="solid"/>
+          </a:ln>
+        </p:spPr>
+      </p:sp>
+      <p:sp>
+        <p:nvSpPr>
+          <p:cNvPr id="6" name="Text 3">
+            <a:hlinkClick r:id="rId2" tooltip="" action="ppaction://hlinksldjump"/>
+          </p:cNvPr>
+          <p:cNvSpPr/>
+          <p:nvPr/>
+        </p:nvSpPr>
+        <p:spPr>
+          <a:xfrm>
+            <a:off x="1325880" y="5943600"/>
+            <a:ext cx="3108960" cy="603504"/>
+          </a:xfrm>
+          <a:prstGeom prst="rect">
+            <a:avLst/>
+          </a:prstGeom>
+          <a:noFill/>
+          <a:ln/>
+        </p:spPr>
+        <p:txBody>
+          <a:bodyPr wrap="square" lIns="0" tIns="0" rIns="0" bIns="0" rtlCol="0" anchor="ctr"/>
+          <a:lstStyle/>
+          <a:p>
+            <a:pPr algn="ctr" indent="0" marL="0">
+              <a:buNone/>
+            </a:pPr>
+            <a:r>
+              <a:rPr lang="en-US" sz="1400" b="1" u="sng" dirty="0">
+                <a:solidFill>
+                  <a:srgbClr val="1B1F3B"/>
+                </a:solidFill>
+                <a:latin typeface="Calibri" pitchFamily="34" charset="0"/>
+                <a:ea typeface="Calibri" pitchFamily="34" charset="-122"/>
+                <a:cs typeface="Calibri" pitchFamily="34" charset="-120"/>
+                <a:hlinkClick r:id="rId2" action="ppaction://hlinksldjump" tooltip="">
+                  <a:extLst>
+                    <a:ext uri="{A12FA001-AC4F-418D-AE19-62706E023703}">
+                      <ahyp:hlinkClr xmlns:ahyp="http://schemas.microsoft.com/office/drawing/2018/hyperlinkcolor" val="tx"/>
+                    </a:ext>
+                  </a:extLst>
+                </a:hlinkClick>
+              </a:rPr>
+              <a:t>Qwen-7B</a:t>
+            </a:r>
+            <a:endParaRPr lang="en-US" sz="1400" dirty="0"/>
+          </a:p>
+        </p:txBody>
+      </p:sp>
+      <p:sp>
+        <p:nvSpPr>
+          <p:cNvPr id="7" name="Shape 4"/>
+          <p:cNvSpPr/>
+          <p:nvPr/>
+        </p:nvSpPr>
+        <p:spPr>
+          <a:xfrm>
+            <a:off x="4544568" y="5943600"/>
+            <a:ext cx="3108960" cy="603504"/>
+          </a:xfrm>
+          <a:prstGeom prst="roundRect">
+            <a:avLst>
+              <a:gd name="adj" fmla="val 12121"/>
+            </a:avLst>
+          </a:prstGeom>
+          <a:solidFill>
+            <a:srgbClr val="1B1F3B"/>
+          </a:solidFill>
+          <a:ln w="12700">
+            <a:solidFill>
+              <a:srgbClr val="1B1F3B"/>
+            </a:solidFill>
+            <a:prstDash val="solid"/>
+          </a:ln>
+        </p:spPr>
+      </p:sp>
+      <p:sp>
+        <p:nvSpPr>
+          <p:cNvPr id="8" name="Text 5"/>
+          <p:cNvSpPr/>
+          <p:nvPr/>
+        </p:nvSpPr>
+        <p:spPr>
+          <a:xfrm>
+            <a:off x="4544568" y="5943600"/>
+            <a:ext cx="3108960" cy="603504"/>
+          </a:xfrm>
+          <a:prstGeom prst="rect">
+            <a:avLst/>
+          </a:prstGeom>
+          <a:noFill/>
+          <a:ln/>
+        </p:spPr>
+        <p:txBody>
+          <a:bodyPr wrap="square" lIns="0" tIns="0" rIns="0" bIns="0" rtlCol="0" anchor="ctr"/>
+          <a:lstStyle/>
+          <a:p>
+            <a:pPr algn="ctr" indent="0" marL="0">
+              <a:buNone/>
+            </a:pPr>
+            <a:r>
+              <a:rPr lang="en-US" sz="1400" b="1" dirty="0">
+                <a:solidFill>
+                  <a:srgbClr val="FFFFFF"/>
+                </a:solidFill>
+                <a:latin typeface="Calibri" pitchFamily="34" charset="0"/>
+                <a:ea typeface="Calibri" pitchFamily="34" charset="-122"/>
+                <a:cs typeface="Calibri" pitchFamily="34" charset="-120"/>
+              </a:rPr>
+              <a:t>InternVL3-8B</a:t>
+            </a:r>
+            <a:endParaRPr lang="en-US" sz="1400" dirty="0"/>
+          </a:p>
+        </p:txBody>
+      </p:sp>
+      <p:sp>
+        <p:nvSpPr>
+          <p:cNvPr id="9" name="Shape 6"/>
+          <p:cNvSpPr/>
+          <p:nvPr/>
+        </p:nvSpPr>
+        <p:spPr>
+          <a:xfrm>
+            <a:off x="7763256" y="5943600"/>
+            <a:ext cx="3108960" cy="603504"/>
+          </a:xfrm>
+          <a:prstGeom prst="roundRect">
+            <a:avLst>
+              <a:gd name="adj" fmla="val 12121"/>
+            </a:avLst>
+          </a:prstGeom>
+          <a:solidFill>
+            <a:srgbClr val="F5F6FA"/>
+          </a:solidFill>
+          <a:ln w="12700">
+            <a:solidFill>
+              <a:srgbClr val="E4E6EF"/>
+            </a:solidFill>
+            <a:prstDash val="solid"/>
+          </a:ln>
+        </p:spPr>
+      </p:sp>
+      <p:sp>
+        <p:nvSpPr>
+          <p:cNvPr id="10" name="Text 7">
+            <a:hlinkClick r:id="rId3" tooltip="" action="ppaction://hlinksldjump"/>
+          </p:cNvPr>
+          <p:cNvSpPr/>
+          <p:nvPr/>
+        </p:nvSpPr>
+        <p:spPr>
+          <a:xfrm>
+            <a:off x="7763256" y="5943600"/>
+            <a:ext cx="3108960" cy="603504"/>
+          </a:xfrm>
+          <a:prstGeom prst="rect">
+            <a:avLst/>
+          </a:prstGeom>
+          <a:noFill/>
+          <a:ln/>
+        </p:spPr>
+        <p:txBody>
+          <a:bodyPr wrap="square" lIns="0" tIns="0" rIns="0" bIns="0" rtlCol="0" anchor="ctr"/>
+          <a:lstStyle/>
+          <a:p>
+            <a:pPr algn="ctr" indent="0" marL="0">
+              <a:buNone/>
+            </a:pPr>
+            <a:r>
+              <a:rPr lang="en-US" sz="1400" b="1" u="sng" dirty="0">
+                <a:solidFill>
+                  <a:srgbClr val="1B1F3B"/>
+                </a:solidFill>
+                <a:latin typeface="Calibri" pitchFamily="34" charset="0"/>
+                <a:ea typeface="Calibri" pitchFamily="34" charset="-122"/>
+                <a:cs typeface="Calibri" pitchFamily="34" charset="-120"/>
+                <a:hlinkClick r:id="rId3" action="ppaction://hlinksldjump" tooltip="">
+                  <a:extLst>
+                    <a:ext uri="{A12FA001-AC4F-418D-AE19-62706E023703}">
+                      <ahyp:hlinkClr xmlns:ahyp="http://schemas.microsoft.com/office/drawing/2018/hyperlinkcolor" val="tx"/>
+                    </a:ext>
+                  </a:extLst>
+                </a:hlinkClick>
+              </a:rPr>
+              <a:t>Both overlaid</a:t>
+            </a:r>
+            <a:endParaRPr lang="en-US" sz="1400" dirty="0"/>
+          </a:p>
+        </p:txBody>
+      </p:sp>
+      <p:sp>
+        <p:nvSpPr>
+          <p:cNvPr id="11" name="Text 8"/>
+          <p:cNvSpPr/>
+          <p:nvPr/>
+        </p:nvSpPr>
+        <p:spPr>
+          <a:xfrm>
+            <a:off x="11551615" y="6400800"/>
+            <a:ext cx="365760" cy="274320"/>
+          </a:xfrm>
+          <a:prstGeom prst="rect">
+            <a:avLst/>
+          </a:prstGeom>
+          <a:noFill/>
+          <a:ln/>
+        </p:spPr>
+        <p:txBody>
+          <a:bodyPr wrap="square" lIns="0" tIns="0" rIns="0" bIns="0" rtlCol="0" anchor="ctr"/>
+          <a:lstStyle/>
+          <a:p>
+            <a:pPr algn="r" indent="0" marL="0">
+              <a:buNone/>
+            </a:pPr>
+            <a:r>
+              <a:rPr lang="en-US" sz="1000" dirty="0">
+                <a:solidFill>
+                  <a:srgbClr val="9AA0B0"/>
+                </a:solidFill>
+                <a:latin typeface="Calibri" pitchFamily="34" charset="0"/>
+                <a:ea typeface="Calibri" pitchFamily="34" charset="-122"/>
+                <a:cs typeface="Calibri" pitchFamily="34" charset="-120"/>
+              </a:rPr>
+              <a:t>21</a:t>
+            </a:r>
+            <a:endParaRPr lang="en-US" sz="1000" dirty="0"/>
+          </a:p>
+        </p:txBody>
+      </p:sp>
+    </p:spTree>
+  </p:cSld>
+  <p:clrMapOvr>
+    <a:masterClrMapping/>
+  </p:clrMapOvr>
+</p:sld>
+</file>
+
+<file path=ppt/slides/slide22.xml><?xml version="1.0" encoding="utf-8"?>
+<p:sld xmlns:a="http://schemas.openxmlformats.org/drawingml/2006/main" xmlns:r="http://schemas.openxmlformats.org/officeDocument/2006/relationships" xmlns:p="http://schemas.openxmlformats.org/presentationml/2006/main">
+  <p:cSld name="Slide 22">
+    <p:bg>
+      <p:bgPr>
+        <a:solidFill>
+          <a:srgbClr val="FFFFFF"/>
+        </a:solidFill>
+      </p:bgPr>
+    </p:bg>
+    <p:spTree>
+      <p:nvGrpSpPr>
+        <p:cNvPr id="1" name=""/>
+        <p:cNvGrpSpPr/>
+        <p:nvPr/>
+      </p:nvGrpSpPr>
+      <p:grpSpPr>
+        <a:xfrm>
+          <a:off x="0" y="0"/>
+          <a:ext cx="0" cy="0"/>
+          <a:chOff x="0" y="0"/>
+          <a:chExt cx="0" cy="0"/>
+        </a:xfrm>
+      </p:grpSpPr>
+      <p:sp>
+        <p:nvSpPr>
+          <p:cNvPr id="2" name="Text 0"/>
+          <p:cNvSpPr/>
+          <p:nvPr/>
+        </p:nvSpPr>
+        <p:spPr>
+          <a:xfrm>
+            <a:off x="685800" y="502920"/>
+            <a:ext cx="10820095" cy="274320"/>
+          </a:xfrm>
+          <a:prstGeom prst="rect">
+            <a:avLst/>
+          </a:prstGeom>
+          <a:noFill/>
+          <a:ln/>
+        </p:spPr>
+        <p:txBody>
+          <a:bodyPr wrap="square" lIns="0" tIns="0" rIns="0" bIns="0" rtlCol="0" anchor="ctr"/>
+          <a:lstStyle/>
+          <a:p>
+            <a:pPr indent="0" marL="0">
+              <a:buNone/>
+            </a:pPr>
+            <a:r>
+              <a:rPr lang="en-US" sz="1200" b="1" spc="300" kern="0" dirty="0">
+                <a:solidFill>
+                  <a:srgbClr val="C44E52"/>
+                </a:solidFill>
+                <a:latin typeface="Calibri" pitchFamily="34" charset="0"/>
+                <a:ea typeface="Calibri" pitchFamily="34" charset="-122"/>
+                <a:cs typeface="Calibri" pitchFamily="34" charset="-120"/>
+              </a:rPr>
+              <a:t>INTERACTIVE · MODEL EXPLORER</a:t>
+            </a:r>
+            <a:endParaRPr lang="en-US" sz="1200" dirty="0"/>
+          </a:p>
+        </p:txBody>
+      </p:sp>
+      <p:sp>
+        <p:nvSpPr>
+          <p:cNvPr id="3" name="Text 1"/>
+          <p:cNvSpPr/>
+          <p:nvPr/>
+        </p:nvSpPr>
+        <p:spPr>
+          <a:xfrm>
+            <a:off x="685800" y="841248"/>
+            <a:ext cx="10820095" cy="868680"/>
+          </a:xfrm>
+          <a:prstGeom prst="rect">
+            <a:avLst/>
+          </a:prstGeom>
+          <a:noFill/>
+          <a:ln/>
+        </p:spPr>
+        <p:txBody>
+          <a:bodyPr wrap="square" lIns="0" tIns="0" rIns="0" bIns="0" rtlCol="0" anchor="ctr"/>
+          <a:lstStyle/>
+          <a:p>
+            <a:pPr indent="0" marL="0">
+              <a:lnSpc>
+                <a:spcPts val="2700"/>
+              </a:lnSpc>
+              <a:buNone/>
+            </a:pPr>
+            <a:r>
+              <a:rPr lang="en-US" sz="2500" b="1" dirty="0">
+                <a:solidFill>
+                  <a:srgbClr val="23262F"/>
+                </a:solidFill>
+                <a:latin typeface="Georgia" pitchFamily="34" charset="0"/>
+                <a:ea typeface="Georgia" pitchFamily="34" charset="-122"/>
+                <a:cs typeface="Georgia" pitchFamily="34" charset="-120"/>
+              </a:rPr>
+              <a:t>Does it hold across models?  ▸ click a button</a:t>
+            </a:r>
+            <a:endParaRPr lang="en-US" sz="2500" dirty="0"/>
+          </a:p>
+        </p:txBody>
+      </p:sp>
+      <p:pic>
+        <p:nvPicPr>
+          <p:cNvPr id="4" name="Image 0" descr="/Users/xiaochuan/Desktop/Projects/P5_Multi_linguistic_histoBias/v3/experiments/exp3a_mixed_effects/figures/figE_cross_model_OR.png">    </p:cNvPr>
+          <p:cNvPicPr>
+            <a:picLocks noChangeAspect="1"/>
+          </p:cNvPicPr>
+          <p:nvPr/>
+        </p:nvPicPr>
+        <p:blipFill>
+          <a:blip r:embed="rId1"/>
+          <a:stretch>
+            <a:fillRect/>
+          </a:stretch>
+        </p:blipFill>
+        <p:spPr>
+          <a:xfrm>
+            <a:off x="1709928" y="1737360"/>
+            <a:ext cx="8778240" cy="3364599"/>
+          </a:xfrm>
+          <a:prstGeom prst="rect">
+            <a:avLst/>
+          </a:prstGeom>
+        </p:spPr>
+      </p:pic>
+      <p:sp>
+        <p:nvSpPr>
+          <p:cNvPr id="5" name="Shape 2"/>
+          <p:cNvSpPr/>
+          <p:nvPr/>
+        </p:nvSpPr>
+        <p:spPr>
+          <a:xfrm>
+            <a:off x="1325880" y="5943600"/>
+            <a:ext cx="3108960" cy="603504"/>
+          </a:xfrm>
+          <a:prstGeom prst="roundRect">
+            <a:avLst>
+              <a:gd name="adj" fmla="val 12121"/>
+            </a:avLst>
+          </a:prstGeom>
+          <a:solidFill>
+            <a:srgbClr val="F5F6FA"/>
+          </a:solidFill>
+          <a:ln w="12700">
+            <a:solidFill>
+              <a:srgbClr val="E4E6EF"/>
+            </a:solidFill>
+            <a:prstDash val="solid"/>
+          </a:ln>
+        </p:spPr>
+      </p:sp>
+      <p:sp>
+        <p:nvSpPr>
+          <p:cNvPr id="6" name="Text 3">
+            <a:hlinkClick r:id="rId2" tooltip="" action="ppaction://hlinksldjump"/>
+          </p:cNvPr>
+          <p:cNvSpPr/>
+          <p:nvPr/>
+        </p:nvSpPr>
+        <p:spPr>
+          <a:xfrm>
+            <a:off x="1325880" y="5943600"/>
+            <a:ext cx="3108960" cy="603504"/>
+          </a:xfrm>
+          <a:prstGeom prst="rect">
+            <a:avLst/>
+          </a:prstGeom>
+          <a:noFill/>
+          <a:ln/>
+        </p:spPr>
+        <p:txBody>
+          <a:bodyPr wrap="square" lIns="0" tIns="0" rIns="0" bIns="0" rtlCol="0" anchor="ctr"/>
+          <a:lstStyle/>
+          <a:p>
+            <a:pPr algn="ctr" indent="0" marL="0">
+              <a:buNone/>
+            </a:pPr>
+            <a:r>
+              <a:rPr lang="en-US" sz="1400" b="1" u="sng" dirty="0">
+                <a:solidFill>
+                  <a:srgbClr val="1B1F3B"/>
+                </a:solidFill>
+                <a:latin typeface="Calibri" pitchFamily="34" charset="0"/>
+                <a:ea typeface="Calibri" pitchFamily="34" charset="-122"/>
+                <a:cs typeface="Calibri" pitchFamily="34" charset="-120"/>
+                <a:hlinkClick r:id="rId2" action="ppaction://hlinksldjump" tooltip="">
+                  <a:extLst>
+                    <a:ext uri="{A12FA001-AC4F-418D-AE19-62706E023703}">
+                      <ahyp:hlinkClr xmlns:ahyp="http://schemas.microsoft.com/office/drawing/2018/hyperlinkcolor" val="tx"/>
+                    </a:ext>
+                  </a:extLst>
+                </a:hlinkClick>
+              </a:rPr>
+              <a:t>Qwen-7B</a:t>
+            </a:r>
+            <a:endParaRPr lang="en-US" sz="1400" dirty="0"/>
+          </a:p>
+        </p:txBody>
+      </p:sp>
+      <p:sp>
+        <p:nvSpPr>
+          <p:cNvPr id="7" name="Shape 4"/>
+          <p:cNvSpPr/>
+          <p:nvPr/>
+        </p:nvSpPr>
+        <p:spPr>
+          <a:xfrm>
+            <a:off x="4544568" y="5943600"/>
+            <a:ext cx="3108960" cy="603504"/>
+          </a:xfrm>
+          <a:prstGeom prst="roundRect">
+            <a:avLst>
+              <a:gd name="adj" fmla="val 12121"/>
+            </a:avLst>
+          </a:prstGeom>
+          <a:solidFill>
+            <a:srgbClr val="F5F6FA"/>
+          </a:solidFill>
+          <a:ln w="12700">
+            <a:solidFill>
+              <a:srgbClr val="E4E6EF"/>
+            </a:solidFill>
+            <a:prstDash val="solid"/>
+          </a:ln>
+        </p:spPr>
+      </p:sp>
+      <p:sp>
+        <p:nvSpPr>
+          <p:cNvPr id="8" name="Text 5">
+            <a:hlinkClick r:id="rId3" tooltip="" action="ppaction://hlinksldjump"/>
+          </p:cNvPr>
+          <p:cNvSpPr/>
+          <p:nvPr/>
+        </p:nvSpPr>
+        <p:spPr>
+          <a:xfrm>
+            <a:off x="4544568" y="5943600"/>
+            <a:ext cx="3108960" cy="603504"/>
+          </a:xfrm>
+          <a:prstGeom prst="rect">
+            <a:avLst/>
+          </a:prstGeom>
+          <a:noFill/>
+          <a:ln/>
+        </p:spPr>
+        <p:txBody>
+          <a:bodyPr wrap="square" lIns="0" tIns="0" rIns="0" bIns="0" rtlCol="0" anchor="ctr"/>
+          <a:lstStyle/>
+          <a:p>
+            <a:pPr algn="ctr" indent="0" marL="0">
+              <a:buNone/>
+            </a:pPr>
+            <a:r>
+              <a:rPr lang="en-US" sz="1400" b="1" u="sng" dirty="0">
+                <a:solidFill>
+                  <a:srgbClr val="1B1F3B"/>
+                </a:solidFill>
+                <a:latin typeface="Calibri" pitchFamily="34" charset="0"/>
+                <a:ea typeface="Calibri" pitchFamily="34" charset="-122"/>
+                <a:cs typeface="Calibri" pitchFamily="34" charset="-120"/>
+                <a:hlinkClick r:id="rId3" action="ppaction://hlinksldjump" tooltip="">
+                  <a:extLst>
+                    <a:ext uri="{A12FA001-AC4F-418D-AE19-62706E023703}">
+                      <ahyp:hlinkClr xmlns:ahyp="http://schemas.microsoft.com/office/drawing/2018/hyperlinkcolor" val="tx"/>
+                    </a:ext>
+                  </a:extLst>
+                </a:hlinkClick>
+              </a:rPr>
+              <a:t>InternVL3-8B</a:t>
+            </a:r>
+            <a:endParaRPr lang="en-US" sz="1400" dirty="0"/>
+          </a:p>
+        </p:txBody>
+      </p:sp>
+      <p:sp>
+        <p:nvSpPr>
+          <p:cNvPr id="9" name="Shape 6"/>
+          <p:cNvSpPr/>
+          <p:nvPr/>
+        </p:nvSpPr>
+        <p:spPr>
+          <a:xfrm>
+            <a:off x="7763256" y="5943600"/>
+            <a:ext cx="3108960" cy="603504"/>
+          </a:xfrm>
+          <a:prstGeom prst="roundRect">
+            <a:avLst>
+              <a:gd name="adj" fmla="val 12121"/>
+            </a:avLst>
+          </a:prstGeom>
+          <a:solidFill>
+            <a:srgbClr val="1B1F3B"/>
+          </a:solidFill>
+          <a:ln w="12700">
+            <a:solidFill>
+              <a:srgbClr val="1B1F3B"/>
+            </a:solidFill>
+            <a:prstDash val="solid"/>
+          </a:ln>
+        </p:spPr>
+      </p:sp>
+      <p:sp>
+        <p:nvSpPr>
+          <p:cNvPr id="10" name="Text 7"/>
+          <p:cNvSpPr/>
+          <p:nvPr/>
+        </p:nvSpPr>
+        <p:spPr>
+          <a:xfrm>
+            <a:off x="7763256" y="5943600"/>
+            <a:ext cx="3108960" cy="603504"/>
+          </a:xfrm>
+          <a:prstGeom prst="rect">
+            <a:avLst/>
+          </a:prstGeom>
+          <a:noFill/>
+          <a:ln/>
+        </p:spPr>
+        <p:txBody>
+          <a:bodyPr wrap="square" lIns="0" tIns="0" rIns="0" bIns="0" rtlCol="0" anchor="ctr"/>
+          <a:lstStyle/>
+          <a:p>
+            <a:pPr algn="ctr" indent="0" marL="0">
+              <a:buNone/>
+            </a:pPr>
+            <a:r>
+              <a:rPr lang="en-US" sz="1400" b="1" dirty="0">
+                <a:solidFill>
+                  <a:srgbClr val="FFFFFF"/>
+                </a:solidFill>
+                <a:latin typeface="Calibri" pitchFamily="34" charset="0"/>
+                <a:ea typeface="Calibri" pitchFamily="34" charset="-122"/>
+                <a:cs typeface="Calibri" pitchFamily="34" charset="-120"/>
+              </a:rPr>
+              <a:t>Both overlaid</a:t>
+            </a:r>
+            <a:endParaRPr lang="en-US" sz="1400" dirty="0"/>
+          </a:p>
+        </p:txBody>
+      </p:sp>
+      <p:sp>
+        <p:nvSpPr>
+          <p:cNvPr id="11" name="Text 8"/>
+          <p:cNvSpPr/>
+          <p:nvPr/>
+        </p:nvSpPr>
+        <p:spPr>
+          <a:xfrm>
+            <a:off x="11551615" y="6400800"/>
+            <a:ext cx="365760" cy="274320"/>
+          </a:xfrm>
+          <a:prstGeom prst="rect">
+            <a:avLst/>
+          </a:prstGeom>
+          <a:noFill/>
+          <a:ln/>
+        </p:spPr>
+        <p:txBody>
+          <a:bodyPr wrap="square" lIns="0" tIns="0" rIns="0" bIns="0" rtlCol="0" anchor="ctr"/>
+          <a:lstStyle/>
+          <a:p>
+            <a:pPr algn="r" indent="0" marL="0">
+              <a:buNone/>
+            </a:pPr>
+            <a:r>
+              <a:rPr lang="en-US" sz="1000" dirty="0">
+                <a:solidFill>
+                  <a:srgbClr val="9AA0B0"/>
+                </a:solidFill>
+                <a:latin typeface="Calibri" pitchFamily="34" charset="0"/>
+                <a:ea typeface="Calibri" pitchFamily="34" charset="-122"/>
+                <a:cs typeface="Calibri" pitchFamily="34" charset="-120"/>
+              </a:rPr>
+              <a:t>22</a:t>
             </a:r>
             <a:endParaRPr lang="en-US" sz="1000" dirty="0"/>
           </a:p>

</xml_diff>

<commit_message>
Deck: add 3 method-backup appendix slides (why InternVL3, mixed-effects+LRT, back-translation QA)
Co-Authored-By: Claude Opus 4.8 <noreply@anthropic.com>
</commit_message>
<xml_diff>
--- a/v3/paper/ProgressReport_2.pptx
+++ b/v3/paper/ProgressReport_2.pptx
@@ -27,9 +27,12 @@
     <p:sldId id="275" r:id="rId21"/>
     <p:sldId id="276" r:id="rId22"/>
     <p:sldId id="277" r:id="rId23"/>
+    <p:sldId id="278" r:id="rId24"/>
+    <p:sldId id="279" r:id="rId25"/>
+    <p:sldId id="280" r:id="rId26"/>
   </p:sldIdLst>
   <p:notesMasterIdLst>
-    <p:notesMasterId r:id="rId24"/>
+    <p:notesMasterId r:id="rId27"/>
   </p:notesMasterIdLst>
   <p:sldSz cx="12191695" cy="6858000"/>
   <p:notesSz cx="6858000" cy="12191695"/>
@@ -2583,6 +2586,270 @@
             <a:fld id="{F7021451-1387-4CA6-816F-3879F97B5CBC}" type="slidenum">
               <a:rPr lang="en-US"/>
               <a:t>22</a:t>
+            </a:fld>
+            <a:endParaRPr lang="en-US"/>
+          </a:p>
+        </p:txBody>
+      </p:sp>
+    </p:spTree>
+    <p:extLst>
+      <p:ext uri="{BB962C8B-B14F-4D97-AF65-F5344CB8AC3E}">
+        <p14:creationId xmlns:p14="http://schemas.microsoft.com/office/powerpoint/2010/main" val="1024086991"/>
+      </p:ext>
+    </p:extLst>
+  </p:cSld>
+  <p:clrMapOvr>
+    <a:masterClrMapping/>
+  </p:clrMapOvr>
+</p:notes>
+</file>
+
+<file path=ppt/notesSlides/notesSlide23.xml><?xml version="1.0" encoding="utf-8"?>
+<p:notes xmlns:a="http://schemas.openxmlformats.org/drawingml/2006/main" xmlns:r="http://schemas.openxmlformats.org/officeDocument/2006/relationships" xmlns:p="http://schemas.openxmlformats.org/presentationml/2006/main">
+  <p:cSld>
+    <p:spTree>
+      <p:nvGrpSpPr>
+        <p:cNvPr id="1" name=""/>
+        <p:cNvGrpSpPr/>
+        <p:nvPr/>
+      </p:nvGrpSpPr>
+      <p:grpSpPr>
+        <a:xfrm>
+          <a:off x="0" y="0"/>
+          <a:ext cx="0" cy="0"/>
+          <a:chOff x="0" y="0"/>
+          <a:chExt cx="0" cy="0"/>
+        </a:xfrm>
+      </p:grpSpPr>
+      <p:sp>
+        <p:nvSpPr>
+          <p:cNvPr id="2" name="Slide Image Placeholder 1"/>
+          <p:cNvSpPr>
+            <a:spLocks noGrp="1" noRot="1" noChangeAspect="1"/>
+          </p:cNvSpPr>
+          <p:nvPr>
+            <p:ph type="sldImg"/>
+          </p:nvPr>
+        </p:nvSpPr>
+        <p:spPr/>
+      </p:sp>
+      <p:sp>
+        <p:nvSpPr>
+          <p:cNvPr id="3" name="Notes Placeholder 2"/>
+          <p:cNvSpPr>
+            <a:spLocks noGrp="1"/>
+          </p:cNvSpPr>
+          <p:nvPr>
+            <p:ph type="body" idx="1"/>
+          </p:nvPr>
+        </p:nvSpPr>
+        <p:spPr/>
+        <p:txBody>
+          <a:bodyPr/>
+          <a:lstStyle/>
+          <a:p>
+            <a:r>
+              <a:rPr lang="en-US" dirty="0"/>
+              <a:t/>
+            </a:r>
+            <a:endParaRPr lang="en-US" dirty="0"/>
+          </a:p>
+        </p:txBody>
+      </p:sp>
+      <p:sp>
+        <p:nvSpPr>
+          <p:cNvPr id="4" name="Slide Number Placeholder 3"/>
+          <p:cNvSpPr>
+            <a:spLocks noGrp="1"/>
+          </p:cNvSpPr>
+          <p:nvPr>
+            <p:ph type="sldNum" sz="quarter" idx="10"/>
+          </p:nvPr>
+        </p:nvSpPr>
+        <p:spPr/>
+        <p:txBody>
+          <a:bodyPr/>
+          <a:lstStyle/>
+          <a:p>
+            <a:fld id="{F7021451-1387-4CA6-816F-3879F97B5CBC}" type="slidenum">
+              <a:rPr lang="en-US"/>
+              <a:t>23</a:t>
+            </a:fld>
+            <a:endParaRPr lang="en-US"/>
+          </a:p>
+        </p:txBody>
+      </p:sp>
+    </p:spTree>
+    <p:extLst>
+      <p:ext uri="{BB962C8B-B14F-4D97-AF65-F5344CB8AC3E}">
+        <p14:creationId xmlns:p14="http://schemas.microsoft.com/office/powerpoint/2010/main" val="1024086991"/>
+      </p:ext>
+    </p:extLst>
+  </p:cSld>
+  <p:clrMapOvr>
+    <a:masterClrMapping/>
+  </p:clrMapOvr>
+</p:notes>
+</file>
+
+<file path=ppt/notesSlides/notesSlide24.xml><?xml version="1.0" encoding="utf-8"?>
+<p:notes xmlns:a="http://schemas.openxmlformats.org/drawingml/2006/main" xmlns:r="http://schemas.openxmlformats.org/officeDocument/2006/relationships" xmlns:p="http://schemas.openxmlformats.org/presentationml/2006/main">
+  <p:cSld>
+    <p:spTree>
+      <p:nvGrpSpPr>
+        <p:cNvPr id="1" name=""/>
+        <p:cNvGrpSpPr/>
+        <p:nvPr/>
+      </p:nvGrpSpPr>
+      <p:grpSpPr>
+        <a:xfrm>
+          <a:off x="0" y="0"/>
+          <a:ext cx="0" cy="0"/>
+          <a:chOff x="0" y="0"/>
+          <a:chExt cx="0" cy="0"/>
+        </a:xfrm>
+      </p:grpSpPr>
+      <p:sp>
+        <p:nvSpPr>
+          <p:cNvPr id="2" name="Slide Image Placeholder 1"/>
+          <p:cNvSpPr>
+            <a:spLocks noGrp="1" noRot="1" noChangeAspect="1"/>
+          </p:cNvSpPr>
+          <p:nvPr>
+            <p:ph type="sldImg"/>
+          </p:nvPr>
+        </p:nvSpPr>
+        <p:spPr/>
+      </p:sp>
+      <p:sp>
+        <p:nvSpPr>
+          <p:cNvPr id="3" name="Notes Placeholder 2"/>
+          <p:cNvSpPr>
+            <a:spLocks noGrp="1"/>
+          </p:cNvSpPr>
+          <p:nvPr>
+            <p:ph type="body" idx="1"/>
+          </p:nvPr>
+        </p:nvSpPr>
+        <p:spPr/>
+        <p:txBody>
+          <a:bodyPr/>
+          <a:lstStyle/>
+          <a:p>
+            <a:r>
+              <a:rPr lang="en-US" dirty="0"/>
+              <a:t/>
+            </a:r>
+            <a:endParaRPr lang="en-US" dirty="0"/>
+          </a:p>
+        </p:txBody>
+      </p:sp>
+      <p:sp>
+        <p:nvSpPr>
+          <p:cNvPr id="4" name="Slide Number Placeholder 3"/>
+          <p:cNvSpPr>
+            <a:spLocks noGrp="1"/>
+          </p:cNvSpPr>
+          <p:nvPr>
+            <p:ph type="sldNum" sz="quarter" idx="10"/>
+          </p:nvPr>
+        </p:nvSpPr>
+        <p:spPr/>
+        <p:txBody>
+          <a:bodyPr/>
+          <a:lstStyle/>
+          <a:p>
+            <a:fld id="{F7021451-1387-4CA6-816F-3879F97B5CBC}" type="slidenum">
+              <a:rPr lang="en-US"/>
+              <a:t>24</a:t>
+            </a:fld>
+            <a:endParaRPr lang="en-US"/>
+          </a:p>
+        </p:txBody>
+      </p:sp>
+    </p:spTree>
+    <p:extLst>
+      <p:ext uri="{BB962C8B-B14F-4D97-AF65-F5344CB8AC3E}">
+        <p14:creationId xmlns:p14="http://schemas.microsoft.com/office/powerpoint/2010/main" val="1024086991"/>
+      </p:ext>
+    </p:extLst>
+  </p:cSld>
+  <p:clrMapOvr>
+    <a:masterClrMapping/>
+  </p:clrMapOvr>
+</p:notes>
+</file>
+
+<file path=ppt/notesSlides/notesSlide25.xml><?xml version="1.0" encoding="utf-8"?>
+<p:notes xmlns:a="http://schemas.openxmlformats.org/drawingml/2006/main" xmlns:r="http://schemas.openxmlformats.org/officeDocument/2006/relationships" xmlns:p="http://schemas.openxmlformats.org/presentationml/2006/main">
+  <p:cSld>
+    <p:spTree>
+      <p:nvGrpSpPr>
+        <p:cNvPr id="1" name=""/>
+        <p:cNvGrpSpPr/>
+        <p:nvPr/>
+      </p:nvGrpSpPr>
+      <p:grpSpPr>
+        <a:xfrm>
+          <a:off x="0" y="0"/>
+          <a:ext cx="0" cy="0"/>
+          <a:chOff x="0" y="0"/>
+          <a:chExt cx="0" cy="0"/>
+        </a:xfrm>
+      </p:grpSpPr>
+      <p:sp>
+        <p:nvSpPr>
+          <p:cNvPr id="2" name="Slide Image Placeholder 1"/>
+          <p:cNvSpPr>
+            <a:spLocks noGrp="1" noRot="1" noChangeAspect="1"/>
+          </p:cNvSpPr>
+          <p:nvPr>
+            <p:ph type="sldImg"/>
+          </p:nvPr>
+        </p:nvSpPr>
+        <p:spPr/>
+      </p:sp>
+      <p:sp>
+        <p:nvSpPr>
+          <p:cNvPr id="3" name="Notes Placeholder 2"/>
+          <p:cNvSpPr>
+            <a:spLocks noGrp="1"/>
+          </p:cNvSpPr>
+          <p:nvPr>
+            <p:ph type="body" idx="1"/>
+          </p:nvPr>
+        </p:nvSpPr>
+        <p:spPr/>
+        <p:txBody>
+          <a:bodyPr/>
+          <a:lstStyle/>
+          <a:p>
+            <a:r>
+              <a:rPr lang="en-US" dirty="0"/>
+              <a:t/>
+            </a:r>
+            <a:endParaRPr lang="en-US" dirty="0"/>
+          </a:p>
+        </p:txBody>
+      </p:sp>
+      <p:sp>
+        <p:nvSpPr>
+          <p:cNvPr id="4" name="Slide Number Placeholder 3"/>
+          <p:cNvSpPr>
+            <a:spLocks noGrp="1"/>
+          </p:cNvSpPr>
+          <p:nvPr>
+            <p:ph type="sldNum" sz="quarter" idx="10"/>
+          </p:nvPr>
+        </p:nvSpPr>
+        <p:spPr/>
+        <p:txBody>
+          <a:bodyPr/>
+          <a:lstStyle/>
+          <a:p>
+            <a:fld id="{F7021451-1387-4CA6-816F-3879F97B5CBC}" type="slidenum">
+              <a:rPr lang="en-US"/>
+              <a:t>25</a:t>
             </a:fld>
             <a:endParaRPr lang="en-US"/>
           </a:p>
@@ -10393,13 +10660,13 @@
             <a:r>
               <a:rPr lang="en-US" sz="1200" b="1" spc="300" kern="0" dirty="0">
                 <a:solidFill>
-                  <a:srgbClr val="C44E52"/>
+                  <a:srgbClr val="9AA0B0"/>
                 </a:solidFill>
                 <a:latin typeface="Calibri" pitchFamily="34" charset="0"/>
                 <a:ea typeface="Calibri" pitchFamily="34" charset="-122"/>
                 <a:cs typeface="Calibri" pitchFamily="34" charset="-120"/>
               </a:rPr>
-              <a:t>INTERACTIVE · MODEL EXPLORER</a:t>
+              <a:t>BACKUP · METHODS</a:t>
             </a:r>
             <a:endParaRPr lang="en-US" sz="1200" dirty="0"/>
           </a:p>
@@ -10428,12 +10695,12 @@
           <a:p>
             <a:pPr indent="0" marL="0">
               <a:lnSpc>
-                <a:spcPts val="2700"/>
+                <a:spcPts val="2916"/>
               </a:lnSpc>
               <a:buNone/>
             </a:pPr>
             <a:r>
-              <a:rPr lang="en-US" sz="2500" b="1" dirty="0">
+              <a:rPr lang="en-US" sz="2700" b="1" dirty="0">
                 <a:solidFill>
                   <a:srgbClr val="23262F"/>
                 </a:solidFill>
@@ -10441,73 +10708,492 @@
                 <a:ea typeface="Georgia" pitchFamily="34" charset="-122"/>
                 <a:cs typeface="Georgia" pitchFamily="34" charset="-120"/>
               </a:rPr>
-              <a:t>Does it hold across models?  ▸ click a button</a:t>
-            </a:r>
-            <a:endParaRPr lang="en-US" sz="2500" dirty="0"/>
-          </a:p>
-        </p:txBody>
-      </p:sp>
-      <p:pic>
-        <p:nvPicPr>
-          <p:cNvPr id="4" name="Image 0" descr="/Users/xiaochuan/Desktop/Projects/P5_Multi_linguistic_histoBias/v3/experiments/exp3a_mixed_effects/figures/figC_attribute_OR_qwen7b.png">    </p:cNvPr>
-          <p:cNvPicPr>
-            <a:picLocks noChangeAspect="1"/>
-          </p:cNvPicPr>
-          <p:nvPr/>
-        </p:nvPicPr>
-        <p:blipFill>
-          <a:blip r:embed="rId1"/>
-          <a:stretch>
-            <a:fillRect/>
-          </a:stretch>
-        </p:blipFill>
-        <p:spPr>
-          <a:xfrm>
-            <a:off x="1709928" y="1737360"/>
-            <a:ext cx="8778240" cy="3351753"/>
+              <a:t>Why InternVL3-8B as the second model</a:t>
+            </a:r>
+            <a:endParaRPr lang="en-US" sz="2700" dirty="0"/>
+          </a:p>
+        </p:txBody>
+      </p:sp>
+      <p:sp>
+        <p:nvSpPr>
+          <p:cNvPr id="4" name="Text 2"/>
+          <p:cNvSpPr/>
+          <p:nvPr/>
+        </p:nvSpPr>
+        <p:spPr>
+          <a:xfrm>
+            <a:off x="685800" y="1645920"/>
+            <a:ext cx="10820095" cy="457200"/>
           </a:xfrm>
           <a:prstGeom prst="rect">
             <a:avLst/>
           </a:prstGeom>
-        </p:spPr>
-      </p:pic>
-      <p:sp>
-        <p:nvSpPr>
-          <p:cNvPr id="5" name="Shape 2"/>
-          <p:cNvSpPr/>
-          <p:nvPr/>
-        </p:nvSpPr>
-        <p:spPr>
-          <a:xfrm>
-            <a:off x="1325880" y="5943600"/>
-            <a:ext cx="3108960" cy="603504"/>
-          </a:xfrm>
-          <a:prstGeom prst="roundRect">
-            <a:avLst>
-              <a:gd name="adj" fmla="val 12121"/>
-            </a:avLst>
+          <a:noFill/>
+          <a:ln/>
+        </p:spPr>
+        <p:txBody>
+          <a:bodyPr wrap="square" lIns="0" tIns="0" rIns="0" bIns="0" rtlCol="0" anchor="ctr"/>
+          <a:lstStyle/>
+          <a:p>
+            <a:pPr indent="0" marL="0">
+              <a:buNone/>
+            </a:pPr>
+            <a:r>
+              <a:rPr lang="en-US" sz="1500" i="1" dirty="0">
+                <a:solidFill>
+                  <a:srgbClr val="5A6072"/>
+                </a:solidFill>
+                <a:latin typeface="Calibri" pitchFamily="34" charset="0"/>
+                <a:ea typeface="Calibri" pitchFamily="34" charset="-122"/>
+                <a:cs typeface="Calibri" pitchFamily="34" charset="-120"/>
+              </a:rPr>
+              <a:t>Goal: rule out “it's just a Qwen quirk.” A second, independent family tests whether the finding generalizes.</a:t>
+            </a:r>
+            <a:endParaRPr lang="en-US" sz="1500" dirty="0"/>
+          </a:p>
+        </p:txBody>
+      </p:sp>
+      <p:sp>
+        <p:nvSpPr>
+          <p:cNvPr id="5" name="Shape 3"/>
+          <p:cNvSpPr/>
+          <p:nvPr/>
+        </p:nvSpPr>
+        <p:spPr>
+          <a:xfrm>
+            <a:off x="685800" y="2450592"/>
+            <a:ext cx="384048" cy="384048"/>
+          </a:xfrm>
+          <a:prstGeom prst="ellipse">
+            <a:avLst/>
+          </a:prstGeom>
+          <a:solidFill>
+            <a:srgbClr val="C44E52"/>
+          </a:solidFill>
+          <a:ln/>
+        </p:spPr>
+      </p:sp>
+      <p:sp>
+        <p:nvSpPr>
+          <p:cNvPr id="6" name="Text 4"/>
+          <p:cNvSpPr/>
+          <p:nvPr/>
+        </p:nvSpPr>
+        <p:spPr>
+          <a:xfrm>
+            <a:off x="685800" y="2450592"/>
+            <a:ext cx="384048" cy="384048"/>
+          </a:xfrm>
+          <a:prstGeom prst="rect">
+            <a:avLst/>
+          </a:prstGeom>
+          <a:noFill/>
+          <a:ln/>
+        </p:spPr>
+        <p:txBody>
+          <a:bodyPr wrap="square" lIns="0" tIns="0" rIns="0" bIns="0" rtlCol="0" anchor="ctr"/>
+          <a:lstStyle/>
+          <a:p>
+            <a:pPr algn="ctr" indent="0" marL="0">
+              <a:buNone/>
+            </a:pPr>
+            <a:r>
+              <a:rPr lang="en-US" sz="1500" b="1" dirty="0">
+                <a:solidFill>
+                  <a:srgbClr val="FFFFFF"/>
+                </a:solidFill>
+                <a:latin typeface="Georgia" pitchFamily="34" charset="0"/>
+                <a:ea typeface="Georgia" pitchFamily="34" charset="-122"/>
+                <a:cs typeface="Georgia" pitchFamily="34" charset="-120"/>
+              </a:rPr>
+              <a:t>1</a:t>
+            </a:r>
+            <a:endParaRPr lang="en-US" sz="1500" dirty="0"/>
+          </a:p>
+        </p:txBody>
+      </p:sp>
+      <p:sp>
+        <p:nvSpPr>
+          <p:cNvPr id="7" name="Text 5"/>
+          <p:cNvSpPr/>
+          <p:nvPr/>
+        </p:nvSpPr>
+        <p:spPr>
+          <a:xfrm>
+            <a:off x="1280160" y="2404872"/>
+            <a:ext cx="3383280" cy="457200"/>
+          </a:xfrm>
+          <a:prstGeom prst="rect">
+            <a:avLst/>
+          </a:prstGeom>
+          <a:noFill/>
+          <a:ln/>
+        </p:spPr>
+        <p:txBody>
+          <a:bodyPr wrap="square" lIns="0" tIns="0" rIns="0" bIns="0" rtlCol="0" anchor="t"/>
+          <a:lstStyle/>
+          <a:p>
+            <a:pPr indent="0" marL="0">
+              <a:buNone/>
+            </a:pPr>
+            <a:r>
+              <a:rPr lang="en-US" sz="1600" b="1" dirty="0">
+                <a:solidFill>
+                  <a:srgbClr val="23262F"/>
+                </a:solidFill>
+                <a:latin typeface="Georgia" pitchFamily="34" charset="0"/>
+                <a:ea typeface="Georgia" pitchFamily="34" charset="-122"/>
+                <a:cs typeface="Georgia" pitchFamily="34" charset="-120"/>
+              </a:rPr>
+              <a:t>Different family</a:t>
+            </a:r>
+            <a:endParaRPr lang="en-US" sz="1600" dirty="0"/>
+          </a:p>
+        </p:txBody>
+      </p:sp>
+      <p:sp>
+        <p:nvSpPr>
+          <p:cNvPr id="8" name="Text 6"/>
+          <p:cNvSpPr/>
+          <p:nvPr/>
+        </p:nvSpPr>
+        <p:spPr>
+          <a:xfrm>
+            <a:off x="4754880" y="2404872"/>
+            <a:ext cx="7406640" cy="777240"/>
+          </a:xfrm>
+          <a:prstGeom prst="rect">
+            <a:avLst/>
+          </a:prstGeom>
+          <a:noFill/>
+          <a:ln/>
+        </p:spPr>
+        <p:txBody>
+          <a:bodyPr wrap="square" lIns="0" tIns="0" rIns="0" bIns="0" rtlCol="0" anchor="t"/>
+          <a:lstStyle/>
+          <a:p>
+            <a:pPr indent="0" marL="0">
+              <a:buNone/>
+            </a:pPr>
+            <a:r>
+              <a:rPr lang="en-US" sz="1400" dirty="0">
+                <a:solidFill>
+                  <a:srgbClr val="5A6072"/>
+                </a:solidFill>
+                <a:latin typeface="Calibri" pitchFamily="34" charset="0"/>
+                <a:ea typeface="Calibri" pitchFamily="34" charset="-122"/>
+                <a:cs typeface="Calibri" pitchFamily="34" charset="-120"/>
+              </a:rPr>
+              <a:t>OpenGVLab, not Alibaba — independent architecture and training, not a Qwen variant.</a:t>
+            </a:r>
+            <a:endParaRPr lang="en-US" sz="1400" dirty="0"/>
+          </a:p>
+        </p:txBody>
+      </p:sp>
+      <p:sp>
+        <p:nvSpPr>
+          <p:cNvPr id="9" name="Shape 7"/>
+          <p:cNvSpPr/>
+          <p:nvPr/>
+        </p:nvSpPr>
+        <p:spPr>
+          <a:xfrm>
+            <a:off x="685800" y="3383280"/>
+            <a:ext cx="384048" cy="384048"/>
+          </a:xfrm>
+          <a:prstGeom prst="ellipse">
+            <a:avLst/>
+          </a:prstGeom>
+          <a:solidFill>
+            <a:srgbClr val="4C72B0"/>
+          </a:solidFill>
+          <a:ln/>
+        </p:spPr>
+      </p:sp>
+      <p:sp>
+        <p:nvSpPr>
+          <p:cNvPr id="10" name="Text 8"/>
+          <p:cNvSpPr/>
+          <p:nvPr/>
+        </p:nvSpPr>
+        <p:spPr>
+          <a:xfrm>
+            <a:off x="685800" y="3383280"/>
+            <a:ext cx="384048" cy="384048"/>
+          </a:xfrm>
+          <a:prstGeom prst="rect">
+            <a:avLst/>
+          </a:prstGeom>
+          <a:noFill/>
+          <a:ln/>
+        </p:spPr>
+        <p:txBody>
+          <a:bodyPr wrap="square" lIns="0" tIns="0" rIns="0" bIns="0" rtlCol="0" anchor="ctr"/>
+          <a:lstStyle/>
+          <a:p>
+            <a:pPr algn="ctr" indent="0" marL="0">
+              <a:buNone/>
+            </a:pPr>
+            <a:r>
+              <a:rPr lang="en-US" sz="1500" b="1" dirty="0">
+                <a:solidFill>
+                  <a:srgbClr val="FFFFFF"/>
+                </a:solidFill>
+                <a:latin typeface="Georgia" pitchFamily="34" charset="0"/>
+                <a:ea typeface="Georgia" pitchFamily="34" charset="-122"/>
+                <a:cs typeface="Georgia" pitchFamily="34" charset="-120"/>
+              </a:rPr>
+              <a:t>2</a:t>
+            </a:r>
+            <a:endParaRPr lang="en-US" sz="1500" dirty="0"/>
+          </a:p>
+        </p:txBody>
+      </p:sp>
+      <p:sp>
+        <p:nvSpPr>
+          <p:cNvPr id="11" name="Text 9"/>
+          <p:cNvSpPr/>
+          <p:nvPr/>
+        </p:nvSpPr>
+        <p:spPr>
+          <a:xfrm>
+            <a:off x="1280160" y="3337560"/>
+            <a:ext cx="3383280" cy="457200"/>
+          </a:xfrm>
+          <a:prstGeom prst="rect">
+            <a:avLst/>
+          </a:prstGeom>
+          <a:noFill/>
+          <a:ln/>
+        </p:spPr>
+        <p:txBody>
+          <a:bodyPr wrap="square" lIns="0" tIns="0" rIns="0" bIns="0" rtlCol="0" anchor="t"/>
+          <a:lstStyle/>
+          <a:p>
+            <a:pPr indent="0" marL="0">
+              <a:buNone/>
+            </a:pPr>
+            <a:r>
+              <a:rPr lang="en-US" sz="1600" b="1" dirty="0">
+                <a:solidFill>
+                  <a:srgbClr val="23262F"/>
+                </a:solidFill>
+                <a:latin typeface="Georgia" pitchFamily="34" charset="0"/>
+                <a:ea typeface="Georgia" pitchFamily="34" charset="-122"/>
+                <a:cs typeface="Georgia" pitchFamily="34" charset="-120"/>
+              </a:rPr>
+              <a:t>Size-matched</a:t>
+            </a:r>
+            <a:endParaRPr lang="en-US" sz="1600" dirty="0"/>
+          </a:p>
+        </p:txBody>
+      </p:sp>
+      <p:sp>
+        <p:nvSpPr>
+          <p:cNvPr id="12" name="Text 10"/>
+          <p:cNvSpPr/>
+          <p:nvPr/>
+        </p:nvSpPr>
+        <p:spPr>
+          <a:xfrm>
+            <a:off x="4754880" y="3337560"/>
+            <a:ext cx="7406640" cy="777240"/>
+          </a:xfrm>
+          <a:prstGeom prst="rect">
+            <a:avLst/>
+          </a:prstGeom>
+          <a:noFill/>
+          <a:ln/>
+        </p:spPr>
+        <p:txBody>
+          <a:bodyPr wrap="square" lIns="0" tIns="0" rIns="0" bIns="0" rtlCol="0" anchor="t"/>
+          <a:lstStyle/>
+          <a:p>
+            <a:pPr indent="0" marL="0">
+              <a:buNone/>
+            </a:pPr>
+            <a:r>
+              <a:rPr lang="en-US" sz="1400" dirty="0">
+                <a:solidFill>
+                  <a:srgbClr val="5A6072"/>
+                </a:solidFill>
+                <a:latin typeface="Calibri" pitchFamily="34" charset="0"/>
+                <a:ea typeface="Calibri" pitchFamily="34" charset="-122"/>
+                <a:cs typeface="Calibri" pitchFamily="34" charset="-120"/>
+              </a:rPr>
+              <a:t>≈8B vs Qwen's 7B — controls for scale, so a difference isn't “one is far bigger.”</a:t>
+            </a:r>
+            <a:endParaRPr lang="en-US" sz="1400" dirty="0"/>
+          </a:p>
+        </p:txBody>
+      </p:sp>
+      <p:sp>
+        <p:nvSpPr>
+          <p:cNvPr id="13" name="Shape 11"/>
+          <p:cNvSpPr/>
+          <p:nvPr/>
+        </p:nvSpPr>
+        <p:spPr>
+          <a:xfrm>
+            <a:off x="685800" y="4315968"/>
+            <a:ext cx="384048" cy="384048"/>
+          </a:xfrm>
+          <a:prstGeom prst="ellipse">
+            <a:avLst/>
+          </a:prstGeom>
+          <a:solidFill>
+            <a:srgbClr val="55A868"/>
+          </a:solidFill>
+          <a:ln/>
+        </p:spPr>
+      </p:sp>
+      <p:sp>
+        <p:nvSpPr>
+          <p:cNvPr id="14" name="Text 12"/>
+          <p:cNvSpPr/>
+          <p:nvPr/>
+        </p:nvSpPr>
+        <p:spPr>
+          <a:xfrm>
+            <a:off x="685800" y="4315968"/>
+            <a:ext cx="384048" cy="384048"/>
+          </a:xfrm>
+          <a:prstGeom prst="rect">
+            <a:avLst/>
+          </a:prstGeom>
+          <a:noFill/>
+          <a:ln/>
+        </p:spPr>
+        <p:txBody>
+          <a:bodyPr wrap="square" lIns="0" tIns="0" rIns="0" bIns="0" rtlCol="0" anchor="ctr"/>
+          <a:lstStyle/>
+          <a:p>
+            <a:pPr algn="ctr" indent="0" marL="0">
+              <a:buNone/>
+            </a:pPr>
+            <a:r>
+              <a:rPr lang="en-US" sz="1500" b="1" dirty="0">
+                <a:solidFill>
+                  <a:srgbClr val="FFFFFF"/>
+                </a:solidFill>
+                <a:latin typeface="Georgia" pitchFamily="34" charset="0"/>
+                <a:ea typeface="Georgia" pitchFamily="34" charset="-122"/>
+                <a:cs typeface="Georgia" pitchFamily="34" charset="-120"/>
+              </a:rPr>
+              <a:t>3</a:t>
+            </a:r>
+            <a:endParaRPr lang="en-US" sz="1500" dirty="0"/>
+          </a:p>
+        </p:txBody>
+      </p:sp>
+      <p:sp>
+        <p:nvSpPr>
+          <p:cNvPr id="15" name="Text 13"/>
+          <p:cNvSpPr/>
+          <p:nvPr/>
+        </p:nvSpPr>
+        <p:spPr>
+          <a:xfrm>
+            <a:off x="1280160" y="4270248"/>
+            <a:ext cx="3383280" cy="457200"/>
+          </a:xfrm>
+          <a:prstGeom prst="rect">
+            <a:avLst/>
+          </a:prstGeom>
+          <a:noFill/>
+          <a:ln/>
+        </p:spPr>
+        <p:txBody>
+          <a:bodyPr wrap="square" lIns="0" tIns="0" rIns="0" bIns="0" rtlCol="0" anchor="t"/>
+          <a:lstStyle/>
+          <a:p>
+            <a:pPr indent="0" marL="0">
+              <a:buNone/>
+            </a:pPr>
+            <a:r>
+              <a:rPr lang="en-US" sz="1600" b="1" dirty="0">
+                <a:solidFill>
+                  <a:srgbClr val="23262F"/>
+                </a:solidFill>
+                <a:latin typeface="Georgia" pitchFamily="34" charset="0"/>
+                <a:ea typeface="Georgia" pitchFamily="34" charset="-122"/>
+                <a:cs typeface="Georgia" pitchFamily="34" charset="-120"/>
+              </a:rPr>
+              <a:t>Strong, standard baseline</a:t>
+            </a:r>
+            <a:endParaRPr lang="en-US" sz="1600" dirty="0"/>
+          </a:p>
+        </p:txBody>
+      </p:sp>
+      <p:sp>
+        <p:nvSpPr>
+          <p:cNvPr id="16" name="Text 14"/>
+          <p:cNvSpPr/>
+          <p:nvPr/>
+        </p:nvSpPr>
+        <p:spPr>
+          <a:xfrm>
+            <a:off x="4754880" y="4270248"/>
+            <a:ext cx="7406640" cy="777240"/>
+          </a:xfrm>
+          <a:prstGeom prst="rect">
+            <a:avLst/>
+          </a:prstGeom>
+          <a:noFill/>
+          <a:ln/>
+        </p:spPr>
+        <p:txBody>
+          <a:bodyPr wrap="square" lIns="0" tIns="0" rIns="0" bIns="0" rtlCol="0" anchor="t"/>
+          <a:lstStyle/>
+          <a:p>
+            <a:pPr indent="0" marL="0">
+              <a:buNone/>
+            </a:pPr>
+            <a:r>
+              <a:rPr lang="en-US" sz="1400" dirty="0">
+                <a:solidFill>
+                  <a:srgbClr val="5A6072"/>
+                </a:solidFill>
+                <a:latin typeface="Calibri" pitchFamily="34" charset="0"/>
+                <a:ea typeface="Calibri" pitchFamily="34" charset="-122"/>
+                <a:cs typeface="Calibri" pitchFamily="34" charset="-120"/>
+              </a:rPr>
+              <a:t>A top open VLM family widely used in papers — credible and representative.</a:t>
+            </a:r>
+            <a:endParaRPr lang="en-US" sz="1400" dirty="0"/>
+          </a:p>
+        </p:txBody>
+      </p:sp>
+      <p:sp>
+        <p:nvSpPr>
+          <p:cNvPr id="17" name="Shape 15"/>
+          <p:cNvSpPr/>
+          <p:nvPr/>
+        </p:nvSpPr>
+        <p:spPr>
+          <a:xfrm>
+            <a:off x="685800" y="5248656"/>
+            <a:ext cx="384048" cy="384048"/>
+          </a:xfrm>
+          <a:prstGeom prst="ellipse">
+            <a:avLst/>
           </a:prstGeom>
           <a:solidFill>
             <a:srgbClr val="1B1F3B"/>
           </a:solidFill>
-          <a:ln w="12700">
-            <a:solidFill>
-              <a:srgbClr val="1B1F3B"/>
-            </a:solidFill>
-            <a:prstDash val="solid"/>
-          </a:ln>
-        </p:spPr>
-      </p:sp>
-      <p:sp>
-        <p:nvSpPr>
-          <p:cNvPr id="6" name="Text 3"/>
-          <p:cNvSpPr/>
-          <p:nvPr/>
-        </p:nvSpPr>
-        <p:spPr>
-          <a:xfrm>
-            <a:off x="1325880" y="5943600"/>
-            <a:ext cx="3108960" cy="603504"/>
+          <a:ln/>
+        </p:spPr>
+      </p:sp>
+      <p:sp>
+        <p:nvSpPr>
+          <p:cNvPr id="18" name="Text 16"/>
+          <p:cNvSpPr/>
+          <p:nvPr/>
+        </p:nvSpPr>
+        <p:spPr>
+          <a:xfrm>
+            <a:off x="685800" y="5248656"/>
+            <a:ext cx="384048" cy="384048"/>
           </a:xfrm>
           <a:prstGeom prst="rect">
             <a:avLst/>
@@ -10523,15 +11209,93 @@
               <a:buNone/>
             </a:pPr>
             <a:r>
-              <a:rPr lang="en-US" sz="1400" b="1" dirty="0">
+              <a:rPr lang="en-US" sz="1500" b="1" dirty="0">
                 <a:solidFill>
                   <a:srgbClr val="FFFFFF"/>
+                </a:solidFill>
+                <a:latin typeface="Georgia" pitchFamily="34" charset="0"/>
+                <a:ea typeface="Georgia" pitchFamily="34" charset="-122"/>
+                <a:cs typeface="Georgia" pitchFamily="34" charset="-120"/>
+              </a:rPr>
+              <a:t>4</a:t>
+            </a:r>
+            <a:endParaRPr lang="en-US" sz="1500" dirty="0"/>
+          </a:p>
+        </p:txBody>
+      </p:sp>
+      <p:sp>
+        <p:nvSpPr>
+          <p:cNvPr id="19" name="Text 17"/>
+          <p:cNvSpPr/>
+          <p:nvPr/>
+        </p:nvSpPr>
+        <p:spPr>
+          <a:xfrm>
+            <a:off x="1280160" y="5202936"/>
+            <a:ext cx="3383280" cy="457200"/>
+          </a:xfrm>
+          <a:prstGeom prst="rect">
+            <a:avLst/>
+          </a:prstGeom>
+          <a:noFill/>
+          <a:ln/>
+        </p:spPr>
+        <p:txBody>
+          <a:bodyPr wrap="square" lIns="0" tIns="0" rIns="0" bIns="0" rtlCol="0" anchor="t"/>
+          <a:lstStyle/>
+          <a:p>
+            <a:pPr indent="0" marL="0">
+              <a:buNone/>
+            </a:pPr>
+            <a:r>
+              <a:rPr lang="en-US" sz="1600" b="1" dirty="0">
+                <a:solidFill>
+                  <a:srgbClr val="23262F"/>
+                </a:solidFill>
+                <a:latin typeface="Georgia" pitchFamily="34" charset="0"/>
+                <a:ea typeface="Georgia" pitchFamily="34" charset="-122"/>
+                <a:cs typeface="Georgia" pitchFamily="34" charset="-120"/>
+              </a:rPr>
+              <a:t>Fits the pipeline</a:t>
+            </a:r>
+            <a:endParaRPr lang="en-US" sz="1600" dirty="0"/>
+          </a:p>
+        </p:txBody>
+      </p:sp>
+      <p:sp>
+        <p:nvSpPr>
+          <p:cNvPr id="20" name="Text 18"/>
+          <p:cNvSpPr/>
+          <p:nvPr/>
+        </p:nvSpPr>
+        <p:spPr>
+          <a:xfrm>
+            <a:off x="4754880" y="5202936"/>
+            <a:ext cx="7406640" cy="777240"/>
+          </a:xfrm>
+          <a:prstGeom prst="rect">
+            <a:avLst/>
+          </a:prstGeom>
+          <a:noFill/>
+          <a:ln/>
+        </p:spPr>
+        <p:txBody>
+          <a:bodyPr wrap="square" lIns="0" tIns="0" rIns="0" bIns="0" rtlCol="0" anchor="t"/>
+          <a:lstStyle/>
+          <a:p>
+            <a:pPr indent="0" marL="0">
+              <a:buNone/>
+            </a:pPr>
+            <a:r>
+              <a:rPr lang="en-US" sz="1400" dirty="0">
+                <a:solidFill>
+                  <a:srgbClr val="5A6072"/>
                 </a:solidFill>
                 <a:latin typeface="Calibri" pitchFamily="34" charset="0"/>
                 <a:ea typeface="Calibri" pitchFamily="34" charset="-122"/>
                 <a:cs typeface="Calibri" pitchFamily="34" charset="-120"/>
               </a:rPr>
-              <a:t>Qwen-7B</a:t>
+              <a:t>Multi-image and multilingual; the HF-native checkpoint loads via the standard API.</a:t>
             </a:r>
             <a:endParaRPr lang="en-US" sz="1400" dirty="0"/>
           </a:p>
@@ -10539,157 +11303,7 @@
       </p:sp>
       <p:sp>
         <p:nvSpPr>
-          <p:cNvPr id="7" name="Shape 4"/>
-          <p:cNvSpPr/>
-          <p:nvPr/>
-        </p:nvSpPr>
-        <p:spPr>
-          <a:xfrm>
-            <a:off x="4544568" y="5943600"/>
-            <a:ext cx="3108960" cy="603504"/>
-          </a:xfrm>
-          <a:prstGeom prst="roundRect">
-            <a:avLst>
-              <a:gd name="adj" fmla="val 12121"/>
-            </a:avLst>
-          </a:prstGeom>
-          <a:solidFill>
-            <a:srgbClr val="F5F6FA"/>
-          </a:solidFill>
-          <a:ln w="12700">
-            <a:solidFill>
-              <a:srgbClr val="E4E6EF"/>
-            </a:solidFill>
-            <a:prstDash val="solid"/>
-          </a:ln>
-        </p:spPr>
-      </p:sp>
-      <p:sp>
-        <p:nvSpPr>
-          <p:cNvPr id="8" name="Text 5">
-            <a:hlinkClick r:id="rId2" tooltip="" action="ppaction://hlinksldjump"/>
-          </p:cNvPr>
-          <p:cNvSpPr/>
-          <p:nvPr/>
-        </p:nvSpPr>
-        <p:spPr>
-          <a:xfrm>
-            <a:off x="4544568" y="5943600"/>
-            <a:ext cx="3108960" cy="603504"/>
-          </a:xfrm>
-          <a:prstGeom prst="rect">
-            <a:avLst/>
-          </a:prstGeom>
-          <a:noFill/>
-          <a:ln/>
-        </p:spPr>
-        <p:txBody>
-          <a:bodyPr wrap="square" lIns="0" tIns="0" rIns="0" bIns="0" rtlCol="0" anchor="ctr"/>
-          <a:lstStyle/>
-          <a:p>
-            <a:pPr algn="ctr" indent="0" marL="0">
-              <a:buNone/>
-            </a:pPr>
-            <a:r>
-              <a:rPr lang="en-US" sz="1400" b="1" u="sng" dirty="0">
-                <a:solidFill>
-                  <a:srgbClr val="1B1F3B"/>
-                </a:solidFill>
-                <a:latin typeface="Calibri" pitchFamily="34" charset="0"/>
-                <a:ea typeface="Calibri" pitchFamily="34" charset="-122"/>
-                <a:cs typeface="Calibri" pitchFamily="34" charset="-120"/>
-                <a:hlinkClick r:id="rId2" action="ppaction://hlinksldjump" tooltip="">
-                  <a:extLst>
-                    <a:ext uri="{A12FA001-AC4F-418D-AE19-62706E023703}">
-                      <ahyp:hlinkClr xmlns:ahyp="http://schemas.microsoft.com/office/drawing/2018/hyperlinkcolor" val="tx"/>
-                    </a:ext>
-                  </a:extLst>
-                </a:hlinkClick>
-              </a:rPr>
-              <a:t>InternVL3-8B</a:t>
-            </a:r>
-            <a:endParaRPr lang="en-US" sz="1400" dirty="0"/>
-          </a:p>
-        </p:txBody>
-      </p:sp>
-      <p:sp>
-        <p:nvSpPr>
-          <p:cNvPr id="9" name="Shape 6"/>
-          <p:cNvSpPr/>
-          <p:nvPr/>
-        </p:nvSpPr>
-        <p:spPr>
-          <a:xfrm>
-            <a:off x="7763256" y="5943600"/>
-            <a:ext cx="3108960" cy="603504"/>
-          </a:xfrm>
-          <a:prstGeom prst="roundRect">
-            <a:avLst>
-              <a:gd name="adj" fmla="val 12121"/>
-            </a:avLst>
-          </a:prstGeom>
-          <a:solidFill>
-            <a:srgbClr val="F5F6FA"/>
-          </a:solidFill>
-          <a:ln w="12700">
-            <a:solidFill>
-              <a:srgbClr val="E4E6EF"/>
-            </a:solidFill>
-            <a:prstDash val="solid"/>
-          </a:ln>
-        </p:spPr>
-      </p:sp>
-      <p:sp>
-        <p:nvSpPr>
-          <p:cNvPr id="10" name="Text 7">
-            <a:hlinkClick r:id="rId3" tooltip="" action="ppaction://hlinksldjump"/>
-          </p:cNvPr>
-          <p:cNvSpPr/>
-          <p:nvPr/>
-        </p:nvSpPr>
-        <p:spPr>
-          <a:xfrm>
-            <a:off x="7763256" y="5943600"/>
-            <a:ext cx="3108960" cy="603504"/>
-          </a:xfrm>
-          <a:prstGeom prst="rect">
-            <a:avLst/>
-          </a:prstGeom>
-          <a:noFill/>
-          <a:ln/>
-        </p:spPr>
-        <p:txBody>
-          <a:bodyPr wrap="square" lIns="0" tIns="0" rIns="0" bIns="0" rtlCol="0" anchor="ctr"/>
-          <a:lstStyle/>
-          <a:p>
-            <a:pPr algn="ctr" indent="0" marL="0">
-              <a:buNone/>
-            </a:pPr>
-            <a:r>
-              <a:rPr lang="en-US" sz="1400" b="1" u="sng" dirty="0">
-                <a:solidFill>
-                  <a:srgbClr val="1B1F3B"/>
-                </a:solidFill>
-                <a:latin typeface="Calibri" pitchFamily="34" charset="0"/>
-                <a:ea typeface="Calibri" pitchFamily="34" charset="-122"/>
-                <a:cs typeface="Calibri" pitchFamily="34" charset="-120"/>
-                <a:hlinkClick r:id="rId3" action="ppaction://hlinksldjump" tooltip="">
-                  <a:extLst>
-                    <a:ext uri="{A12FA001-AC4F-418D-AE19-62706E023703}">
-                      <ahyp:hlinkClr xmlns:ahyp="http://schemas.microsoft.com/office/drawing/2018/hyperlinkcolor" val="tx"/>
-                    </a:ext>
-                  </a:extLst>
-                </a:hlinkClick>
-              </a:rPr>
-              <a:t>Both overlaid</a:t>
-            </a:r>
-            <a:endParaRPr lang="en-US" sz="1400" dirty="0"/>
-          </a:p>
-        </p:txBody>
-      </p:sp>
-      <p:sp>
-        <p:nvSpPr>
-          <p:cNvPr id="11" name="Text 8"/>
+          <p:cNvPr id="21" name="Text 19"/>
           <p:cNvSpPr/>
           <p:nvPr/>
         </p:nvSpPr>
@@ -10785,13 +11399,13 @@
             <a:r>
               <a:rPr lang="en-US" sz="1200" b="1" spc="300" kern="0" dirty="0">
                 <a:solidFill>
-                  <a:srgbClr val="C44E52"/>
+                  <a:srgbClr val="9AA0B0"/>
                 </a:solidFill>
                 <a:latin typeface="Calibri" pitchFamily="34" charset="0"/>
                 <a:ea typeface="Calibri" pitchFamily="34" charset="-122"/>
                 <a:cs typeface="Calibri" pitchFamily="34" charset="-120"/>
               </a:rPr>
-              <a:t>INTERACTIVE · MODEL EXPLORER</a:t>
+              <a:t>BACKUP · METHODS</a:t>
             </a:r>
             <a:endParaRPr lang="en-US" sz="1200" dirty="0"/>
           </a:p>
@@ -10820,12 +11434,12 @@
           <a:p>
             <a:pPr indent="0" marL="0">
               <a:lnSpc>
-                <a:spcPts val="2700"/>
+                <a:spcPts val="2808"/>
               </a:lnSpc>
               <a:buNone/>
             </a:pPr>
             <a:r>
-              <a:rPr lang="en-US" sz="2500" b="1" dirty="0">
+              <a:rPr lang="en-US" sz="2600" b="1" dirty="0">
                 <a:solidFill>
                   <a:srgbClr val="23262F"/>
                 </a:solidFill>
@@ -10833,75 +11447,83 @@
                 <a:ea typeface="Georgia" pitchFamily="34" charset="-122"/>
                 <a:cs typeface="Georgia" pitchFamily="34" charset="-120"/>
               </a:rPr>
-              <a:t>Does it hold across models?  ▸ click a button</a:t>
-            </a:r>
-            <a:endParaRPr lang="en-US" sz="2500" dirty="0"/>
-          </a:p>
-        </p:txBody>
-      </p:sp>
-      <p:pic>
-        <p:nvPicPr>
-          <p:cNvPr id="4" name="Image 0" descr="/Users/xiaochuan/Desktop/Projects/P5_Multi_linguistic_histoBias/v3/experiments/exp3a_mixed_effects/figures/figC_attribute_OR_internvl8b.png">    </p:cNvPr>
-          <p:cNvPicPr>
-            <a:picLocks noChangeAspect="1"/>
-          </p:cNvPicPr>
-          <p:nvPr/>
-        </p:nvPicPr>
-        <p:blipFill>
-          <a:blip r:embed="rId1"/>
-          <a:stretch>
-            <a:fillRect/>
-          </a:stretch>
-        </p:blipFill>
-        <p:spPr>
-          <a:xfrm>
-            <a:off x="1709928" y="1737360"/>
-            <a:ext cx="8778240" cy="3351753"/>
+              <a:t>Mixed-effects logistic regression &amp; the LRT</a:t>
+            </a:r>
+            <a:endParaRPr lang="en-US" sz="2600" dirty="0"/>
+          </a:p>
+        </p:txBody>
+      </p:sp>
+      <p:sp>
+        <p:nvSpPr>
+          <p:cNvPr id="4" name="Text 2"/>
+          <p:cNvSpPr/>
+          <p:nvPr/>
+        </p:nvSpPr>
+        <p:spPr>
+          <a:xfrm>
+            <a:off x="685800" y="1691640"/>
+            <a:ext cx="5303520" cy="365760"/>
           </a:xfrm>
           <a:prstGeom prst="rect">
             <a:avLst/>
           </a:prstGeom>
-        </p:spPr>
-      </p:pic>
-      <p:sp>
-        <p:nvSpPr>
-          <p:cNvPr id="5" name="Shape 2"/>
-          <p:cNvSpPr/>
-          <p:nvPr/>
-        </p:nvSpPr>
-        <p:spPr>
-          <a:xfrm>
-            <a:off x="1325880" y="5943600"/>
-            <a:ext cx="3108960" cy="603504"/>
+          <a:noFill/>
+          <a:ln/>
+        </p:spPr>
+        <p:txBody>
+          <a:bodyPr wrap="square" lIns="0" tIns="0" rIns="0" bIns="0" rtlCol="0" anchor="ctr"/>
+          <a:lstStyle/>
+          <a:p>
+            <a:pPr indent="0" marL="0">
+              <a:buNone/>
+            </a:pPr>
+            <a:r>
+              <a:rPr lang="en-US" sz="1600" b="1" dirty="0">
+                <a:solidFill>
+                  <a:srgbClr val="C44E52"/>
+                </a:solidFill>
+                <a:latin typeface="Georgia" pitchFamily="34" charset="0"/>
+                <a:ea typeface="Georgia" pitchFamily="34" charset="-122"/>
+                <a:cs typeface="Georgia" pitchFamily="34" charset="-120"/>
+              </a:rPr>
+              <a:t>The model</a:t>
+            </a:r>
+            <a:endParaRPr lang="en-US" sz="1600" dirty="0"/>
+          </a:p>
+        </p:txBody>
+      </p:sp>
+      <p:sp>
+        <p:nvSpPr>
+          <p:cNvPr id="5" name="Shape 3"/>
+          <p:cNvSpPr/>
+          <p:nvPr/>
+        </p:nvSpPr>
+        <p:spPr>
+          <a:xfrm>
+            <a:off x="685800" y="2103120"/>
+            <a:ext cx="5349240" cy="640080"/>
           </a:xfrm>
           <a:prstGeom prst="roundRect">
             <a:avLst>
-              <a:gd name="adj" fmla="val 12121"/>
+              <a:gd name="adj" fmla="val 11429"/>
             </a:avLst>
           </a:prstGeom>
           <a:solidFill>
-            <a:srgbClr val="F5F6FA"/>
+            <a:srgbClr val="1B1F3B"/>
           </a:solidFill>
-          <a:ln w="12700">
-            <a:solidFill>
-              <a:srgbClr val="E4E6EF"/>
-            </a:solidFill>
-            <a:prstDash val="solid"/>
-          </a:ln>
-        </p:spPr>
-      </p:sp>
-      <p:sp>
-        <p:nvSpPr>
-          <p:cNvPr id="6" name="Text 3">
-            <a:hlinkClick r:id="rId2" tooltip="" action="ppaction://hlinksldjump"/>
-          </p:cNvPr>
-          <p:cNvSpPr/>
-          <p:nvPr/>
-        </p:nvSpPr>
-        <p:spPr>
-          <a:xfrm>
-            <a:off x="1325880" y="5943600"/>
-            <a:ext cx="3108960" cy="603504"/>
+          <a:ln/>
+        </p:spPr>
+      </p:sp>
+      <p:sp>
+        <p:nvSpPr>
+          <p:cNvPr id="6" name="Text 4"/>
+          <p:cNvSpPr/>
+          <p:nvPr/>
+        </p:nvSpPr>
+        <p:spPr>
+          <a:xfrm>
+            <a:off x="685800" y="2103120"/>
+            <a:ext cx="5349240" cy="640080"/>
           </a:xfrm>
           <a:prstGeom prst="rect">
             <a:avLst/>
@@ -10910,178 +11532,1364 @@
           <a:ln/>
         </p:spPr>
         <p:txBody>
-          <a:bodyPr wrap="square" lIns="0" tIns="0" rIns="0" bIns="0" rtlCol="0" anchor="ctr"/>
+          <a:bodyPr wrap="square" lIns="50800" tIns="50800" rIns="50800" bIns="50800" rtlCol="0" anchor="ctr"/>
           <a:lstStyle/>
           <a:p>
             <a:pPr algn="ctr" indent="0" marL="0">
               <a:buNone/>
             </a:pPr>
             <a:r>
-              <a:rPr lang="en-US" sz="1400" b="1" u="sng" dirty="0">
-                <a:solidFill>
-                  <a:srgbClr val="1B1F3B"/>
+              <a:rPr lang="en-US" sz="1250" dirty="0">
+                <a:solidFill>
+                  <a:srgbClr val="FFFFFF"/>
+                </a:solidFill>
+                <a:latin typeface="Courier New" pitchFamily="34" charset="0"/>
+                <a:ea typeface="Courier New" pitchFamily="34" charset="-122"/>
+                <a:cs typeface="Courier New" pitchFamily="34" charset="-120"/>
+              </a:rPr>
+              <a:t>picked_adv ~ socio_attr + lang + gender + (1 | item)</a:t>
+            </a:r>
+            <a:endParaRPr lang="en-US" sz="1250" dirty="0"/>
+          </a:p>
+        </p:txBody>
+      </p:sp>
+      <p:sp>
+        <p:nvSpPr>
+          <p:cNvPr id="7" name="Text 5"/>
+          <p:cNvSpPr/>
+          <p:nvPr/>
+        </p:nvSpPr>
+        <p:spPr>
+          <a:xfrm>
+            <a:off x="685800" y="2971800"/>
+            <a:ext cx="5349240" cy="2743200"/>
+          </a:xfrm>
+          <a:prstGeom prst="rect">
+            <a:avLst/>
+          </a:prstGeom>
+          <a:noFill/>
+          <a:ln/>
+        </p:spPr>
+        <p:txBody>
+          <a:bodyPr wrap="square" lIns="0" tIns="0" rIns="0" bIns="0" rtlCol="0" anchor="t"/>
+          <a:lstStyle/>
+          <a:p>
+            <a:pPr marL="203200" indent="-203200">
+              <a:lnSpc>
+                <a:spcPct val="100000"/>
+              </a:lnSpc>
+              <a:spcAft>
+                <a:spcPts val="900"/>
+              </a:spcAft>
+              <a:buSzPct val="100000"/>
+              <a:buChar char="•"/>
+            </a:pPr>
+            <a:r>
+              <a:rPr lang="en-US" sz="1350" dirty="0">
+                <a:solidFill>
+                  <a:srgbClr val="23262F"/>
                 </a:solidFill>
                 <a:latin typeface="Calibri" pitchFamily="34" charset="0"/>
                 <a:ea typeface="Calibri" pitchFamily="34" charset="-122"/>
                 <a:cs typeface="Calibri" pitchFamily="34" charset="-120"/>
-                <a:hlinkClick r:id="rId2" action="ppaction://hlinksldjump" tooltip="">
-                  <a:extLst>
-                    <a:ext uri="{A12FA001-AC4F-418D-AE19-62706E023703}">
-                      <ahyp:hlinkClr xmlns:ahyp="http://schemas.microsoft.com/office/drawing/2018/hyperlinkcolor" val="tx"/>
-                    </a:ext>
-                  </a:extLst>
-                </a:hlinkClick>
-              </a:rPr>
-              <a:t>Qwen-7B</a:t>
-            </a:r>
-            <a:endParaRPr lang="en-US" sz="1400" dirty="0"/>
-          </a:p>
-        </p:txBody>
-      </p:sp>
-      <p:sp>
-        <p:nvSpPr>
-          <p:cNvPr id="7" name="Shape 4"/>
-          <p:cNvSpPr/>
-          <p:nvPr/>
-        </p:nvSpPr>
-        <p:spPr>
-          <a:xfrm>
-            <a:off x="4544568" y="5943600"/>
-            <a:ext cx="3108960" cy="603504"/>
-          </a:xfrm>
-          <a:prstGeom prst="roundRect">
-            <a:avLst>
-              <a:gd name="adj" fmla="val 12121"/>
-            </a:avLst>
-          </a:prstGeom>
-          <a:solidFill>
-            <a:srgbClr val="1B1F3B"/>
-          </a:solidFill>
-          <a:ln w="12700">
-            <a:solidFill>
-              <a:srgbClr val="1B1F3B"/>
-            </a:solidFill>
-            <a:prstDash val="solid"/>
-          </a:ln>
-        </p:spPr>
-      </p:sp>
-      <p:sp>
-        <p:nvSpPr>
-          <p:cNvPr id="8" name="Text 5"/>
-          <p:cNvSpPr/>
-          <p:nvPr/>
-        </p:nvSpPr>
-        <p:spPr>
-          <a:xfrm>
-            <a:off x="4544568" y="5943600"/>
-            <a:ext cx="3108960" cy="603504"/>
-          </a:xfrm>
-          <a:prstGeom prst="rect">
-            <a:avLst/>
-          </a:prstGeom>
-          <a:noFill/>
-          <a:ln/>
-        </p:spPr>
-        <p:txBody>
-          <a:bodyPr wrap="square" lIns="0" tIns="0" rIns="0" bIns="0" rtlCol="0" anchor="ctr"/>
-          <a:lstStyle/>
-          <a:p>
-            <a:pPr algn="ctr" indent="0" marL="0">
-              <a:buNone/>
-            </a:pPr>
-            <a:r>
-              <a:rPr lang="en-US" sz="1400" b="1" dirty="0">
-                <a:solidFill>
-                  <a:srgbClr val="FFFFFF"/>
+              </a:rPr>
+              <a:t>Logistic → models P(pick prototype); coefficients exponentiate to odds ratios (OR).</a:t>
+            </a:r>
+            <a:endParaRPr lang="en-US" sz="1350" dirty="0"/>
+          </a:p>
+          <a:p>
+            <a:pPr marL="203200" indent="-203200">
+              <a:lnSpc>
+                <a:spcPct val="100000"/>
+              </a:lnSpc>
+              <a:spcAft>
+                <a:spcPts val="900"/>
+              </a:spcAft>
+              <a:buSzPct val="100000"/>
+              <a:buChar char="•"/>
+            </a:pPr>
+            <a:r>
+              <a:rPr lang="en-US" sz="1350" dirty="0">
+                <a:solidFill>
+                  <a:srgbClr val="23262F"/>
                 </a:solidFill>
                 <a:latin typeface="Calibri" pitchFamily="34" charset="0"/>
                 <a:ea typeface="Calibri" pitchFamily="34" charset="-122"/>
                 <a:cs typeface="Calibri" pitchFamily="34" charset="-120"/>
               </a:rPr>
-              <a:t>InternVL3-8B</a:t>
-            </a:r>
-            <a:endParaRPr lang="en-US" sz="1400" dirty="0"/>
-          </a:p>
-        </p:txBody>
-      </p:sp>
-      <p:sp>
-        <p:nvSpPr>
-          <p:cNvPr id="9" name="Shape 6"/>
-          <p:cNvSpPr/>
-          <p:nvPr/>
-        </p:nvSpPr>
-        <p:spPr>
-          <a:xfrm>
-            <a:off x="7763256" y="5943600"/>
-            <a:ext cx="3108960" cy="603504"/>
-          </a:xfrm>
-          <a:prstGeom prst="roundRect">
-            <a:avLst>
-              <a:gd name="adj" fmla="val 12121"/>
-            </a:avLst>
-          </a:prstGeom>
-          <a:solidFill>
-            <a:srgbClr val="F5F6FA"/>
-          </a:solidFill>
-          <a:ln w="12700">
-            <a:solidFill>
-              <a:srgbClr val="E4E6EF"/>
-            </a:solidFill>
-            <a:prstDash val="solid"/>
-          </a:ln>
-        </p:spPr>
-      </p:sp>
-      <p:sp>
-        <p:nvSpPr>
-          <p:cNvPr id="10" name="Text 7">
-            <a:hlinkClick r:id="rId3" tooltip="" action="ppaction://hlinksldjump"/>
-          </p:cNvPr>
-          <p:cNvSpPr/>
-          <p:nvPr/>
-        </p:nvSpPr>
-        <p:spPr>
-          <a:xfrm>
-            <a:off x="7763256" y="5943600"/>
-            <a:ext cx="3108960" cy="603504"/>
-          </a:xfrm>
-          <a:prstGeom prst="rect">
-            <a:avLst/>
-          </a:prstGeom>
-          <a:noFill/>
-          <a:ln/>
-        </p:spPr>
-        <p:txBody>
-          <a:bodyPr wrap="square" lIns="0" tIns="0" rIns="0" bIns="0" rtlCol="0" anchor="ctr"/>
-          <a:lstStyle/>
-          <a:p>
-            <a:pPr algn="ctr" indent="0" marL="0">
-              <a:buNone/>
-            </a:pPr>
-            <a:r>
-              <a:rPr lang="en-US" sz="1400" b="1" u="sng" dirty="0">
-                <a:solidFill>
-                  <a:srgbClr val="1B1F3B"/>
+              <a:t>Fixed effects (socio_attr, lang, gender) = what we estimate.</a:t>
+            </a:r>
+            <a:endParaRPr lang="en-US" sz="1350" dirty="0"/>
+          </a:p>
+          <a:p>
+            <a:pPr marL="203200" indent="-203200">
+              <a:lnSpc>
+                <a:spcPct val="100000"/>
+              </a:lnSpc>
+              <a:spcAft>
+                <a:spcPts val="900"/>
+              </a:spcAft>
+              <a:buSzPct val="100000"/>
+              <a:buChar char="•"/>
+            </a:pPr>
+            <a:r>
+              <a:rPr lang="en-US" sz="1350" dirty="0">
+                <a:solidFill>
+                  <a:srgbClr val="23262F"/>
                 </a:solidFill>
                 <a:latin typeface="Calibri" pitchFamily="34" charset="0"/>
                 <a:ea typeface="Calibri" pitchFamily="34" charset="-122"/>
                 <a:cs typeface="Calibri" pitchFamily="34" charset="-120"/>
-                <a:hlinkClick r:id="rId3" action="ppaction://hlinksldjump" tooltip="">
-                  <a:extLst>
-                    <a:ext uri="{A12FA001-AC4F-418D-AE19-62706E023703}">
-                      <ahyp:hlinkClr xmlns:ahyp="http://schemas.microsoft.com/office/drawing/2018/hyperlinkcolor" val="tx"/>
-                    </a:ext>
-                  </a:extLst>
-                </a:hlinkClick>
-              </a:rPr>
-              <a:t>Both overlaid</a:t>
-            </a:r>
-            <a:endParaRPr lang="en-US" sz="1400" dirty="0"/>
-          </a:p>
-        </p:txBody>
-      </p:sp>
+              </a:rPr>
+              <a:t>Random intercept (1 | item) = each image-pair gets its own baseline — the same item repeats in 7 languages, so those 7 views are not independent.</a:t>
+            </a:r>
+            <a:endParaRPr lang="en-US" sz="1350" dirty="0"/>
+          </a:p>
+        </p:txBody>
+      </p:sp>
+      <p:sp>
+        <p:nvSpPr>
+          <p:cNvPr id="8" name="Text 6"/>
+          <p:cNvSpPr/>
+          <p:nvPr/>
+        </p:nvSpPr>
+        <p:spPr>
+          <a:xfrm>
+            <a:off x="6583680" y="1691640"/>
+            <a:ext cx="4937760" cy="365760"/>
+          </a:xfrm>
+          <a:prstGeom prst="rect">
+            <a:avLst/>
+          </a:prstGeom>
+          <a:noFill/>
+          <a:ln/>
+        </p:spPr>
+        <p:txBody>
+          <a:bodyPr wrap="square" lIns="0" tIns="0" rIns="0" bIns="0" rtlCol="0" anchor="ctr"/>
+          <a:lstStyle/>
+          <a:p>
+            <a:pPr indent="0" marL="0">
+              <a:buNone/>
+            </a:pPr>
+            <a:r>
+              <a:rPr lang="en-US" sz="1600" b="1" dirty="0">
+                <a:solidFill>
+                  <a:srgbClr val="4C72B0"/>
+                </a:solidFill>
+                <a:latin typeface="Georgia" pitchFamily="34" charset="0"/>
+                <a:ea typeface="Georgia" pitchFamily="34" charset="-122"/>
+                <a:cs typeface="Georgia" pitchFamily="34" charset="-120"/>
+              </a:rPr>
+              <a:t>The test  ·  LRT</a:t>
+            </a:r>
+            <a:endParaRPr lang="en-US" sz="1600" dirty="0"/>
+          </a:p>
+        </p:txBody>
+      </p:sp>
+      <p:sp>
+        <p:nvSpPr>
+          <p:cNvPr id="9" name="Text 7"/>
+          <p:cNvSpPr/>
+          <p:nvPr/>
+        </p:nvSpPr>
+        <p:spPr>
+          <a:xfrm>
+            <a:off x="6583680" y="2103120"/>
+            <a:ext cx="4937760" cy="1554480"/>
+          </a:xfrm>
+          <a:prstGeom prst="rect">
+            <a:avLst/>
+          </a:prstGeom>
+          <a:noFill/>
+          <a:ln/>
+        </p:spPr>
+        <p:txBody>
+          <a:bodyPr wrap="square" lIns="0" tIns="0" rIns="0" bIns="0" rtlCol="0" anchor="t"/>
+          <a:lstStyle/>
+          <a:p>
+            <a:pPr marL="203200" indent="-203200">
+              <a:lnSpc>
+                <a:spcPct val="100000"/>
+              </a:lnSpc>
+              <a:spcAft>
+                <a:spcPts val="900"/>
+              </a:spcAft>
+              <a:buSzPct val="100000"/>
+              <a:buChar char="•"/>
+            </a:pPr>
+            <a:r>
+              <a:rPr lang="en-US" sz="1350" dirty="0">
+                <a:solidFill>
+                  <a:srgbClr val="23262F"/>
+                </a:solidFill>
+                <a:latin typeface="Calibri" pitchFamily="34" charset="0"/>
+                <a:ea typeface="Calibri" pitchFamily="34" charset="-122"/>
+                <a:cs typeface="Calibri" pitchFamily="34" charset="-120"/>
+              </a:rPr>
+              <a:t>Fit two nested models (with vs without a factor); compare fit by likelihood.</a:t>
+            </a:r>
+            <a:endParaRPr lang="en-US" sz="1350" dirty="0"/>
+          </a:p>
+          <a:p>
+            <a:pPr marL="203200" indent="-203200">
+              <a:lnSpc>
+                <a:spcPct val="100000"/>
+              </a:lnSpc>
+              <a:spcAft>
+                <a:spcPts val="900"/>
+              </a:spcAft>
+              <a:buSzPct val="100000"/>
+              <a:buChar char="•"/>
+            </a:pPr>
+            <a:r>
+              <a:rPr lang="en-US" sz="1350" dirty="0">
+                <a:solidFill>
+                  <a:srgbClr val="23262F"/>
+                </a:solidFill>
+                <a:latin typeface="Calibri" pitchFamily="34" charset="0"/>
+                <a:ea typeface="Calibri" pitchFamily="34" charset="-122"/>
+                <a:cs typeface="Calibri" pitchFamily="34" charset="-120"/>
+              </a:rPr>
+              <a:t>χ² = 2×(LL_big − LL_small); p from chi-squared → one p-value per whole factor.</a:t>
+            </a:r>
+            <a:endParaRPr lang="en-US" sz="1350" dirty="0"/>
+          </a:p>
+        </p:txBody>
+      </p:sp>
+      <p:graphicFrame>
+        <p:nvGraphicFramePr>
+          <p:cNvPr id="22" name="Table 0"/>
+          <p:cNvGraphicFramePr>
+            <a:graphicFrameLocks noGrp="1"/>
+          </p:cNvGraphicFramePr>
+          <p:nvPr>
+            <p:extLst>
+              <p:ext uri="{D42A27DB-BD31-4B8C-83A1-F6EECF244321}">
+                <p14:modId xmlns:p14="http://schemas.microsoft.com/office/powerpoint/2010/main" val="1579011935"/>
+              </p:ext>
+            </p:extLst>
+          </p:nvPr>
+        </p:nvGraphicFramePr>
+        <p:xfrm>
+          <a:off x="6583680" y="3794760"/>
+          <a:ext cx="4937760" cy="914400"/>
+        </p:xfrm>
+        <a:graphic>
+          <a:graphicData uri="http://schemas.openxmlformats.org/drawingml/2006/table">
+            <a:tbl>
+              <a:tblPr/>
+              <a:tblGrid>
+                <a:gridCol w="1554480"/>
+                <a:gridCol w="914400"/>
+                <a:gridCol w="1280160"/>
+                <a:gridCol w="1188720"/>
+              </a:tblGrid>
+              <a:tr h="420624">
+                <a:tc>
+                  <a:txBody>
+                    <a:bodyPr/>
+                    <a:lstStyle/>
+                    <a:p>
+                      <a:pPr indent="0" marL="0">
+                        <a:buNone/>
+                      </a:pPr>
+                      <a:r>
+                        <a:rPr lang="en-US" sz="1150" b="1" dirty="0">
+                          <a:solidFill>
+                            <a:srgbClr val="FFFFFF"/>
+                          </a:solidFill>
+                          <a:latin typeface="Calibri" pitchFamily="34" charset="0"/>
+                          <a:ea typeface="Calibri" pitchFamily="34" charset="-122"/>
+                          <a:cs typeface="Calibri" pitchFamily="34" charset="-120"/>
+                        </a:rPr>
+                        <a:t>factor</a:t>
+                      </a:r>
+                      <a:endParaRPr lang="en-US" sz="1150" dirty="0">
+                        <a:latin typeface="Calibri" charset="0"/>
+                        <a:ea typeface="Calibri" charset="0"/>
+                        <a:cs typeface="Calibri" charset="0"/>
+                      </a:endParaRPr>
+                    </a:p>
+                  </a:txBody>
+                  <a:tcPr marL="63500" marR="63500" marT="25400" marB="25400" anchor="ctr">
+                    <a:lnL w="6350" cap="flat" cmpd="sng" algn="ctr">
+                      <a:solidFill>
+                        <a:srgbClr val="E4E6EF"/>
+                      </a:solidFill>
+                      <a:prstDash val="solid"/>
+                      <a:round/>
+                      <a:headEnd type="none" w="med" len="med"/>
+                      <a:tailEnd type="none" w="med" len="med"/>
+                    </a:lnL>
+                    <a:lnR w="6350" cap="flat" cmpd="sng" algn="ctr">
+                      <a:solidFill>
+                        <a:srgbClr val="E4E6EF"/>
+                      </a:solidFill>
+                      <a:prstDash val="solid"/>
+                      <a:round/>
+                      <a:headEnd type="none" w="med" len="med"/>
+                      <a:tailEnd type="none" w="med" len="med"/>
+                    </a:lnR>
+                    <a:lnT w="6350" cap="flat" cmpd="sng" algn="ctr">
+                      <a:solidFill>
+                        <a:srgbClr val="E4E6EF"/>
+                      </a:solidFill>
+                      <a:prstDash val="solid"/>
+                      <a:round/>
+                      <a:headEnd type="none" w="med" len="med"/>
+                      <a:tailEnd type="none" w="med" len="med"/>
+                    </a:lnT>
+                    <a:lnB w="6350" cap="flat" cmpd="sng" algn="ctr">
+                      <a:solidFill>
+                        <a:srgbClr val="E4E6EF"/>
+                      </a:solidFill>
+                      <a:prstDash val="solid"/>
+                      <a:round/>
+                      <a:headEnd type="none" w="med" len="med"/>
+                      <a:tailEnd type="none" w="med" len="med"/>
+                    </a:lnB>
+                    <a:solidFill>
+                      <a:srgbClr val="1B1F3B"/>
+                    </a:solidFill>
+                  </a:tcPr>
+                </a:tc>
+                <a:tc>
+                  <a:txBody>
+                    <a:bodyPr/>
+                    <a:lstStyle/>
+                    <a:p>
+                      <a:pPr indent="0" marL="0">
+                        <a:buNone/>
+                      </a:pPr>
+                      <a:r>
+                        <a:rPr lang="en-US" sz="1150" b="1" dirty="0">
+                          <a:solidFill>
+                            <a:srgbClr val="FFFFFF"/>
+                          </a:solidFill>
+                          <a:latin typeface="Calibri" pitchFamily="34" charset="0"/>
+                          <a:ea typeface="Calibri" pitchFamily="34" charset="-122"/>
+                          <a:cs typeface="Calibri" pitchFamily="34" charset="-120"/>
+                        </a:rPr>
+                        <a:t>χ²</a:t>
+                      </a:r>
+                      <a:endParaRPr lang="en-US" sz="1150" dirty="0">
+                        <a:latin typeface="Calibri" charset="0"/>
+                        <a:ea typeface="Calibri" charset="0"/>
+                        <a:cs typeface="Calibri" charset="0"/>
+                      </a:endParaRPr>
+                    </a:p>
+                  </a:txBody>
+                  <a:tcPr marL="63500" marR="63500" marT="25400" marB="25400" anchor="ctr">
+                    <a:lnL w="6350" cap="flat" cmpd="sng" algn="ctr">
+                      <a:solidFill>
+                        <a:srgbClr val="E4E6EF"/>
+                      </a:solidFill>
+                      <a:prstDash val="solid"/>
+                      <a:round/>
+                      <a:headEnd type="none" w="med" len="med"/>
+                      <a:tailEnd type="none" w="med" len="med"/>
+                    </a:lnL>
+                    <a:lnR w="6350" cap="flat" cmpd="sng" algn="ctr">
+                      <a:solidFill>
+                        <a:srgbClr val="E4E6EF"/>
+                      </a:solidFill>
+                      <a:prstDash val="solid"/>
+                      <a:round/>
+                      <a:headEnd type="none" w="med" len="med"/>
+                      <a:tailEnd type="none" w="med" len="med"/>
+                    </a:lnR>
+                    <a:lnT w="6350" cap="flat" cmpd="sng" algn="ctr">
+                      <a:solidFill>
+                        <a:srgbClr val="E4E6EF"/>
+                      </a:solidFill>
+                      <a:prstDash val="solid"/>
+                      <a:round/>
+                      <a:headEnd type="none" w="med" len="med"/>
+                      <a:tailEnd type="none" w="med" len="med"/>
+                    </a:lnT>
+                    <a:lnB w="6350" cap="flat" cmpd="sng" algn="ctr">
+                      <a:solidFill>
+                        <a:srgbClr val="E4E6EF"/>
+                      </a:solidFill>
+                      <a:prstDash val="solid"/>
+                      <a:round/>
+                      <a:headEnd type="none" w="med" len="med"/>
+                      <a:tailEnd type="none" w="med" len="med"/>
+                    </a:lnB>
+                    <a:solidFill>
+                      <a:srgbClr val="1B1F3B"/>
+                    </a:solidFill>
+                  </a:tcPr>
+                </a:tc>
+                <a:tc>
+                  <a:txBody>
+                    <a:bodyPr/>
+                    <a:lstStyle/>
+                    <a:p>
+                      <a:pPr indent="0" marL="0">
+                        <a:buNone/>
+                      </a:pPr>
+                      <a:r>
+                        <a:rPr lang="en-US" sz="1150" b="1" dirty="0">
+                          <a:solidFill>
+                            <a:srgbClr val="FFFFFF"/>
+                          </a:solidFill>
+                          <a:latin typeface="Calibri" pitchFamily="34" charset="0"/>
+                          <a:ea typeface="Calibri" pitchFamily="34" charset="-122"/>
+                          <a:cs typeface="Calibri" pitchFamily="34" charset="-120"/>
+                        </a:rPr>
+                        <a:t>p</a:t>
+                      </a:r>
+                      <a:endParaRPr lang="en-US" sz="1150" dirty="0">
+                        <a:latin typeface="Calibri" charset="0"/>
+                        <a:ea typeface="Calibri" charset="0"/>
+                        <a:cs typeface="Calibri" charset="0"/>
+                      </a:endParaRPr>
+                    </a:p>
+                  </a:txBody>
+                  <a:tcPr marL="63500" marR="63500" marT="25400" marB="25400" anchor="ctr">
+                    <a:lnL w="6350" cap="flat" cmpd="sng" algn="ctr">
+                      <a:solidFill>
+                        <a:srgbClr val="E4E6EF"/>
+                      </a:solidFill>
+                      <a:prstDash val="solid"/>
+                      <a:round/>
+                      <a:headEnd type="none" w="med" len="med"/>
+                      <a:tailEnd type="none" w="med" len="med"/>
+                    </a:lnL>
+                    <a:lnR w="6350" cap="flat" cmpd="sng" algn="ctr">
+                      <a:solidFill>
+                        <a:srgbClr val="E4E6EF"/>
+                      </a:solidFill>
+                      <a:prstDash val="solid"/>
+                      <a:round/>
+                      <a:headEnd type="none" w="med" len="med"/>
+                      <a:tailEnd type="none" w="med" len="med"/>
+                    </a:lnR>
+                    <a:lnT w="6350" cap="flat" cmpd="sng" algn="ctr">
+                      <a:solidFill>
+                        <a:srgbClr val="E4E6EF"/>
+                      </a:solidFill>
+                      <a:prstDash val="solid"/>
+                      <a:round/>
+                      <a:headEnd type="none" w="med" len="med"/>
+                      <a:tailEnd type="none" w="med" len="med"/>
+                    </a:lnT>
+                    <a:lnB w="6350" cap="flat" cmpd="sng" algn="ctr">
+                      <a:solidFill>
+                        <a:srgbClr val="E4E6EF"/>
+                      </a:solidFill>
+                      <a:prstDash val="solid"/>
+                      <a:round/>
+                      <a:headEnd type="none" w="med" len="med"/>
+                      <a:tailEnd type="none" w="med" len="med"/>
+                    </a:lnB>
+                    <a:solidFill>
+                      <a:srgbClr val="1B1F3B"/>
+                    </a:solidFill>
+                  </a:tcPr>
+                </a:tc>
+                <a:tc>
+                  <a:txBody>
+                    <a:bodyPr/>
+                    <a:lstStyle/>
+                    <a:p>
+                      <a:pPr indent="0" marL="0">
+                        <a:buNone/>
+                      </a:pPr>
+                      <a:r>
+                        <a:rPr lang="en-US" sz="1150" b="1" dirty="0">
+                          <a:solidFill>
+                            <a:srgbClr val="FFFFFF"/>
+                          </a:solidFill>
+                          <a:latin typeface="Calibri" pitchFamily="34" charset="0"/>
+                          <a:ea typeface="Calibri" pitchFamily="34" charset="-122"/>
+                          <a:cs typeface="Calibri" pitchFamily="34" charset="-120"/>
+                        </a:rPr>
+                        <a:t>verdict</a:t>
+                      </a:r>
+                      <a:endParaRPr lang="en-US" sz="1150" dirty="0">
+                        <a:latin typeface="Calibri" charset="0"/>
+                        <a:ea typeface="Calibri" charset="0"/>
+                        <a:cs typeface="Calibri" charset="0"/>
+                      </a:endParaRPr>
+                    </a:p>
+                  </a:txBody>
+                  <a:tcPr marL="63500" marR="63500" marT="25400" marB="25400" anchor="ctr">
+                    <a:lnL w="6350" cap="flat" cmpd="sng" algn="ctr">
+                      <a:solidFill>
+                        <a:srgbClr val="E4E6EF"/>
+                      </a:solidFill>
+                      <a:prstDash val="solid"/>
+                      <a:round/>
+                      <a:headEnd type="none" w="med" len="med"/>
+                      <a:tailEnd type="none" w="med" len="med"/>
+                    </a:lnL>
+                    <a:lnR w="6350" cap="flat" cmpd="sng" algn="ctr">
+                      <a:solidFill>
+                        <a:srgbClr val="E4E6EF"/>
+                      </a:solidFill>
+                      <a:prstDash val="solid"/>
+                      <a:round/>
+                      <a:headEnd type="none" w="med" len="med"/>
+                      <a:tailEnd type="none" w="med" len="med"/>
+                    </a:lnR>
+                    <a:lnT w="6350" cap="flat" cmpd="sng" algn="ctr">
+                      <a:solidFill>
+                        <a:srgbClr val="E4E6EF"/>
+                      </a:solidFill>
+                      <a:prstDash val="solid"/>
+                      <a:round/>
+                      <a:headEnd type="none" w="med" len="med"/>
+                      <a:tailEnd type="none" w="med" len="med"/>
+                    </a:lnT>
+                    <a:lnB w="6350" cap="flat" cmpd="sng" algn="ctr">
+                      <a:solidFill>
+                        <a:srgbClr val="E4E6EF"/>
+                      </a:solidFill>
+                      <a:prstDash val="solid"/>
+                      <a:round/>
+                      <a:headEnd type="none" w="med" len="med"/>
+                      <a:tailEnd type="none" w="med" len="med"/>
+                    </a:lnB>
+                    <a:solidFill>
+                      <a:srgbClr val="1B1F3B"/>
+                    </a:solidFill>
+                  </a:tcPr>
+                </a:tc>
+              </a:tr>
+              <a:tr h="420624">
+                <a:tc>
+                  <a:txBody>
+                    <a:bodyPr/>
+                    <a:lstStyle/>
+                    <a:p>
+                      <a:pPr indent="0" marL="0">
+                        <a:buNone/>
+                      </a:pPr>
+                      <a:r>
+                        <a:rPr lang="en-US" sz="1200" b="1" dirty="0">
+                          <a:solidFill>
+                            <a:srgbClr val="23262F"/>
+                          </a:solidFill>
+                          <a:latin typeface="Calibri" pitchFamily="34" charset="0"/>
+                          <a:ea typeface="Calibri" pitchFamily="34" charset="-122"/>
+                          <a:cs typeface="Calibri" pitchFamily="34" charset="-120"/>
+                        </a:rPr>
+                        <a:t>socio_attr</a:t>
+                      </a:r>
+                      <a:endParaRPr lang="en-US" sz="1200" dirty="0">
+                        <a:latin typeface="Calibri" charset="0"/>
+                        <a:ea typeface="Calibri" charset="0"/>
+                        <a:cs typeface="Calibri" charset="0"/>
+                      </a:endParaRPr>
+                    </a:p>
+                  </a:txBody>
+                  <a:tcPr marL="63500" marR="63500" marT="25400" marB="25400" anchor="ctr">
+                    <a:lnL w="6350" cap="flat" cmpd="sng" algn="ctr">
+                      <a:solidFill>
+                        <a:srgbClr val="E4E6EF"/>
+                      </a:solidFill>
+                      <a:prstDash val="solid"/>
+                      <a:round/>
+                      <a:headEnd type="none" w="med" len="med"/>
+                      <a:tailEnd type="none" w="med" len="med"/>
+                    </a:lnL>
+                    <a:lnR w="6350" cap="flat" cmpd="sng" algn="ctr">
+                      <a:solidFill>
+                        <a:srgbClr val="E4E6EF"/>
+                      </a:solidFill>
+                      <a:prstDash val="solid"/>
+                      <a:round/>
+                      <a:headEnd type="none" w="med" len="med"/>
+                      <a:tailEnd type="none" w="med" len="med"/>
+                    </a:lnR>
+                    <a:lnT w="6350" cap="flat" cmpd="sng" algn="ctr">
+                      <a:solidFill>
+                        <a:srgbClr val="E4E6EF"/>
+                      </a:solidFill>
+                      <a:prstDash val="solid"/>
+                      <a:round/>
+                      <a:headEnd type="none" w="med" len="med"/>
+                      <a:tailEnd type="none" w="med" len="med"/>
+                    </a:lnT>
+                    <a:lnB w="6350" cap="flat" cmpd="sng" algn="ctr">
+                      <a:solidFill>
+                        <a:srgbClr val="E4E6EF"/>
+                      </a:solidFill>
+                      <a:prstDash val="solid"/>
+                      <a:round/>
+                      <a:headEnd type="none" w="med" len="med"/>
+                      <a:tailEnd type="none" w="med" len="med"/>
+                    </a:lnB>
+                  </a:tcPr>
+                </a:tc>
+                <a:tc>
+                  <a:txBody>
+                    <a:bodyPr/>
+                    <a:lstStyle/>
+                    <a:p>
+                      <a:pPr indent="0" marL="0">
+                        <a:buNone/>
+                      </a:pPr>
+                      <a:r>
+                        <a:rPr lang="en-US" sz="1200" dirty="0">
+                          <a:solidFill>
+                            <a:srgbClr val="23262F"/>
+                          </a:solidFill>
+                          <a:latin typeface="Calibri" pitchFamily="34" charset="0"/>
+                          <a:ea typeface="Calibri" pitchFamily="34" charset="-122"/>
+                          <a:cs typeface="Calibri" pitchFamily="34" charset="-120"/>
+                        </a:rPr>
+                        <a:t>70.1</a:t>
+                      </a:r>
+                      <a:endParaRPr lang="en-US" sz="1200" dirty="0">
+                        <a:latin typeface="Calibri" charset="0"/>
+                        <a:ea typeface="Calibri" charset="0"/>
+                        <a:cs typeface="Calibri" charset="0"/>
+                      </a:endParaRPr>
+                    </a:p>
+                  </a:txBody>
+                  <a:tcPr marL="63500" marR="63500" marT="25400" marB="25400" anchor="ctr">
+                    <a:lnL w="6350" cap="flat" cmpd="sng" algn="ctr">
+                      <a:solidFill>
+                        <a:srgbClr val="E4E6EF"/>
+                      </a:solidFill>
+                      <a:prstDash val="solid"/>
+                      <a:round/>
+                      <a:headEnd type="none" w="med" len="med"/>
+                      <a:tailEnd type="none" w="med" len="med"/>
+                    </a:lnL>
+                    <a:lnR w="6350" cap="flat" cmpd="sng" algn="ctr">
+                      <a:solidFill>
+                        <a:srgbClr val="E4E6EF"/>
+                      </a:solidFill>
+                      <a:prstDash val="solid"/>
+                      <a:round/>
+                      <a:headEnd type="none" w="med" len="med"/>
+                      <a:tailEnd type="none" w="med" len="med"/>
+                    </a:lnR>
+                    <a:lnT w="6350" cap="flat" cmpd="sng" algn="ctr">
+                      <a:solidFill>
+                        <a:srgbClr val="E4E6EF"/>
+                      </a:solidFill>
+                      <a:prstDash val="solid"/>
+                      <a:round/>
+                      <a:headEnd type="none" w="med" len="med"/>
+                      <a:tailEnd type="none" w="med" len="med"/>
+                    </a:lnT>
+                    <a:lnB w="6350" cap="flat" cmpd="sng" algn="ctr">
+                      <a:solidFill>
+                        <a:srgbClr val="E4E6EF"/>
+                      </a:solidFill>
+                      <a:prstDash val="solid"/>
+                      <a:round/>
+                      <a:headEnd type="none" w="med" len="med"/>
+                      <a:tailEnd type="none" w="med" len="med"/>
+                    </a:lnB>
+                  </a:tcPr>
+                </a:tc>
+                <a:tc>
+                  <a:txBody>
+                    <a:bodyPr/>
+                    <a:lstStyle/>
+                    <a:p>
+                      <a:pPr indent="0" marL="0">
+                        <a:buNone/>
+                      </a:pPr>
+                      <a:r>
+                        <a:rPr lang="en-US" sz="1200" b="1" dirty="0">
+                          <a:solidFill>
+                            <a:srgbClr val="C44E52"/>
+                          </a:solidFill>
+                          <a:latin typeface="Calibri" pitchFamily="34" charset="0"/>
+                          <a:ea typeface="Calibri" pitchFamily="34" charset="-122"/>
+                          <a:cs typeface="Calibri" pitchFamily="34" charset="-120"/>
+                        </a:rPr>
+                        <a:t>2×10⁻¹⁴</a:t>
+                      </a:r>
+                      <a:endParaRPr lang="en-US" sz="1200" dirty="0">
+                        <a:latin typeface="Calibri" charset="0"/>
+                        <a:ea typeface="Calibri" charset="0"/>
+                        <a:cs typeface="Calibri" charset="0"/>
+                      </a:endParaRPr>
+                    </a:p>
+                  </a:txBody>
+                  <a:tcPr marL="63500" marR="63500" marT="25400" marB="25400" anchor="ctr">
+                    <a:lnL w="6350" cap="flat" cmpd="sng" algn="ctr">
+                      <a:solidFill>
+                        <a:srgbClr val="E4E6EF"/>
+                      </a:solidFill>
+                      <a:prstDash val="solid"/>
+                      <a:round/>
+                      <a:headEnd type="none" w="med" len="med"/>
+                      <a:tailEnd type="none" w="med" len="med"/>
+                    </a:lnL>
+                    <a:lnR w="6350" cap="flat" cmpd="sng" algn="ctr">
+                      <a:solidFill>
+                        <a:srgbClr val="E4E6EF"/>
+                      </a:solidFill>
+                      <a:prstDash val="solid"/>
+                      <a:round/>
+                      <a:headEnd type="none" w="med" len="med"/>
+                      <a:tailEnd type="none" w="med" len="med"/>
+                    </a:lnR>
+                    <a:lnT w="6350" cap="flat" cmpd="sng" algn="ctr">
+                      <a:solidFill>
+                        <a:srgbClr val="E4E6EF"/>
+                      </a:solidFill>
+                      <a:prstDash val="solid"/>
+                      <a:round/>
+                      <a:headEnd type="none" w="med" len="med"/>
+                      <a:tailEnd type="none" w="med" len="med"/>
+                    </a:lnT>
+                    <a:lnB w="6350" cap="flat" cmpd="sng" algn="ctr">
+                      <a:solidFill>
+                        <a:srgbClr val="E4E6EF"/>
+                      </a:solidFill>
+                      <a:prstDash val="solid"/>
+                      <a:round/>
+                      <a:headEnd type="none" w="med" len="med"/>
+                      <a:tailEnd type="none" w="med" len="med"/>
+                    </a:lnB>
+                  </a:tcPr>
+                </a:tc>
+                <a:tc>
+                  <a:txBody>
+                    <a:bodyPr/>
+                    <a:lstStyle/>
+                    <a:p>
+                      <a:pPr indent="0" marL="0">
+                        <a:buNone/>
+                      </a:pPr>
+                      <a:r>
+                        <a:rPr lang="en-US" sz="1200" dirty="0">
+                          <a:solidFill>
+                            <a:srgbClr val="C44E52"/>
+                          </a:solidFill>
+                          <a:latin typeface="Calibri" pitchFamily="34" charset="0"/>
+                          <a:ea typeface="Calibri" pitchFamily="34" charset="-122"/>
+                          <a:cs typeface="Calibri" pitchFamily="34" charset="-120"/>
+                        </a:rPr>
+                        <a:t>significant</a:t>
+                      </a:r>
+                      <a:endParaRPr lang="en-US" sz="1200" dirty="0">
+                        <a:latin typeface="Calibri" charset="0"/>
+                        <a:ea typeface="Calibri" charset="0"/>
+                        <a:cs typeface="Calibri" charset="0"/>
+                      </a:endParaRPr>
+                    </a:p>
+                  </a:txBody>
+                  <a:tcPr marL="63500" marR="63500" marT="25400" marB="25400" anchor="ctr">
+                    <a:lnL w="6350" cap="flat" cmpd="sng" algn="ctr">
+                      <a:solidFill>
+                        <a:srgbClr val="E4E6EF"/>
+                      </a:solidFill>
+                      <a:prstDash val="solid"/>
+                      <a:round/>
+                      <a:headEnd type="none" w="med" len="med"/>
+                      <a:tailEnd type="none" w="med" len="med"/>
+                    </a:lnL>
+                    <a:lnR w="6350" cap="flat" cmpd="sng" algn="ctr">
+                      <a:solidFill>
+                        <a:srgbClr val="E4E6EF"/>
+                      </a:solidFill>
+                      <a:prstDash val="solid"/>
+                      <a:round/>
+                      <a:headEnd type="none" w="med" len="med"/>
+                      <a:tailEnd type="none" w="med" len="med"/>
+                    </a:lnR>
+                    <a:lnT w="6350" cap="flat" cmpd="sng" algn="ctr">
+                      <a:solidFill>
+                        <a:srgbClr val="E4E6EF"/>
+                      </a:solidFill>
+                      <a:prstDash val="solid"/>
+                      <a:round/>
+                      <a:headEnd type="none" w="med" len="med"/>
+                      <a:tailEnd type="none" w="med" len="med"/>
+                    </a:lnT>
+                    <a:lnB w="6350" cap="flat" cmpd="sng" algn="ctr">
+                      <a:solidFill>
+                        <a:srgbClr val="E4E6EF"/>
+                      </a:solidFill>
+                      <a:prstDash val="solid"/>
+                      <a:round/>
+                      <a:headEnd type="none" w="med" len="med"/>
+                      <a:tailEnd type="none" w="med" len="med"/>
+                    </a:lnB>
+                  </a:tcPr>
+                </a:tc>
+              </a:tr>
+              <a:tr h="420624">
+                <a:tc>
+                  <a:txBody>
+                    <a:bodyPr/>
+                    <a:lstStyle/>
+                    <a:p>
+                      <a:pPr indent="0" marL="0">
+                        <a:buNone/>
+                      </a:pPr>
+                      <a:r>
+                        <a:rPr lang="en-US" sz="1200" b="1" dirty="0">
+                          <a:solidFill>
+                            <a:srgbClr val="23262F"/>
+                          </a:solidFill>
+                          <a:latin typeface="Calibri" pitchFamily="34" charset="0"/>
+                          <a:ea typeface="Calibri" pitchFamily="34" charset="-122"/>
+                          <a:cs typeface="Calibri" pitchFamily="34" charset="-120"/>
+                        </a:rPr>
+                        <a:t>language</a:t>
+                      </a:r>
+                      <a:endParaRPr lang="en-US" sz="1200" dirty="0">
+                        <a:latin typeface="Calibri" charset="0"/>
+                        <a:ea typeface="Calibri" charset="0"/>
+                        <a:cs typeface="Calibri" charset="0"/>
+                      </a:endParaRPr>
+                    </a:p>
+                  </a:txBody>
+                  <a:tcPr marL="63500" marR="63500" marT="25400" marB="25400" anchor="ctr">
+                    <a:lnL w="6350" cap="flat" cmpd="sng" algn="ctr">
+                      <a:solidFill>
+                        <a:srgbClr val="E4E6EF"/>
+                      </a:solidFill>
+                      <a:prstDash val="solid"/>
+                      <a:round/>
+                      <a:headEnd type="none" w="med" len="med"/>
+                      <a:tailEnd type="none" w="med" len="med"/>
+                    </a:lnL>
+                    <a:lnR w="6350" cap="flat" cmpd="sng" algn="ctr">
+                      <a:solidFill>
+                        <a:srgbClr val="E4E6EF"/>
+                      </a:solidFill>
+                      <a:prstDash val="solid"/>
+                      <a:round/>
+                      <a:headEnd type="none" w="med" len="med"/>
+                      <a:tailEnd type="none" w="med" len="med"/>
+                    </a:lnR>
+                    <a:lnT w="6350" cap="flat" cmpd="sng" algn="ctr">
+                      <a:solidFill>
+                        <a:srgbClr val="E4E6EF"/>
+                      </a:solidFill>
+                      <a:prstDash val="solid"/>
+                      <a:round/>
+                      <a:headEnd type="none" w="med" len="med"/>
+                      <a:tailEnd type="none" w="med" len="med"/>
+                    </a:lnT>
+                    <a:lnB w="6350" cap="flat" cmpd="sng" algn="ctr">
+                      <a:solidFill>
+                        <a:srgbClr val="E4E6EF"/>
+                      </a:solidFill>
+                      <a:prstDash val="solid"/>
+                      <a:round/>
+                      <a:headEnd type="none" w="med" len="med"/>
+                      <a:tailEnd type="none" w="med" len="med"/>
+                    </a:lnB>
+                  </a:tcPr>
+                </a:tc>
+                <a:tc>
+                  <a:txBody>
+                    <a:bodyPr/>
+                    <a:lstStyle/>
+                    <a:p>
+                      <a:pPr indent="0" marL="0">
+                        <a:buNone/>
+                      </a:pPr>
+                      <a:r>
+                        <a:rPr lang="en-US" sz="1200" dirty="0">
+                          <a:solidFill>
+                            <a:srgbClr val="23262F"/>
+                          </a:solidFill>
+                          <a:latin typeface="Calibri" pitchFamily="34" charset="0"/>
+                          <a:ea typeface="Calibri" pitchFamily="34" charset="-122"/>
+                          <a:cs typeface="Calibri" pitchFamily="34" charset="-120"/>
+                        </a:rPr>
+                        <a:t>14.6</a:t>
+                      </a:r>
+                      <a:endParaRPr lang="en-US" sz="1200" dirty="0">
+                        <a:latin typeface="Calibri" charset="0"/>
+                        <a:ea typeface="Calibri" charset="0"/>
+                        <a:cs typeface="Calibri" charset="0"/>
+                      </a:endParaRPr>
+                    </a:p>
+                  </a:txBody>
+                  <a:tcPr marL="63500" marR="63500" marT="25400" marB="25400" anchor="ctr">
+                    <a:lnL w="6350" cap="flat" cmpd="sng" algn="ctr">
+                      <a:solidFill>
+                        <a:srgbClr val="E4E6EF"/>
+                      </a:solidFill>
+                      <a:prstDash val="solid"/>
+                      <a:round/>
+                      <a:headEnd type="none" w="med" len="med"/>
+                      <a:tailEnd type="none" w="med" len="med"/>
+                    </a:lnL>
+                    <a:lnR w="6350" cap="flat" cmpd="sng" algn="ctr">
+                      <a:solidFill>
+                        <a:srgbClr val="E4E6EF"/>
+                      </a:solidFill>
+                      <a:prstDash val="solid"/>
+                      <a:round/>
+                      <a:headEnd type="none" w="med" len="med"/>
+                      <a:tailEnd type="none" w="med" len="med"/>
+                    </a:lnR>
+                    <a:lnT w="6350" cap="flat" cmpd="sng" algn="ctr">
+                      <a:solidFill>
+                        <a:srgbClr val="E4E6EF"/>
+                      </a:solidFill>
+                      <a:prstDash val="solid"/>
+                      <a:round/>
+                      <a:headEnd type="none" w="med" len="med"/>
+                      <a:tailEnd type="none" w="med" len="med"/>
+                    </a:lnT>
+                    <a:lnB w="6350" cap="flat" cmpd="sng" algn="ctr">
+                      <a:solidFill>
+                        <a:srgbClr val="E4E6EF"/>
+                      </a:solidFill>
+                      <a:prstDash val="solid"/>
+                      <a:round/>
+                      <a:headEnd type="none" w="med" len="med"/>
+                      <a:tailEnd type="none" w="med" len="med"/>
+                    </a:lnB>
+                  </a:tcPr>
+                </a:tc>
+                <a:tc>
+                  <a:txBody>
+                    <a:bodyPr/>
+                    <a:lstStyle/>
+                    <a:p>
+                      <a:pPr indent="0" marL="0">
+                        <a:buNone/>
+                      </a:pPr>
+                      <a:r>
+                        <a:rPr lang="en-US" sz="1200" b="1" dirty="0">
+                          <a:solidFill>
+                            <a:srgbClr val="C44E52"/>
+                          </a:solidFill>
+                          <a:latin typeface="Calibri" pitchFamily="34" charset="0"/>
+                          <a:ea typeface="Calibri" pitchFamily="34" charset="-122"/>
+                          <a:cs typeface="Calibri" pitchFamily="34" charset="-120"/>
+                        </a:rPr>
+                        <a:t>0.024</a:t>
+                      </a:r>
+                      <a:endParaRPr lang="en-US" sz="1200" dirty="0">
+                        <a:latin typeface="Calibri" charset="0"/>
+                        <a:ea typeface="Calibri" charset="0"/>
+                        <a:cs typeface="Calibri" charset="0"/>
+                      </a:endParaRPr>
+                    </a:p>
+                  </a:txBody>
+                  <a:tcPr marL="63500" marR="63500" marT="25400" marB="25400" anchor="ctr">
+                    <a:lnL w="6350" cap="flat" cmpd="sng" algn="ctr">
+                      <a:solidFill>
+                        <a:srgbClr val="E4E6EF"/>
+                      </a:solidFill>
+                      <a:prstDash val="solid"/>
+                      <a:round/>
+                      <a:headEnd type="none" w="med" len="med"/>
+                      <a:tailEnd type="none" w="med" len="med"/>
+                    </a:lnL>
+                    <a:lnR w="6350" cap="flat" cmpd="sng" algn="ctr">
+                      <a:solidFill>
+                        <a:srgbClr val="E4E6EF"/>
+                      </a:solidFill>
+                      <a:prstDash val="solid"/>
+                      <a:round/>
+                      <a:headEnd type="none" w="med" len="med"/>
+                      <a:tailEnd type="none" w="med" len="med"/>
+                    </a:lnR>
+                    <a:lnT w="6350" cap="flat" cmpd="sng" algn="ctr">
+                      <a:solidFill>
+                        <a:srgbClr val="E4E6EF"/>
+                      </a:solidFill>
+                      <a:prstDash val="solid"/>
+                      <a:round/>
+                      <a:headEnd type="none" w="med" len="med"/>
+                      <a:tailEnd type="none" w="med" len="med"/>
+                    </a:lnT>
+                    <a:lnB w="6350" cap="flat" cmpd="sng" algn="ctr">
+                      <a:solidFill>
+                        <a:srgbClr val="E4E6EF"/>
+                      </a:solidFill>
+                      <a:prstDash val="solid"/>
+                      <a:round/>
+                      <a:headEnd type="none" w="med" len="med"/>
+                      <a:tailEnd type="none" w="med" len="med"/>
+                    </a:lnB>
+                  </a:tcPr>
+                </a:tc>
+                <a:tc>
+                  <a:txBody>
+                    <a:bodyPr/>
+                    <a:lstStyle/>
+                    <a:p>
+                      <a:pPr indent="0" marL="0">
+                        <a:buNone/>
+                      </a:pPr>
+                      <a:r>
+                        <a:rPr lang="en-US" sz="1200" dirty="0">
+                          <a:solidFill>
+                            <a:srgbClr val="C44E52"/>
+                          </a:solidFill>
+                          <a:latin typeface="Calibri" pitchFamily="34" charset="0"/>
+                          <a:ea typeface="Calibri" pitchFamily="34" charset="-122"/>
+                          <a:cs typeface="Calibri" pitchFamily="34" charset="-120"/>
+                        </a:rPr>
+                        <a:t>significant</a:t>
+                      </a:r>
+                      <a:endParaRPr lang="en-US" sz="1200" dirty="0">
+                        <a:latin typeface="Calibri" charset="0"/>
+                        <a:ea typeface="Calibri" charset="0"/>
+                        <a:cs typeface="Calibri" charset="0"/>
+                      </a:endParaRPr>
+                    </a:p>
+                  </a:txBody>
+                  <a:tcPr marL="63500" marR="63500" marT="25400" marB="25400" anchor="ctr">
+                    <a:lnL w="6350" cap="flat" cmpd="sng" algn="ctr">
+                      <a:solidFill>
+                        <a:srgbClr val="E4E6EF"/>
+                      </a:solidFill>
+                      <a:prstDash val="solid"/>
+                      <a:round/>
+                      <a:headEnd type="none" w="med" len="med"/>
+                      <a:tailEnd type="none" w="med" len="med"/>
+                    </a:lnL>
+                    <a:lnR w="6350" cap="flat" cmpd="sng" algn="ctr">
+                      <a:solidFill>
+                        <a:srgbClr val="E4E6EF"/>
+                      </a:solidFill>
+                      <a:prstDash val="solid"/>
+                      <a:round/>
+                      <a:headEnd type="none" w="med" len="med"/>
+                      <a:tailEnd type="none" w="med" len="med"/>
+                    </a:lnR>
+                    <a:lnT w="6350" cap="flat" cmpd="sng" algn="ctr">
+                      <a:solidFill>
+                        <a:srgbClr val="E4E6EF"/>
+                      </a:solidFill>
+                      <a:prstDash val="solid"/>
+                      <a:round/>
+                      <a:headEnd type="none" w="med" len="med"/>
+                      <a:tailEnd type="none" w="med" len="med"/>
+                    </a:lnT>
+                    <a:lnB w="6350" cap="flat" cmpd="sng" algn="ctr">
+                      <a:solidFill>
+                        <a:srgbClr val="E4E6EF"/>
+                      </a:solidFill>
+                      <a:prstDash val="solid"/>
+                      <a:round/>
+                      <a:headEnd type="none" w="med" len="med"/>
+                      <a:tailEnd type="none" w="med" len="med"/>
+                    </a:lnB>
+                  </a:tcPr>
+                </a:tc>
+              </a:tr>
+              <a:tr h="420624">
+                <a:tc>
+                  <a:txBody>
+                    <a:bodyPr/>
+                    <a:lstStyle/>
+                    <a:p>
+                      <a:pPr indent="0" marL="0">
+                        <a:buNone/>
+                      </a:pPr>
+                      <a:r>
+                        <a:rPr lang="en-US" sz="1200" b="1" dirty="0">
+                          <a:solidFill>
+                            <a:srgbClr val="23262F"/>
+                          </a:solidFill>
+                          <a:latin typeface="Calibri" pitchFamily="34" charset="0"/>
+                          <a:ea typeface="Calibri" pitchFamily="34" charset="-122"/>
+                          <a:cs typeface="Calibri" pitchFamily="34" charset="-120"/>
+                        </a:rPr>
+                        <a:t>attr × lang</a:t>
+                      </a:r>
+                      <a:endParaRPr lang="en-US" sz="1200" dirty="0">
+                        <a:latin typeface="Calibri" charset="0"/>
+                        <a:ea typeface="Calibri" charset="0"/>
+                        <a:cs typeface="Calibri" charset="0"/>
+                      </a:endParaRPr>
+                    </a:p>
+                  </a:txBody>
+                  <a:tcPr marL="63500" marR="63500" marT="25400" marB="25400" anchor="ctr">
+                    <a:lnL w="6350" cap="flat" cmpd="sng" algn="ctr">
+                      <a:solidFill>
+                        <a:srgbClr val="E4E6EF"/>
+                      </a:solidFill>
+                      <a:prstDash val="solid"/>
+                      <a:round/>
+                      <a:headEnd type="none" w="med" len="med"/>
+                      <a:tailEnd type="none" w="med" len="med"/>
+                    </a:lnL>
+                    <a:lnR w="6350" cap="flat" cmpd="sng" algn="ctr">
+                      <a:solidFill>
+                        <a:srgbClr val="E4E6EF"/>
+                      </a:solidFill>
+                      <a:prstDash val="solid"/>
+                      <a:round/>
+                      <a:headEnd type="none" w="med" len="med"/>
+                      <a:tailEnd type="none" w="med" len="med"/>
+                    </a:lnR>
+                    <a:lnT w="6350" cap="flat" cmpd="sng" algn="ctr">
+                      <a:solidFill>
+                        <a:srgbClr val="E4E6EF"/>
+                      </a:solidFill>
+                      <a:prstDash val="solid"/>
+                      <a:round/>
+                      <a:headEnd type="none" w="med" len="med"/>
+                      <a:tailEnd type="none" w="med" len="med"/>
+                    </a:lnT>
+                    <a:lnB w="6350" cap="flat" cmpd="sng" algn="ctr">
+                      <a:solidFill>
+                        <a:srgbClr val="E4E6EF"/>
+                      </a:solidFill>
+                      <a:prstDash val="solid"/>
+                      <a:round/>
+                      <a:headEnd type="none" w="med" len="med"/>
+                      <a:tailEnd type="none" w="med" len="med"/>
+                    </a:lnB>
+                  </a:tcPr>
+                </a:tc>
+                <a:tc>
+                  <a:txBody>
+                    <a:bodyPr/>
+                    <a:lstStyle/>
+                    <a:p>
+                      <a:pPr indent="0" marL="0">
+                        <a:buNone/>
+                      </a:pPr>
+                      <a:r>
+                        <a:rPr lang="en-US" sz="1200" dirty="0">
+                          <a:solidFill>
+                            <a:srgbClr val="23262F"/>
+                          </a:solidFill>
+                          <a:latin typeface="Calibri" pitchFamily="34" charset="0"/>
+                          <a:ea typeface="Calibri" pitchFamily="34" charset="-122"/>
+                          <a:cs typeface="Calibri" pitchFamily="34" charset="-120"/>
+                        </a:rPr>
+                        <a:t>18.8</a:t>
+                      </a:r>
+                      <a:endParaRPr lang="en-US" sz="1200" dirty="0">
+                        <a:latin typeface="Calibri" charset="0"/>
+                        <a:ea typeface="Calibri" charset="0"/>
+                        <a:cs typeface="Calibri" charset="0"/>
+                      </a:endParaRPr>
+                    </a:p>
+                  </a:txBody>
+                  <a:tcPr marL="63500" marR="63500" marT="25400" marB="25400" anchor="ctr">
+                    <a:lnL w="6350" cap="flat" cmpd="sng" algn="ctr">
+                      <a:solidFill>
+                        <a:srgbClr val="E4E6EF"/>
+                      </a:solidFill>
+                      <a:prstDash val="solid"/>
+                      <a:round/>
+                      <a:headEnd type="none" w="med" len="med"/>
+                      <a:tailEnd type="none" w="med" len="med"/>
+                    </a:lnL>
+                    <a:lnR w="6350" cap="flat" cmpd="sng" algn="ctr">
+                      <a:solidFill>
+                        <a:srgbClr val="E4E6EF"/>
+                      </a:solidFill>
+                      <a:prstDash val="solid"/>
+                      <a:round/>
+                      <a:headEnd type="none" w="med" len="med"/>
+                      <a:tailEnd type="none" w="med" len="med"/>
+                    </a:lnR>
+                    <a:lnT w="6350" cap="flat" cmpd="sng" algn="ctr">
+                      <a:solidFill>
+                        <a:srgbClr val="E4E6EF"/>
+                      </a:solidFill>
+                      <a:prstDash val="solid"/>
+                      <a:round/>
+                      <a:headEnd type="none" w="med" len="med"/>
+                      <a:tailEnd type="none" w="med" len="med"/>
+                    </a:lnT>
+                    <a:lnB w="6350" cap="flat" cmpd="sng" algn="ctr">
+                      <a:solidFill>
+                        <a:srgbClr val="E4E6EF"/>
+                      </a:solidFill>
+                      <a:prstDash val="solid"/>
+                      <a:round/>
+                      <a:headEnd type="none" w="med" len="med"/>
+                      <a:tailEnd type="none" w="med" len="med"/>
+                    </a:lnB>
+                  </a:tcPr>
+                </a:tc>
+                <a:tc>
+                  <a:txBody>
+                    <a:bodyPr/>
+                    <a:lstStyle/>
+                    <a:p>
+                      <a:pPr indent="0" marL="0">
+                        <a:buNone/>
+                      </a:pPr>
+                      <a:r>
+                        <a:rPr lang="en-US" sz="1200" dirty="0">
+                          <a:solidFill>
+                            <a:srgbClr val="23262F"/>
+                          </a:solidFill>
+                          <a:latin typeface="Calibri" pitchFamily="34" charset="0"/>
+                          <a:ea typeface="Calibri" pitchFamily="34" charset="-122"/>
+                          <a:cs typeface="Calibri" pitchFamily="34" charset="-120"/>
+                        </a:rPr>
+                        <a:t>0.76</a:t>
+                      </a:r>
+                      <a:endParaRPr lang="en-US" sz="1200" dirty="0">
+                        <a:latin typeface="Calibri" charset="0"/>
+                        <a:ea typeface="Calibri" charset="0"/>
+                        <a:cs typeface="Calibri" charset="0"/>
+                      </a:endParaRPr>
+                    </a:p>
+                  </a:txBody>
+                  <a:tcPr marL="63500" marR="63500" marT="25400" marB="25400" anchor="ctr">
+                    <a:lnL w="6350" cap="flat" cmpd="sng" algn="ctr">
+                      <a:solidFill>
+                        <a:srgbClr val="E4E6EF"/>
+                      </a:solidFill>
+                      <a:prstDash val="solid"/>
+                      <a:round/>
+                      <a:headEnd type="none" w="med" len="med"/>
+                      <a:tailEnd type="none" w="med" len="med"/>
+                    </a:lnL>
+                    <a:lnR w="6350" cap="flat" cmpd="sng" algn="ctr">
+                      <a:solidFill>
+                        <a:srgbClr val="E4E6EF"/>
+                      </a:solidFill>
+                      <a:prstDash val="solid"/>
+                      <a:round/>
+                      <a:headEnd type="none" w="med" len="med"/>
+                      <a:tailEnd type="none" w="med" len="med"/>
+                    </a:lnR>
+                    <a:lnT w="6350" cap="flat" cmpd="sng" algn="ctr">
+                      <a:solidFill>
+                        <a:srgbClr val="E4E6EF"/>
+                      </a:solidFill>
+                      <a:prstDash val="solid"/>
+                      <a:round/>
+                      <a:headEnd type="none" w="med" len="med"/>
+                      <a:tailEnd type="none" w="med" len="med"/>
+                    </a:lnT>
+                    <a:lnB w="6350" cap="flat" cmpd="sng" algn="ctr">
+                      <a:solidFill>
+                        <a:srgbClr val="E4E6EF"/>
+                      </a:solidFill>
+                      <a:prstDash val="solid"/>
+                      <a:round/>
+                      <a:headEnd type="none" w="med" len="med"/>
+                      <a:tailEnd type="none" w="med" len="med"/>
+                    </a:lnB>
+                  </a:tcPr>
+                </a:tc>
+                <a:tc>
+                  <a:txBody>
+                    <a:bodyPr/>
+                    <a:lstStyle/>
+                    <a:p>
+                      <a:pPr indent="0" marL="0">
+                        <a:buNone/>
+                      </a:pPr>
+                      <a:r>
+                        <a:rPr lang="en-US" sz="1200" dirty="0">
+                          <a:solidFill>
+                            <a:srgbClr val="5A6072"/>
+                          </a:solidFill>
+                          <a:latin typeface="Calibri" pitchFamily="34" charset="0"/>
+                          <a:ea typeface="Calibri" pitchFamily="34" charset="-122"/>
+                          <a:cs typeface="Calibri" pitchFamily="34" charset="-120"/>
+                        </a:rPr>
+                        <a:t>n.s.</a:t>
+                      </a:r>
+                      <a:endParaRPr lang="en-US" sz="1200" dirty="0">
+                        <a:latin typeface="Calibri" charset="0"/>
+                        <a:ea typeface="Calibri" charset="0"/>
+                        <a:cs typeface="Calibri" charset="0"/>
+                      </a:endParaRPr>
+                    </a:p>
+                  </a:txBody>
+                  <a:tcPr marL="63500" marR="63500" marT="25400" marB="25400" anchor="ctr">
+                    <a:lnL w="6350" cap="flat" cmpd="sng" algn="ctr">
+                      <a:solidFill>
+                        <a:srgbClr val="E4E6EF"/>
+                      </a:solidFill>
+                      <a:prstDash val="solid"/>
+                      <a:round/>
+                      <a:headEnd type="none" w="med" len="med"/>
+                      <a:tailEnd type="none" w="med" len="med"/>
+                    </a:lnL>
+                    <a:lnR w="6350" cap="flat" cmpd="sng" algn="ctr">
+                      <a:solidFill>
+                        <a:srgbClr val="E4E6EF"/>
+                      </a:solidFill>
+                      <a:prstDash val="solid"/>
+                      <a:round/>
+                      <a:headEnd type="none" w="med" len="med"/>
+                      <a:tailEnd type="none" w="med" len="med"/>
+                    </a:lnR>
+                    <a:lnT w="6350" cap="flat" cmpd="sng" algn="ctr">
+                      <a:solidFill>
+                        <a:srgbClr val="E4E6EF"/>
+                      </a:solidFill>
+                      <a:prstDash val="solid"/>
+                      <a:round/>
+                      <a:headEnd type="none" w="med" len="med"/>
+                      <a:tailEnd type="none" w="med" len="med"/>
+                    </a:lnT>
+                    <a:lnB w="6350" cap="flat" cmpd="sng" algn="ctr">
+                      <a:solidFill>
+                        <a:srgbClr val="E4E6EF"/>
+                      </a:solidFill>
+                      <a:prstDash val="solid"/>
+                      <a:round/>
+                      <a:headEnd type="none" w="med" len="med"/>
+                      <a:tailEnd type="none" w="med" len="med"/>
+                    </a:lnB>
+                  </a:tcPr>
+                </a:tc>
+              </a:tr>
+            </a:tbl>
+          </a:graphicData>
+        </a:graphic>
+      </p:graphicFrame>
       <p:sp>
         <p:nvSpPr>
           <p:cNvPr id="11" name="Text 8"/>
+          <p:cNvSpPr/>
+          <p:nvPr/>
+        </p:nvSpPr>
+        <p:spPr>
+          <a:xfrm>
+            <a:off x="6583680" y="5806440"/>
+            <a:ext cx="4937760" cy="274320"/>
+          </a:xfrm>
+          <a:prstGeom prst="rect">
+            <a:avLst/>
+          </a:prstGeom>
+          <a:noFill/>
+          <a:ln/>
+        </p:spPr>
+        <p:txBody>
+          <a:bodyPr wrap="square" lIns="0" tIns="0" rIns="0" bIns="0" rtlCol="0" anchor="ctr"/>
+          <a:lstStyle/>
+          <a:p>
+            <a:pPr algn="ctr" indent="0" marL="0">
+              <a:buNone/>
+            </a:pPr>
+            <a:r>
+              <a:rPr lang="en-US" sz="1050" i="1" dirty="0">
+                <a:solidFill>
+                  <a:srgbClr val="9AA0B0"/>
+                </a:solidFill>
+                <a:latin typeface="Calibri" pitchFamily="34" charset="0"/>
+                <a:ea typeface="Calibri" pitchFamily="34" charset="-122"/>
+                <a:cs typeface="Calibri" pitchFamily="34" charset="-120"/>
+              </a:rPr>
+              <a:t>Qwen-7B; same pattern in InternVL3-8B. Implemented with item-clustered robust SEs (no statsmodels on the cluster).</a:t>
+            </a:r>
+            <a:endParaRPr lang="en-US" sz="1050" dirty="0"/>
+          </a:p>
+        </p:txBody>
+      </p:sp>
+      <p:sp>
+        <p:nvSpPr>
+          <p:cNvPr id="12" name="Text 9"/>
           <p:cNvSpPr/>
           <p:nvPr/>
         </p:nvSpPr>
@@ -11177,13 +12985,13 @@
             <a:r>
               <a:rPr lang="en-US" sz="1200" b="1" spc="300" kern="0" dirty="0">
                 <a:solidFill>
-                  <a:srgbClr val="C44E52"/>
+                  <a:srgbClr val="9AA0B0"/>
                 </a:solidFill>
                 <a:latin typeface="Calibri" pitchFamily="34" charset="0"/>
                 <a:ea typeface="Calibri" pitchFamily="34" charset="-122"/>
                 <a:cs typeface="Calibri" pitchFamily="34" charset="-120"/>
               </a:rPr>
-              <a:t>INTERACTIVE · MODEL EXPLORER</a:t>
+              <a:t>BACKUP · METHODS</a:t>
             </a:r>
             <a:endParaRPr lang="en-US" sz="1200" dirty="0"/>
           </a:p>
@@ -11212,12 +13020,12 @@
           <a:p>
             <a:pPr indent="0" marL="0">
               <a:lnSpc>
-                <a:spcPts val="2700"/>
+                <a:spcPts val="2808"/>
               </a:lnSpc>
               <a:buNone/>
             </a:pPr>
             <a:r>
-              <a:rPr lang="en-US" sz="2500" b="1" dirty="0">
+              <a:rPr lang="en-US" sz="2600" b="1" dirty="0">
                 <a:solidFill>
                   <a:srgbClr val="23262F"/>
                 </a:solidFill>
@@ -11225,50 +13033,65 @@
                 <a:ea typeface="Georgia" pitchFamily="34" charset="-122"/>
                 <a:cs typeface="Georgia" pitchFamily="34" charset="-120"/>
               </a:rPr>
-              <a:t>Does it hold across models?  ▸ click a button</a:t>
-            </a:r>
-            <a:endParaRPr lang="en-US" sz="2500" dirty="0"/>
-          </a:p>
-        </p:txBody>
-      </p:sp>
-      <p:pic>
-        <p:nvPicPr>
-          <p:cNvPr id="4" name="Image 0" descr="/Users/xiaochuan/Desktop/Projects/P5_Multi_linguistic_histoBias/v3/experiments/exp3a_mixed_effects/figures/figE_cross_model_OR.png">    </p:cNvPr>
-          <p:cNvPicPr>
-            <a:picLocks noChangeAspect="1"/>
-          </p:cNvPicPr>
-          <p:nvPr/>
-        </p:nvPicPr>
-        <p:blipFill>
-          <a:blip r:embed="rId1"/>
-          <a:stretch>
-            <a:fillRect/>
-          </a:stretch>
-        </p:blipFill>
-        <p:spPr>
-          <a:xfrm>
-            <a:off x="1709928" y="1737360"/>
-            <a:ext cx="8778240" cy="3364599"/>
+              <a:t>Back-translation translation-quality check</a:t>
+            </a:r>
+            <a:endParaRPr lang="en-US" sz="2600" dirty="0"/>
+          </a:p>
+        </p:txBody>
+      </p:sp>
+      <p:sp>
+        <p:nvSpPr>
+          <p:cNvPr id="4" name="Text 2"/>
+          <p:cNvSpPr/>
+          <p:nvPr/>
+        </p:nvSpPr>
+        <p:spPr>
+          <a:xfrm>
+            <a:off x="685800" y="1645920"/>
+            <a:ext cx="10820095" cy="365760"/>
           </a:xfrm>
           <a:prstGeom prst="rect">
             <a:avLst/>
           </a:prstGeom>
-        </p:spPr>
-      </p:pic>
-      <p:sp>
-        <p:nvSpPr>
-          <p:cNvPr id="5" name="Shape 2"/>
-          <p:cNvSpPr/>
-          <p:nvPr/>
-        </p:nvSpPr>
-        <p:spPr>
-          <a:xfrm>
-            <a:off x="1325880" y="5943600"/>
-            <a:ext cx="3108960" cy="603504"/>
+          <a:noFill/>
+          <a:ln/>
+        </p:spPr>
+        <p:txBody>
+          <a:bodyPr wrap="square" lIns="0" tIns="0" rIns="0" bIns="0" rtlCol="0" anchor="ctr"/>
+          <a:lstStyle/>
+          <a:p>
+            <a:pPr indent="0" marL="0">
+              <a:buNone/>
+            </a:pPr>
+            <a:r>
+              <a:rPr lang="en-US" sz="1500" i="1" dirty="0">
+                <a:solidFill>
+                  <a:srgbClr val="5A6072"/>
+                </a:solidFill>
+                <a:latin typeface="Calibri" pitchFamily="34" charset="0"/>
+                <a:ea typeface="Calibri" pitchFamily="34" charset="-122"/>
+                <a:cs typeface="Calibri" pitchFamily="34" charset="-120"/>
+              </a:rPr>
+              <a:t>We can't read all 7 languages — so we round-trip each prompt back to English and measure how much it drifted.</a:t>
+            </a:r>
+            <a:endParaRPr lang="en-US" sz="1500" dirty="0"/>
+          </a:p>
+        </p:txBody>
+      </p:sp>
+      <p:sp>
+        <p:nvSpPr>
+          <p:cNvPr id="5" name="Shape 3"/>
+          <p:cNvSpPr/>
+          <p:nvPr/>
+        </p:nvSpPr>
+        <p:spPr>
+          <a:xfrm>
+            <a:off x="685800" y="2286000"/>
+            <a:ext cx="2468880" cy="868680"/>
           </a:xfrm>
           <a:prstGeom prst="roundRect">
             <a:avLst>
-              <a:gd name="adj" fmla="val 12121"/>
+              <a:gd name="adj" fmla="val 8421"/>
             </a:avLst>
           </a:prstGeom>
           <a:solidFill>
@@ -11284,7 +13107,757 @@
       </p:sp>
       <p:sp>
         <p:nvSpPr>
-          <p:cNvPr id="6" name="Text 3">
+          <p:cNvPr id="6" name="Text 4"/>
+          <p:cNvSpPr/>
+          <p:nvPr/>
+        </p:nvSpPr>
+        <p:spPr>
+          <a:xfrm>
+            <a:off x="685800" y="2286000"/>
+            <a:ext cx="2468880" cy="868680"/>
+          </a:xfrm>
+          <a:prstGeom prst="rect">
+            <a:avLst/>
+          </a:prstGeom>
+          <a:noFill/>
+          <a:ln/>
+        </p:spPr>
+        <p:txBody>
+          <a:bodyPr wrap="square" lIns="25400" tIns="25400" rIns="25400" bIns="25400" rtlCol="0" anchor="ctr"/>
+          <a:lstStyle/>
+          <a:p>
+            <a:pPr algn="ctr" indent="0" marL="0">
+              <a:buNone/>
+            </a:pPr>
+            <a:r>
+              <a:rPr lang="en-US" sz="1300" b="1" dirty="0">
+                <a:solidFill>
+                  <a:srgbClr val="23262F"/>
+                </a:solidFill>
+                <a:latin typeface="Calibri" pitchFamily="34" charset="0"/>
+                <a:ea typeface="Calibri" pitchFamily="34" charset="-122"/>
+                <a:cs typeface="Calibri" pitchFamily="34" charset="-120"/>
+              </a:rPr>
+              <a:t>English prompt</a:t>
+            </a:r>
+            <a:endParaRPr lang="en-US" sz="1300" dirty="0"/>
+          </a:p>
+          <a:p>
+            <a:pPr algn="ctr" indent="0" marL="0">
+              <a:buNone/>
+            </a:pPr>
+            <a:r>
+              <a:rPr lang="en-US" sz="1050" dirty="0">
+                <a:solidFill>
+                  <a:srgbClr val="5A6072"/>
+                </a:solidFill>
+                <a:latin typeface="Calibri" pitchFamily="34" charset="0"/>
+                <a:ea typeface="Calibri" pitchFamily="34" charset="-122"/>
+                <a:cs typeface="Calibri" pitchFamily="34" charset="-120"/>
+              </a:rPr>
+              <a:t>original E</a:t>
+            </a:r>
+            <a:endParaRPr lang="en-US" sz="1300" dirty="0"/>
+          </a:p>
+        </p:txBody>
+      </p:sp>
+      <p:sp>
+        <p:nvSpPr>
+          <p:cNvPr id="7" name="Shape 5"/>
+          <p:cNvSpPr/>
+          <p:nvPr/>
+        </p:nvSpPr>
+        <p:spPr>
+          <a:xfrm>
+            <a:off x="3246120" y="2715768"/>
+            <a:ext cx="502920" cy="0"/>
+          </a:xfrm>
+          <a:prstGeom prst="line">
+            <a:avLst/>
+          </a:prstGeom>
+          <a:noFill/>
+          <a:ln w="25400">
+            <a:solidFill>
+              <a:srgbClr val="C44E52"/>
+            </a:solidFill>
+            <a:prstDash val="solid"/>
+            <a:tailEnd type="triangle"/>
+          </a:ln>
+        </p:spPr>
+      </p:sp>
+      <p:sp>
+        <p:nvSpPr>
+          <p:cNvPr id="8" name="Text 6"/>
+          <p:cNvSpPr/>
+          <p:nvPr/>
+        </p:nvSpPr>
+        <p:spPr>
+          <a:xfrm>
+            <a:off x="3017520" y="2331720"/>
+            <a:ext cx="960120" cy="274320"/>
+          </a:xfrm>
+          <a:prstGeom prst="rect">
+            <a:avLst/>
+          </a:prstGeom>
+          <a:noFill/>
+          <a:ln/>
+        </p:spPr>
+        <p:txBody>
+          <a:bodyPr wrap="square" lIns="0" tIns="0" rIns="0" bIns="0" rtlCol="0" anchor="ctr"/>
+          <a:lstStyle/>
+          <a:p>
+            <a:pPr algn="ctr" indent="0" marL="0">
+              <a:buNone/>
+            </a:pPr>
+            <a:r>
+              <a:rPr lang="en-US" sz="1000" i="1" dirty="0">
+                <a:solidFill>
+                  <a:srgbClr val="C44E52"/>
+                </a:solidFill>
+                <a:latin typeface="Calibri" pitchFamily="34" charset="0"/>
+                <a:ea typeface="Calibri" pitchFamily="34" charset="-122"/>
+                <a:cs typeface="Calibri" pitchFamily="34" charset="-120"/>
+              </a:rPr>
+              <a:t>translate</a:t>
+            </a:r>
+            <a:endParaRPr lang="en-US" sz="1000" dirty="0"/>
+          </a:p>
+        </p:txBody>
+      </p:sp>
+      <p:sp>
+        <p:nvSpPr>
+          <p:cNvPr id="9" name="Shape 7"/>
+          <p:cNvSpPr/>
+          <p:nvPr/>
+        </p:nvSpPr>
+        <p:spPr>
+          <a:xfrm>
+            <a:off x="3886200" y="2286000"/>
+            <a:ext cx="2468880" cy="868680"/>
+          </a:xfrm>
+          <a:prstGeom prst="roundRect">
+            <a:avLst>
+              <a:gd name="adj" fmla="val 8421"/>
+            </a:avLst>
+          </a:prstGeom>
+          <a:solidFill>
+            <a:srgbClr val="F5F6FA"/>
+          </a:solidFill>
+          <a:ln w="12700">
+            <a:solidFill>
+              <a:srgbClr val="E4E6EF"/>
+            </a:solidFill>
+            <a:prstDash val="solid"/>
+          </a:ln>
+        </p:spPr>
+      </p:sp>
+      <p:sp>
+        <p:nvSpPr>
+          <p:cNvPr id="10" name="Text 8"/>
+          <p:cNvSpPr/>
+          <p:nvPr/>
+        </p:nvSpPr>
+        <p:spPr>
+          <a:xfrm>
+            <a:off x="3886200" y="2286000"/>
+            <a:ext cx="2468880" cy="868680"/>
+          </a:xfrm>
+          <a:prstGeom prst="rect">
+            <a:avLst/>
+          </a:prstGeom>
+          <a:noFill/>
+          <a:ln/>
+        </p:spPr>
+        <p:txBody>
+          <a:bodyPr wrap="square" lIns="25400" tIns="25400" rIns="25400" bIns="25400" rtlCol="0" anchor="ctr"/>
+          <a:lstStyle/>
+          <a:p>
+            <a:pPr algn="ctr" indent="0" marL="0">
+              <a:buNone/>
+            </a:pPr>
+            <a:r>
+              <a:rPr lang="en-US" sz="1300" b="1" dirty="0">
+                <a:solidFill>
+                  <a:srgbClr val="23262F"/>
+                </a:solidFill>
+                <a:latin typeface="Calibri" pitchFamily="34" charset="0"/>
+                <a:ea typeface="Calibri" pitchFamily="34" charset="-122"/>
+                <a:cs typeface="Calibri" pitchFamily="34" charset="-120"/>
+              </a:rPr>
+              <a:t>Greek text</a:t>
+            </a:r>
+            <a:endParaRPr lang="en-US" sz="1300" dirty="0"/>
+          </a:p>
+          <a:p>
+            <a:pPr algn="ctr" indent="0" marL="0">
+              <a:buNone/>
+            </a:pPr>
+            <a:r>
+              <a:rPr lang="en-US" sz="1050" dirty="0">
+                <a:solidFill>
+                  <a:srgbClr val="5A6072"/>
+                </a:solidFill>
+                <a:latin typeface="Calibri" pitchFamily="34" charset="0"/>
+                <a:ea typeface="Calibri" pitchFamily="34" charset="-122"/>
+                <a:cs typeface="Calibri" pitchFamily="34" charset="-120"/>
+              </a:rPr>
+              <a:t>shown to the model</a:t>
+            </a:r>
+            <a:endParaRPr lang="en-US" sz="1300" dirty="0"/>
+          </a:p>
+        </p:txBody>
+      </p:sp>
+      <p:sp>
+        <p:nvSpPr>
+          <p:cNvPr id="11" name="Shape 9"/>
+          <p:cNvSpPr/>
+          <p:nvPr/>
+        </p:nvSpPr>
+        <p:spPr>
+          <a:xfrm>
+            <a:off x="6446520" y="2715768"/>
+            <a:ext cx="502920" cy="0"/>
+          </a:xfrm>
+          <a:prstGeom prst="line">
+            <a:avLst/>
+          </a:prstGeom>
+          <a:noFill/>
+          <a:ln w="25400">
+            <a:solidFill>
+              <a:srgbClr val="C44E52"/>
+            </a:solidFill>
+            <a:prstDash val="solid"/>
+            <a:tailEnd type="triangle"/>
+          </a:ln>
+        </p:spPr>
+      </p:sp>
+      <p:sp>
+        <p:nvSpPr>
+          <p:cNvPr id="12" name="Text 10"/>
+          <p:cNvSpPr/>
+          <p:nvPr/>
+        </p:nvSpPr>
+        <p:spPr>
+          <a:xfrm>
+            <a:off x="6217920" y="2331720"/>
+            <a:ext cx="960120" cy="274320"/>
+          </a:xfrm>
+          <a:prstGeom prst="rect">
+            <a:avLst/>
+          </a:prstGeom>
+          <a:noFill/>
+          <a:ln/>
+        </p:spPr>
+        <p:txBody>
+          <a:bodyPr wrap="square" lIns="0" tIns="0" rIns="0" bIns="0" rtlCol="0" anchor="ctr"/>
+          <a:lstStyle/>
+          <a:p>
+            <a:pPr algn="ctr" indent="0" marL="0">
+              <a:buNone/>
+            </a:pPr>
+            <a:r>
+              <a:rPr lang="en-US" sz="1000" i="1" dirty="0">
+                <a:solidFill>
+                  <a:srgbClr val="C44E52"/>
+                </a:solidFill>
+                <a:latin typeface="Calibri" pitchFamily="34" charset="0"/>
+                <a:ea typeface="Calibri" pitchFamily="34" charset="-122"/>
+                <a:cs typeface="Calibri" pitchFamily="34" charset="-120"/>
+              </a:rPr>
+              <a:t>back-translate</a:t>
+            </a:r>
+            <a:endParaRPr lang="en-US" sz="1000" dirty="0"/>
+          </a:p>
+        </p:txBody>
+      </p:sp>
+      <p:sp>
+        <p:nvSpPr>
+          <p:cNvPr id="13" name="Shape 11"/>
+          <p:cNvSpPr/>
+          <p:nvPr/>
+        </p:nvSpPr>
+        <p:spPr>
+          <a:xfrm>
+            <a:off x="7086600" y="2286000"/>
+            <a:ext cx="2468880" cy="868680"/>
+          </a:xfrm>
+          <a:prstGeom prst="roundRect">
+            <a:avLst>
+              <a:gd name="adj" fmla="val 8421"/>
+            </a:avLst>
+          </a:prstGeom>
+          <a:solidFill>
+            <a:srgbClr val="F5F6FA"/>
+          </a:solidFill>
+          <a:ln w="12700">
+            <a:solidFill>
+              <a:srgbClr val="E4E6EF"/>
+            </a:solidFill>
+            <a:prstDash val="solid"/>
+          </a:ln>
+        </p:spPr>
+      </p:sp>
+      <p:sp>
+        <p:nvSpPr>
+          <p:cNvPr id="14" name="Text 12"/>
+          <p:cNvSpPr/>
+          <p:nvPr/>
+        </p:nvSpPr>
+        <p:spPr>
+          <a:xfrm>
+            <a:off x="7086600" y="2286000"/>
+            <a:ext cx="2468880" cy="868680"/>
+          </a:xfrm>
+          <a:prstGeom prst="rect">
+            <a:avLst/>
+          </a:prstGeom>
+          <a:noFill/>
+          <a:ln/>
+        </p:spPr>
+        <p:txBody>
+          <a:bodyPr wrap="square" lIns="25400" tIns="25400" rIns="25400" bIns="25400" rtlCol="0" anchor="ctr"/>
+          <a:lstStyle/>
+          <a:p>
+            <a:pPr algn="ctr" indent="0" marL="0">
+              <a:buNone/>
+            </a:pPr>
+            <a:r>
+              <a:rPr lang="en-US" sz="1300" b="1" dirty="0">
+                <a:solidFill>
+                  <a:srgbClr val="23262F"/>
+                </a:solidFill>
+                <a:latin typeface="Calibri" pitchFamily="34" charset="0"/>
+                <a:ea typeface="Calibri" pitchFamily="34" charset="-122"/>
+                <a:cs typeface="Calibri" pitchFamily="34" charset="-120"/>
+              </a:rPr>
+              <a:t>English again</a:t>
+            </a:r>
+            <a:endParaRPr lang="en-US" sz="1300" dirty="0"/>
+          </a:p>
+          <a:p>
+            <a:pPr algn="ctr" indent="0" marL="0">
+              <a:buNone/>
+            </a:pPr>
+            <a:r>
+              <a:rPr lang="en-US" sz="1050" dirty="0">
+                <a:solidFill>
+                  <a:srgbClr val="5A6072"/>
+                </a:solidFill>
+                <a:latin typeface="Calibri" pitchFamily="34" charset="0"/>
+                <a:ea typeface="Calibri" pitchFamily="34" charset="-122"/>
+                <a:cs typeface="Calibri" pitchFamily="34" charset="-120"/>
+              </a:rPr>
+              <a:t>E′</a:t>
+            </a:r>
+            <a:endParaRPr lang="en-US" sz="1300" dirty="0"/>
+          </a:p>
+        </p:txBody>
+      </p:sp>
+      <p:sp>
+        <p:nvSpPr>
+          <p:cNvPr id="15" name="Text 13"/>
+          <p:cNvSpPr/>
+          <p:nvPr/>
+        </p:nvSpPr>
+        <p:spPr>
+          <a:xfrm>
+            <a:off x="9738360" y="2286000"/>
+            <a:ext cx="2103120" cy="868680"/>
+          </a:xfrm>
+          <a:prstGeom prst="rect">
+            <a:avLst/>
+          </a:prstGeom>
+          <a:noFill/>
+          <a:ln/>
+        </p:spPr>
+        <p:txBody>
+          <a:bodyPr wrap="square" lIns="0" tIns="0" rIns="0" bIns="0" rtlCol="0" anchor="ctr"/>
+          <a:lstStyle/>
+          <a:p>
+            <a:pPr algn="ctr" indent="0" marL="0">
+              <a:buNone/>
+            </a:pPr>
+            <a:r>
+              <a:rPr lang="en-US" sz="1300" b="1" dirty="0">
+                <a:solidFill>
+                  <a:srgbClr val="1B1F3B"/>
+                </a:solidFill>
+                <a:latin typeface="Georgia" pitchFamily="34" charset="0"/>
+                <a:ea typeface="Georgia" pitchFamily="34" charset="-122"/>
+                <a:cs typeface="Georgia" pitchFamily="34" charset="-120"/>
+              </a:rPr>
+              <a:t>compare  E vs E′  →  token-F1</a:t>
+            </a:r>
+            <a:endParaRPr lang="en-US" sz="1300" dirty="0"/>
+          </a:p>
+        </p:txBody>
+      </p:sp>
+      <p:sp>
+        <p:nvSpPr>
+          <p:cNvPr id="16" name="Text 14"/>
+          <p:cNvSpPr/>
+          <p:nvPr/>
+        </p:nvSpPr>
+        <p:spPr>
+          <a:xfrm>
+            <a:off x="685800" y="3657600"/>
+            <a:ext cx="10820095" cy="2377440"/>
+          </a:xfrm>
+          <a:prstGeom prst="rect">
+            <a:avLst/>
+          </a:prstGeom>
+          <a:noFill/>
+          <a:ln/>
+        </p:spPr>
+        <p:txBody>
+          <a:bodyPr wrap="square" lIns="0" tIns="0" rIns="0" bIns="0" rtlCol="0" anchor="t"/>
+          <a:lstStyle/>
+          <a:p>
+            <a:pPr marL="203200" indent="-203200">
+              <a:lnSpc>
+                <a:spcPct val="100000"/>
+              </a:lnSpc>
+              <a:spcAft>
+                <a:spcPts val="1100"/>
+              </a:spcAft>
+              <a:buSzPct val="100000"/>
+              <a:buChar char="•"/>
+            </a:pPr>
+            <a:r>
+              <a:rPr lang="en-US" sz="1450" dirty="0">
+                <a:solidFill>
+                  <a:srgbClr val="23262F"/>
+                </a:solidFill>
+                <a:latin typeface="Calibri" pitchFamily="34" charset="0"/>
+                <a:ea typeface="Calibri" pitchFamily="34" charset="-122"/>
+                <a:cs typeface="Calibri" pitchFamily="34" charset="-120"/>
+              </a:rPr>
+              <a:t>If the language effect were a translation artifact, the most-biased languages would drift the MOST.</a:t>
+            </a:r>
+            <a:endParaRPr lang="en-US" sz="1450" dirty="0"/>
+          </a:p>
+          <a:p>
+            <a:pPr marL="203200" indent="-203200">
+              <a:lnSpc>
+                <a:spcPct val="100000"/>
+              </a:lnSpc>
+              <a:spcAft>
+                <a:spcPts val="1100"/>
+              </a:spcAft>
+              <a:buSzPct val="100000"/>
+              <a:buChar char="•"/>
+            </a:pPr>
+            <a:r>
+              <a:rPr lang="en-US" sz="1450" dirty="0">
+                <a:solidFill>
+                  <a:srgbClr val="23262F"/>
+                </a:solidFill>
+                <a:latin typeface="Calibri" pitchFamily="34" charset="0"/>
+                <a:ea typeface="Calibri" pitchFamily="34" charset="-122"/>
+                <a:cs typeface="Calibri" pitchFamily="34" charset="-120"/>
+              </a:rPr>
+              <a:t>Instead the opposite: Greek (0.88) and Bengali (0.86) — the most biased — have the HIGHEST fidelity; Hindi / Russian (0.79) — not biased — the lowest.</a:t>
+            </a:r>
+            <a:endParaRPr lang="en-US" sz="1450" dirty="0"/>
+          </a:p>
+          <a:p>
+            <a:pPr marL="203200" indent="-203200">
+              <a:lnSpc>
+                <a:spcPct val="100000"/>
+              </a:lnSpc>
+              <a:spcAft>
+                <a:spcPts val="1100"/>
+              </a:spcAft>
+              <a:buSzPct val="100000"/>
+              <a:buChar char="•"/>
+            </a:pPr>
+            <a:r>
+              <a:rPr lang="en-US" sz="1450" dirty="0">
+                <a:solidFill>
+                  <a:srgbClr val="23262F"/>
+                </a:solidFill>
+                <a:latin typeface="Calibri" pitchFamily="34" charset="0"/>
+                <a:ea typeface="Calibri" pitchFamily="34" charset="-122"/>
+                <a:cs typeface="Calibri" pitchFamily="34" charset="-120"/>
+              </a:rPr>
+              <a:t>Caveat: a lexical check using the same MT system — a sanity check that rules out the obvious confound, not a proof.</a:t>
+            </a:r>
+            <a:endParaRPr lang="en-US" sz="1450" dirty="0"/>
+          </a:p>
+        </p:txBody>
+      </p:sp>
+      <p:sp>
+        <p:nvSpPr>
+          <p:cNvPr id="17" name="Text 15"/>
+          <p:cNvSpPr/>
+          <p:nvPr/>
+        </p:nvSpPr>
+        <p:spPr>
+          <a:xfrm>
+            <a:off x="11551615" y="6400800"/>
+            <a:ext cx="365760" cy="274320"/>
+          </a:xfrm>
+          <a:prstGeom prst="rect">
+            <a:avLst/>
+          </a:prstGeom>
+          <a:noFill/>
+          <a:ln/>
+        </p:spPr>
+        <p:txBody>
+          <a:bodyPr wrap="square" lIns="0" tIns="0" rIns="0" bIns="0" rtlCol="0" anchor="ctr"/>
+          <a:lstStyle/>
+          <a:p>
+            <a:pPr algn="r" indent="0" marL="0">
+              <a:buNone/>
+            </a:pPr>
+            <a:r>
+              <a:rPr lang="en-US" sz="1000" dirty="0">
+                <a:solidFill>
+                  <a:srgbClr val="9AA0B0"/>
+                </a:solidFill>
+                <a:latin typeface="Calibri" pitchFamily="34" charset="0"/>
+                <a:ea typeface="Calibri" pitchFamily="34" charset="-122"/>
+                <a:cs typeface="Calibri" pitchFamily="34" charset="-120"/>
+              </a:rPr>
+              <a:t>22</a:t>
+            </a:r>
+            <a:endParaRPr lang="en-US" sz="1000" dirty="0"/>
+          </a:p>
+        </p:txBody>
+      </p:sp>
+    </p:spTree>
+  </p:cSld>
+  <p:clrMapOvr>
+    <a:masterClrMapping/>
+  </p:clrMapOvr>
+</p:sld>
+</file>
+
+<file path=ppt/slides/slide23.xml><?xml version="1.0" encoding="utf-8"?>
+<p:sld xmlns:a="http://schemas.openxmlformats.org/drawingml/2006/main" xmlns:r="http://schemas.openxmlformats.org/officeDocument/2006/relationships" xmlns:p="http://schemas.openxmlformats.org/presentationml/2006/main">
+  <p:cSld name="Slide 23">
+    <p:bg>
+      <p:bgPr>
+        <a:solidFill>
+          <a:srgbClr val="FFFFFF"/>
+        </a:solidFill>
+      </p:bgPr>
+    </p:bg>
+    <p:spTree>
+      <p:nvGrpSpPr>
+        <p:cNvPr id="1" name=""/>
+        <p:cNvGrpSpPr/>
+        <p:nvPr/>
+      </p:nvGrpSpPr>
+      <p:grpSpPr>
+        <a:xfrm>
+          <a:off x="0" y="0"/>
+          <a:ext cx="0" cy="0"/>
+          <a:chOff x="0" y="0"/>
+          <a:chExt cx="0" cy="0"/>
+        </a:xfrm>
+      </p:grpSpPr>
+      <p:sp>
+        <p:nvSpPr>
+          <p:cNvPr id="2" name="Text 0"/>
+          <p:cNvSpPr/>
+          <p:nvPr/>
+        </p:nvSpPr>
+        <p:spPr>
+          <a:xfrm>
+            <a:off x="685800" y="502920"/>
+            <a:ext cx="10820095" cy="274320"/>
+          </a:xfrm>
+          <a:prstGeom prst="rect">
+            <a:avLst/>
+          </a:prstGeom>
+          <a:noFill/>
+          <a:ln/>
+        </p:spPr>
+        <p:txBody>
+          <a:bodyPr wrap="square" lIns="0" tIns="0" rIns="0" bIns="0" rtlCol="0" anchor="ctr"/>
+          <a:lstStyle/>
+          <a:p>
+            <a:pPr indent="0" marL="0">
+              <a:buNone/>
+            </a:pPr>
+            <a:r>
+              <a:rPr lang="en-US" sz="1200" b="1" spc="300" kern="0" dirty="0">
+                <a:solidFill>
+                  <a:srgbClr val="C44E52"/>
+                </a:solidFill>
+                <a:latin typeface="Calibri" pitchFamily="34" charset="0"/>
+                <a:ea typeface="Calibri" pitchFamily="34" charset="-122"/>
+                <a:cs typeface="Calibri" pitchFamily="34" charset="-120"/>
+              </a:rPr>
+              <a:t>INTERACTIVE · MODEL EXPLORER</a:t>
+            </a:r>
+            <a:endParaRPr lang="en-US" sz="1200" dirty="0"/>
+          </a:p>
+        </p:txBody>
+      </p:sp>
+      <p:sp>
+        <p:nvSpPr>
+          <p:cNvPr id="3" name="Text 1"/>
+          <p:cNvSpPr/>
+          <p:nvPr/>
+        </p:nvSpPr>
+        <p:spPr>
+          <a:xfrm>
+            <a:off x="685800" y="841248"/>
+            <a:ext cx="10820095" cy="868680"/>
+          </a:xfrm>
+          <a:prstGeom prst="rect">
+            <a:avLst/>
+          </a:prstGeom>
+          <a:noFill/>
+          <a:ln/>
+        </p:spPr>
+        <p:txBody>
+          <a:bodyPr wrap="square" lIns="0" tIns="0" rIns="0" bIns="0" rtlCol="0" anchor="ctr"/>
+          <a:lstStyle/>
+          <a:p>
+            <a:pPr indent="0" marL="0">
+              <a:lnSpc>
+                <a:spcPts val="2700"/>
+              </a:lnSpc>
+              <a:buNone/>
+            </a:pPr>
+            <a:r>
+              <a:rPr lang="en-US" sz="2500" b="1" dirty="0">
+                <a:solidFill>
+                  <a:srgbClr val="23262F"/>
+                </a:solidFill>
+                <a:latin typeface="Georgia" pitchFamily="34" charset="0"/>
+                <a:ea typeface="Georgia" pitchFamily="34" charset="-122"/>
+                <a:cs typeface="Georgia" pitchFamily="34" charset="-120"/>
+              </a:rPr>
+              <a:t>Does it hold across models?  ▸ click a button</a:t>
+            </a:r>
+            <a:endParaRPr lang="en-US" sz="2500" dirty="0"/>
+          </a:p>
+        </p:txBody>
+      </p:sp>
+      <p:pic>
+        <p:nvPicPr>
+          <p:cNvPr id="4" name="Image 0" descr="/Users/xiaochuan/Desktop/Projects/P5_Multi_linguistic_histoBias/v3/experiments/exp3a_mixed_effects/figures/figC_attribute_OR_qwen7b.png">    </p:cNvPr>
+          <p:cNvPicPr>
+            <a:picLocks noChangeAspect="1"/>
+          </p:cNvPicPr>
+          <p:nvPr/>
+        </p:nvPicPr>
+        <p:blipFill>
+          <a:blip r:embed="rId1"/>
+          <a:stretch>
+            <a:fillRect/>
+          </a:stretch>
+        </p:blipFill>
+        <p:spPr>
+          <a:xfrm>
+            <a:off x="1709928" y="1737360"/>
+            <a:ext cx="8778240" cy="3351753"/>
+          </a:xfrm>
+          <a:prstGeom prst="rect">
+            <a:avLst/>
+          </a:prstGeom>
+        </p:spPr>
+      </p:pic>
+      <p:sp>
+        <p:nvSpPr>
+          <p:cNvPr id="5" name="Shape 2"/>
+          <p:cNvSpPr/>
+          <p:nvPr/>
+        </p:nvSpPr>
+        <p:spPr>
+          <a:xfrm>
+            <a:off x="1325880" y="5943600"/>
+            <a:ext cx="3108960" cy="603504"/>
+          </a:xfrm>
+          <a:prstGeom prst="roundRect">
+            <a:avLst>
+              <a:gd name="adj" fmla="val 12121"/>
+            </a:avLst>
+          </a:prstGeom>
+          <a:solidFill>
+            <a:srgbClr val="1B1F3B"/>
+          </a:solidFill>
+          <a:ln w="12700">
+            <a:solidFill>
+              <a:srgbClr val="1B1F3B"/>
+            </a:solidFill>
+            <a:prstDash val="solid"/>
+          </a:ln>
+        </p:spPr>
+      </p:sp>
+      <p:sp>
+        <p:nvSpPr>
+          <p:cNvPr id="6" name="Text 3"/>
+          <p:cNvSpPr/>
+          <p:nvPr/>
+        </p:nvSpPr>
+        <p:spPr>
+          <a:xfrm>
+            <a:off x="1325880" y="5943600"/>
+            <a:ext cx="3108960" cy="603504"/>
+          </a:xfrm>
+          <a:prstGeom prst="rect">
+            <a:avLst/>
+          </a:prstGeom>
+          <a:noFill/>
+          <a:ln/>
+        </p:spPr>
+        <p:txBody>
+          <a:bodyPr wrap="square" lIns="0" tIns="0" rIns="0" bIns="0" rtlCol="0" anchor="ctr"/>
+          <a:lstStyle/>
+          <a:p>
+            <a:pPr algn="ctr" indent="0" marL="0">
+              <a:buNone/>
+            </a:pPr>
+            <a:r>
+              <a:rPr lang="en-US" sz="1400" b="1" dirty="0">
+                <a:solidFill>
+                  <a:srgbClr val="FFFFFF"/>
+                </a:solidFill>
+                <a:latin typeface="Calibri" pitchFamily="34" charset="0"/>
+                <a:ea typeface="Calibri" pitchFamily="34" charset="-122"/>
+                <a:cs typeface="Calibri" pitchFamily="34" charset="-120"/>
+              </a:rPr>
+              <a:t>Qwen-7B</a:t>
+            </a:r>
+            <a:endParaRPr lang="en-US" sz="1400" dirty="0"/>
+          </a:p>
+        </p:txBody>
+      </p:sp>
+      <p:sp>
+        <p:nvSpPr>
+          <p:cNvPr id="7" name="Shape 4"/>
+          <p:cNvSpPr/>
+          <p:nvPr/>
+        </p:nvSpPr>
+        <p:spPr>
+          <a:xfrm>
+            <a:off x="4544568" y="5943600"/>
+            <a:ext cx="3108960" cy="603504"/>
+          </a:xfrm>
+          <a:prstGeom prst="roundRect">
+            <a:avLst>
+              <a:gd name="adj" fmla="val 12121"/>
+            </a:avLst>
+          </a:prstGeom>
+          <a:solidFill>
+            <a:srgbClr val="F5F6FA"/>
+          </a:solidFill>
+          <a:ln w="12700">
+            <a:solidFill>
+              <a:srgbClr val="E4E6EF"/>
+            </a:solidFill>
+            <a:prstDash val="solid"/>
+          </a:ln>
+        </p:spPr>
+      </p:sp>
+      <p:sp>
+        <p:nvSpPr>
+          <p:cNvPr id="8" name="Text 5">
             <a:hlinkClick r:id="rId2" tooltip="" action="ppaction://hlinksldjump"/>
           </p:cNvPr>
           <p:cNvSpPr/>
@@ -11292,7 +13865,7 @@
         </p:nvSpPr>
         <p:spPr>
           <a:xfrm>
-            <a:off x="1325880" y="5943600"/>
+            <a:off x="4544568" y="5943600"/>
             <a:ext cx="3108960" cy="603504"/>
           </a:xfrm>
           <a:prstGeom prst="rect">
@@ -11324,7 +13897,7 @@
                   </a:extLst>
                 </a:hlinkClick>
               </a:rPr>
-              <a:t>Qwen-7B</a:t>
+              <a:t>InternVL3-8B</a:t>
             </a:r>
             <a:endParaRPr lang="en-US" sz="1400" dirty="0"/>
           </a:p>
@@ -11332,13 +13905,13 @@
       </p:sp>
       <p:sp>
         <p:nvSpPr>
-          <p:cNvPr id="7" name="Shape 4"/>
-          <p:cNvSpPr/>
-          <p:nvPr/>
-        </p:nvSpPr>
-        <p:spPr>
-          <a:xfrm>
-            <a:off x="4544568" y="5943600"/>
+          <p:cNvPr id="9" name="Shape 6"/>
+          <p:cNvSpPr/>
+          <p:nvPr/>
+        </p:nvSpPr>
+        <p:spPr>
+          <a:xfrm>
+            <a:off x="7763256" y="5943600"/>
             <a:ext cx="3108960" cy="603504"/>
           </a:xfrm>
           <a:prstGeom prst="roundRect">
@@ -11359,7 +13932,7 @@
       </p:sp>
       <p:sp>
         <p:nvSpPr>
-          <p:cNvPr id="8" name="Text 5">
+          <p:cNvPr id="10" name="Text 7">
             <a:hlinkClick r:id="rId3" tooltip="" action="ppaction://hlinksldjump"/>
           </p:cNvPr>
           <p:cNvSpPr/>
@@ -11367,7 +13940,7 @@
         </p:nvSpPr>
         <p:spPr>
           <a:xfrm>
-            <a:off x="4544568" y="5943600"/>
+            <a:off x="7763256" y="5943600"/>
             <a:ext cx="3108960" cy="603504"/>
           </a:xfrm>
           <a:prstGeom prst="rect">
@@ -11399,7 +13972,7 @@
                   </a:extLst>
                 </a:hlinkClick>
               </a:rPr>
-              <a:t>InternVL3-8B</a:t>
+              <a:t>Both overlaid</a:t>
             </a:r>
             <a:endParaRPr lang="en-US" sz="1400" dirty="0"/>
           </a:p>
@@ -11407,13 +13980,264 @@
       </p:sp>
       <p:sp>
         <p:nvSpPr>
-          <p:cNvPr id="9" name="Shape 6"/>
-          <p:cNvSpPr/>
-          <p:nvPr/>
-        </p:nvSpPr>
-        <p:spPr>
-          <a:xfrm>
-            <a:off x="7763256" y="5943600"/>
+          <p:cNvPr id="11" name="Text 8"/>
+          <p:cNvSpPr/>
+          <p:nvPr/>
+        </p:nvSpPr>
+        <p:spPr>
+          <a:xfrm>
+            <a:off x="11551615" y="6400800"/>
+            <a:ext cx="365760" cy="274320"/>
+          </a:xfrm>
+          <a:prstGeom prst="rect">
+            <a:avLst/>
+          </a:prstGeom>
+          <a:noFill/>
+          <a:ln/>
+        </p:spPr>
+        <p:txBody>
+          <a:bodyPr wrap="square" lIns="0" tIns="0" rIns="0" bIns="0" rtlCol="0" anchor="ctr"/>
+          <a:lstStyle/>
+          <a:p>
+            <a:pPr algn="r" indent="0" marL="0">
+              <a:buNone/>
+            </a:pPr>
+            <a:r>
+              <a:rPr lang="en-US" sz="1000" dirty="0">
+                <a:solidFill>
+                  <a:srgbClr val="9AA0B0"/>
+                </a:solidFill>
+                <a:latin typeface="Calibri" pitchFamily="34" charset="0"/>
+                <a:ea typeface="Calibri" pitchFamily="34" charset="-122"/>
+                <a:cs typeface="Calibri" pitchFamily="34" charset="-120"/>
+              </a:rPr>
+              <a:t>23</a:t>
+            </a:r>
+            <a:endParaRPr lang="en-US" sz="1000" dirty="0"/>
+          </a:p>
+        </p:txBody>
+      </p:sp>
+    </p:spTree>
+  </p:cSld>
+  <p:clrMapOvr>
+    <a:masterClrMapping/>
+  </p:clrMapOvr>
+</p:sld>
+</file>
+
+<file path=ppt/slides/slide24.xml><?xml version="1.0" encoding="utf-8"?>
+<p:sld xmlns:a="http://schemas.openxmlformats.org/drawingml/2006/main" xmlns:r="http://schemas.openxmlformats.org/officeDocument/2006/relationships" xmlns:p="http://schemas.openxmlformats.org/presentationml/2006/main">
+  <p:cSld name="Slide 24">
+    <p:bg>
+      <p:bgPr>
+        <a:solidFill>
+          <a:srgbClr val="FFFFFF"/>
+        </a:solidFill>
+      </p:bgPr>
+    </p:bg>
+    <p:spTree>
+      <p:nvGrpSpPr>
+        <p:cNvPr id="1" name=""/>
+        <p:cNvGrpSpPr/>
+        <p:nvPr/>
+      </p:nvGrpSpPr>
+      <p:grpSpPr>
+        <a:xfrm>
+          <a:off x="0" y="0"/>
+          <a:ext cx="0" cy="0"/>
+          <a:chOff x="0" y="0"/>
+          <a:chExt cx="0" cy="0"/>
+        </a:xfrm>
+      </p:grpSpPr>
+      <p:sp>
+        <p:nvSpPr>
+          <p:cNvPr id="2" name="Text 0"/>
+          <p:cNvSpPr/>
+          <p:nvPr/>
+        </p:nvSpPr>
+        <p:spPr>
+          <a:xfrm>
+            <a:off x="685800" y="502920"/>
+            <a:ext cx="10820095" cy="274320"/>
+          </a:xfrm>
+          <a:prstGeom prst="rect">
+            <a:avLst/>
+          </a:prstGeom>
+          <a:noFill/>
+          <a:ln/>
+        </p:spPr>
+        <p:txBody>
+          <a:bodyPr wrap="square" lIns="0" tIns="0" rIns="0" bIns="0" rtlCol="0" anchor="ctr"/>
+          <a:lstStyle/>
+          <a:p>
+            <a:pPr indent="0" marL="0">
+              <a:buNone/>
+            </a:pPr>
+            <a:r>
+              <a:rPr lang="en-US" sz="1200" b="1" spc="300" kern="0" dirty="0">
+                <a:solidFill>
+                  <a:srgbClr val="C44E52"/>
+                </a:solidFill>
+                <a:latin typeface="Calibri" pitchFamily="34" charset="0"/>
+                <a:ea typeface="Calibri" pitchFamily="34" charset="-122"/>
+                <a:cs typeface="Calibri" pitchFamily="34" charset="-120"/>
+              </a:rPr>
+              <a:t>INTERACTIVE · MODEL EXPLORER</a:t>
+            </a:r>
+            <a:endParaRPr lang="en-US" sz="1200" dirty="0"/>
+          </a:p>
+        </p:txBody>
+      </p:sp>
+      <p:sp>
+        <p:nvSpPr>
+          <p:cNvPr id="3" name="Text 1"/>
+          <p:cNvSpPr/>
+          <p:nvPr/>
+        </p:nvSpPr>
+        <p:spPr>
+          <a:xfrm>
+            <a:off x="685800" y="841248"/>
+            <a:ext cx="10820095" cy="868680"/>
+          </a:xfrm>
+          <a:prstGeom prst="rect">
+            <a:avLst/>
+          </a:prstGeom>
+          <a:noFill/>
+          <a:ln/>
+        </p:spPr>
+        <p:txBody>
+          <a:bodyPr wrap="square" lIns="0" tIns="0" rIns="0" bIns="0" rtlCol="0" anchor="ctr"/>
+          <a:lstStyle/>
+          <a:p>
+            <a:pPr indent="0" marL="0">
+              <a:lnSpc>
+                <a:spcPts val="2700"/>
+              </a:lnSpc>
+              <a:buNone/>
+            </a:pPr>
+            <a:r>
+              <a:rPr lang="en-US" sz="2500" b="1" dirty="0">
+                <a:solidFill>
+                  <a:srgbClr val="23262F"/>
+                </a:solidFill>
+                <a:latin typeface="Georgia" pitchFamily="34" charset="0"/>
+                <a:ea typeface="Georgia" pitchFamily="34" charset="-122"/>
+                <a:cs typeface="Georgia" pitchFamily="34" charset="-120"/>
+              </a:rPr>
+              <a:t>Does it hold across models?  ▸ click a button</a:t>
+            </a:r>
+            <a:endParaRPr lang="en-US" sz="2500" dirty="0"/>
+          </a:p>
+        </p:txBody>
+      </p:sp>
+      <p:pic>
+        <p:nvPicPr>
+          <p:cNvPr id="4" name="Image 0" descr="/Users/xiaochuan/Desktop/Projects/P5_Multi_linguistic_histoBias/v3/experiments/exp3a_mixed_effects/figures/figC_attribute_OR_internvl8b.png">    </p:cNvPr>
+          <p:cNvPicPr>
+            <a:picLocks noChangeAspect="1"/>
+          </p:cNvPicPr>
+          <p:nvPr/>
+        </p:nvPicPr>
+        <p:blipFill>
+          <a:blip r:embed="rId1"/>
+          <a:stretch>
+            <a:fillRect/>
+          </a:stretch>
+        </p:blipFill>
+        <p:spPr>
+          <a:xfrm>
+            <a:off x="1709928" y="1737360"/>
+            <a:ext cx="8778240" cy="3351753"/>
+          </a:xfrm>
+          <a:prstGeom prst="rect">
+            <a:avLst/>
+          </a:prstGeom>
+        </p:spPr>
+      </p:pic>
+      <p:sp>
+        <p:nvSpPr>
+          <p:cNvPr id="5" name="Shape 2"/>
+          <p:cNvSpPr/>
+          <p:nvPr/>
+        </p:nvSpPr>
+        <p:spPr>
+          <a:xfrm>
+            <a:off x="1325880" y="5943600"/>
+            <a:ext cx="3108960" cy="603504"/>
+          </a:xfrm>
+          <a:prstGeom prst="roundRect">
+            <a:avLst>
+              <a:gd name="adj" fmla="val 12121"/>
+            </a:avLst>
+          </a:prstGeom>
+          <a:solidFill>
+            <a:srgbClr val="F5F6FA"/>
+          </a:solidFill>
+          <a:ln w="12700">
+            <a:solidFill>
+              <a:srgbClr val="E4E6EF"/>
+            </a:solidFill>
+            <a:prstDash val="solid"/>
+          </a:ln>
+        </p:spPr>
+      </p:sp>
+      <p:sp>
+        <p:nvSpPr>
+          <p:cNvPr id="6" name="Text 3">
+            <a:hlinkClick r:id="rId2" tooltip="" action="ppaction://hlinksldjump"/>
+          </p:cNvPr>
+          <p:cNvSpPr/>
+          <p:nvPr/>
+        </p:nvSpPr>
+        <p:spPr>
+          <a:xfrm>
+            <a:off x="1325880" y="5943600"/>
+            <a:ext cx="3108960" cy="603504"/>
+          </a:xfrm>
+          <a:prstGeom prst="rect">
+            <a:avLst/>
+          </a:prstGeom>
+          <a:noFill/>
+          <a:ln/>
+        </p:spPr>
+        <p:txBody>
+          <a:bodyPr wrap="square" lIns="0" tIns="0" rIns="0" bIns="0" rtlCol="0" anchor="ctr"/>
+          <a:lstStyle/>
+          <a:p>
+            <a:pPr algn="ctr" indent="0" marL="0">
+              <a:buNone/>
+            </a:pPr>
+            <a:r>
+              <a:rPr lang="en-US" sz="1400" b="1" u="sng" dirty="0">
+                <a:solidFill>
+                  <a:srgbClr val="1B1F3B"/>
+                </a:solidFill>
+                <a:latin typeface="Calibri" pitchFamily="34" charset="0"/>
+                <a:ea typeface="Calibri" pitchFamily="34" charset="-122"/>
+                <a:cs typeface="Calibri" pitchFamily="34" charset="-120"/>
+                <a:hlinkClick r:id="rId2" action="ppaction://hlinksldjump" tooltip="">
+                  <a:extLst>
+                    <a:ext uri="{A12FA001-AC4F-418D-AE19-62706E023703}">
+                      <ahyp:hlinkClr xmlns:ahyp="http://schemas.microsoft.com/office/drawing/2018/hyperlinkcolor" val="tx"/>
+                    </a:ext>
+                  </a:extLst>
+                </a:hlinkClick>
+              </a:rPr>
+              <a:t>Qwen-7B</a:t>
+            </a:r>
+            <a:endParaRPr lang="en-US" sz="1400" dirty="0"/>
+          </a:p>
+        </p:txBody>
+      </p:sp>
+      <p:sp>
+        <p:nvSpPr>
+          <p:cNvPr id="7" name="Shape 4"/>
+          <p:cNvSpPr/>
+          <p:nvPr/>
+        </p:nvSpPr>
+        <p:spPr>
+          <a:xfrm>
+            <a:off x="4544568" y="5943600"/>
             <a:ext cx="3108960" cy="603504"/>
           </a:xfrm>
           <a:prstGeom prst="roundRect">
@@ -11434,13 +14258,13 @@
       </p:sp>
       <p:sp>
         <p:nvSpPr>
-          <p:cNvPr id="10" name="Text 7"/>
-          <p:cNvSpPr/>
-          <p:nvPr/>
-        </p:nvSpPr>
-        <p:spPr>
-          <a:xfrm>
-            <a:off x="7763256" y="5943600"/>
+          <p:cNvPr id="8" name="Text 5"/>
+          <p:cNvSpPr/>
+          <p:nvPr/>
+        </p:nvSpPr>
+        <p:spPr>
+          <a:xfrm>
+            <a:off x="4544568" y="5943600"/>
             <a:ext cx="3108960" cy="603504"/>
           </a:xfrm>
           <a:prstGeom prst="rect">
@@ -11465,7 +14289,7 @@
                 <a:ea typeface="Calibri" pitchFamily="34" charset="-122"/>
                 <a:cs typeface="Calibri" pitchFamily="34" charset="-120"/>
               </a:rPr>
-              <a:t>Both overlaid</a:t>
+              <a:t>InternVL3-8B</a:t>
             </a:r>
             <a:endParaRPr lang="en-US" sz="1400" dirty="0"/>
           </a:p>
@@ -11473,14 +14297,43 @@
       </p:sp>
       <p:sp>
         <p:nvSpPr>
-          <p:cNvPr id="11" name="Text 8"/>
-          <p:cNvSpPr/>
-          <p:nvPr/>
-        </p:nvSpPr>
-        <p:spPr>
-          <a:xfrm>
-            <a:off x="11551615" y="6400800"/>
-            <a:ext cx="365760" cy="274320"/>
+          <p:cNvPr id="9" name="Shape 6"/>
+          <p:cNvSpPr/>
+          <p:nvPr/>
+        </p:nvSpPr>
+        <p:spPr>
+          <a:xfrm>
+            <a:off x="7763256" y="5943600"/>
+            <a:ext cx="3108960" cy="603504"/>
+          </a:xfrm>
+          <a:prstGeom prst="roundRect">
+            <a:avLst>
+              <a:gd name="adj" fmla="val 12121"/>
+            </a:avLst>
+          </a:prstGeom>
+          <a:solidFill>
+            <a:srgbClr val="F5F6FA"/>
+          </a:solidFill>
+          <a:ln w="12700">
+            <a:solidFill>
+              <a:srgbClr val="E4E6EF"/>
+            </a:solidFill>
+            <a:prstDash val="solid"/>
+          </a:ln>
+        </p:spPr>
+      </p:sp>
+      <p:sp>
+        <p:nvSpPr>
+          <p:cNvPr id="10" name="Text 7">
+            <a:hlinkClick r:id="rId3" tooltip="" action="ppaction://hlinksldjump"/>
+          </p:cNvPr>
+          <p:cNvSpPr/>
+          <p:nvPr/>
+        </p:nvSpPr>
+        <p:spPr>
+          <a:xfrm>
+            <a:off x="7763256" y="5943600"/>
+            <a:ext cx="3108960" cy="603504"/>
           </a:xfrm>
           <a:prstGeom prst="rect">
             <a:avLst/>
@@ -11492,19 +14345,457 @@
           <a:bodyPr wrap="square" lIns="0" tIns="0" rIns="0" bIns="0" rtlCol="0" anchor="ctr"/>
           <a:lstStyle/>
           <a:p>
-            <a:pPr algn="r" indent="0" marL="0">
+            <a:pPr algn="ctr" indent="0" marL="0">
               <a:buNone/>
             </a:pPr>
             <a:r>
-              <a:rPr lang="en-US" sz="1000" dirty="0">
-                <a:solidFill>
-                  <a:srgbClr val="9AA0B0"/>
+              <a:rPr lang="en-US" sz="1400" b="1" u="sng" dirty="0">
+                <a:solidFill>
+                  <a:srgbClr val="1B1F3B"/>
                 </a:solidFill>
                 <a:latin typeface="Calibri" pitchFamily="34" charset="0"/>
                 <a:ea typeface="Calibri" pitchFamily="34" charset="-122"/>
                 <a:cs typeface="Calibri" pitchFamily="34" charset="-120"/>
-              </a:rPr>
-              <a:t>22</a:t>
+                <a:hlinkClick r:id="rId3" action="ppaction://hlinksldjump" tooltip="">
+                  <a:extLst>
+                    <a:ext uri="{A12FA001-AC4F-418D-AE19-62706E023703}">
+                      <ahyp:hlinkClr xmlns:ahyp="http://schemas.microsoft.com/office/drawing/2018/hyperlinkcolor" val="tx"/>
+                    </a:ext>
+                  </a:extLst>
+                </a:hlinkClick>
+              </a:rPr>
+              <a:t>Both overlaid</a:t>
+            </a:r>
+            <a:endParaRPr lang="en-US" sz="1400" dirty="0"/>
+          </a:p>
+        </p:txBody>
+      </p:sp>
+      <p:sp>
+        <p:nvSpPr>
+          <p:cNvPr id="11" name="Text 8"/>
+          <p:cNvSpPr/>
+          <p:nvPr/>
+        </p:nvSpPr>
+        <p:spPr>
+          <a:xfrm>
+            <a:off x="11551615" y="6400800"/>
+            <a:ext cx="365760" cy="274320"/>
+          </a:xfrm>
+          <a:prstGeom prst="rect">
+            <a:avLst/>
+          </a:prstGeom>
+          <a:noFill/>
+          <a:ln/>
+        </p:spPr>
+        <p:txBody>
+          <a:bodyPr wrap="square" lIns="0" tIns="0" rIns="0" bIns="0" rtlCol="0" anchor="ctr"/>
+          <a:lstStyle/>
+          <a:p>
+            <a:pPr algn="r" indent="0" marL="0">
+              <a:buNone/>
+            </a:pPr>
+            <a:r>
+              <a:rPr lang="en-US" sz="1000" dirty="0">
+                <a:solidFill>
+                  <a:srgbClr val="9AA0B0"/>
+                </a:solidFill>
+                <a:latin typeface="Calibri" pitchFamily="34" charset="0"/>
+                <a:ea typeface="Calibri" pitchFamily="34" charset="-122"/>
+                <a:cs typeface="Calibri" pitchFamily="34" charset="-120"/>
+              </a:rPr>
+              <a:t>24</a:t>
+            </a:r>
+            <a:endParaRPr lang="en-US" sz="1000" dirty="0"/>
+          </a:p>
+        </p:txBody>
+      </p:sp>
+    </p:spTree>
+  </p:cSld>
+  <p:clrMapOvr>
+    <a:masterClrMapping/>
+  </p:clrMapOvr>
+</p:sld>
+</file>
+
+<file path=ppt/slides/slide25.xml><?xml version="1.0" encoding="utf-8"?>
+<p:sld xmlns:a="http://schemas.openxmlformats.org/drawingml/2006/main" xmlns:r="http://schemas.openxmlformats.org/officeDocument/2006/relationships" xmlns:p="http://schemas.openxmlformats.org/presentationml/2006/main">
+  <p:cSld name="Slide 25">
+    <p:bg>
+      <p:bgPr>
+        <a:solidFill>
+          <a:srgbClr val="FFFFFF"/>
+        </a:solidFill>
+      </p:bgPr>
+    </p:bg>
+    <p:spTree>
+      <p:nvGrpSpPr>
+        <p:cNvPr id="1" name=""/>
+        <p:cNvGrpSpPr/>
+        <p:nvPr/>
+      </p:nvGrpSpPr>
+      <p:grpSpPr>
+        <a:xfrm>
+          <a:off x="0" y="0"/>
+          <a:ext cx="0" cy="0"/>
+          <a:chOff x="0" y="0"/>
+          <a:chExt cx="0" cy="0"/>
+        </a:xfrm>
+      </p:grpSpPr>
+      <p:sp>
+        <p:nvSpPr>
+          <p:cNvPr id="2" name="Text 0"/>
+          <p:cNvSpPr/>
+          <p:nvPr/>
+        </p:nvSpPr>
+        <p:spPr>
+          <a:xfrm>
+            <a:off x="685800" y="502920"/>
+            <a:ext cx="10820095" cy="274320"/>
+          </a:xfrm>
+          <a:prstGeom prst="rect">
+            <a:avLst/>
+          </a:prstGeom>
+          <a:noFill/>
+          <a:ln/>
+        </p:spPr>
+        <p:txBody>
+          <a:bodyPr wrap="square" lIns="0" tIns="0" rIns="0" bIns="0" rtlCol="0" anchor="ctr"/>
+          <a:lstStyle/>
+          <a:p>
+            <a:pPr indent="0" marL="0">
+              <a:buNone/>
+            </a:pPr>
+            <a:r>
+              <a:rPr lang="en-US" sz="1200" b="1" spc="300" kern="0" dirty="0">
+                <a:solidFill>
+                  <a:srgbClr val="C44E52"/>
+                </a:solidFill>
+                <a:latin typeface="Calibri" pitchFamily="34" charset="0"/>
+                <a:ea typeface="Calibri" pitchFamily="34" charset="-122"/>
+                <a:cs typeface="Calibri" pitchFamily="34" charset="-120"/>
+              </a:rPr>
+              <a:t>INTERACTIVE · MODEL EXPLORER</a:t>
+            </a:r>
+            <a:endParaRPr lang="en-US" sz="1200" dirty="0"/>
+          </a:p>
+        </p:txBody>
+      </p:sp>
+      <p:sp>
+        <p:nvSpPr>
+          <p:cNvPr id="3" name="Text 1"/>
+          <p:cNvSpPr/>
+          <p:nvPr/>
+        </p:nvSpPr>
+        <p:spPr>
+          <a:xfrm>
+            <a:off x="685800" y="841248"/>
+            <a:ext cx="10820095" cy="868680"/>
+          </a:xfrm>
+          <a:prstGeom prst="rect">
+            <a:avLst/>
+          </a:prstGeom>
+          <a:noFill/>
+          <a:ln/>
+        </p:spPr>
+        <p:txBody>
+          <a:bodyPr wrap="square" lIns="0" tIns="0" rIns="0" bIns="0" rtlCol="0" anchor="ctr"/>
+          <a:lstStyle/>
+          <a:p>
+            <a:pPr indent="0" marL="0">
+              <a:lnSpc>
+                <a:spcPts val="2700"/>
+              </a:lnSpc>
+              <a:buNone/>
+            </a:pPr>
+            <a:r>
+              <a:rPr lang="en-US" sz="2500" b="1" dirty="0">
+                <a:solidFill>
+                  <a:srgbClr val="23262F"/>
+                </a:solidFill>
+                <a:latin typeface="Georgia" pitchFamily="34" charset="0"/>
+                <a:ea typeface="Georgia" pitchFamily="34" charset="-122"/>
+                <a:cs typeface="Georgia" pitchFamily="34" charset="-120"/>
+              </a:rPr>
+              <a:t>Does it hold across models?  ▸ click a button</a:t>
+            </a:r>
+            <a:endParaRPr lang="en-US" sz="2500" dirty="0"/>
+          </a:p>
+        </p:txBody>
+      </p:sp>
+      <p:pic>
+        <p:nvPicPr>
+          <p:cNvPr id="4" name="Image 0" descr="/Users/xiaochuan/Desktop/Projects/P5_Multi_linguistic_histoBias/v3/experiments/exp3a_mixed_effects/figures/figE_cross_model_OR.png">    </p:cNvPr>
+          <p:cNvPicPr>
+            <a:picLocks noChangeAspect="1"/>
+          </p:cNvPicPr>
+          <p:nvPr/>
+        </p:nvPicPr>
+        <p:blipFill>
+          <a:blip r:embed="rId1"/>
+          <a:stretch>
+            <a:fillRect/>
+          </a:stretch>
+        </p:blipFill>
+        <p:spPr>
+          <a:xfrm>
+            <a:off x="1709928" y="1737360"/>
+            <a:ext cx="8778240" cy="3364599"/>
+          </a:xfrm>
+          <a:prstGeom prst="rect">
+            <a:avLst/>
+          </a:prstGeom>
+        </p:spPr>
+      </p:pic>
+      <p:sp>
+        <p:nvSpPr>
+          <p:cNvPr id="5" name="Shape 2"/>
+          <p:cNvSpPr/>
+          <p:nvPr/>
+        </p:nvSpPr>
+        <p:spPr>
+          <a:xfrm>
+            <a:off x="1325880" y="5943600"/>
+            <a:ext cx="3108960" cy="603504"/>
+          </a:xfrm>
+          <a:prstGeom prst="roundRect">
+            <a:avLst>
+              <a:gd name="adj" fmla="val 12121"/>
+            </a:avLst>
+          </a:prstGeom>
+          <a:solidFill>
+            <a:srgbClr val="F5F6FA"/>
+          </a:solidFill>
+          <a:ln w="12700">
+            <a:solidFill>
+              <a:srgbClr val="E4E6EF"/>
+            </a:solidFill>
+            <a:prstDash val="solid"/>
+          </a:ln>
+        </p:spPr>
+      </p:sp>
+      <p:sp>
+        <p:nvSpPr>
+          <p:cNvPr id="6" name="Text 3">
+            <a:hlinkClick r:id="rId2" tooltip="" action="ppaction://hlinksldjump"/>
+          </p:cNvPr>
+          <p:cNvSpPr/>
+          <p:nvPr/>
+        </p:nvSpPr>
+        <p:spPr>
+          <a:xfrm>
+            <a:off x="1325880" y="5943600"/>
+            <a:ext cx="3108960" cy="603504"/>
+          </a:xfrm>
+          <a:prstGeom prst="rect">
+            <a:avLst/>
+          </a:prstGeom>
+          <a:noFill/>
+          <a:ln/>
+        </p:spPr>
+        <p:txBody>
+          <a:bodyPr wrap="square" lIns="0" tIns="0" rIns="0" bIns="0" rtlCol="0" anchor="ctr"/>
+          <a:lstStyle/>
+          <a:p>
+            <a:pPr algn="ctr" indent="0" marL="0">
+              <a:buNone/>
+            </a:pPr>
+            <a:r>
+              <a:rPr lang="en-US" sz="1400" b="1" u="sng" dirty="0">
+                <a:solidFill>
+                  <a:srgbClr val="1B1F3B"/>
+                </a:solidFill>
+                <a:latin typeface="Calibri" pitchFamily="34" charset="0"/>
+                <a:ea typeface="Calibri" pitchFamily="34" charset="-122"/>
+                <a:cs typeface="Calibri" pitchFamily="34" charset="-120"/>
+                <a:hlinkClick r:id="rId2" action="ppaction://hlinksldjump" tooltip="">
+                  <a:extLst>
+                    <a:ext uri="{A12FA001-AC4F-418D-AE19-62706E023703}">
+                      <ahyp:hlinkClr xmlns:ahyp="http://schemas.microsoft.com/office/drawing/2018/hyperlinkcolor" val="tx"/>
+                    </a:ext>
+                  </a:extLst>
+                </a:hlinkClick>
+              </a:rPr>
+              <a:t>Qwen-7B</a:t>
+            </a:r>
+            <a:endParaRPr lang="en-US" sz="1400" dirty="0"/>
+          </a:p>
+        </p:txBody>
+      </p:sp>
+      <p:sp>
+        <p:nvSpPr>
+          <p:cNvPr id="7" name="Shape 4"/>
+          <p:cNvSpPr/>
+          <p:nvPr/>
+        </p:nvSpPr>
+        <p:spPr>
+          <a:xfrm>
+            <a:off x="4544568" y="5943600"/>
+            <a:ext cx="3108960" cy="603504"/>
+          </a:xfrm>
+          <a:prstGeom prst="roundRect">
+            <a:avLst>
+              <a:gd name="adj" fmla="val 12121"/>
+            </a:avLst>
+          </a:prstGeom>
+          <a:solidFill>
+            <a:srgbClr val="F5F6FA"/>
+          </a:solidFill>
+          <a:ln w="12700">
+            <a:solidFill>
+              <a:srgbClr val="E4E6EF"/>
+            </a:solidFill>
+            <a:prstDash val="solid"/>
+          </a:ln>
+        </p:spPr>
+      </p:sp>
+      <p:sp>
+        <p:nvSpPr>
+          <p:cNvPr id="8" name="Text 5">
+            <a:hlinkClick r:id="rId3" tooltip="" action="ppaction://hlinksldjump"/>
+          </p:cNvPr>
+          <p:cNvSpPr/>
+          <p:nvPr/>
+        </p:nvSpPr>
+        <p:spPr>
+          <a:xfrm>
+            <a:off x="4544568" y="5943600"/>
+            <a:ext cx="3108960" cy="603504"/>
+          </a:xfrm>
+          <a:prstGeom prst="rect">
+            <a:avLst/>
+          </a:prstGeom>
+          <a:noFill/>
+          <a:ln/>
+        </p:spPr>
+        <p:txBody>
+          <a:bodyPr wrap="square" lIns="0" tIns="0" rIns="0" bIns="0" rtlCol="0" anchor="ctr"/>
+          <a:lstStyle/>
+          <a:p>
+            <a:pPr algn="ctr" indent="0" marL="0">
+              <a:buNone/>
+            </a:pPr>
+            <a:r>
+              <a:rPr lang="en-US" sz="1400" b="1" u="sng" dirty="0">
+                <a:solidFill>
+                  <a:srgbClr val="1B1F3B"/>
+                </a:solidFill>
+                <a:latin typeface="Calibri" pitchFamily="34" charset="0"/>
+                <a:ea typeface="Calibri" pitchFamily="34" charset="-122"/>
+                <a:cs typeface="Calibri" pitchFamily="34" charset="-120"/>
+                <a:hlinkClick r:id="rId3" action="ppaction://hlinksldjump" tooltip="">
+                  <a:extLst>
+                    <a:ext uri="{A12FA001-AC4F-418D-AE19-62706E023703}">
+                      <ahyp:hlinkClr xmlns:ahyp="http://schemas.microsoft.com/office/drawing/2018/hyperlinkcolor" val="tx"/>
+                    </a:ext>
+                  </a:extLst>
+                </a:hlinkClick>
+              </a:rPr>
+              <a:t>InternVL3-8B</a:t>
+            </a:r>
+            <a:endParaRPr lang="en-US" sz="1400" dirty="0"/>
+          </a:p>
+        </p:txBody>
+      </p:sp>
+      <p:sp>
+        <p:nvSpPr>
+          <p:cNvPr id="9" name="Shape 6"/>
+          <p:cNvSpPr/>
+          <p:nvPr/>
+        </p:nvSpPr>
+        <p:spPr>
+          <a:xfrm>
+            <a:off x="7763256" y="5943600"/>
+            <a:ext cx="3108960" cy="603504"/>
+          </a:xfrm>
+          <a:prstGeom prst="roundRect">
+            <a:avLst>
+              <a:gd name="adj" fmla="val 12121"/>
+            </a:avLst>
+          </a:prstGeom>
+          <a:solidFill>
+            <a:srgbClr val="1B1F3B"/>
+          </a:solidFill>
+          <a:ln w="12700">
+            <a:solidFill>
+              <a:srgbClr val="1B1F3B"/>
+            </a:solidFill>
+            <a:prstDash val="solid"/>
+          </a:ln>
+        </p:spPr>
+      </p:sp>
+      <p:sp>
+        <p:nvSpPr>
+          <p:cNvPr id="10" name="Text 7"/>
+          <p:cNvSpPr/>
+          <p:nvPr/>
+        </p:nvSpPr>
+        <p:spPr>
+          <a:xfrm>
+            <a:off x="7763256" y="5943600"/>
+            <a:ext cx="3108960" cy="603504"/>
+          </a:xfrm>
+          <a:prstGeom prst="rect">
+            <a:avLst/>
+          </a:prstGeom>
+          <a:noFill/>
+          <a:ln/>
+        </p:spPr>
+        <p:txBody>
+          <a:bodyPr wrap="square" lIns="0" tIns="0" rIns="0" bIns="0" rtlCol="0" anchor="ctr"/>
+          <a:lstStyle/>
+          <a:p>
+            <a:pPr algn="ctr" indent="0" marL="0">
+              <a:buNone/>
+            </a:pPr>
+            <a:r>
+              <a:rPr lang="en-US" sz="1400" b="1" dirty="0">
+                <a:solidFill>
+                  <a:srgbClr val="FFFFFF"/>
+                </a:solidFill>
+                <a:latin typeface="Calibri" pitchFamily="34" charset="0"/>
+                <a:ea typeface="Calibri" pitchFamily="34" charset="-122"/>
+                <a:cs typeface="Calibri" pitchFamily="34" charset="-120"/>
+              </a:rPr>
+              <a:t>Both overlaid</a:t>
+            </a:r>
+            <a:endParaRPr lang="en-US" sz="1400" dirty="0"/>
+          </a:p>
+        </p:txBody>
+      </p:sp>
+      <p:sp>
+        <p:nvSpPr>
+          <p:cNvPr id="11" name="Text 8"/>
+          <p:cNvSpPr/>
+          <p:nvPr/>
+        </p:nvSpPr>
+        <p:spPr>
+          <a:xfrm>
+            <a:off x="11551615" y="6400800"/>
+            <a:ext cx="365760" cy="274320"/>
+          </a:xfrm>
+          <a:prstGeom prst="rect">
+            <a:avLst/>
+          </a:prstGeom>
+          <a:noFill/>
+          <a:ln/>
+        </p:spPr>
+        <p:txBody>
+          <a:bodyPr wrap="square" lIns="0" tIns="0" rIns="0" bIns="0" rtlCol="0" anchor="ctr"/>
+          <a:lstStyle/>
+          <a:p>
+            <a:pPr algn="r" indent="0" marL="0">
+              <a:buNone/>
+            </a:pPr>
+            <a:r>
+              <a:rPr lang="en-US" sz="1000" dirty="0">
+                <a:solidFill>
+                  <a:srgbClr val="9AA0B0"/>
+                </a:solidFill>
+                <a:latin typeface="Calibri" pitchFamily="34" charset="0"/>
+                <a:ea typeface="Calibri" pitchFamily="34" charset="-122"/>
+                <a:cs typeface="Calibri" pitchFamily="34" charset="-120"/>
+              </a:rPr>
+              <a:t>25</a:t>
             </a:r>
             <a:endParaRPr lang="en-US" sz="1000" dirty="0"/>
           </a:p>

</xml_diff>

<commit_message>
Slide 8: refresh attribute bar chart on the 7-language Qwen run (was the v2 4-lang figA)
Co-Authored-By: Claude Opus 4.8 <noreply@anthropic.com>
</commit_message>
<xml_diff>
--- a/v3/paper/ProgressReport_2.pptx
+++ b/v3/paper/ProgressReport_2.pptx
@@ -19451,7 +19451,7 @@
                 <a:ea typeface="Calibri" pitchFamily="34" charset="-122"/>
                 <a:cs typeface="Calibri" pitchFamily="34" charset="-120"/>
               </a:rPr>
-              <a:t>Demography's flat ~0.56 average hides a 0.30 spread.</a:t>
+              <a:t>Demography's flat ~0.58 average hides a ~0.28 spread across attributes.</a:t>
             </a:r>
             <a:endParaRPr lang="en-US" sz="1700" dirty="0"/>
           </a:p>
@@ -19531,7 +19531,7 @@
       </p:sp>
       <p:pic>
         <p:nvPicPr>
-          <p:cNvPr id="5" name="Image 0" descr="/Users/xiaochuan/Desktop/Projects/P5_Multi_linguistic_histoBias/v2/experiments/exp2_attribute_bias/figures/figA_bias_by_attribute.png">    </p:cNvPr>
+          <p:cNvPr id="5" name="Image 0" descr="/Users/xiaochuan/Desktop/Projects/P5_Multi_linguistic_histoBias/v3/experiments/exp3a_mixed_effects/figures/figA7_attribute_qwen7lang.png">    </p:cNvPr>
           <p:cNvPicPr>
             <a:picLocks noChangeAspect="1"/>
           </p:cNvPicPr>
@@ -19586,7 +19586,7 @@
                 <a:ea typeface="Calibri" pitchFamily="34" charset="-122"/>
                 <a:cs typeface="Calibri" pitchFamily="34" charset="-120"/>
               </a:rPr>
-              <a:t>Prototypicality error rate by socio-attribute (Qwen2.5-VL-7B).</a:t>
+              <a:t>Prototypicality error rate by socio-attribute — Qwen2.5-VL-7B, all 7 languages.</a:t>
             </a:r>
             <a:endParaRPr lang="en-US" sz="1050" dirty="0"/>
           </a:p>

</xml_diff>

<commit_message>
Deck: add backup slide formally defining CFR / SBR / SCR (26 slides)
Co-Authored-By: Claude Opus 4.8 <noreply@anthropic.com>
</commit_message>
<xml_diff>
--- a/v3/paper/ProgressReport_2.pptx
+++ b/v3/paper/ProgressReport_2.pptx
@@ -30,9 +30,10 @@
     <p:sldId id="278" r:id="rId24"/>
     <p:sldId id="279" r:id="rId25"/>
     <p:sldId id="280" r:id="rId26"/>
+    <p:sldId id="281" r:id="rId27"/>
   </p:sldIdLst>
   <p:notesMasterIdLst>
-    <p:notesMasterId r:id="rId27"/>
+    <p:notesMasterId r:id="rId28"/>
   </p:notesMasterIdLst>
   <p:sldSz cx="12191695" cy="6858000"/>
   <p:notesSz cx="6858000" cy="12191695"/>
@@ -2850,6 +2851,94 @@
             <a:fld id="{F7021451-1387-4CA6-816F-3879F97B5CBC}" type="slidenum">
               <a:rPr lang="en-US"/>
               <a:t>25</a:t>
+            </a:fld>
+            <a:endParaRPr lang="en-US"/>
+          </a:p>
+        </p:txBody>
+      </p:sp>
+    </p:spTree>
+    <p:extLst>
+      <p:ext uri="{BB962C8B-B14F-4D97-AF65-F5344CB8AC3E}">
+        <p14:creationId xmlns:p14="http://schemas.microsoft.com/office/powerpoint/2010/main" val="1024086991"/>
+      </p:ext>
+    </p:extLst>
+  </p:cSld>
+  <p:clrMapOvr>
+    <a:masterClrMapping/>
+  </p:clrMapOvr>
+</p:notes>
+</file>
+
+<file path=ppt/notesSlides/notesSlide26.xml><?xml version="1.0" encoding="utf-8"?>
+<p:notes xmlns:a="http://schemas.openxmlformats.org/drawingml/2006/main" xmlns:r="http://schemas.openxmlformats.org/officeDocument/2006/relationships" xmlns:p="http://schemas.openxmlformats.org/presentationml/2006/main">
+  <p:cSld>
+    <p:spTree>
+      <p:nvGrpSpPr>
+        <p:cNvPr id="1" name=""/>
+        <p:cNvGrpSpPr/>
+        <p:nvPr/>
+      </p:nvGrpSpPr>
+      <p:grpSpPr>
+        <a:xfrm>
+          <a:off x="0" y="0"/>
+          <a:ext cx="0" cy="0"/>
+          <a:chOff x="0" y="0"/>
+          <a:chExt cx="0" cy="0"/>
+        </a:xfrm>
+      </p:grpSpPr>
+      <p:sp>
+        <p:nvSpPr>
+          <p:cNvPr id="2" name="Slide Image Placeholder 1"/>
+          <p:cNvSpPr>
+            <a:spLocks noGrp="1" noRot="1" noChangeAspect="1"/>
+          </p:cNvSpPr>
+          <p:nvPr>
+            <p:ph type="sldImg"/>
+          </p:nvPr>
+        </p:nvSpPr>
+        <p:spPr/>
+      </p:sp>
+      <p:sp>
+        <p:nvSpPr>
+          <p:cNvPr id="3" name="Notes Placeholder 2"/>
+          <p:cNvSpPr>
+            <a:spLocks noGrp="1"/>
+          </p:cNvSpPr>
+          <p:nvPr>
+            <p:ph type="body" idx="1"/>
+          </p:nvPr>
+        </p:nvSpPr>
+        <p:spPr/>
+        <p:txBody>
+          <a:bodyPr/>
+          <a:lstStyle/>
+          <a:p>
+            <a:r>
+              <a:rPr lang="en-US" dirty="0"/>
+              <a:t/>
+            </a:r>
+            <a:endParaRPr lang="en-US" dirty="0"/>
+          </a:p>
+        </p:txBody>
+      </p:sp>
+      <p:sp>
+        <p:nvSpPr>
+          <p:cNvPr id="4" name="Slide Number Placeholder 3"/>
+          <p:cNvSpPr>
+            <a:spLocks noGrp="1"/>
+          </p:cNvSpPr>
+          <p:nvPr>
+            <p:ph type="sldNum" sz="quarter" idx="10"/>
+          </p:nvPr>
+        </p:nvSpPr>
+        <p:spPr/>
+        <p:txBody>
+          <a:bodyPr/>
+          <a:lstStyle/>
+          <a:p>
+            <a:fld id="{F7021451-1387-4CA6-816F-3879F97B5CBC}" type="slidenum">
+              <a:rPr lang="en-US"/>
+              <a:t>26</a:t>
             </a:fld>
             <a:endParaRPr lang="en-US"/>
           </a:p>
@@ -13684,13 +13773,13 @@
             <a:r>
               <a:rPr lang="en-US" sz="1200" b="1" spc="300" kern="0" dirty="0">
                 <a:solidFill>
-                  <a:srgbClr val="C44E52"/>
+                  <a:srgbClr val="9AA0B0"/>
                 </a:solidFill>
                 <a:latin typeface="Calibri" pitchFamily="34" charset="0"/>
                 <a:ea typeface="Calibri" pitchFamily="34" charset="-122"/>
                 <a:cs typeface="Calibri" pitchFamily="34" charset="-120"/>
               </a:rPr>
-              <a:t>INTERACTIVE · MODEL EXPLORER</a:t>
+              <a:t>BACKUP · METHODS</a:t>
             </a:r>
             <a:endParaRPr lang="en-US" sz="1200" dirty="0"/>
           </a:p>
@@ -13719,12 +13808,12 @@
           <a:p>
             <a:pPr indent="0" marL="0">
               <a:lnSpc>
-                <a:spcPts val="2700"/>
+                <a:spcPts val="2808"/>
               </a:lnSpc>
               <a:buNone/>
             </a:pPr>
             <a:r>
-              <a:rPr lang="en-US" sz="2500" b="1" dirty="0">
+              <a:rPr lang="en-US" sz="2600" b="1" dirty="0">
                 <a:solidFill>
                   <a:srgbClr val="23262F"/>
                 </a:solidFill>
@@ -13732,73 +13821,83 @@
                 <a:ea typeface="Georgia" pitchFamily="34" charset="-122"/>
                 <a:cs typeface="Georgia" pitchFamily="34" charset="-120"/>
               </a:rPr>
-              <a:t>Does it hold across models?  ▸ click a button</a:t>
-            </a:r>
-            <a:endParaRPr lang="en-US" sz="2500" dirty="0"/>
-          </a:p>
-        </p:txBody>
-      </p:sp>
-      <p:pic>
-        <p:nvPicPr>
-          <p:cNvPr id="4" name="Image 0" descr="/Users/xiaochuan/Desktop/Projects/P5_Multi_linguistic_histoBias/v3/experiments/exp3a_mixed_effects/figures/figC_attribute_OR_qwen7b.png">    </p:cNvPr>
-          <p:cNvPicPr>
-            <a:picLocks noChangeAspect="1"/>
-          </p:cNvPicPr>
-          <p:nvPr/>
-        </p:nvPicPr>
-        <p:blipFill>
-          <a:blip r:embed="rId1"/>
-          <a:stretch>
-            <a:fillRect/>
-          </a:stretch>
-        </p:blipFill>
-        <p:spPr>
-          <a:xfrm>
-            <a:off x="1709928" y="1737360"/>
-            <a:ext cx="8778240" cy="3351753"/>
+              <a:t>The cross-lingual metrics, defined</a:t>
+            </a:r>
+            <a:endParaRPr lang="en-US" sz="2600" dirty="0"/>
+          </a:p>
+        </p:txBody>
+      </p:sp>
+      <p:sp>
+        <p:nvSpPr>
+          <p:cNvPr id="4" name="Text 2"/>
+          <p:cNvSpPr/>
+          <p:nvPr/>
+        </p:nvSpPr>
+        <p:spPr>
+          <a:xfrm>
+            <a:off x="685800" y="1645920"/>
+            <a:ext cx="10820095" cy="365760"/>
           </a:xfrm>
           <a:prstGeom prst="rect">
             <a:avLst/>
           </a:prstGeom>
-        </p:spPr>
-      </p:pic>
-      <p:sp>
-        <p:nvSpPr>
-          <p:cNvPr id="5" name="Shape 2"/>
-          <p:cNvSpPr/>
-          <p:nvPr/>
-        </p:nvSpPr>
-        <p:spPr>
-          <a:xfrm>
-            <a:off x="1325880" y="5943600"/>
-            <a:ext cx="3108960" cy="603504"/>
+          <a:noFill/>
+          <a:ln/>
+        </p:spPr>
+        <p:txBody>
+          <a:bodyPr wrap="square" lIns="0" tIns="0" rIns="0" bIns="0" rtlCol="0" anchor="ctr"/>
+          <a:lstStyle/>
+          <a:p>
+            <a:pPr indent="0" marL="0">
+              <a:buNone/>
+            </a:pPr>
+            <a:r>
+              <a:rPr lang="en-US" sz="1500" i="1" dirty="0">
+                <a:solidFill>
+                  <a:srgbClr val="5A6072"/>
+                </a:solidFill>
+                <a:latin typeface="Calibri" pitchFamily="34" charset="0"/>
+                <a:ea typeface="Calibri" pitchFamily="34" charset="-122"/>
+                <a:cs typeface="Calibri" pitchFamily="34" charset="-120"/>
+              </a:rPr>
+              <a:t>For each image-pair we summarise its behaviour across all its languages (items judged in ≥ 2 languages).</a:t>
+            </a:r>
+            <a:endParaRPr lang="en-US" sz="1500" dirty="0"/>
+          </a:p>
+        </p:txBody>
+      </p:sp>
+      <p:sp>
+        <p:nvSpPr>
+          <p:cNvPr id="5" name="Shape 3"/>
+          <p:cNvSpPr/>
+          <p:nvPr/>
+        </p:nvSpPr>
+        <p:spPr>
+          <a:xfrm>
+            <a:off x="685800" y="2148840"/>
+            <a:ext cx="10820095" cy="822960"/>
           </a:xfrm>
           <a:prstGeom prst="roundRect">
             <a:avLst>
-              <a:gd name="adj" fmla="val 12121"/>
+              <a:gd name="adj" fmla="val 8889"/>
             </a:avLst>
           </a:prstGeom>
           <a:solidFill>
             <a:srgbClr val="1B1F3B"/>
           </a:solidFill>
-          <a:ln w="12700">
-            <a:solidFill>
-              <a:srgbClr val="1B1F3B"/>
-            </a:solidFill>
-            <a:prstDash val="solid"/>
-          </a:ln>
-        </p:spPr>
-      </p:sp>
-      <p:sp>
-        <p:nvSpPr>
-          <p:cNvPr id="6" name="Text 3"/>
-          <p:cNvSpPr/>
-          <p:nvPr/>
-        </p:nvSpPr>
-        <p:spPr>
-          <a:xfrm>
-            <a:off x="1325880" y="5943600"/>
-            <a:ext cx="3108960" cy="603504"/>
+          <a:ln/>
+        </p:spPr>
+      </p:sp>
+      <p:sp>
+        <p:nvSpPr>
+          <p:cNvPr id="6" name="Text 4"/>
+          <p:cNvSpPr/>
+          <p:nvPr/>
+        </p:nvSpPr>
+        <p:spPr>
+          <a:xfrm>
+            <a:off x="685800" y="2148840"/>
+            <a:ext cx="10820095" cy="822960"/>
           </a:xfrm>
           <a:prstGeom prst="rect">
             <a:avLst/>
@@ -13807,141 +13906,147 @@
           <a:ln/>
         </p:spPr>
         <p:txBody>
-          <a:bodyPr wrap="square" lIns="0" tIns="0" rIns="0" bIns="0" rtlCol="0" anchor="ctr"/>
+          <a:bodyPr wrap="square" lIns="50800" tIns="50800" rIns="50800" bIns="50800" rtlCol="0" anchor="ctr"/>
           <a:lstStyle/>
           <a:p>
             <a:pPr algn="ctr" indent="0" marL="0">
               <a:buNone/>
             </a:pPr>
             <a:r>
-              <a:rPr lang="en-US" sz="1400" b="1" dirty="0">
+              <a:rPr lang="en-US" sz="1250" dirty="0">
                 <a:solidFill>
                   <a:srgbClr val="FFFFFF"/>
+                </a:solidFill>
+                <a:latin typeface="Courier New" pitchFamily="34" charset="0"/>
+                <a:ea typeface="Courier New" pitchFamily="34" charset="-122"/>
+                <a:cs typeface="Courier New" pitchFamily="34" charset="-120"/>
+              </a:rPr>
+              <a:t>per item, across languages:   all-wrong → SBR   ·   all-right → SCR   ·   mixed → CFR</a:t>
+            </a:r>
+            <a:endParaRPr lang="en-US" sz="1250" dirty="0"/>
+          </a:p>
+          <a:p>
+            <a:pPr algn="ctr" indent="0" marL="0">
+              <a:buNone/>
+            </a:pPr>
+            <a:r>
+              <a:rPr lang="en-US" sz="1250" dirty="0">
+                <a:solidFill>
+                  <a:srgbClr val="FFFFFF"/>
+                </a:solidFill>
+                <a:latin typeface="Courier New" pitchFamily="34" charset="0"/>
+                <a:ea typeface="Courier New" pitchFamily="34" charset="-122"/>
+                <a:cs typeface="Courier New" pitchFamily="34" charset="-120"/>
+              </a:rPr>
+              <a:t>CFR + SBR + SCR = 1</a:t>
+            </a:r>
+            <a:endParaRPr lang="en-US" sz="1250" dirty="0"/>
+          </a:p>
+        </p:txBody>
+      </p:sp>
+      <p:sp>
+        <p:nvSpPr>
+          <p:cNvPr id="7" name="Shape 5"/>
+          <p:cNvSpPr/>
+          <p:nvPr/>
+        </p:nvSpPr>
+        <p:spPr>
+          <a:xfrm>
+            <a:off x="685800" y="3319272"/>
+            <a:ext cx="146304" cy="146304"/>
+          </a:xfrm>
+          <a:prstGeom prst="ellipse">
+            <a:avLst/>
+          </a:prstGeom>
+          <a:solidFill>
+            <a:srgbClr val="C44E52"/>
+          </a:solidFill>
+          <a:ln/>
+        </p:spPr>
+      </p:sp>
+      <p:sp>
+        <p:nvSpPr>
+          <p:cNvPr id="8" name="Text 6"/>
+          <p:cNvSpPr/>
+          <p:nvPr/>
+        </p:nvSpPr>
+        <p:spPr>
+          <a:xfrm>
+            <a:off x="1005840" y="3246120"/>
+            <a:ext cx="10500055" cy="548640"/>
+          </a:xfrm>
+          <a:prstGeom prst="rect">
+            <a:avLst/>
+          </a:prstGeom>
+          <a:noFill/>
+          <a:ln/>
+        </p:spPr>
+        <p:txBody>
+          <a:bodyPr wrap="square" lIns="0" tIns="0" rIns="0" bIns="0" rtlCol="0" anchor="t"/>
+          <a:lstStyle/>
+          <a:p>
+            <a:pPr indent="0" marL="0">
+              <a:buNone/>
+            </a:pPr>
+            <a:r>
+              <a:rPr lang="en-US" sz="1550" b="1" dirty="0">
+                <a:solidFill>
+                  <a:srgbClr val="C44E52"/>
                 </a:solidFill>
                 <a:latin typeface="Calibri" pitchFamily="34" charset="0"/>
                 <a:ea typeface="Calibri" pitchFamily="34" charset="-122"/>
                 <a:cs typeface="Calibri" pitchFamily="34" charset="-120"/>
               </a:rPr>
-              <a:t>Qwen-7B</a:t>
-            </a:r>
-            <a:endParaRPr lang="en-US" sz="1400" dirty="0"/>
-          </a:p>
-        </p:txBody>
-      </p:sp>
-      <p:sp>
-        <p:nvSpPr>
-          <p:cNvPr id="7" name="Shape 4"/>
-          <p:cNvSpPr/>
-          <p:nvPr/>
-        </p:nvSpPr>
-        <p:spPr>
-          <a:xfrm>
-            <a:off x="4544568" y="5943600"/>
-            <a:ext cx="3108960" cy="603504"/>
-          </a:xfrm>
-          <a:prstGeom prst="roundRect">
-            <a:avLst>
-              <a:gd name="adj" fmla="val 12121"/>
-            </a:avLst>
-          </a:prstGeom>
-          <a:solidFill>
-            <a:srgbClr val="F5F6FA"/>
-          </a:solidFill>
-          <a:ln w="12700">
-            <a:solidFill>
-              <a:srgbClr val="E4E6EF"/>
-            </a:solidFill>
-            <a:prstDash val="solid"/>
-          </a:ln>
-        </p:spPr>
-      </p:sp>
-      <p:sp>
-        <p:nvSpPr>
-          <p:cNvPr id="8" name="Text 5">
-            <a:hlinkClick r:id="rId2" tooltip="" action="ppaction://hlinksldjump"/>
-          </p:cNvPr>
-          <p:cNvSpPr/>
-          <p:nvPr/>
-        </p:nvSpPr>
-        <p:spPr>
-          <a:xfrm>
-            <a:off x="4544568" y="5943600"/>
-            <a:ext cx="3108960" cy="603504"/>
-          </a:xfrm>
-          <a:prstGeom prst="rect">
-            <a:avLst/>
-          </a:prstGeom>
-          <a:noFill/>
-          <a:ln/>
-        </p:spPr>
-        <p:txBody>
-          <a:bodyPr wrap="square" lIns="0" tIns="0" rIns="0" bIns="0" rtlCol="0" anchor="ctr"/>
-          <a:lstStyle/>
-          <a:p>
-            <a:pPr algn="ctr" indent="0" marL="0">
+              <a:t>Cross-lingual Flip Rate (CFR)  </a:t>
+            </a:r>
+            <a:pPr indent="0" marL="0">
               <a:buNone/>
             </a:pPr>
             <a:r>
-              <a:rPr lang="en-US" sz="1400" b="1" u="sng" dirty="0">
-                <a:solidFill>
-                  <a:srgbClr val="1B1F3B"/>
+              <a:rPr lang="en-US" sz="1550" dirty="0">
+                <a:solidFill>
+                  <a:srgbClr val="23262F"/>
                 </a:solidFill>
                 <a:latin typeface="Calibri" pitchFamily="34" charset="0"/>
                 <a:ea typeface="Calibri" pitchFamily="34" charset="-122"/>
                 <a:cs typeface="Calibri" pitchFamily="34" charset="-120"/>
-                <a:hlinkClick r:id="rId2" action="ppaction://hlinksldjump" tooltip="">
-                  <a:extLst>
-                    <a:ext uri="{A12FA001-AC4F-418D-AE19-62706E023703}">
-                      <ahyp:hlinkClr xmlns:ahyp="http://schemas.microsoft.com/office/drawing/2018/hyperlinkcolor" val="tx"/>
-                    </a:ext>
-                  </a:extLst>
-                </a:hlinkClick>
-              </a:rPr>
-              <a:t>InternVL3-8B</a:t>
-            </a:r>
-            <a:endParaRPr lang="en-US" sz="1400" dirty="0"/>
-          </a:p>
-        </p:txBody>
-      </p:sp>
-      <p:sp>
-        <p:nvSpPr>
-          <p:cNvPr id="9" name="Shape 6"/>
-          <p:cNvSpPr/>
-          <p:nvPr/>
-        </p:nvSpPr>
-        <p:spPr>
-          <a:xfrm>
-            <a:off x="7763256" y="5943600"/>
-            <a:ext cx="3108960" cy="603504"/>
-          </a:xfrm>
-          <a:prstGeom prst="roundRect">
-            <a:avLst>
-              <a:gd name="adj" fmla="val 12121"/>
-            </a:avLst>
+              </a:rPr>
+              <a:t>— the model's choice changes across languages — the item is not stable.</a:t>
+            </a:r>
+            <a:endParaRPr lang="en-US" sz="1550" dirty="0"/>
+          </a:p>
+        </p:txBody>
+      </p:sp>
+      <p:sp>
+        <p:nvSpPr>
+          <p:cNvPr id="9" name="Shape 7"/>
+          <p:cNvSpPr/>
+          <p:nvPr/>
+        </p:nvSpPr>
+        <p:spPr>
+          <a:xfrm>
+            <a:off x="685800" y="4069080"/>
+            <a:ext cx="146304" cy="146304"/>
+          </a:xfrm>
+          <a:prstGeom prst="ellipse">
+            <a:avLst/>
           </a:prstGeom>
           <a:solidFill>
-            <a:srgbClr val="F5F6FA"/>
+            <a:srgbClr val="4C72B0"/>
           </a:solidFill>
-          <a:ln w="12700">
-            <a:solidFill>
-              <a:srgbClr val="E4E6EF"/>
-            </a:solidFill>
-            <a:prstDash val="solid"/>
-          </a:ln>
-        </p:spPr>
-      </p:sp>
-      <p:sp>
-        <p:nvSpPr>
-          <p:cNvPr id="10" name="Text 7">
-            <a:hlinkClick r:id="rId3" tooltip="" action="ppaction://hlinksldjump"/>
-          </p:cNvPr>
-          <p:cNvSpPr/>
-          <p:nvPr/>
-        </p:nvSpPr>
-        <p:spPr>
-          <a:xfrm>
-            <a:off x="7763256" y="5943600"/>
-            <a:ext cx="3108960" cy="603504"/>
+          <a:ln/>
+        </p:spPr>
+      </p:sp>
+      <p:sp>
+        <p:nvSpPr>
+          <p:cNvPr id="10" name="Text 8"/>
+          <p:cNvSpPr/>
+          <p:nvPr/>
+        </p:nvSpPr>
+        <p:spPr>
+          <a:xfrm>
+            <a:off x="1005840" y="3995928"/>
+            <a:ext cx="10500055" cy="548640"/>
           </a:xfrm>
           <a:prstGeom prst="rect">
             <a:avLst/>
@@ -13950,37 +14055,156 @@
           <a:ln/>
         </p:spPr>
         <p:txBody>
-          <a:bodyPr wrap="square" lIns="0" tIns="0" rIns="0" bIns="0" rtlCol="0" anchor="ctr"/>
-          <a:lstStyle/>
-          <a:p>
-            <a:pPr algn="ctr" indent="0" marL="0">
+          <a:bodyPr wrap="square" lIns="0" tIns="0" rIns="0" bIns="0" rtlCol="0" anchor="t"/>
+          <a:lstStyle/>
+          <a:p>
+            <a:pPr indent="0" marL="0">
               <a:buNone/>
             </a:pPr>
             <a:r>
-              <a:rPr lang="en-US" sz="1400" b="1" u="sng" dirty="0">
-                <a:solidFill>
-                  <a:srgbClr val="1B1F3B"/>
+              <a:rPr lang="en-US" sz="1550" b="1" dirty="0">
+                <a:solidFill>
+                  <a:srgbClr val="4C72B0"/>
                 </a:solidFill>
                 <a:latin typeface="Calibri" pitchFamily="34" charset="0"/>
                 <a:ea typeface="Calibri" pitchFamily="34" charset="-122"/>
                 <a:cs typeface="Calibri" pitchFamily="34" charset="-120"/>
-                <a:hlinkClick r:id="rId3" action="ppaction://hlinksldjump" tooltip="">
-                  <a:extLst>
-                    <a:ext uri="{A12FA001-AC4F-418D-AE19-62706E023703}">
-                      <ahyp:hlinkClr xmlns:ahyp="http://schemas.microsoft.com/office/drawing/2018/hyperlinkcolor" val="tx"/>
-                    </a:ext>
-                  </a:extLst>
-                </a:hlinkClick>
-              </a:rPr>
-              <a:t>Both overlaid</a:t>
-            </a:r>
-            <a:endParaRPr lang="en-US" sz="1400" dirty="0"/>
-          </a:p>
-        </p:txBody>
-      </p:sp>
-      <p:sp>
-        <p:nvSpPr>
-          <p:cNvPr id="11" name="Text 8"/>
+              </a:rPr>
+              <a:t>Stable Bias Rate (SBR)  </a:t>
+            </a:r>
+            <a:pPr indent="0" marL="0">
+              <a:buNone/>
+            </a:pPr>
+            <a:r>
+              <a:rPr lang="en-US" sz="1550" dirty="0">
+                <a:solidFill>
+                  <a:srgbClr val="23262F"/>
+                </a:solidFill>
+                <a:latin typeface="Calibri" pitchFamily="34" charset="0"/>
+                <a:ea typeface="Calibri" pitchFamily="34" charset="-122"/>
+                <a:cs typeface="Calibri" pitchFamily="34" charset="-120"/>
+              </a:rPr>
+              <a:t>— the model picks the prototypical-but-wrong image in every language.</a:t>
+            </a:r>
+            <a:endParaRPr lang="en-US" sz="1550" dirty="0"/>
+          </a:p>
+        </p:txBody>
+      </p:sp>
+      <p:sp>
+        <p:nvSpPr>
+          <p:cNvPr id="11" name="Shape 9"/>
+          <p:cNvSpPr/>
+          <p:nvPr/>
+        </p:nvSpPr>
+        <p:spPr>
+          <a:xfrm>
+            <a:off x="685800" y="4818888"/>
+            <a:ext cx="146304" cy="146304"/>
+          </a:xfrm>
+          <a:prstGeom prst="ellipse">
+            <a:avLst/>
+          </a:prstGeom>
+          <a:solidFill>
+            <a:srgbClr val="55A868"/>
+          </a:solidFill>
+          <a:ln/>
+        </p:spPr>
+      </p:sp>
+      <p:sp>
+        <p:nvSpPr>
+          <p:cNvPr id="12" name="Text 10"/>
+          <p:cNvSpPr/>
+          <p:nvPr/>
+        </p:nvSpPr>
+        <p:spPr>
+          <a:xfrm>
+            <a:off x="1005840" y="4745736"/>
+            <a:ext cx="10500055" cy="548640"/>
+          </a:xfrm>
+          <a:prstGeom prst="rect">
+            <a:avLst/>
+          </a:prstGeom>
+          <a:noFill/>
+          <a:ln/>
+        </p:spPr>
+        <p:txBody>
+          <a:bodyPr wrap="square" lIns="0" tIns="0" rIns="0" bIns="0" rtlCol="0" anchor="t"/>
+          <a:lstStyle/>
+          <a:p>
+            <a:pPr indent="0" marL="0">
+              <a:buNone/>
+            </a:pPr>
+            <a:r>
+              <a:rPr lang="en-US" sz="1550" b="1" dirty="0">
+                <a:solidFill>
+                  <a:srgbClr val="55A868"/>
+                </a:solidFill>
+                <a:latin typeface="Calibri" pitchFamily="34" charset="0"/>
+                <a:ea typeface="Calibri" pitchFamily="34" charset="-122"/>
+                <a:cs typeface="Calibri" pitchFamily="34" charset="-120"/>
+              </a:rPr>
+              <a:t>Stable Correct Rate (SCR)  </a:t>
+            </a:r>
+            <a:pPr indent="0" marL="0">
+              <a:buNone/>
+            </a:pPr>
+            <a:r>
+              <a:rPr lang="en-US" sz="1550" dirty="0">
+                <a:solidFill>
+                  <a:srgbClr val="23262F"/>
+                </a:solidFill>
+                <a:latin typeface="Calibri" pitchFamily="34" charset="0"/>
+                <a:ea typeface="Calibri" pitchFamily="34" charset="-122"/>
+                <a:cs typeface="Calibri" pitchFamily="34" charset="-120"/>
+              </a:rPr>
+              <a:t>— the model picks the correct image in every language.</a:t>
+            </a:r>
+            <a:endParaRPr lang="en-US" sz="1550" dirty="0"/>
+          </a:p>
+        </p:txBody>
+      </p:sp>
+      <p:sp>
+        <p:nvSpPr>
+          <p:cNvPr id="13" name="Text 11"/>
+          <p:cNvSpPr/>
+          <p:nvPr/>
+        </p:nvSpPr>
+        <p:spPr>
+          <a:xfrm>
+            <a:off x="685800" y="5669280"/>
+            <a:ext cx="10820095" cy="640080"/>
+          </a:xfrm>
+          <a:prstGeom prst="rect">
+            <a:avLst/>
+          </a:prstGeom>
+          <a:noFill/>
+          <a:ln/>
+        </p:spPr>
+        <p:txBody>
+          <a:bodyPr wrap="square" lIns="0" tIns="0" rIns="0" bIns="0" rtlCol="0" anchor="ctr"/>
+          <a:lstStyle/>
+          <a:p>
+            <a:pPr indent="0" marL="0">
+              <a:buNone/>
+            </a:pPr>
+            <a:r>
+              <a:rPr lang="en-US" sz="1300" i="1" dirty="0">
+                <a:solidFill>
+                  <a:srgbClr val="5A6072"/>
+                </a:solidFill>
+                <a:latin typeface="Calibri" pitchFamily="34" charset="0"/>
+                <a:ea typeface="Calibri" pitchFamily="34" charset="-122"/>
+                <a:cs typeface="Calibri" pitchFamily="34" charset="-120"/>
+              </a:rPr>
+              <a:t>These are item-level summaries across languages, not per-judgment — which is why a flat aggregate error rate can still hide heavy item-level flipping (overall CFR ≈ 0.65).</a:t>
+            </a:r>
+            <a:endParaRPr lang="en-US" sz="1300" dirty="0"/>
+          </a:p>
+        </p:txBody>
+      </p:sp>
+      <p:sp>
+        <p:nvSpPr>
+          <p:cNvPr id="14" name="Text 12"/>
           <p:cNvSpPr/>
           <p:nvPr/>
         </p:nvSpPr>
@@ -14132,7 +14356,7 @@
       </p:sp>
       <p:pic>
         <p:nvPicPr>
-          <p:cNvPr id="4" name="Image 0" descr="/Users/xiaochuan/Desktop/Projects/P5_Multi_linguistic_histoBias/v3/experiments/exp3a_mixed_effects/figures/figC_attribute_OR_internvl8b.png">    </p:cNvPr>
+          <p:cNvPr id="4" name="Image 0" descr="/Users/xiaochuan/Desktop/Projects/P5_Multi_linguistic_histoBias/v3/experiments/exp3a_mixed_effects/figures/figC_attribute_OR_qwen7b.png">    </p:cNvPr>
           <p:cNvPicPr>
             <a:picLocks noChangeAspect="1"/>
           </p:cNvPicPr>
@@ -14163,6 +14387,72 @@
         <p:spPr>
           <a:xfrm>
             <a:off x="1325880" y="5943600"/>
+            <a:ext cx="3108960" cy="603504"/>
+          </a:xfrm>
+          <a:prstGeom prst="roundRect">
+            <a:avLst>
+              <a:gd name="adj" fmla="val 12121"/>
+            </a:avLst>
+          </a:prstGeom>
+          <a:solidFill>
+            <a:srgbClr val="1B1F3B"/>
+          </a:solidFill>
+          <a:ln w="12700">
+            <a:solidFill>
+              <a:srgbClr val="1B1F3B"/>
+            </a:solidFill>
+            <a:prstDash val="solid"/>
+          </a:ln>
+        </p:spPr>
+      </p:sp>
+      <p:sp>
+        <p:nvSpPr>
+          <p:cNvPr id="6" name="Text 3"/>
+          <p:cNvSpPr/>
+          <p:nvPr/>
+        </p:nvSpPr>
+        <p:spPr>
+          <a:xfrm>
+            <a:off x="1325880" y="5943600"/>
+            <a:ext cx="3108960" cy="603504"/>
+          </a:xfrm>
+          <a:prstGeom prst="rect">
+            <a:avLst/>
+          </a:prstGeom>
+          <a:noFill/>
+          <a:ln/>
+        </p:spPr>
+        <p:txBody>
+          <a:bodyPr wrap="square" lIns="0" tIns="0" rIns="0" bIns="0" rtlCol="0" anchor="ctr"/>
+          <a:lstStyle/>
+          <a:p>
+            <a:pPr algn="ctr" indent="0" marL="0">
+              <a:buNone/>
+            </a:pPr>
+            <a:r>
+              <a:rPr lang="en-US" sz="1400" b="1" dirty="0">
+                <a:solidFill>
+                  <a:srgbClr val="FFFFFF"/>
+                </a:solidFill>
+                <a:latin typeface="Calibri" pitchFamily="34" charset="0"/>
+                <a:ea typeface="Calibri" pitchFamily="34" charset="-122"/>
+                <a:cs typeface="Calibri" pitchFamily="34" charset="-120"/>
+              </a:rPr>
+              <a:t>Qwen-7B</a:t>
+            </a:r>
+            <a:endParaRPr lang="en-US" sz="1400" dirty="0"/>
+          </a:p>
+        </p:txBody>
+      </p:sp>
+      <p:sp>
+        <p:nvSpPr>
+          <p:cNvPr id="7" name="Shape 4"/>
+          <p:cNvSpPr/>
+          <p:nvPr/>
+        </p:nvSpPr>
+        <p:spPr>
+          <a:xfrm>
+            <a:off x="4544568" y="5943600"/>
             <a:ext cx="3108960" cy="603504"/>
           </a:xfrm>
           <a:prstGeom prst="roundRect">
@@ -14183,7 +14473,7 @@
       </p:sp>
       <p:sp>
         <p:nvSpPr>
-          <p:cNvPr id="6" name="Text 3">
+          <p:cNvPr id="8" name="Text 5">
             <a:hlinkClick r:id="rId2" tooltip="" action="ppaction://hlinksldjump"/>
           </p:cNvPr>
           <p:cNvSpPr/>
@@ -14191,7 +14481,7 @@
         </p:nvSpPr>
         <p:spPr>
           <a:xfrm>
-            <a:off x="1325880" y="5943600"/>
+            <a:off x="4544568" y="5943600"/>
             <a:ext cx="3108960" cy="603504"/>
           </a:xfrm>
           <a:prstGeom prst="rect">
@@ -14222,72 +14512,6 @@
                     </a:ext>
                   </a:extLst>
                 </a:hlinkClick>
-              </a:rPr>
-              <a:t>Qwen-7B</a:t>
-            </a:r>
-            <a:endParaRPr lang="en-US" sz="1400" dirty="0"/>
-          </a:p>
-        </p:txBody>
-      </p:sp>
-      <p:sp>
-        <p:nvSpPr>
-          <p:cNvPr id="7" name="Shape 4"/>
-          <p:cNvSpPr/>
-          <p:nvPr/>
-        </p:nvSpPr>
-        <p:spPr>
-          <a:xfrm>
-            <a:off x="4544568" y="5943600"/>
-            <a:ext cx="3108960" cy="603504"/>
-          </a:xfrm>
-          <a:prstGeom prst="roundRect">
-            <a:avLst>
-              <a:gd name="adj" fmla="val 12121"/>
-            </a:avLst>
-          </a:prstGeom>
-          <a:solidFill>
-            <a:srgbClr val="1B1F3B"/>
-          </a:solidFill>
-          <a:ln w="12700">
-            <a:solidFill>
-              <a:srgbClr val="1B1F3B"/>
-            </a:solidFill>
-            <a:prstDash val="solid"/>
-          </a:ln>
-        </p:spPr>
-      </p:sp>
-      <p:sp>
-        <p:nvSpPr>
-          <p:cNvPr id="8" name="Text 5"/>
-          <p:cNvSpPr/>
-          <p:nvPr/>
-        </p:nvSpPr>
-        <p:spPr>
-          <a:xfrm>
-            <a:off x="4544568" y="5943600"/>
-            <a:ext cx="3108960" cy="603504"/>
-          </a:xfrm>
-          <a:prstGeom prst="rect">
-            <a:avLst/>
-          </a:prstGeom>
-          <a:noFill/>
-          <a:ln/>
-        </p:spPr>
-        <p:txBody>
-          <a:bodyPr wrap="square" lIns="0" tIns="0" rIns="0" bIns="0" rtlCol="0" anchor="ctr"/>
-          <a:lstStyle/>
-          <a:p>
-            <a:pPr algn="ctr" indent="0" marL="0">
-              <a:buNone/>
-            </a:pPr>
-            <a:r>
-              <a:rPr lang="en-US" sz="1400" b="1" dirty="0">
-                <a:solidFill>
-                  <a:srgbClr val="FFFFFF"/>
-                </a:solidFill>
-                <a:latin typeface="Calibri" pitchFamily="34" charset="0"/>
-                <a:ea typeface="Calibri" pitchFamily="34" charset="-122"/>
-                <a:cs typeface="Calibri" pitchFamily="34" charset="-120"/>
               </a:rPr>
               <a:t>InternVL3-8B</a:t>
             </a:r>
@@ -14524,7 +14748,7 @@
       </p:sp>
       <p:pic>
         <p:nvPicPr>
-          <p:cNvPr id="4" name="Image 0" descr="/Users/xiaochuan/Desktop/Projects/P5_Multi_linguistic_histoBias/v3/experiments/exp3a_mixed_effects/figures/figE_cross_model_OR.png">    </p:cNvPr>
+          <p:cNvPr id="4" name="Image 0" descr="/Users/xiaochuan/Desktop/Projects/P5_Multi_linguistic_histoBias/v3/experiments/exp3a_mixed_effects/figures/figC_attribute_OR_internvl8b.png">    </p:cNvPr>
           <p:cNvPicPr>
             <a:picLocks noChangeAspect="1"/>
           </p:cNvPicPr>
@@ -14539,7 +14763,7 @@
         <p:spPr>
           <a:xfrm>
             <a:off x="1709928" y="1737360"/>
-            <a:ext cx="8778240" cy="3364599"/>
+            <a:ext cx="8778240" cy="3351753"/>
           </a:xfrm>
           <a:prstGeom prst="rect">
             <a:avLst/>
@@ -14638,6 +14862,72 @@
             </a:avLst>
           </a:prstGeom>
           <a:solidFill>
+            <a:srgbClr val="1B1F3B"/>
+          </a:solidFill>
+          <a:ln w="12700">
+            <a:solidFill>
+              <a:srgbClr val="1B1F3B"/>
+            </a:solidFill>
+            <a:prstDash val="solid"/>
+          </a:ln>
+        </p:spPr>
+      </p:sp>
+      <p:sp>
+        <p:nvSpPr>
+          <p:cNvPr id="8" name="Text 5"/>
+          <p:cNvSpPr/>
+          <p:nvPr/>
+        </p:nvSpPr>
+        <p:spPr>
+          <a:xfrm>
+            <a:off x="4544568" y="5943600"/>
+            <a:ext cx="3108960" cy="603504"/>
+          </a:xfrm>
+          <a:prstGeom prst="rect">
+            <a:avLst/>
+          </a:prstGeom>
+          <a:noFill/>
+          <a:ln/>
+        </p:spPr>
+        <p:txBody>
+          <a:bodyPr wrap="square" lIns="0" tIns="0" rIns="0" bIns="0" rtlCol="0" anchor="ctr"/>
+          <a:lstStyle/>
+          <a:p>
+            <a:pPr algn="ctr" indent="0" marL="0">
+              <a:buNone/>
+            </a:pPr>
+            <a:r>
+              <a:rPr lang="en-US" sz="1400" b="1" dirty="0">
+                <a:solidFill>
+                  <a:srgbClr val="FFFFFF"/>
+                </a:solidFill>
+                <a:latin typeface="Calibri" pitchFamily="34" charset="0"/>
+                <a:ea typeface="Calibri" pitchFamily="34" charset="-122"/>
+                <a:cs typeface="Calibri" pitchFamily="34" charset="-120"/>
+              </a:rPr>
+              <a:t>InternVL3-8B</a:t>
+            </a:r>
+            <a:endParaRPr lang="en-US" sz="1400" dirty="0"/>
+          </a:p>
+        </p:txBody>
+      </p:sp>
+      <p:sp>
+        <p:nvSpPr>
+          <p:cNvPr id="9" name="Shape 6"/>
+          <p:cNvSpPr/>
+          <p:nvPr/>
+        </p:nvSpPr>
+        <p:spPr>
+          <a:xfrm>
+            <a:off x="7763256" y="5943600"/>
+            <a:ext cx="3108960" cy="603504"/>
+          </a:xfrm>
+          <a:prstGeom prst="roundRect">
+            <a:avLst>
+              <a:gd name="adj" fmla="val 12121"/>
+            </a:avLst>
+          </a:prstGeom>
+          <a:solidFill>
             <a:srgbClr val="F5F6FA"/>
           </a:solidFill>
           <a:ln w="12700">
@@ -14650,7 +14940,7 @@
       </p:sp>
       <p:sp>
         <p:nvSpPr>
-          <p:cNvPr id="8" name="Text 5">
+          <p:cNvPr id="10" name="Text 7">
             <a:hlinkClick r:id="rId3" tooltip="" action="ppaction://hlinksldjump"/>
           </p:cNvPr>
           <p:cNvSpPr/>
@@ -14658,7 +14948,7 @@
         </p:nvSpPr>
         <p:spPr>
           <a:xfrm>
-            <a:off x="4544568" y="5943600"/>
+            <a:off x="7763256" y="5943600"/>
             <a:ext cx="3108960" cy="603504"/>
           </a:xfrm>
           <a:prstGeom prst="rect">
@@ -14690,6 +14980,332 @@
                   </a:extLst>
                 </a:hlinkClick>
               </a:rPr>
+              <a:t>Both overlaid</a:t>
+            </a:r>
+            <a:endParaRPr lang="en-US" sz="1400" dirty="0"/>
+          </a:p>
+        </p:txBody>
+      </p:sp>
+      <p:sp>
+        <p:nvSpPr>
+          <p:cNvPr id="11" name="Text 8"/>
+          <p:cNvSpPr/>
+          <p:nvPr/>
+        </p:nvSpPr>
+        <p:spPr>
+          <a:xfrm>
+            <a:off x="11551615" y="6400800"/>
+            <a:ext cx="365760" cy="274320"/>
+          </a:xfrm>
+          <a:prstGeom prst="rect">
+            <a:avLst/>
+          </a:prstGeom>
+          <a:noFill/>
+          <a:ln/>
+        </p:spPr>
+        <p:txBody>
+          <a:bodyPr wrap="square" lIns="0" tIns="0" rIns="0" bIns="0" rtlCol="0" anchor="ctr"/>
+          <a:lstStyle/>
+          <a:p>
+            <a:pPr algn="r" indent="0" marL="0">
+              <a:buNone/>
+            </a:pPr>
+            <a:r>
+              <a:rPr lang="en-US" sz="1000" dirty="0">
+                <a:solidFill>
+                  <a:srgbClr val="9AA0B0"/>
+                </a:solidFill>
+                <a:latin typeface="Calibri" pitchFamily="34" charset="0"/>
+                <a:ea typeface="Calibri" pitchFamily="34" charset="-122"/>
+                <a:cs typeface="Calibri" pitchFamily="34" charset="-120"/>
+              </a:rPr>
+              <a:t>25</a:t>
+            </a:r>
+            <a:endParaRPr lang="en-US" sz="1000" dirty="0"/>
+          </a:p>
+        </p:txBody>
+      </p:sp>
+    </p:spTree>
+  </p:cSld>
+  <p:clrMapOvr>
+    <a:masterClrMapping/>
+  </p:clrMapOvr>
+</p:sld>
+</file>
+
+<file path=ppt/slides/slide26.xml><?xml version="1.0" encoding="utf-8"?>
+<p:sld xmlns:a="http://schemas.openxmlformats.org/drawingml/2006/main" xmlns:r="http://schemas.openxmlformats.org/officeDocument/2006/relationships" xmlns:p="http://schemas.openxmlformats.org/presentationml/2006/main">
+  <p:cSld name="Slide 26">
+    <p:bg>
+      <p:bgPr>
+        <a:solidFill>
+          <a:srgbClr val="FFFFFF"/>
+        </a:solidFill>
+      </p:bgPr>
+    </p:bg>
+    <p:spTree>
+      <p:nvGrpSpPr>
+        <p:cNvPr id="1" name=""/>
+        <p:cNvGrpSpPr/>
+        <p:nvPr/>
+      </p:nvGrpSpPr>
+      <p:grpSpPr>
+        <a:xfrm>
+          <a:off x="0" y="0"/>
+          <a:ext cx="0" cy="0"/>
+          <a:chOff x="0" y="0"/>
+          <a:chExt cx="0" cy="0"/>
+        </a:xfrm>
+      </p:grpSpPr>
+      <p:sp>
+        <p:nvSpPr>
+          <p:cNvPr id="2" name="Text 0"/>
+          <p:cNvSpPr/>
+          <p:nvPr/>
+        </p:nvSpPr>
+        <p:spPr>
+          <a:xfrm>
+            <a:off x="685800" y="502920"/>
+            <a:ext cx="10820095" cy="274320"/>
+          </a:xfrm>
+          <a:prstGeom prst="rect">
+            <a:avLst/>
+          </a:prstGeom>
+          <a:noFill/>
+          <a:ln/>
+        </p:spPr>
+        <p:txBody>
+          <a:bodyPr wrap="square" lIns="0" tIns="0" rIns="0" bIns="0" rtlCol="0" anchor="ctr"/>
+          <a:lstStyle/>
+          <a:p>
+            <a:pPr indent="0" marL="0">
+              <a:buNone/>
+            </a:pPr>
+            <a:r>
+              <a:rPr lang="en-US" sz="1200" b="1" spc="300" kern="0" dirty="0">
+                <a:solidFill>
+                  <a:srgbClr val="C44E52"/>
+                </a:solidFill>
+                <a:latin typeface="Calibri" pitchFamily="34" charset="0"/>
+                <a:ea typeface="Calibri" pitchFamily="34" charset="-122"/>
+                <a:cs typeface="Calibri" pitchFamily="34" charset="-120"/>
+              </a:rPr>
+              <a:t>INTERACTIVE · MODEL EXPLORER</a:t>
+            </a:r>
+            <a:endParaRPr lang="en-US" sz="1200" dirty="0"/>
+          </a:p>
+        </p:txBody>
+      </p:sp>
+      <p:sp>
+        <p:nvSpPr>
+          <p:cNvPr id="3" name="Text 1"/>
+          <p:cNvSpPr/>
+          <p:nvPr/>
+        </p:nvSpPr>
+        <p:spPr>
+          <a:xfrm>
+            <a:off x="685800" y="841248"/>
+            <a:ext cx="10820095" cy="868680"/>
+          </a:xfrm>
+          <a:prstGeom prst="rect">
+            <a:avLst/>
+          </a:prstGeom>
+          <a:noFill/>
+          <a:ln/>
+        </p:spPr>
+        <p:txBody>
+          <a:bodyPr wrap="square" lIns="0" tIns="0" rIns="0" bIns="0" rtlCol="0" anchor="ctr"/>
+          <a:lstStyle/>
+          <a:p>
+            <a:pPr indent="0" marL="0">
+              <a:lnSpc>
+                <a:spcPts val="2700"/>
+              </a:lnSpc>
+              <a:buNone/>
+            </a:pPr>
+            <a:r>
+              <a:rPr lang="en-US" sz="2500" b="1" dirty="0">
+                <a:solidFill>
+                  <a:srgbClr val="23262F"/>
+                </a:solidFill>
+                <a:latin typeface="Georgia" pitchFamily="34" charset="0"/>
+                <a:ea typeface="Georgia" pitchFamily="34" charset="-122"/>
+                <a:cs typeface="Georgia" pitchFamily="34" charset="-120"/>
+              </a:rPr>
+              <a:t>Does it hold across models?  ▸ click a button</a:t>
+            </a:r>
+            <a:endParaRPr lang="en-US" sz="2500" dirty="0"/>
+          </a:p>
+        </p:txBody>
+      </p:sp>
+      <p:pic>
+        <p:nvPicPr>
+          <p:cNvPr id="4" name="Image 0" descr="/Users/xiaochuan/Desktop/Projects/P5_Multi_linguistic_histoBias/v3/experiments/exp3a_mixed_effects/figures/figE_cross_model_OR.png">    </p:cNvPr>
+          <p:cNvPicPr>
+            <a:picLocks noChangeAspect="1"/>
+          </p:cNvPicPr>
+          <p:nvPr/>
+        </p:nvPicPr>
+        <p:blipFill>
+          <a:blip r:embed="rId1"/>
+          <a:stretch>
+            <a:fillRect/>
+          </a:stretch>
+        </p:blipFill>
+        <p:spPr>
+          <a:xfrm>
+            <a:off x="1709928" y="1737360"/>
+            <a:ext cx="8778240" cy="3364599"/>
+          </a:xfrm>
+          <a:prstGeom prst="rect">
+            <a:avLst/>
+          </a:prstGeom>
+        </p:spPr>
+      </p:pic>
+      <p:sp>
+        <p:nvSpPr>
+          <p:cNvPr id="5" name="Shape 2"/>
+          <p:cNvSpPr/>
+          <p:nvPr/>
+        </p:nvSpPr>
+        <p:spPr>
+          <a:xfrm>
+            <a:off x="1325880" y="5943600"/>
+            <a:ext cx="3108960" cy="603504"/>
+          </a:xfrm>
+          <a:prstGeom prst="roundRect">
+            <a:avLst>
+              <a:gd name="adj" fmla="val 12121"/>
+            </a:avLst>
+          </a:prstGeom>
+          <a:solidFill>
+            <a:srgbClr val="F5F6FA"/>
+          </a:solidFill>
+          <a:ln w="12700">
+            <a:solidFill>
+              <a:srgbClr val="E4E6EF"/>
+            </a:solidFill>
+            <a:prstDash val="solid"/>
+          </a:ln>
+        </p:spPr>
+      </p:sp>
+      <p:sp>
+        <p:nvSpPr>
+          <p:cNvPr id="6" name="Text 3">
+            <a:hlinkClick r:id="rId2" tooltip="" action="ppaction://hlinksldjump"/>
+          </p:cNvPr>
+          <p:cNvSpPr/>
+          <p:nvPr/>
+        </p:nvSpPr>
+        <p:spPr>
+          <a:xfrm>
+            <a:off x="1325880" y="5943600"/>
+            <a:ext cx="3108960" cy="603504"/>
+          </a:xfrm>
+          <a:prstGeom prst="rect">
+            <a:avLst/>
+          </a:prstGeom>
+          <a:noFill/>
+          <a:ln/>
+        </p:spPr>
+        <p:txBody>
+          <a:bodyPr wrap="square" lIns="0" tIns="0" rIns="0" bIns="0" rtlCol="0" anchor="ctr"/>
+          <a:lstStyle/>
+          <a:p>
+            <a:pPr algn="ctr" indent="0" marL="0">
+              <a:buNone/>
+            </a:pPr>
+            <a:r>
+              <a:rPr lang="en-US" sz="1400" b="1" u="sng" dirty="0">
+                <a:solidFill>
+                  <a:srgbClr val="1B1F3B"/>
+                </a:solidFill>
+                <a:latin typeface="Calibri" pitchFamily="34" charset="0"/>
+                <a:ea typeface="Calibri" pitchFamily="34" charset="-122"/>
+                <a:cs typeface="Calibri" pitchFamily="34" charset="-120"/>
+                <a:hlinkClick r:id="rId2" action="ppaction://hlinksldjump" tooltip="">
+                  <a:extLst>
+                    <a:ext uri="{A12FA001-AC4F-418D-AE19-62706E023703}">
+                      <ahyp:hlinkClr xmlns:ahyp="http://schemas.microsoft.com/office/drawing/2018/hyperlinkcolor" val="tx"/>
+                    </a:ext>
+                  </a:extLst>
+                </a:hlinkClick>
+              </a:rPr>
+              <a:t>Qwen-7B</a:t>
+            </a:r>
+            <a:endParaRPr lang="en-US" sz="1400" dirty="0"/>
+          </a:p>
+        </p:txBody>
+      </p:sp>
+      <p:sp>
+        <p:nvSpPr>
+          <p:cNvPr id="7" name="Shape 4"/>
+          <p:cNvSpPr/>
+          <p:nvPr/>
+        </p:nvSpPr>
+        <p:spPr>
+          <a:xfrm>
+            <a:off x="4544568" y="5943600"/>
+            <a:ext cx="3108960" cy="603504"/>
+          </a:xfrm>
+          <a:prstGeom prst="roundRect">
+            <a:avLst>
+              <a:gd name="adj" fmla="val 12121"/>
+            </a:avLst>
+          </a:prstGeom>
+          <a:solidFill>
+            <a:srgbClr val="F5F6FA"/>
+          </a:solidFill>
+          <a:ln w="12700">
+            <a:solidFill>
+              <a:srgbClr val="E4E6EF"/>
+            </a:solidFill>
+            <a:prstDash val="solid"/>
+          </a:ln>
+        </p:spPr>
+      </p:sp>
+      <p:sp>
+        <p:nvSpPr>
+          <p:cNvPr id="8" name="Text 5">
+            <a:hlinkClick r:id="rId3" tooltip="" action="ppaction://hlinksldjump"/>
+          </p:cNvPr>
+          <p:cNvSpPr/>
+          <p:nvPr/>
+        </p:nvSpPr>
+        <p:spPr>
+          <a:xfrm>
+            <a:off x="4544568" y="5943600"/>
+            <a:ext cx="3108960" cy="603504"/>
+          </a:xfrm>
+          <a:prstGeom prst="rect">
+            <a:avLst/>
+          </a:prstGeom>
+          <a:noFill/>
+          <a:ln/>
+        </p:spPr>
+        <p:txBody>
+          <a:bodyPr wrap="square" lIns="0" tIns="0" rIns="0" bIns="0" rtlCol="0" anchor="ctr"/>
+          <a:lstStyle/>
+          <a:p>
+            <a:pPr algn="ctr" indent="0" marL="0">
+              <a:buNone/>
+            </a:pPr>
+            <a:r>
+              <a:rPr lang="en-US" sz="1400" b="1" u="sng" dirty="0">
+                <a:solidFill>
+                  <a:srgbClr val="1B1F3B"/>
+                </a:solidFill>
+                <a:latin typeface="Calibri" pitchFamily="34" charset="0"/>
+                <a:ea typeface="Calibri" pitchFamily="34" charset="-122"/>
+                <a:cs typeface="Calibri" pitchFamily="34" charset="-120"/>
+                <a:hlinkClick r:id="rId3" action="ppaction://hlinksldjump" tooltip="">
+                  <a:extLst>
+                    <a:ext uri="{A12FA001-AC4F-418D-AE19-62706E023703}">
+                      <ahyp:hlinkClr xmlns:ahyp="http://schemas.microsoft.com/office/drawing/2018/hyperlinkcolor" val="tx"/>
+                    </a:ext>
+                  </a:extLst>
+                </a:hlinkClick>
+              </a:rPr>
               <a:t>InternVL3-8B</a:t>
             </a:r>
             <a:endParaRPr lang="en-US" sz="1400" dirty="0"/>
@@ -14795,7 +15411,7 @@
                 <a:ea typeface="Calibri" pitchFamily="34" charset="-122"/>
                 <a:cs typeface="Calibri" pitchFamily="34" charset="-120"/>
               </a:rPr>
-              <a:t>25</a:t>
+              <a:t>26</a:t>
             </a:r>
             <a:endParaRPr lang="en-US" sz="1000" dirty="0"/>
           </a:p>

</xml_diff>

<commit_message>
Deck: split slide 12 into CFR and SBR pages (definition + formula + chart each); 27 slides
Co-Authored-By: Claude Opus 4.8 <noreply@anthropic.com>
</commit_message>
<xml_diff>
--- a/v3/paper/ProgressReport_2.pptx
+++ b/v3/paper/ProgressReport_2.pptx
@@ -19,7 +19,8 @@
     <p:sldId id="264" r:id="rId10"/>
     <p:sldId id="265" r:id="rId11"/>
     <p:sldId id="266" r:id="rId12"/>
-    <p:sldId id="267" r:id="rId13"/>
+    <p:sldId id="282" r:id="rId33"/>
+    <p:sldId id="283" r:id="rId34"/>
     <p:sldId id="268" r:id="rId14"/>
     <p:sldId id="269" r:id="rId15"/>
     <p:sldId id="270" r:id="rId16"/>
@@ -827,6 +828,458 @@
 </c:chartSpace>
 </file>
 
+<file path=ppt/charts/chart3.xml><?xml version="1.0" encoding="utf-8"?>
+<c:chartSpace xmlns:c="http://schemas.openxmlformats.org/drawingml/2006/chart" xmlns:a="http://schemas.openxmlformats.org/drawingml/2006/main" xmlns:r="http://schemas.openxmlformats.org/officeDocument/2006/relationships">
+  <c:date1904 val="0"/>
+  <c:chart>
+    <c:title>
+      <c:tx>
+        <c:rich>
+          <a:bodyPr/>
+          <a:lstStyle/>
+          <a:p>
+            <a:r>
+              <a:rPr sz="1200" b="0"/>
+              <a:t>Cross-lingual Flip Rate by attribute</a:t>
+            </a:r>
+          </a:p>
+        </c:rich>
+      </c:tx>
+      <c:layout/>
+      <c:overlay val="0"/>
+    </c:title>
+    <c:autoTitleDeleted val="0"/>
+    <c:plotArea>
+      <c:barChart>
+        <c:barDir val="col"/>
+        <c:grouping val="clustered"/>
+        <c:ser>
+          <c:idx val="0"/>
+          <c:order val="0"/>
+          <c:tx>
+            <c:strRef>
+              <c:f>Sheet1!$B$1</c:f>
+              <c:strCache>
+                <c:ptCount val="1"/>
+                <c:pt idx="0">
+                  <c:v>Qwen2.5-VL-7B</c:v>
+                </c:pt>
+              </c:strCache>
+            </c:strRef>
+          </c:tx>
+          <c:spPr>
+            <a:solidFill>
+              <a:srgbClr val="4C72B0"/>
+            </a:solidFill>
+          </c:spPr>
+          <c:cat>
+            <c:strRef>
+              <c:f>Sheet1!$A$2:$A$6</c:f>
+              <c:strCache>
+                <c:ptCount val="5"/>
+                <c:pt idx="0">
+                  <c:v>Wealth</c:v>
+                </c:pt>
+                <c:pt idx="1">
+                  <c:v>Power</c:v>
+                </c:pt>
+                <c:pt idx="2">
+                  <c:v>Civility</c:v>
+                </c:pt>
+                <c:pt idx="3">
+                  <c:v>Morality</c:v>
+                </c:pt>
+                <c:pt idx="4">
+                  <c:v>Intellect</c:v>
+                </c:pt>
+              </c:strCache>
+            </c:strRef>
+          </c:cat>
+          <c:val>
+            <c:numRef>
+              <c:f>Sheet1!$B$2:$B$6</c:f>
+              <c:numCache>
+                <c:formatCode>General</c:formatCode>
+                <c:ptCount val="5"/>
+                <c:pt idx="0">
+                  <c:v>0.39</c:v>
+                </c:pt>
+                <c:pt idx="1">
+                  <c:v>0.61</c:v>
+                </c:pt>
+                <c:pt idx="2">
+                  <c:v>0.66</c:v>
+                </c:pt>
+                <c:pt idx="3">
+                  <c:v>0.67</c:v>
+                </c:pt>
+                <c:pt idx="4">
+                  <c:v>0.71</c:v>
+                </c:pt>
+              </c:numCache>
+            </c:numRef>
+          </c:val>
+        </c:ser>
+        <c:ser>
+          <c:idx val="1"/>
+          <c:order val="1"/>
+          <c:tx>
+            <c:strRef>
+              <c:f>Sheet1!$C$1</c:f>
+              <c:strCache>
+                <c:ptCount val="1"/>
+                <c:pt idx="0">
+                  <c:v>InternVL3-8B</c:v>
+                </c:pt>
+              </c:strCache>
+            </c:strRef>
+          </c:tx>
+          <c:spPr>
+            <a:solidFill>
+              <a:srgbClr val="C44E52"/>
+            </a:solidFill>
+          </c:spPr>
+          <c:cat>
+            <c:strRef>
+              <c:f>Sheet1!$A$2:$A$6</c:f>
+              <c:strCache>
+                <c:ptCount val="5"/>
+                <c:pt idx="0">
+                  <c:v>Wealth</c:v>
+                </c:pt>
+                <c:pt idx="1">
+                  <c:v>Power</c:v>
+                </c:pt>
+                <c:pt idx="2">
+                  <c:v>Civility</c:v>
+                </c:pt>
+                <c:pt idx="3">
+                  <c:v>Morality</c:v>
+                </c:pt>
+                <c:pt idx="4">
+                  <c:v>Intellect</c:v>
+                </c:pt>
+              </c:strCache>
+            </c:strRef>
+          </c:cat>
+          <c:val>
+            <c:numRef>
+              <c:f>Sheet1!$C$2:$C$6</c:f>
+              <c:numCache>
+                <c:formatCode>General</c:formatCode>
+                <c:ptCount val="5"/>
+                <c:pt idx="0">
+                  <c:v>0.52</c:v>
+                </c:pt>
+                <c:pt idx="1">
+                  <c:v>0.55</c:v>
+                </c:pt>
+                <c:pt idx="2">
+                  <c:v>0.59</c:v>
+                </c:pt>
+                <c:pt idx="3">
+                  <c:v>0.67</c:v>
+                </c:pt>
+                <c:pt idx="4">
+                  <c:v>0.67</c:v>
+                </c:pt>
+              </c:numCache>
+            </c:numRef>
+          </c:val>
+        </c:ser>
+        <c:axId val="-2068027336"/>
+        <c:axId val="-2113994440"/>
+      </c:barChart>
+      <c:catAx>
+        <c:axId val="-2068027336"/>
+        <c:scaling>
+          <c:orientation val="minMax"/>
+        </c:scaling>
+        <c:delete val="0"/>
+        <c:axPos val="b"/>
+        <c:majorTickMark val="out"/>
+        <c:minorTickMark val="none"/>
+        <c:tickLblPos val="nextTo"/>
+        <c:crossAx val="-2113994440"/>
+        <c:crosses val="autoZero"/>
+        <c:auto val="1"/>
+        <c:lblAlgn val="ctr"/>
+        <c:lblOffset val="100"/>
+        <c:noMultiLvlLbl val="0"/>
+      </c:catAx>
+      <c:valAx>
+        <c:axId val="-2113994440"/>
+        <c:scaling>
+          <c:max val="0.8"/>
+          <c:min val="0.0"/>
+        </c:scaling>
+        <c:delete val="0"/>
+        <c:axPos val="l"/>
+        <c:majorGridlines/>
+        <c:majorTickMark val="out"/>
+        <c:minorTickMark val="none"/>
+        <c:tickLblPos val="nextTo"/>
+        <c:crossAx val="-2068027336"/>
+        <c:crosses val="autoZero"/>
+      </c:valAx>
+    </c:plotArea>
+    <c:legend>
+      <c:legendPos val="t"/>
+      <c:overlay val="0"/>
+      <c:txPr>
+        <a:bodyPr/>
+        <a:lstStyle/>
+        <a:p>
+          <a:pPr>
+            <a:defRPr sz="1100"/>
+          </a:pPr>
+        </a:p>
+      </c:txPr>
+    </c:legend>
+    <c:dispBlanksAs val="gap"/>
+  </c:chart>
+  <c:txPr>
+    <a:bodyPr/>
+    <a:lstStyle/>
+    <a:p>
+      <a:pPr>
+        <a:defRPr sz="1800"/>
+      </a:pPr>
+      <a:endParaRPr lang="en-US"/>
+    </a:p>
+  </c:txPr>
+  <c:externalData r:id="rId1">
+    <c:autoUpdate val="0"/>
+  </c:externalData>
+</c:chartSpace>
+</file>
+
+<file path=ppt/charts/chart4.xml><?xml version="1.0" encoding="utf-8"?>
+<c:chartSpace xmlns:c="http://schemas.openxmlformats.org/drawingml/2006/chart" xmlns:a="http://schemas.openxmlformats.org/drawingml/2006/main" xmlns:r="http://schemas.openxmlformats.org/officeDocument/2006/relationships">
+  <c:date1904 val="0"/>
+  <c:chart>
+    <c:title>
+      <c:tx>
+        <c:rich>
+          <a:bodyPr/>
+          <a:lstStyle/>
+          <a:p>
+            <a:r>
+              <a:rPr sz="1200" b="0"/>
+              <a:t>Stable Bias Rate by attribute (wrong image in all 7 languages)</a:t>
+            </a:r>
+          </a:p>
+        </c:rich>
+      </c:tx>
+      <c:layout/>
+      <c:overlay val="0"/>
+    </c:title>
+    <c:autoTitleDeleted val="0"/>
+    <c:plotArea>
+      <c:barChart>
+        <c:barDir val="col"/>
+        <c:grouping val="clustered"/>
+        <c:ser>
+          <c:idx val="0"/>
+          <c:order val="0"/>
+          <c:tx>
+            <c:strRef>
+              <c:f>Sheet1!$B$1</c:f>
+              <c:strCache>
+                <c:ptCount val="1"/>
+                <c:pt idx="0">
+                  <c:v>Qwen2.5-VL-7B</c:v>
+                </c:pt>
+              </c:strCache>
+            </c:strRef>
+          </c:tx>
+          <c:spPr>
+            <a:solidFill>
+              <a:srgbClr val="4C72B0"/>
+            </a:solidFill>
+          </c:spPr>
+          <c:cat>
+            <c:strRef>
+              <c:f>Sheet1!$A$2:$A$6</c:f>
+              <c:strCache>
+                <c:ptCount val="5"/>
+                <c:pt idx="0">
+                  <c:v>Wealth</c:v>
+                </c:pt>
+                <c:pt idx="1">
+                  <c:v>Power</c:v>
+                </c:pt>
+                <c:pt idx="2">
+                  <c:v>Civility</c:v>
+                </c:pt>
+                <c:pt idx="3">
+                  <c:v>Morality</c:v>
+                </c:pt>
+                <c:pt idx="4">
+                  <c:v>Intellect</c:v>
+                </c:pt>
+              </c:strCache>
+            </c:strRef>
+          </c:cat>
+          <c:val>
+            <c:numRef>
+              <c:f>Sheet1!$B$2:$B$6</c:f>
+              <c:numCache>
+                <c:formatCode>General</c:formatCode>
+                <c:ptCount val="5"/>
+                <c:pt idx="0">
+                  <c:v>0.58</c:v>
+                </c:pt>
+                <c:pt idx="1">
+                  <c:v>0.28</c:v>
+                </c:pt>
+                <c:pt idx="2">
+                  <c:v>0.22</c:v>
+                </c:pt>
+                <c:pt idx="3">
+                  <c:v>0.18</c:v>
+                </c:pt>
+                <c:pt idx="4">
+                  <c:v>0.17</c:v>
+                </c:pt>
+              </c:numCache>
+            </c:numRef>
+          </c:val>
+        </c:ser>
+        <c:ser>
+          <c:idx val="1"/>
+          <c:order val="1"/>
+          <c:tx>
+            <c:strRef>
+              <c:f>Sheet1!$C$1</c:f>
+              <c:strCache>
+                <c:ptCount val="1"/>
+                <c:pt idx="0">
+                  <c:v>InternVL3-8B</c:v>
+                </c:pt>
+              </c:strCache>
+            </c:strRef>
+          </c:tx>
+          <c:spPr>
+            <a:solidFill>
+              <a:srgbClr val="C44E52"/>
+            </a:solidFill>
+          </c:spPr>
+          <c:cat>
+            <c:strRef>
+              <c:f>Sheet1!$A$2:$A$6</c:f>
+              <c:strCache>
+                <c:ptCount val="5"/>
+                <c:pt idx="0">
+                  <c:v>Wealth</c:v>
+                </c:pt>
+                <c:pt idx="1">
+                  <c:v>Power</c:v>
+                </c:pt>
+                <c:pt idx="2">
+                  <c:v>Civility</c:v>
+                </c:pt>
+                <c:pt idx="3">
+                  <c:v>Morality</c:v>
+                </c:pt>
+                <c:pt idx="4">
+                  <c:v>Intellect</c:v>
+                </c:pt>
+              </c:strCache>
+            </c:strRef>
+          </c:cat>
+          <c:val>
+            <c:numRef>
+              <c:f>Sheet1!$C$2:$C$6</c:f>
+              <c:numCache>
+                <c:formatCode>General</c:formatCode>
+                <c:ptCount val="5"/>
+                <c:pt idx="0">
+                  <c:v>0.45</c:v>
+                </c:pt>
+                <c:pt idx="1">
+                  <c:v>0.36</c:v>
+                </c:pt>
+                <c:pt idx="2">
+                  <c:v>0.3</c:v>
+                </c:pt>
+                <c:pt idx="3">
+                  <c:v>0.23</c:v>
+                </c:pt>
+                <c:pt idx="4">
+                  <c:v>0.19</c:v>
+                </c:pt>
+              </c:numCache>
+            </c:numRef>
+          </c:val>
+        </c:ser>
+        <c:axId val="-2068027336"/>
+        <c:axId val="-2113994440"/>
+      </c:barChart>
+      <c:catAx>
+        <c:axId val="-2068027336"/>
+        <c:scaling>
+          <c:orientation val="minMax"/>
+        </c:scaling>
+        <c:delete val="0"/>
+        <c:axPos val="b"/>
+        <c:majorTickMark val="out"/>
+        <c:minorTickMark val="none"/>
+        <c:tickLblPos val="nextTo"/>
+        <c:crossAx val="-2113994440"/>
+        <c:crosses val="autoZero"/>
+        <c:auto val="1"/>
+        <c:lblAlgn val="ctr"/>
+        <c:lblOffset val="100"/>
+        <c:noMultiLvlLbl val="0"/>
+      </c:catAx>
+      <c:valAx>
+        <c:axId val="-2113994440"/>
+        <c:scaling>
+          <c:max val="0.7"/>
+          <c:min val="0.0"/>
+        </c:scaling>
+        <c:delete val="0"/>
+        <c:axPos val="l"/>
+        <c:majorGridlines/>
+        <c:majorTickMark val="out"/>
+        <c:minorTickMark val="none"/>
+        <c:tickLblPos val="nextTo"/>
+        <c:crossAx val="-2068027336"/>
+        <c:crosses val="autoZero"/>
+      </c:valAx>
+    </c:plotArea>
+    <c:legend>
+      <c:legendPos val="t"/>
+      <c:overlay val="0"/>
+      <c:txPr>
+        <a:bodyPr/>
+        <a:lstStyle/>
+        <a:p>
+          <a:pPr>
+            <a:defRPr sz="1100"/>
+          </a:pPr>
+        </a:p>
+      </c:txPr>
+    </c:legend>
+    <c:dispBlanksAs val="gap"/>
+  </c:chart>
+  <c:txPr>
+    <a:bodyPr/>
+    <a:lstStyle/>
+    <a:p>
+      <a:pPr>
+        <a:defRPr sz="1800"/>
+      </a:pPr>
+      <a:endParaRPr lang="en-US"/>
+    </a:p>
+  </c:txPr>
+  <c:externalData r:id="rId1">
+    <c:autoUpdate val="0"/>
+  </c:externalData>
+</c:chartSpace>
+</file>
+
 <file path=ppt/notesMasters/notesMaster1.xml><?xml version="1.0" encoding="utf-8"?>
 <p:notesMaster xmlns:a="http://schemas.openxmlformats.org/drawingml/2006/main" xmlns:r="http://schemas.openxmlformats.org/officeDocument/2006/relationships" xmlns:p="http://schemas.openxmlformats.org/presentationml/2006/main">
   <p:cSld>
@@ -2825,6 +3278,56 @@
         <p14:creationId xmlns:p14="http://schemas.microsoft.com/office/powerpoint/2010/main" val="1024086991"/>
       </p:ext>
     </p:extLst>
+  </p:cSld>
+  <p:clrMapOvr>
+    <a:masterClrMapping/>
+  </p:clrMapOvr>
+</p:notes>
+</file>
+
+<file path=ppt/notesSlides/notesSlide27.xml><?xml version="1.0" encoding="utf-8"?>
+<p:notes xmlns:a="http://schemas.openxmlformats.org/drawingml/2006/main" xmlns:p="http://schemas.openxmlformats.org/presentationml/2006/main" xmlns:r="http://schemas.openxmlformats.org/officeDocument/2006/relationships">
+  <p:cSld>
+    <p:spTree>
+      <p:nvGrpSpPr>
+        <p:cNvPr id="1" name=""/>
+        <p:cNvGrpSpPr/>
+        <p:nvPr/>
+      </p:nvGrpSpPr>
+      <p:grpSpPr>
+        <a:xfrm>
+          <a:off x="0" y="0"/>
+          <a:ext cx="0" cy="0"/>
+          <a:chOff x="0" y="0"/>
+          <a:chExt cx="0" cy="0"/>
+        </a:xfrm>
+      </p:grpSpPr>
+    </p:spTree>
+  </p:cSld>
+  <p:clrMapOvr>
+    <a:masterClrMapping/>
+  </p:clrMapOvr>
+</p:notes>
+</file>
+
+<file path=ppt/notesSlides/notesSlide28.xml><?xml version="1.0" encoding="utf-8"?>
+<p:notes xmlns:a="http://schemas.openxmlformats.org/drawingml/2006/main" xmlns:p="http://schemas.openxmlformats.org/presentationml/2006/main" xmlns:r="http://schemas.openxmlformats.org/officeDocument/2006/relationships">
+  <p:cSld>
+    <p:spTree>
+      <p:nvGrpSpPr>
+        <p:cNvPr id="1" name=""/>
+        <p:cNvGrpSpPr/>
+        <p:nvPr/>
+      </p:nvGrpSpPr>
+      <p:grpSpPr>
+        <a:xfrm>
+          <a:off x="0" y="0"/>
+          <a:ext cx="0" cy="0"/>
+          <a:chOff x="0" y="0"/>
+          <a:chExt cx="0" cy="0"/>
+        </a:xfrm>
+      </p:grpSpPr>
+    </p:spTree>
   </p:cSld>
   <p:clrMapOvr>
     <a:masterClrMapping/>
@@ -15967,6 +16470,482 @@
           </a:p>
         </p:txBody>
       </p:sp>
+    </p:spTree>
+  </p:cSld>
+  <p:clrMapOvr>
+    <a:masterClrMapping/>
+  </p:clrMapOvr>
+</p:sld>
+</file>
+
+<file path=ppt/slides/slide27.xml><?xml version="1.0" encoding="utf-8"?>
+<p:sld xmlns:a="http://schemas.openxmlformats.org/drawingml/2006/main" xmlns:p="http://schemas.openxmlformats.org/presentationml/2006/main" xmlns:r="http://schemas.openxmlformats.org/officeDocument/2006/relationships">
+  <p:cSld>
+    <p:bg>
+      <p:bgPr>
+        <a:solidFill>
+          <a:srgbClr val="FFFFFF"/>
+        </a:solidFill>
+        <a:effectLst/>
+      </p:bgPr>
+    </p:bg>
+    <p:spTree>
+      <p:nvGrpSpPr>
+        <p:cNvPr id="1" name=""/>
+        <p:cNvGrpSpPr/>
+        <p:nvPr/>
+      </p:nvGrpSpPr>
+      <p:grpSpPr/>
+      <p:sp>
+        <p:nvSpPr>
+          <p:cNvPr id="2" name="TextBox 1"/>
+          <p:cNvSpPr txBox="1"/>
+          <p:nvPr/>
+        </p:nvSpPr>
+        <p:spPr>
+          <a:xfrm>
+            <a:off x="685800" y="457200"/>
+            <a:ext cx="8229600" cy="320040"/>
+          </a:xfrm>
+          <a:prstGeom prst="rect">
+            <a:avLst/>
+          </a:prstGeom>
+          <a:noFill/>
+        </p:spPr>
+        <p:txBody>
+          <a:bodyPr wrap="square" anchor="t">
+            <a:spAutoFit/>
+          </a:bodyPr>
+          <a:lstStyle/>
+          <a:p>
+            <a:pPr algn="l">
+              <a:spcAft>
+                <a:spcPts val="800"/>
+              </a:spcAft>
+            </a:pPr>
+            <a:r>
+              <a:rPr sz="1200" b="1" i="0">
+                <a:solidFill>
+                  <a:srgbClr val="C44E52"/>
+                </a:solidFill>
+                <a:latin typeface="Calibri"/>
+              </a:rPr>
+              <a:t>NEW BEHAVIOURAL METRIC · 1 OF 2</a:t>
+            </a:r>
+          </a:p>
+        </p:txBody>
+      </p:sp>
+      <p:sp>
+        <p:nvSpPr>
+          <p:cNvPr id="3" name="TextBox 2"/>
+          <p:cNvSpPr txBox="1"/>
+          <p:nvPr/>
+        </p:nvSpPr>
+        <p:spPr>
+          <a:xfrm>
+            <a:off x="658368" y="822960"/>
+            <a:ext cx="10789920" cy="914400"/>
+          </a:xfrm>
+          <a:prstGeom prst="rect">
+            <a:avLst/>
+          </a:prstGeom>
+          <a:noFill/>
+        </p:spPr>
+        <p:txBody>
+          <a:bodyPr wrap="square" anchor="t">
+            <a:spAutoFit/>
+          </a:bodyPr>
+          <a:lstStyle/>
+          <a:p>
+            <a:pPr algn="l">
+              <a:spcAft>
+                <a:spcPts val="800"/>
+              </a:spcAft>
+            </a:pPr>
+            <a:r>
+              <a:rPr sz="3000" b="1" i="0">
+                <a:solidFill>
+                  <a:srgbClr val="23262F"/>
+                </a:solidFill>
+                <a:latin typeface="Georgia"/>
+              </a:rPr>
+              <a:t>Cross-lingual Flip Rate (CFR)</a:t>
+            </a:r>
+          </a:p>
+        </p:txBody>
+      </p:sp>
+      <p:sp>
+        <p:nvSpPr>
+          <p:cNvPr id="4" name="TextBox 3"/>
+          <p:cNvSpPr txBox="1"/>
+          <p:nvPr/>
+        </p:nvSpPr>
+        <p:spPr>
+          <a:xfrm>
+            <a:off x="685800" y="1965960"/>
+            <a:ext cx="5120640" cy="2194560"/>
+          </a:xfrm>
+          <a:prstGeom prst="rect">
+            <a:avLst/>
+          </a:prstGeom>
+          <a:noFill/>
+        </p:spPr>
+        <p:txBody>
+          <a:bodyPr wrap="square" anchor="t">
+            <a:spAutoFit/>
+          </a:bodyPr>
+          <a:lstStyle/>
+          <a:p>
+            <a:pPr algn="l">
+              <a:spcAft>
+                <a:spcPts val="800"/>
+              </a:spcAft>
+            </a:pPr>
+            <a:r>
+              <a:rPr sz="1650" b="0" i="0">
+                <a:solidFill>
+                  <a:srgbClr val="23262F"/>
+                </a:solidFill>
+                <a:latin typeface="Calibri"/>
+              </a:rPr>
+              <a:t>Does the model's choice change when only the language changes?</a:t>
+            </a:r>
+          </a:p>
+          <a:p>
+            <a:pPr algn="l">
+              <a:spcAft>
+                <a:spcPts val="800"/>
+              </a:spcAft>
+            </a:pPr>
+            <a:r>
+              <a:rPr sz="1650" b="0" i="0">
+                <a:solidFill>
+                  <a:srgbClr val="23262F"/>
+                </a:solidFill>
+                <a:latin typeface="Calibri"/>
+              </a:rPr>
+              <a:t>Overall CFR ≈ 0.65 — about two-thirds of image-pairs flip at least once.</a:t>
+            </a:r>
+          </a:p>
+          <a:p>
+            <a:pPr algn="l">
+              <a:spcAft>
+                <a:spcPts val="800"/>
+              </a:spcAft>
+            </a:pPr>
+            <a:r>
+              <a:rPr sz="1650" b="0" i="0">
+                <a:solidFill>
+                  <a:srgbClr val="23262F"/>
+                </a:solidFill>
+                <a:latin typeface="Calibri"/>
+              </a:rPr>
+              <a:t>Wealth flips the LEAST — it is locked in (low flip = high stable bias).</a:t>
+            </a:r>
+          </a:p>
+        </p:txBody>
+      </p:sp>
+      <p:sp>
+        <p:nvSpPr>
+          <p:cNvPr id="5" name="Rounded Rectangle 4"/>
+          <p:cNvSpPr/>
+          <p:nvPr/>
+        </p:nvSpPr>
+        <p:spPr>
+          <a:xfrm>
+            <a:off x="685800" y="4297680"/>
+            <a:ext cx="5120640" cy="777240"/>
+          </a:xfrm>
+          <a:prstGeom prst="roundRect">
+            <a:avLst/>
+          </a:prstGeom>
+          <a:solidFill>
+            <a:srgbClr val="1B1F3B"/>
+          </a:solidFill>
+          <a:ln>
+            <a:noFill/>
+          </a:ln>
+          <a:effectLst/>
+        </p:spPr>
+        <p:style>
+          <a:lnRef idx="1">
+            <a:schemeClr val="accent1"/>
+          </a:lnRef>
+          <a:fillRef idx="3">
+            <a:schemeClr val="accent1"/>
+          </a:fillRef>
+          <a:effectRef idx="2">
+            <a:schemeClr val="accent1"/>
+          </a:effectRef>
+          <a:fontRef idx="minor">
+            <a:schemeClr val="lt1"/>
+          </a:fontRef>
+        </p:style>
+        <p:txBody>
+          <a:bodyPr rtlCol="0" anchor="ctr" wrap="square"/>
+          <a:lstStyle/>
+          <a:p>
+            <a:pPr algn="ctr"/>
+            <a:r>
+              <a:rPr sz="1300" b="0">
+                <a:solidFill>
+                  <a:srgbClr val="FFFFFF"/>
+                </a:solidFill>
+                <a:latin typeface="Courier New"/>
+              </a:rPr>
+              <a:t>CFR  =  #(items whose answer differs across languages)  /  #(items)</a:t>
+            </a:r>
+          </a:p>
+        </p:txBody>
+      </p:sp>
+      <p:graphicFrame>
+        <p:nvGraphicFramePr>
+          <p:cNvPr id="6" name="Chart 5"/>
+          <p:cNvGraphicFramePr>
+            <a:graphicFrameLocks noGrp="1"/>
+          </p:cNvGraphicFramePr>
+          <p:nvPr/>
+        </p:nvGraphicFramePr>
+        <p:xfrm>
+          <a:off x="6126480" y="1737360"/>
+          <a:ext cx="5486400" cy="4297680"/>
+        </p:xfrm>
+        <a:graphic>
+          <a:graphicData uri="http://schemas.openxmlformats.org/drawingml/2006/chart">
+            <c:chart xmlns:c="http://schemas.openxmlformats.org/drawingml/2006/chart" r:id="rId2"/>
+          </a:graphicData>
+        </a:graphic>
+      </p:graphicFrame>
+    </p:spTree>
+  </p:cSld>
+  <p:clrMapOvr>
+    <a:masterClrMapping/>
+  </p:clrMapOvr>
+</p:sld>
+</file>
+
+<file path=ppt/slides/slide28.xml><?xml version="1.0" encoding="utf-8"?>
+<p:sld xmlns:a="http://schemas.openxmlformats.org/drawingml/2006/main" xmlns:p="http://schemas.openxmlformats.org/presentationml/2006/main" xmlns:r="http://schemas.openxmlformats.org/officeDocument/2006/relationships">
+  <p:cSld>
+    <p:bg>
+      <p:bgPr>
+        <a:solidFill>
+          <a:srgbClr val="FFFFFF"/>
+        </a:solidFill>
+        <a:effectLst/>
+      </p:bgPr>
+    </p:bg>
+    <p:spTree>
+      <p:nvGrpSpPr>
+        <p:cNvPr id="1" name=""/>
+        <p:cNvGrpSpPr/>
+        <p:nvPr/>
+      </p:nvGrpSpPr>
+      <p:grpSpPr/>
+      <p:sp>
+        <p:nvSpPr>
+          <p:cNvPr id="2" name="TextBox 1"/>
+          <p:cNvSpPr txBox="1"/>
+          <p:nvPr/>
+        </p:nvSpPr>
+        <p:spPr>
+          <a:xfrm>
+            <a:off x="685800" y="457200"/>
+            <a:ext cx="8229600" cy="320040"/>
+          </a:xfrm>
+          <a:prstGeom prst="rect">
+            <a:avLst/>
+          </a:prstGeom>
+          <a:noFill/>
+        </p:spPr>
+        <p:txBody>
+          <a:bodyPr wrap="square" anchor="t">
+            <a:spAutoFit/>
+          </a:bodyPr>
+          <a:lstStyle/>
+          <a:p>
+            <a:pPr algn="l">
+              <a:spcAft>
+                <a:spcPts val="800"/>
+              </a:spcAft>
+            </a:pPr>
+            <a:r>
+              <a:rPr sz="1200" b="1" i="0">
+                <a:solidFill>
+                  <a:srgbClr val="C44E52"/>
+                </a:solidFill>
+                <a:latin typeface="Calibri"/>
+              </a:rPr>
+              <a:t>NEW BEHAVIOURAL METRIC · 2 OF 2</a:t>
+            </a:r>
+          </a:p>
+        </p:txBody>
+      </p:sp>
+      <p:sp>
+        <p:nvSpPr>
+          <p:cNvPr id="3" name="TextBox 2"/>
+          <p:cNvSpPr txBox="1"/>
+          <p:nvPr/>
+        </p:nvSpPr>
+        <p:spPr>
+          <a:xfrm>
+            <a:off x="658368" y="822960"/>
+            <a:ext cx="10789920" cy="914400"/>
+          </a:xfrm>
+          <a:prstGeom prst="rect">
+            <a:avLst/>
+          </a:prstGeom>
+          <a:noFill/>
+        </p:spPr>
+        <p:txBody>
+          <a:bodyPr wrap="square" anchor="t">
+            <a:spAutoFit/>
+          </a:bodyPr>
+          <a:lstStyle/>
+          <a:p>
+            <a:pPr algn="l">
+              <a:spcAft>
+                <a:spcPts val="800"/>
+              </a:spcAft>
+            </a:pPr>
+            <a:r>
+              <a:rPr sz="3000" b="1" i="0">
+                <a:solidFill>
+                  <a:srgbClr val="23262F"/>
+                </a:solidFill>
+                <a:latin typeface="Georgia"/>
+              </a:rPr>
+              <a:t>Stable Bias Rate (SBR)</a:t>
+            </a:r>
+          </a:p>
+        </p:txBody>
+      </p:sp>
+      <p:sp>
+        <p:nvSpPr>
+          <p:cNvPr id="4" name="TextBox 3"/>
+          <p:cNvSpPr txBox="1"/>
+          <p:nvPr/>
+        </p:nvSpPr>
+        <p:spPr>
+          <a:xfrm>
+            <a:off x="685800" y="1965960"/>
+            <a:ext cx="5120640" cy="1828800"/>
+          </a:xfrm>
+          <a:prstGeom prst="rect">
+            <a:avLst/>
+          </a:prstGeom>
+          <a:noFill/>
+        </p:spPr>
+        <p:txBody>
+          <a:bodyPr wrap="square" anchor="t">
+            <a:spAutoFit/>
+          </a:bodyPr>
+          <a:lstStyle/>
+          <a:p>
+            <a:pPr algn="l">
+              <a:spcAft>
+                <a:spcPts val="800"/>
+              </a:spcAft>
+            </a:pPr>
+            <a:r>
+              <a:rPr sz="1650" b="0" i="0">
+                <a:solidFill>
+                  <a:srgbClr val="23262F"/>
+                </a:solidFill>
+                <a:latin typeface="Calibri"/>
+              </a:rPr>
+              <a:t>Does the model pick the wrong (prototypical) image in ALL seven languages?</a:t>
+            </a:r>
+          </a:p>
+          <a:p>
+            <a:pPr algn="l">
+              <a:spcAft>
+                <a:spcPts val="800"/>
+              </a:spcAft>
+            </a:pPr>
+            <a:r>
+              <a:rPr sz="1650" b="1" i="0">
+                <a:solidFill>
+                  <a:srgbClr val="C44E52"/>
+                </a:solidFill>
+                <a:latin typeface="Calibri"/>
+              </a:rPr>
+              <a:t>Wealth has the highest SBR in both models — biased everywhere, not flip-flopping.</a:t>
+            </a:r>
+          </a:p>
+        </p:txBody>
+      </p:sp>
+      <p:sp>
+        <p:nvSpPr>
+          <p:cNvPr id="5" name="Rounded Rectangle 4"/>
+          <p:cNvSpPr/>
+          <p:nvPr/>
+        </p:nvSpPr>
+        <p:spPr>
+          <a:xfrm>
+            <a:off x="685800" y="4297680"/>
+            <a:ext cx="5120640" cy="777240"/>
+          </a:xfrm>
+          <a:prstGeom prst="roundRect">
+            <a:avLst/>
+          </a:prstGeom>
+          <a:solidFill>
+            <a:srgbClr val="1B1F3B"/>
+          </a:solidFill>
+          <a:ln>
+            <a:noFill/>
+          </a:ln>
+          <a:effectLst/>
+        </p:spPr>
+        <p:style>
+          <a:lnRef idx="1">
+            <a:schemeClr val="accent1"/>
+          </a:lnRef>
+          <a:fillRef idx="3">
+            <a:schemeClr val="accent1"/>
+          </a:fillRef>
+          <a:effectRef idx="2">
+            <a:schemeClr val="accent1"/>
+          </a:effectRef>
+          <a:fontRef idx="minor">
+            <a:schemeClr val="lt1"/>
+          </a:fontRef>
+        </p:style>
+        <p:txBody>
+          <a:bodyPr rtlCol="0" anchor="ctr" wrap="square"/>
+          <a:lstStyle/>
+          <a:p>
+            <a:pPr algn="ctr"/>
+            <a:r>
+              <a:rPr sz="1300" b="0">
+                <a:solidFill>
+                  <a:srgbClr val="FFFFFF"/>
+                </a:solidFill>
+                <a:latin typeface="Courier New"/>
+              </a:rPr>
+              <a:t>SBR  =  #(items with the prototype chosen in every language)  /  #(items)</a:t>
+            </a:r>
+          </a:p>
+        </p:txBody>
+      </p:sp>
+      <p:graphicFrame>
+        <p:nvGraphicFramePr>
+          <p:cNvPr id="6" name="Chart 5"/>
+          <p:cNvGraphicFramePr>
+            <a:graphicFrameLocks noGrp="1"/>
+          </p:cNvGraphicFramePr>
+          <p:nvPr/>
+        </p:nvGraphicFramePr>
+        <p:xfrm>
+          <a:off x="6126480" y="1737360"/>
+          <a:ext cx="5486400" cy="4297680"/>
+        </p:xfrm>
+        <a:graphic>
+          <a:graphicData uri="http://schemas.openxmlformats.org/drawingml/2006/chart">
+            <c:chart xmlns:c="http://schemas.openxmlformats.org/drawingml/2006/chart" r:id="rId2"/>
+          </a:graphicData>
+        </a:graphic>
+      </p:graphicFrame>
     </p:spTree>
   </p:cSld>
   <p:clrMapOvr>

</xml_diff>

<commit_message>
Deck: latest hand-edited pptx (PR-III final without speaker notes)
Working-tree save of the presentation decks. PR-III keeps the related-work slide,
click animations, and VQAScore updates; speaker notes were removed in PowerPoint
(they remain recoverable in history at 2e05ba3). Also stages the PR-II deck edit.

Co-Authored-By: Claude Opus 4.8 <noreply@anthropic.com>
</commit_message>
<xml_diff>
--- a/v3/paper/ProgressReport_2.pptx
+++ b/v3/paper/ProgressReport_2.pptx
@@ -19,10 +19,9 @@
     <p:sldId id="264" r:id="rId10"/>
     <p:sldId id="265" r:id="rId11"/>
     <p:sldId id="266" r:id="rId12"/>
-    <p:sldId id="282" r:id="rId33"/>
-    <p:sldId id="283" r:id="rId34"/>
-    <p:sldId id="268" r:id="rId14"/>
-    <p:sldId id="269" r:id="rId15"/>
+    <p:sldId id="282" r:id="rId13"/>
+    <p:sldId id="283" r:id="rId14"/>
+    <p:sldId id="268" r:id="rId15"/>
     <p:sldId id="270" r:id="rId16"/>
     <p:sldId id="271" r:id="rId17"/>
     <p:sldId id="272" r:id="rId18"/>
@@ -502,22 +501,9 @@
           <a:bodyPr/>
           <a:lstStyle/>
           <a:p>
-            <a:pPr>
-              <a:defRPr sz="1200" b="0" i="0" u="none" strike="noStrike">
-                <a:solidFill>
-                  <a:srgbClr val="23262F"/>
-                </a:solidFill>
-                <a:latin typeface="Arial"/>
-              </a:defRPr>
-            </a:pPr>
-            <a:r>
-              <a:rPr lang="de-DE" sz="1200" b="0" i="0" u="none" strike="noStrike">
-                <a:solidFill>
-                  <a:srgbClr val="23262F"/>
-                </a:solidFill>
-                <a:latin typeface="Arial"/>
-              </a:rPr>
-              <a:t>Stable Bias Rate by attribute  (chose wrong image in all 7 languages)</a:t>
+            <a:r>
+              <a:rPr lang="de-DE" sz="1200" b="0"/>
+              <a:t>Cross-lingual Flip Rate by attribute</a:t>
             </a:r>
           </a:p>
         </c:rich>
@@ -530,7 +516,7 @@
       <c:barChart>
         <c:barDir val="col"/>
         <c:grouping val="clustered"/>
-        <c:varyColors val="0"/>
+        <c:varyColors val="1"/>
         <c:ser>
           <c:idx val="0"/>
           <c:order val="0"/>
@@ -549,9 +535,284 @@
             <a:solidFill>
               <a:srgbClr val="4C72B0"/>
             </a:solidFill>
-            <a:effectLst/>
           </c:spPr>
-          <c:invertIfNegative val="0"/>
+          <c:invertIfNegative val="1"/>
+          <c:cat>
+            <c:strRef>
+              <c:f>Sheet1!$A$2:$A$6</c:f>
+              <c:strCache>
+                <c:ptCount val="5"/>
+                <c:pt idx="0">
+                  <c:v>Wealth</c:v>
+                </c:pt>
+                <c:pt idx="1">
+                  <c:v>Power</c:v>
+                </c:pt>
+                <c:pt idx="2">
+                  <c:v>Civility</c:v>
+                </c:pt>
+                <c:pt idx="3">
+                  <c:v>Morality</c:v>
+                </c:pt>
+                <c:pt idx="4">
+                  <c:v>Intellect</c:v>
+                </c:pt>
+              </c:strCache>
+            </c:strRef>
+          </c:cat>
+          <c:val>
+            <c:numRef>
+              <c:f>Sheet1!$B$2:$B$6</c:f>
+              <c:numCache>
+                <c:formatCode>General</c:formatCode>
+                <c:ptCount val="5"/>
+                <c:pt idx="0">
+                  <c:v>0.39</c:v>
+                </c:pt>
+                <c:pt idx="1">
+                  <c:v>0.61</c:v>
+                </c:pt>
+                <c:pt idx="2">
+                  <c:v>0.66</c:v>
+                </c:pt>
+                <c:pt idx="3">
+                  <c:v>0.67</c:v>
+                </c:pt>
+                <c:pt idx="4">
+                  <c:v>0.71</c:v>
+                </c:pt>
+              </c:numCache>
+            </c:numRef>
+          </c:val>
+          <c:extLst>
+            <c:ext xmlns:c14="http://schemas.microsoft.com/office/drawing/2007/8/2/chart" uri="{6F2FDCE9-48DA-4B69-8628-5D25D57E5C99}">
+              <c14:invertSolidFillFmt>
+                <c14:spPr xmlns:c14="http://schemas.microsoft.com/office/drawing/2007/8/2/chart">
+                  <a:solidFill>
+                    <a:srgbClr val="FFFFFF"/>
+                  </a:solidFill>
+                </c14:spPr>
+              </c14:invertSolidFillFmt>
+            </c:ext>
+            <c:ext xmlns:c16="http://schemas.microsoft.com/office/drawing/2014/chart" uri="{C3380CC4-5D6E-409C-BE32-E72D297353CC}">
+              <c16:uniqueId val="{00000000-A9CE-2745-843B-86FF51FCF3C5}"/>
+            </c:ext>
+          </c:extLst>
+        </c:ser>
+        <c:ser>
+          <c:idx val="1"/>
+          <c:order val="1"/>
+          <c:tx>
+            <c:strRef>
+              <c:f>Sheet1!$C$1</c:f>
+              <c:strCache>
+                <c:ptCount val="1"/>
+                <c:pt idx="0">
+                  <c:v>InternVL3-8B</c:v>
+                </c:pt>
+              </c:strCache>
+            </c:strRef>
+          </c:tx>
+          <c:spPr>
+            <a:solidFill>
+              <a:srgbClr val="C44E52"/>
+            </a:solidFill>
+          </c:spPr>
+          <c:invertIfNegative val="1"/>
+          <c:cat>
+            <c:strRef>
+              <c:f>Sheet1!$A$2:$A$6</c:f>
+              <c:strCache>
+                <c:ptCount val="5"/>
+                <c:pt idx="0">
+                  <c:v>Wealth</c:v>
+                </c:pt>
+                <c:pt idx="1">
+                  <c:v>Power</c:v>
+                </c:pt>
+                <c:pt idx="2">
+                  <c:v>Civility</c:v>
+                </c:pt>
+                <c:pt idx="3">
+                  <c:v>Morality</c:v>
+                </c:pt>
+                <c:pt idx="4">
+                  <c:v>Intellect</c:v>
+                </c:pt>
+              </c:strCache>
+            </c:strRef>
+          </c:cat>
+          <c:val>
+            <c:numRef>
+              <c:f>Sheet1!$C$2:$C$6</c:f>
+              <c:numCache>
+                <c:formatCode>General</c:formatCode>
+                <c:ptCount val="5"/>
+                <c:pt idx="0">
+                  <c:v>0.52</c:v>
+                </c:pt>
+                <c:pt idx="1">
+                  <c:v>0.55000000000000004</c:v>
+                </c:pt>
+                <c:pt idx="2">
+                  <c:v>0.59</c:v>
+                </c:pt>
+                <c:pt idx="3">
+                  <c:v>0.67</c:v>
+                </c:pt>
+                <c:pt idx="4">
+                  <c:v>0.67</c:v>
+                </c:pt>
+              </c:numCache>
+            </c:numRef>
+          </c:val>
+          <c:extLst>
+            <c:ext xmlns:c14="http://schemas.microsoft.com/office/drawing/2007/8/2/chart" uri="{6F2FDCE9-48DA-4B69-8628-5D25D57E5C99}">
+              <c14:invertSolidFillFmt>
+                <c14:spPr xmlns:c14="http://schemas.microsoft.com/office/drawing/2007/8/2/chart">
+                  <a:solidFill>
+                    <a:srgbClr val="FFFFFF"/>
+                  </a:solidFill>
+                </c14:spPr>
+              </c14:invertSolidFillFmt>
+            </c:ext>
+            <c:ext xmlns:c16="http://schemas.microsoft.com/office/drawing/2014/chart" uri="{C3380CC4-5D6E-409C-BE32-E72D297353CC}">
+              <c16:uniqueId val="{00000001-A9CE-2745-843B-86FF51FCF3C5}"/>
+            </c:ext>
+          </c:extLst>
+        </c:ser>
+        <c:dLbls>
+          <c:showLegendKey val="0"/>
+          <c:showVal val="0"/>
+          <c:showCatName val="0"/>
+          <c:showSerName val="0"/>
+          <c:showPercent val="0"/>
+          <c:showBubbleSize val="0"/>
+        </c:dLbls>
+        <c:gapWidth val="150"/>
+        <c:axId val="-2068027336"/>
+        <c:axId val="-2113994440"/>
+      </c:barChart>
+      <c:catAx>
+        <c:axId val="-2068027336"/>
+        <c:scaling>
+          <c:orientation val="minMax"/>
+        </c:scaling>
+        <c:delete val="0"/>
+        <c:axPos val="b"/>
+        <c:numFmt formatCode="General" sourceLinked="0"/>
+        <c:majorTickMark val="out"/>
+        <c:minorTickMark val="none"/>
+        <c:tickLblPos val="nextTo"/>
+        <c:crossAx val="-2113994440"/>
+        <c:crosses val="autoZero"/>
+        <c:auto val="1"/>
+        <c:lblAlgn val="ctr"/>
+        <c:lblOffset val="100"/>
+        <c:noMultiLvlLbl val="0"/>
+      </c:catAx>
+      <c:valAx>
+        <c:axId val="-2113994440"/>
+        <c:scaling>
+          <c:orientation val="minMax"/>
+          <c:max val="0.8"/>
+          <c:min val="0"/>
+        </c:scaling>
+        <c:delete val="0"/>
+        <c:axPos val="l"/>
+        <c:majorGridlines/>
+        <c:numFmt formatCode="General" sourceLinked="1"/>
+        <c:majorTickMark val="out"/>
+        <c:minorTickMark val="none"/>
+        <c:tickLblPos val="nextTo"/>
+        <c:crossAx val="-2068027336"/>
+        <c:crosses val="autoZero"/>
+        <c:crossBetween val="between"/>
+      </c:valAx>
+    </c:plotArea>
+    <c:legend>
+      <c:legendPos val="t"/>
+      <c:overlay val="0"/>
+      <c:txPr>
+        <a:bodyPr/>
+        <a:lstStyle/>
+        <a:p>
+          <a:pPr>
+            <a:defRPr sz="1100"/>
+          </a:pPr>
+          <a:endParaRPr lang="zh-CN"/>
+        </a:p>
+      </c:txPr>
+    </c:legend>
+    <c:plotVisOnly val="1"/>
+    <c:dispBlanksAs val="gap"/>
+    <c:showDLblsOverMax val="1"/>
+  </c:chart>
+  <c:txPr>
+    <a:bodyPr/>
+    <a:lstStyle/>
+    <a:p>
+      <a:pPr>
+        <a:defRPr sz="1800"/>
+      </a:pPr>
+      <a:endParaRPr lang="en-US"/>
+    </a:p>
+  </c:txPr>
+  <c:externalData r:id="rId1">
+    <c:autoUpdate val="0"/>
+  </c:externalData>
+</c:chartSpace>
+</file>
+
+<file path=ppt/charts/chart3.xml><?xml version="1.0" encoding="utf-8"?>
+<c:chartSpace xmlns:c="http://schemas.openxmlformats.org/drawingml/2006/chart" xmlns:a="http://schemas.openxmlformats.org/drawingml/2006/main" xmlns:r="http://schemas.openxmlformats.org/officeDocument/2006/relationships" xmlns:c16r2="http://schemas.microsoft.com/office/drawing/2015/06/chart">
+  <c:date1904 val="0"/>
+  <c:lang val="zh-CN"/>
+  <c:roundedCorners val="1"/>
+  <c:style val="2"/>
+  <c:chart>
+    <c:title>
+      <c:tx>
+        <c:rich>
+          <a:bodyPr/>
+          <a:lstStyle/>
+          <a:p>
+            <a:r>
+              <a:rPr lang="de-DE" sz="1200" b="0"/>
+              <a:t>Stable Bias Rate by attribute (wrong image in all 7 languages)</a:t>
+            </a:r>
+          </a:p>
+        </c:rich>
+      </c:tx>
+      <c:overlay val="0"/>
+    </c:title>
+    <c:autoTitleDeleted val="0"/>
+    <c:plotArea>
+      <c:layout/>
+      <c:barChart>
+        <c:barDir val="col"/>
+        <c:grouping val="clustered"/>
+        <c:varyColors val="1"/>
+        <c:ser>
+          <c:idx val="0"/>
+          <c:order val="0"/>
+          <c:tx>
+            <c:strRef>
+              <c:f>Sheet1!$B$1</c:f>
+              <c:strCache>
+                <c:ptCount val="1"/>
+                <c:pt idx="0">
+                  <c:v>Qwen2.5-VL-7B</c:v>
+                </c:pt>
+              </c:strCache>
+            </c:strRef>
+          </c:tx>
+          <c:spPr>
+            <a:solidFill>
+              <a:srgbClr val="4C72B0"/>
+            </a:solidFill>
+          </c:spPr>
+          <c:invertIfNegative val="1"/>
           <c:cat>
             <c:strRef>
               <c:f>Sheet1!$A$2:$A$6</c:f>
@@ -600,8 +861,17 @@
             </c:numRef>
           </c:val>
           <c:extLst>
+            <c:ext xmlns:c14="http://schemas.microsoft.com/office/drawing/2007/8/2/chart" uri="{6F2FDCE9-48DA-4B69-8628-5D25D57E5C99}">
+              <c14:invertSolidFillFmt>
+                <c14:spPr xmlns:c14="http://schemas.microsoft.com/office/drawing/2007/8/2/chart">
+                  <a:solidFill>
+                    <a:srgbClr val="FFFFFF"/>
+                  </a:solidFill>
+                </c14:spPr>
+              </c14:invertSolidFillFmt>
+            </c:ext>
             <c:ext xmlns:c16="http://schemas.microsoft.com/office/drawing/2014/chart" uri="{C3380CC4-5D6E-409C-BE32-E72D297353CC}">
-              <c16:uniqueId val="{00000000-D3FD-D248-83B7-2DCE492A8332}"/>
+              <c16:uniqueId val="{00000000-23B5-6A4A-BA31-13E1AB27FAD8}"/>
             </c:ext>
           </c:extLst>
         </c:ser>
@@ -623,9 +893,8 @@
             <a:solidFill>
               <a:srgbClr val="C44E52"/>
             </a:solidFill>
-            <a:effectLst/>
           </c:spPr>
-          <c:invertIfNegative val="0"/>
+          <c:invertIfNegative val="1"/>
           <c:cat>
             <c:strRef>
               <c:f>Sheet1!$A$2:$A$6</c:f>
@@ -674,8 +943,17 @@
             </c:numRef>
           </c:val>
           <c:extLst>
+            <c:ext xmlns:c14="http://schemas.microsoft.com/office/drawing/2007/8/2/chart" uri="{6F2FDCE9-48DA-4B69-8628-5D25D57E5C99}">
+              <c14:invertSolidFillFmt>
+                <c14:spPr xmlns:c14="http://schemas.microsoft.com/office/drawing/2007/8/2/chart">
+                  <a:solidFill>
+                    <a:srgbClr val="FFFFFF"/>
+                  </a:solidFill>
+                </c14:spPr>
+              </c14:invertSolidFillFmt>
+            </c:ext>
             <c:ext xmlns:c16="http://schemas.microsoft.com/office/drawing/2014/chart" uri="{C3380CC4-5D6E-409C-BE32-E72D297353CC}">
-              <c16:uniqueId val="{00000001-D3FD-D248-83B7-2DCE492A8332}"/>
+              <c16:uniqueId val="{00000001-23B5-6A4A-BA31-13E1AB27FAD8}"/>
             </c:ext>
           </c:extLst>
         </c:ser>
@@ -688,305 +966,6 @@
           <c:showBubbleSize val="0"/>
         </c:dLbls>
         <c:gapWidth val="150"/>
-        <c:axId val="2094734554"/>
-        <c:axId val="2094734552"/>
-      </c:barChart>
-      <c:catAx>
-        <c:axId val="2094734554"/>
-        <c:scaling>
-          <c:orientation val="minMax"/>
-        </c:scaling>
-        <c:delete val="0"/>
-        <c:axPos val="b"/>
-        <c:numFmt formatCode="General" sourceLinked="1"/>
-        <c:majorTickMark val="out"/>
-        <c:minorTickMark val="none"/>
-        <c:tickLblPos val="low"/>
-        <c:spPr>
-          <a:ln w="12700" cap="flat">
-            <a:solidFill>
-              <a:srgbClr val="888888"/>
-            </a:solidFill>
-            <a:prstDash val="solid"/>
-            <a:round/>
-          </a:ln>
-        </c:spPr>
-        <c:txPr>
-          <a:bodyPr/>
-          <a:lstStyle/>
-          <a:p>
-            <a:pPr>
-              <a:defRPr sz="1200" b="0" i="0" u="none" strike="noStrike">
-                <a:solidFill>
-                  <a:srgbClr val="5A6072"/>
-                </a:solidFill>
-                <a:latin typeface="Arial"/>
-              </a:defRPr>
-            </a:pPr>
-            <a:endParaRPr lang="en-US"/>
-          </a:p>
-        </c:txPr>
-        <c:crossAx val="2094734552"/>
-        <c:crosses val="autoZero"/>
-        <c:auto val="1"/>
-        <c:lblAlgn val="ctr"/>
-        <c:lblOffset val="100"/>
-        <c:noMultiLvlLbl val="1"/>
-      </c:catAx>
-      <c:valAx>
-        <c:axId val="2094734552"/>
-        <c:scaling>
-          <c:orientation val="minMax"/>
-          <c:max val="0.7"/>
-          <c:min val="0"/>
-        </c:scaling>
-        <c:delete val="0"/>
-        <c:axPos val="l"/>
-        <c:majorGridlines>
-          <c:spPr>
-            <a:ln w="6350" cap="flat">
-              <a:solidFill>
-                <a:srgbClr val="ECEEF5"/>
-              </a:solidFill>
-              <a:prstDash val="solid"/>
-              <a:round/>
-            </a:ln>
-          </c:spPr>
-        </c:majorGridlines>
-        <c:numFmt formatCode="General" sourceLinked="0"/>
-        <c:majorTickMark val="out"/>
-        <c:minorTickMark val="none"/>
-        <c:tickLblPos val="nextTo"/>
-        <c:spPr>
-          <a:ln w="12700" cap="flat">
-            <a:solidFill>
-              <a:srgbClr val="888888"/>
-            </a:solidFill>
-            <a:prstDash val="solid"/>
-            <a:round/>
-          </a:ln>
-        </c:spPr>
-        <c:txPr>
-          <a:bodyPr/>
-          <a:lstStyle/>
-          <a:p>
-            <a:pPr>
-              <a:defRPr sz="1200" b="0" i="0" u="none" strike="noStrike">
-                <a:solidFill>
-                  <a:srgbClr val="5A6072"/>
-                </a:solidFill>
-                <a:latin typeface="Arial"/>
-              </a:defRPr>
-            </a:pPr>
-            <a:endParaRPr lang="en-US"/>
-          </a:p>
-        </c:txPr>
-        <c:crossAx val="2094734554"/>
-        <c:crosses val="autoZero"/>
-        <c:crossBetween val="between"/>
-      </c:valAx>
-      <c:spPr>
-        <a:noFill/>
-        <a:ln>
-          <a:noFill/>
-        </a:ln>
-        <a:effectLst/>
-      </c:spPr>
-    </c:plotArea>
-    <c:legend>
-      <c:legendPos val="t"/>
-      <c:overlay val="0"/>
-      <c:txPr>
-        <a:bodyPr/>
-        <a:lstStyle/>
-        <a:p>
-          <a:pPr>
-            <a:defRPr sz="1100">
-              <a:solidFill>
-                <a:srgbClr val="5A6072"/>
-              </a:solidFill>
-            </a:defRPr>
-          </a:pPr>
-          <a:endParaRPr lang="en-US"/>
-        </a:p>
-      </c:txPr>
-    </c:legend>
-    <c:plotVisOnly val="1"/>
-    <c:dispBlanksAs val="span"/>
-    <c:showDLblsOverMax val="1"/>
-  </c:chart>
-  <c:spPr>
-    <a:noFill/>
-    <a:ln>
-      <a:noFill/>
-    </a:ln>
-    <a:effectLst/>
-  </c:spPr>
-  <c:externalData r:id="rId1">
-    <c:autoUpdate val="0"/>
-  </c:externalData>
-</c:chartSpace>
-</file>
-
-<file path=ppt/charts/chart3.xml><?xml version="1.0" encoding="utf-8"?>
-<c:chartSpace xmlns:c="http://schemas.openxmlformats.org/drawingml/2006/chart" xmlns:a="http://schemas.openxmlformats.org/drawingml/2006/main" xmlns:r="http://schemas.openxmlformats.org/officeDocument/2006/relationships">
-  <c:date1904 val="0"/>
-  <c:chart>
-    <c:title>
-      <c:tx>
-        <c:rich>
-          <a:bodyPr/>
-          <a:lstStyle/>
-          <a:p>
-            <a:r>
-              <a:rPr sz="1200" b="0"/>
-              <a:t>Cross-lingual Flip Rate by attribute</a:t>
-            </a:r>
-          </a:p>
-        </c:rich>
-      </c:tx>
-      <c:layout/>
-      <c:overlay val="0"/>
-    </c:title>
-    <c:autoTitleDeleted val="0"/>
-    <c:plotArea>
-      <c:barChart>
-        <c:barDir val="col"/>
-        <c:grouping val="clustered"/>
-        <c:ser>
-          <c:idx val="0"/>
-          <c:order val="0"/>
-          <c:tx>
-            <c:strRef>
-              <c:f>Sheet1!$B$1</c:f>
-              <c:strCache>
-                <c:ptCount val="1"/>
-                <c:pt idx="0">
-                  <c:v>Qwen2.5-VL-7B</c:v>
-                </c:pt>
-              </c:strCache>
-            </c:strRef>
-          </c:tx>
-          <c:spPr>
-            <a:solidFill>
-              <a:srgbClr val="4C72B0"/>
-            </a:solidFill>
-          </c:spPr>
-          <c:cat>
-            <c:strRef>
-              <c:f>Sheet1!$A$2:$A$6</c:f>
-              <c:strCache>
-                <c:ptCount val="5"/>
-                <c:pt idx="0">
-                  <c:v>Wealth</c:v>
-                </c:pt>
-                <c:pt idx="1">
-                  <c:v>Power</c:v>
-                </c:pt>
-                <c:pt idx="2">
-                  <c:v>Civility</c:v>
-                </c:pt>
-                <c:pt idx="3">
-                  <c:v>Morality</c:v>
-                </c:pt>
-                <c:pt idx="4">
-                  <c:v>Intellect</c:v>
-                </c:pt>
-              </c:strCache>
-            </c:strRef>
-          </c:cat>
-          <c:val>
-            <c:numRef>
-              <c:f>Sheet1!$B$2:$B$6</c:f>
-              <c:numCache>
-                <c:formatCode>General</c:formatCode>
-                <c:ptCount val="5"/>
-                <c:pt idx="0">
-                  <c:v>0.39</c:v>
-                </c:pt>
-                <c:pt idx="1">
-                  <c:v>0.61</c:v>
-                </c:pt>
-                <c:pt idx="2">
-                  <c:v>0.66</c:v>
-                </c:pt>
-                <c:pt idx="3">
-                  <c:v>0.67</c:v>
-                </c:pt>
-                <c:pt idx="4">
-                  <c:v>0.71</c:v>
-                </c:pt>
-              </c:numCache>
-            </c:numRef>
-          </c:val>
-        </c:ser>
-        <c:ser>
-          <c:idx val="1"/>
-          <c:order val="1"/>
-          <c:tx>
-            <c:strRef>
-              <c:f>Sheet1!$C$1</c:f>
-              <c:strCache>
-                <c:ptCount val="1"/>
-                <c:pt idx="0">
-                  <c:v>InternVL3-8B</c:v>
-                </c:pt>
-              </c:strCache>
-            </c:strRef>
-          </c:tx>
-          <c:spPr>
-            <a:solidFill>
-              <a:srgbClr val="C44E52"/>
-            </a:solidFill>
-          </c:spPr>
-          <c:cat>
-            <c:strRef>
-              <c:f>Sheet1!$A$2:$A$6</c:f>
-              <c:strCache>
-                <c:ptCount val="5"/>
-                <c:pt idx="0">
-                  <c:v>Wealth</c:v>
-                </c:pt>
-                <c:pt idx="1">
-                  <c:v>Power</c:v>
-                </c:pt>
-                <c:pt idx="2">
-                  <c:v>Civility</c:v>
-                </c:pt>
-                <c:pt idx="3">
-                  <c:v>Morality</c:v>
-                </c:pt>
-                <c:pt idx="4">
-                  <c:v>Intellect</c:v>
-                </c:pt>
-              </c:strCache>
-            </c:strRef>
-          </c:cat>
-          <c:val>
-            <c:numRef>
-              <c:f>Sheet1!$C$2:$C$6</c:f>
-              <c:numCache>
-                <c:formatCode>General</c:formatCode>
-                <c:ptCount val="5"/>
-                <c:pt idx="0">
-                  <c:v>0.52</c:v>
-                </c:pt>
-                <c:pt idx="1">
-                  <c:v>0.55</c:v>
-                </c:pt>
-                <c:pt idx="2">
-                  <c:v>0.59</c:v>
-                </c:pt>
-                <c:pt idx="3">
-                  <c:v>0.67</c:v>
-                </c:pt>
-                <c:pt idx="4">
-                  <c:v>0.67</c:v>
-                </c:pt>
-              </c:numCache>
-            </c:numRef>
-          </c:val>
-        </c:ser>
         <c:axId val="-2068027336"/>
         <c:axId val="-2113994440"/>
       </c:barChart>
@@ -997,6 +976,7 @@
         </c:scaling>
         <c:delete val="0"/>
         <c:axPos val="b"/>
+        <c:numFmt formatCode="General" sourceLinked="0"/>
         <c:majorTickMark val="out"/>
         <c:minorTickMark val="none"/>
         <c:tickLblPos val="nextTo"/>
@@ -1010,17 +990,20 @@
       <c:valAx>
         <c:axId val="-2113994440"/>
         <c:scaling>
-          <c:max val="0.8"/>
-          <c:min val="0.0"/>
+          <c:orientation val="minMax"/>
+          <c:max val="0.7"/>
+          <c:min val="0"/>
         </c:scaling>
         <c:delete val="0"/>
         <c:axPos val="l"/>
         <c:majorGridlines/>
+        <c:numFmt formatCode="General" sourceLinked="1"/>
         <c:majorTickMark val="out"/>
         <c:minorTickMark val="none"/>
         <c:tickLblPos val="nextTo"/>
         <c:crossAx val="-2068027336"/>
         <c:crosses val="autoZero"/>
+        <c:crossBetween val="between"/>
       </c:valAx>
     </c:plotArea>
     <c:legend>
@@ -1033,236 +1016,13 @@
           <a:pPr>
             <a:defRPr sz="1100"/>
           </a:pPr>
+          <a:endParaRPr lang="zh-CN"/>
         </a:p>
       </c:txPr>
     </c:legend>
+    <c:plotVisOnly val="1"/>
     <c:dispBlanksAs val="gap"/>
-  </c:chart>
-  <c:txPr>
-    <a:bodyPr/>
-    <a:lstStyle/>
-    <a:p>
-      <a:pPr>
-        <a:defRPr sz="1800"/>
-      </a:pPr>
-      <a:endParaRPr lang="en-US"/>
-    </a:p>
-  </c:txPr>
-  <c:externalData r:id="rId1">
-    <c:autoUpdate val="0"/>
-  </c:externalData>
-</c:chartSpace>
-</file>
-
-<file path=ppt/charts/chart4.xml><?xml version="1.0" encoding="utf-8"?>
-<c:chartSpace xmlns:c="http://schemas.openxmlformats.org/drawingml/2006/chart" xmlns:a="http://schemas.openxmlformats.org/drawingml/2006/main" xmlns:r="http://schemas.openxmlformats.org/officeDocument/2006/relationships">
-  <c:date1904 val="0"/>
-  <c:chart>
-    <c:title>
-      <c:tx>
-        <c:rich>
-          <a:bodyPr/>
-          <a:lstStyle/>
-          <a:p>
-            <a:r>
-              <a:rPr sz="1200" b="0"/>
-              <a:t>Stable Bias Rate by attribute (wrong image in all 7 languages)</a:t>
-            </a:r>
-          </a:p>
-        </c:rich>
-      </c:tx>
-      <c:layout/>
-      <c:overlay val="0"/>
-    </c:title>
-    <c:autoTitleDeleted val="0"/>
-    <c:plotArea>
-      <c:barChart>
-        <c:barDir val="col"/>
-        <c:grouping val="clustered"/>
-        <c:ser>
-          <c:idx val="0"/>
-          <c:order val="0"/>
-          <c:tx>
-            <c:strRef>
-              <c:f>Sheet1!$B$1</c:f>
-              <c:strCache>
-                <c:ptCount val="1"/>
-                <c:pt idx="0">
-                  <c:v>Qwen2.5-VL-7B</c:v>
-                </c:pt>
-              </c:strCache>
-            </c:strRef>
-          </c:tx>
-          <c:spPr>
-            <a:solidFill>
-              <a:srgbClr val="4C72B0"/>
-            </a:solidFill>
-          </c:spPr>
-          <c:cat>
-            <c:strRef>
-              <c:f>Sheet1!$A$2:$A$6</c:f>
-              <c:strCache>
-                <c:ptCount val="5"/>
-                <c:pt idx="0">
-                  <c:v>Wealth</c:v>
-                </c:pt>
-                <c:pt idx="1">
-                  <c:v>Power</c:v>
-                </c:pt>
-                <c:pt idx="2">
-                  <c:v>Civility</c:v>
-                </c:pt>
-                <c:pt idx="3">
-                  <c:v>Morality</c:v>
-                </c:pt>
-                <c:pt idx="4">
-                  <c:v>Intellect</c:v>
-                </c:pt>
-              </c:strCache>
-            </c:strRef>
-          </c:cat>
-          <c:val>
-            <c:numRef>
-              <c:f>Sheet1!$B$2:$B$6</c:f>
-              <c:numCache>
-                <c:formatCode>General</c:formatCode>
-                <c:ptCount val="5"/>
-                <c:pt idx="0">
-                  <c:v>0.58</c:v>
-                </c:pt>
-                <c:pt idx="1">
-                  <c:v>0.28</c:v>
-                </c:pt>
-                <c:pt idx="2">
-                  <c:v>0.22</c:v>
-                </c:pt>
-                <c:pt idx="3">
-                  <c:v>0.18</c:v>
-                </c:pt>
-                <c:pt idx="4">
-                  <c:v>0.17</c:v>
-                </c:pt>
-              </c:numCache>
-            </c:numRef>
-          </c:val>
-        </c:ser>
-        <c:ser>
-          <c:idx val="1"/>
-          <c:order val="1"/>
-          <c:tx>
-            <c:strRef>
-              <c:f>Sheet1!$C$1</c:f>
-              <c:strCache>
-                <c:ptCount val="1"/>
-                <c:pt idx="0">
-                  <c:v>InternVL3-8B</c:v>
-                </c:pt>
-              </c:strCache>
-            </c:strRef>
-          </c:tx>
-          <c:spPr>
-            <a:solidFill>
-              <a:srgbClr val="C44E52"/>
-            </a:solidFill>
-          </c:spPr>
-          <c:cat>
-            <c:strRef>
-              <c:f>Sheet1!$A$2:$A$6</c:f>
-              <c:strCache>
-                <c:ptCount val="5"/>
-                <c:pt idx="0">
-                  <c:v>Wealth</c:v>
-                </c:pt>
-                <c:pt idx="1">
-                  <c:v>Power</c:v>
-                </c:pt>
-                <c:pt idx="2">
-                  <c:v>Civility</c:v>
-                </c:pt>
-                <c:pt idx="3">
-                  <c:v>Morality</c:v>
-                </c:pt>
-                <c:pt idx="4">
-                  <c:v>Intellect</c:v>
-                </c:pt>
-              </c:strCache>
-            </c:strRef>
-          </c:cat>
-          <c:val>
-            <c:numRef>
-              <c:f>Sheet1!$C$2:$C$6</c:f>
-              <c:numCache>
-                <c:formatCode>General</c:formatCode>
-                <c:ptCount val="5"/>
-                <c:pt idx="0">
-                  <c:v>0.45</c:v>
-                </c:pt>
-                <c:pt idx="1">
-                  <c:v>0.36</c:v>
-                </c:pt>
-                <c:pt idx="2">
-                  <c:v>0.3</c:v>
-                </c:pt>
-                <c:pt idx="3">
-                  <c:v>0.23</c:v>
-                </c:pt>
-                <c:pt idx="4">
-                  <c:v>0.19</c:v>
-                </c:pt>
-              </c:numCache>
-            </c:numRef>
-          </c:val>
-        </c:ser>
-        <c:axId val="-2068027336"/>
-        <c:axId val="-2113994440"/>
-      </c:barChart>
-      <c:catAx>
-        <c:axId val="-2068027336"/>
-        <c:scaling>
-          <c:orientation val="minMax"/>
-        </c:scaling>
-        <c:delete val="0"/>
-        <c:axPos val="b"/>
-        <c:majorTickMark val="out"/>
-        <c:minorTickMark val="none"/>
-        <c:tickLblPos val="nextTo"/>
-        <c:crossAx val="-2113994440"/>
-        <c:crosses val="autoZero"/>
-        <c:auto val="1"/>
-        <c:lblAlgn val="ctr"/>
-        <c:lblOffset val="100"/>
-        <c:noMultiLvlLbl val="0"/>
-      </c:catAx>
-      <c:valAx>
-        <c:axId val="-2113994440"/>
-        <c:scaling>
-          <c:max val="0.7"/>
-          <c:min val="0.0"/>
-        </c:scaling>
-        <c:delete val="0"/>
-        <c:axPos val="l"/>
-        <c:majorGridlines/>
-        <c:majorTickMark val="out"/>
-        <c:minorTickMark val="none"/>
-        <c:tickLblPos val="nextTo"/>
-        <c:crossAx val="-2068027336"/>
-        <c:crosses val="autoZero"/>
-      </c:valAx>
-    </c:plotArea>
-    <c:legend>
-      <c:legendPos val="t"/>
-      <c:overlay val="0"/>
-      <c:txPr>
-        <a:bodyPr/>
-        <a:lstStyle/>
-        <a:p>
-          <a:pPr>
-            <a:defRPr sz="1100"/>
-          </a:pPr>
-        </a:p>
-      </c:txPr>
-    </c:legend>
-    <c:dispBlanksAs val="gap"/>
+    <c:showDLblsOverMax val="1"/>
   </c:chart>
   <c:txPr>
     <a:bodyPr/>
@@ -1534,24 +1294,128 @@
           <a:lstStyle/>
           <a:p>
             <a:r>
-              <a:t>EN —</a:t>
-            </a:r>
-          </a:p>
-          <a:p>
-            <a:r>
-              <a:t>This is our second main result, and it actually changed our own conclusion. In the first report we only had four languages, and the bias looked the same in all of them, so we said language did not matter. But when we added two more languages — Bengali and Greek — a clear effect appeared: in these two languages the model is biased more often than in English, and this happens in BOTH models, not just one. So the earlier "language does not matter" was wrong; it was just that four languages were too few to see it. One key detail: the attribute that gets biased (wealth, power) stays the same in every language — only the overall amount of bias goes up. So language does not change WHICH attribute is biased; it changes HOW STRONG the bias is.</a:t>
-            </a:r>
-          </a:p>
-          <a:p/>
-          <a:p>
-            <a:r>
-              <a:t>中文 —</a:t>
-            </a:r>
-          </a:p>
-          <a:p>
-            <a:r>
-              <a:t>这是我们第二个主要结果,而且它改变了我们自己之前的结论。第一次报告只有四种语言,偏见在四种里看着都一样,所以我们说"语言无关"。但加了孟加拉语和希腊语之后,出现了明显的效应:在这两种语言里,模型被带偏的次数比英语更多,而且两个模型都这样,不只一个。所以之前"语言无关"是错的——只是四种语言太少、没测出来。一个关键细节:被带偏的属性(财富、权力)在每种语言里都一样,变的只是偏见的整体强度。所以语言不改变"哪个属性被偏",只改变"偏得多重"。</a:t>
-            </a:r>
+              <a:rPr lang="zh-CN" altLang="zh-CN" dirty="0"/>
+              <a:t>So now, the second main result is about language.</a:t>
+            </a:r>
+          </a:p>
+          <a:p>
+            <a:r>
+              <a:rPr lang="zh-CN" altLang="zh-CN" dirty="0"/>
+              <a:t>And this result actually changed what we thought after the first report. In Report 1, we only had four languages, and at that point the bias looked pretty similar across them. So our early conclusion was basically: maybe language does not matter that much.</a:t>
+            </a:r>
+            <a:endParaRPr lang="en-US" altLang="zh-CN" dirty="0"/>
+          </a:p>
+          <a:p>
+            <a:endParaRPr lang="en-US" altLang="zh-CN" dirty="0"/>
+          </a:p>
+          <a:p>
+            <a:r>
+              <a:rPr lang="zh-CN" altLang="en-US" dirty="0"/>
+              <a:t>换</a:t>
+            </a:r>
+            <a:endParaRPr lang="en-US" altLang="zh-CN" dirty="0"/>
+          </a:p>
+          <a:p>
+            <a:endParaRPr lang="zh-CN" altLang="zh-CN" dirty="0"/>
+          </a:p>
+          <a:p>
+            <a:r>
+              <a:rPr lang="zh-CN" altLang="zh-CN" dirty="0"/>
+              <a:t>But once we added more languages, especially Bengali and Greek, the picture changed. Now we do see a real language effect.</a:t>
+            </a:r>
+          </a:p>
+          <a:p>
+            <a:r>
+              <a:rPr lang="zh-CN" altLang="zh-CN" dirty="0"/>
+              <a:t>What we find is that Bengali and Greek prompts lead to more bias than English prompts. So the images are exactly the same, the task is exactly the same, but when the prompt is written in Bengali or Greek, the model is more likely to choose the prototypical-but-wrong image.</a:t>
+            </a:r>
+            <a:endParaRPr lang="en-US" altLang="zh-CN" dirty="0"/>
+          </a:p>
+          <a:p>
+            <a:endParaRPr lang="zh-CN" altLang="zh-CN" dirty="0"/>
+          </a:p>
+          <a:p>
+            <a:r>
+              <a:rPr lang="zh-CN" altLang="zh-CN" dirty="0"/>
+              <a:t>And importantly, this happens in both model families. We see it in Qwen, and we also see it in InternVL. So this is not just one model behaving strangely.</a:t>
+            </a:r>
+          </a:p>
+          <a:p>
+            <a:r>
+              <a:rPr lang="zh-CN" altLang="zh-CN" dirty="0"/>
+              <a:t>One important detail, though, is that language does not completely change the structure of the bias. The same attributes are still the risky ones. Wealth and Power are still the ones with stronger bias, while Morality and Intellect are much closer to chance.</a:t>
+            </a:r>
+          </a:p>
+          <a:p>
+            <a:r>
+              <a:rPr lang="zh-CN" altLang="zh-CN" dirty="0"/>
+              <a:t>So the way I would summarize this result is: language does not really change </a:t>
+            </a:r>
+            <a:r>
+              <a:rPr lang="zh-CN" altLang="zh-CN" i="1" dirty="0"/>
+              <a:t>which</a:t>
+            </a:r>
+            <a:r>
+              <a:rPr lang="zh-CN" altLang="zh-CN" dirty="0"/>
+              <a:t> attributes are biased. It changes </a:t>
+            </a:r>
+            <a:r>
+              <a:rPr lang="zh-CN" altLang="zh-CN" i="1" dirty="0"/>
+              <a:t>how strong</a:t>
+            </a:r>
+            <a:r>
+              <a:rPr lang="zh-CN" altLang="zh-CN" dirty="0"/>
+              <a:t> the bias is.</a:t>
+            </a:r>
+            <a:endParaRPr lang="en-US" altLang="zh-CN" dirty="0"/>
+          </a:p>
+          <a:p>
+            <a:endParaRPr lang="en-US" altLang="zh-CN" dirty="0"/>
+          </a:p>
+          <a:p>
+            <a:r>
+              <a:rPr lang="en-US" altLang="zh-CN" dirty="0"/>
+              <a:t>---</a:t>
+            </a:r>
+          </a:p>
+          <a:p>
+            <a:r>
+              <a:rPr lang="zh-CN" altLang="zh-CN" dirty="0"/>
+              <a:t>This plot shows the same result in odds-ratio form.</a:t>
+            </a:r>
+          </a:p>
+          <a:p>
+            <a:r>
+              <a:rPr lang="zh-CN" altLang="zh-CN" dirty="0"/>
+              <a:t>The dashed vertical line at 1 means “same as English.” So if a point is around 1, that language behaves roughly like English. If it is to the right of 1, then that language produces more bias than English. If it is to the left, then it produces less bias.</a:t>
+            </a:r>
+          </a:p>
+          <a:p>
+            <a:r>
+              <a:rPr lang="zh-CN" altLang="zh-CN" dirty="0"/>
+              <a:t>The bars are confidence intervals, so they show how uncertain the estimate is.</a:t>
+            </a:r>
+          </a:p>
+          <a:p>
+            <a:r>
+              <a:rPr lang="zh-CN" altLang="zh-CN" dirty="0"/>
+              <a:t>What you can see here is that Chinese, Russian, and Hindi are mostly close to English. Arabic is a little bit higher, but the clearest pattern is Bengali and Greek. For both models, these two languages are on the right side, meaning they increase the odds of choosing the prototypical-but-wrong image.</a:t>
+            </a:r>
+          </a:p>
+          <a:p>
+            <a:r>
+              <a:rPr lang="zh-CN" altLang="zh-CN" dirty="0"/>
+              <a:t>So the important point is not “all non-English languages are worse.” That would be too simple, and it is not what we see.</a:t>
+            </a:r>
+          </a:p>
+          <a:p>
+            <a:r>
+              <a:rPr lang="zh-CN" altLang="zh-CN" dirty="0"/>
+              <a:t>The real pattern is more selective: some languages, especially Bengali and Greek in this setup, make the model rely more on the prototype shortcut.</a:t>
+            </a:r>
+          </a:p>
+          <a:p>
+            <a:endParaRPr lang="zh-CN" altLang="zh-CN" dirty="0"/>
           </a:p>
         </p:txBody>
       </p:sp>
@@ -1636,23 +1500,75 @@
           <a:lstStyle/>
           <a:p>
             <a:r>
-              <a:t>EN —</a:t>
-            </a:r>
-          </a:p>
-          <a:p>
-            <a:r>
-              <a:t>Now the obvious question: maybe Bengali and Greek are just translated badly, so the model loses the meaning and falls back on the stereotype. We checked this directly. For every prompt, we translated it back into English and measured how much it changed. If bad translation were the cause, the most-biased languages should change the most. But we found the opposite: Greek and Bengali — the most biased — have the most faithful translations, while Hindi and Russian, which are not biased, have the worst. So the language effect is real model behavior, not a translation problem. This is exactly the check the reviewers will ask for, so we did it first.</a:t>
-            </a:r>
-          </a:p>
-          <a:p/>
-          <a:p>
-            <a:r>
-              <a:t>中文 —</a:t>
-            </a:r>
-          </a:p>
-          <a:p>
-            <a:r>
-              <a:t>接下来一个很自然的问题:会不会孟加拉语、希腊语只是翻译得差,模型丢了语义、退回刻板印象?我们直接验证了。对每条提示,我们把它翻回英文、量它变了多少。如果是烂翻译导致的,最偏的语言应该变化最大。但结果相反:最偏的希腊语、孟加拉语翻译最忠实;不偏的印地语、俄语反而最差。所以语言效应是模型的真实行为,不是翻译问题。这正是评委会问的检查,我们提前做了。</a:t>
+              <a:rPr lang="zh-CN" altLang="zh-CN" dirty="0"/>
+              <a:t>Now, the obvious question is: maybe this is just a translation problem.</a:t>
+            </a:r>
+          </a:p>
+          <a:p>
+            <a:r>
+              <a:rPr lang="zh-CN" altLang="zh-CN" dirty="0"/>
+              <a:t>Maybe Bengali and Greek were translated badly, so the model could not understand the prompt properly, and then it fell back on the visual stereotype.</a:t>
+            </a:r>
+          </a:p>
+          <a:p>
+            <a:r>
+              <a:rPr lang="zh-CN" altLang="zh-CN" dirty="0"/>
+              <a:t>So we checked that directly.</a:t>
+            </a:r>
+          </a:p>
+          <a:p>
+            <a:r>
+              <a:rPr lang="zh-CN" altLang="zh-CN" dirty="0"/>
+              <a:t>For every non-English prompt, we translated it back into English, and then compared that back-translation with the original English prompt. The idea is simple: if the translated prompt drifted a lot, then the meaning may not have been preserved.</a:t>
+            </a:r>
+          </a:p>
+          <a:p>
+            <a:r>
+              <a:rPr lang="zh-CN" altLang="zh-CN" dirty="0"/>
+              <a:t>So if bad translation were the explanation, we should see the most biased languages also having the worst translation </a:t>
+            </a:r>
+            <a:r>
+              <a:rPr lang="en-US" altLang="zh-CN" dirty="0"/>
+              <a:t>quality</a:t>
+            </a:r>
+          </a:p>
+          <a:p>
+            <a:endParaRPr lang="zh-CN" altLang="zh-CN" dirty="0"/>
+          </a:p>
+          <a:p>
+            <a:r>
+              <a:rPr lang="zh-CN" altLang="zh-CN" dirty="0"/>
+              <a:t>But we actually see the opposite.</a:t>
+            </a:r>
+          </a:p>
+          <a:p>
+            <a:r>
+              <a:rPr lang="zh-CN" altLang="zh-CN" dirty="0"/>
+              <a:t>Greek and Bengali are the most biased languages, but they also have the highest back-translation </a:t>
+            </a:r>
+            <a:r>
+              <a:rPr lang="en-US" altLang="zh-CN" dirty="0"/>
+              <a:t>quality</a:t>
+            </a:r>
+            <a:r>
+              <a:rPr lang="zh-CN" altLang="zh-CN" dirty="0"/>
+              <a:t>. Greek is the highest, and Bengali is also very high. Meanwhile, Hindi and Russian have the lowest fidelity, but they do not show the strongest bias.</a:t>
+            </a:r>
+          </a:p>
+          <a:p>
+            <a:r>
+              <a:rPr lang="zh-CN" altLang="zh-CN" dirty="0"/>
+              <a:t>So this makes the simple translation-artifact explanation unlikely.</a:t>
+            </a:r>
+            <a:endParaRPr lang="en-US" altLang="zh-CN" dirty="0"/>
+          </a:p>
+          <a:p>
+            <a:endParaRPr lang="zh-CN" altLang="zh-CN" dirty="0"/>
+          </a:p>
+          <a:p>
+            <a:r>
+              <a:rPr lang="zh-CN" altLang="zh-CN" dirty="0"/>
+              <a:t>Of course, this does not prove translation is perfect. It is still a sanity check, and it uses the same general translation pipeline. But it does rule out the most obvious concern, which is that the language effect is just coming from bad translations.</a:t>
             </a:r>
           </a:p>
         </p:txBody>
@@ -1712,19 +1628,13 @@
       </p:grpSpPr>
       <p:sp>
         <p:nvSpPr>
-          <p:cNvPr id="2" name="Slide Image Placeholder 1"/>
-          <p:cNvSpPr>
-            <a:spLocks noGrp="1" noRot="1" noChangeAspect="1"/>
-          </p:cNvSpPr>
-          <p:nvPr>
-            <p:ph type="sldImg"/>
-          </p:nvPr>
-        </p:nvSpPr>
-        <p:spPr/>
-      </p:sp>
-      <p:sp>
-        <p:nvSpPr>
-          <p:cNvPr id="3" name="Notes Placeholder 2"/>
+          <p:cNvPr id="2" name="备注占位符 1">
+            <a:extLst>
+              <a:ext uri="{FF2B5EF4-FFF2-40B4-BE49-F238E27FC236}">
+                <a16:creationId xmlns:a16="http://schemas.microsoft.com/office/drawing/2014/main" id="{32A8244E-A35C-64C3-6672-3229F746C06D}"/>
+              </a:ext>
+            </a:extLst>
+          </p:cNvPr>
           <p:cNvSpPr>
             <a:spLocks noGrp="1"/>
           </p:cNvSpPr>
@@ -1732,62 +1642,109 @@
             <p:ph type="body" idx="1"/>
           </p:nvPr>
         </p:nvSpPr>
-        <p:spPr/>
+        <p:spPr>
+          <a:xfrm>
+            <a:off x="685800" y="5867400"/>
+            <a:ext cx="5486400" cy="4800600"/>
+          </a:xfrm>
+          <a:prstGeom prst="rect">
+            <a:avLst/>
+          </a:prstGeom>
+        </p:spPr>
         <p:txBody>
           <a:bodyPr/>
           <a:lstStyle/>
           <a:p>
             <a:r>
-              <a:t>EN —</a:t>
-            </a:r>
-          </a:p>
-          <a:p>
-            <a:r>
-              <a:t>We also added two new ways to measure the bias, beyond the simple error rate. The first is the flip rate: for the same image pair, does the model change its answer when we only change the language? The second is the stable-bias rate: does the model pick the wrong, stereotypical image in all seven languages at once? The key finding is that wealth has the highest stable-bias rate in both models. This means wealth is not just biased on average — the model picks the wrong image for wealth in every single language. It is stably biased, not flip-flopping. So the bias is deep and consistent, not random noise.</a:t>
-            </a:r>
-          </a:p>
-          <a:p/>
-          <a:p>
-            <a:r>
-              <a:t>中文 —</a:t>
-            </a:r>
-          </a:p>
-          <a:p>
-            <a:r>
-              <a:t>我们还加了两个新的度量方式,不只看简单的错误率。第一个是翻转率:对同一对图,只换语言时模型会不会改答案?第二个是稳定偏见率:模型是不是在全部七种语言里都选了那张错的、刻板印象的图?关键发现是:财富在两个模型里的稳定偏见率都最高。这说明财富不只是平均偏——模型在每一种语言里都为财富选错图。它是稳定地偏,不是来回翻。所以这个偏见是深层、一致的,不是随机噪声。</a:t>
-            </a:r>
-          </a:p>
-        </p:txBody>
-      </p:sp>
-      <p:sp>
-        <p:nvSpPr>
-          <p:cNvPr id="4" name="Slide Number Placeholder 3"/>
-          <p:cNvSpPr>
-            <a:spLocks noGrp="1"/>
-          </p:cNvSpPr>
-          <p:nvPr>
-            <p:ph type="sldNum" sz="quarter" idx="10"/>
-          </p:nvPr>
-        </p:nvSpPr>
-        <p:spPr/>
-        <p:txBody>
-          <a:bodyPr/>
-          <a:lstStyle/>
-          <a:p>
-            <a:fld id="{F7021451-1387-4CA6-816F-3879F97B5CBC}" type="slidenum">
-              <a:rPr lang="en-US"/>
-              <a:t>12</a:t>
-            </a:fld>
-            <a:endParaRPr lang="en-US"/>
+              <a:rPr lang="zh-CN" altLang="zh-CN" dirty="0"/>
+              <a:t>Next, we wanted to go beyond average error rates.</a:t>
+            </a:r>
+          </a:p>
+          <a:p>
+            <a:r>
+              <a:rPr lang="zh-CN" altLang="zh-CN" dirty="0"/>
+              <a:t>Average error rate tells us how often the model is wrong overall, but it does not tell us whether the model is stable across languages.</a:t>
+            </a:r>
+          </a:p>
+          <a:p>
+            <a:r>
+              <a:rPr lang="zh-CN" altLang="zh-CN" dirty="0"/>
+              <a:t>So we introduce this first behavioral metric: cross-lingual flip rate.</a:t>
+            </a:r>
+            <a:endParaRPr lang="en-US" altLang="zh-CN" dirty="0"/>
+          </a:p>
+          <a:p>
+            <a:endParaRPr lang="zh-CN" altLang="zh-CN" dirty="0"/>
+          </a:p>
+          <a:p>
+            <a:r>
+              <a:rPr lang="zh-CN" altLang="zh-CN" dirty="0"/>
+              <a:t>The question here is very simple: for the same image pair, if we only change the language of the prompt, does the model change its answer?</a:t>
+            </a:r>
+          </a:p>
+          <a:p>
+            <a:r>
+              <a:rPr lang="zh-CN" altLang="zh-CN" dirty="0"/>
+              <a:t>If the model picks one image in English, but a different image in Bengali or Greek, then that item has flipped.</a:t>
+            </a:r>
+            <a:endParaRPr lang="en-US" altLang="zh-CN" dirty="0"/>
+          </a:p>
+          <a:p>
+            <a:endParaRPr lang="zh-CN" altLang="zh-CN" dirty="0"/>
+          </a:p>
+          <a:p>
+            <a:r>
+              <a:rPr lang="zh-CN" altLang="zh-CN" dirty="0"/>
+              <a:t>Overall, the flip rate is pretty high — about two-thirds of image pairs flip at least once across languages. So even if the average error rate looks stable, underneath that average, many individual items are actually changing their answer depending on language.</a:t>
+            </a:r>
+            <a:endParaRPr lang="en-US" altLang="zh-CN" dirty="0"/>
+          </a:p>
+          <a:p>
+            <a:endParaRPr lang="en-US" altLang="zh-CN" dirty="0"/>
+          </a:p>
+          <a:p>
+            <a:r>
+              <a:rPr lang="zh-CN" altLang="en-US" dirty="0"/>
+              <a:t>换</a:t>
+            </a:r>
+            <a:endParaRPr lang="en-US" altLang="zh-CN" dirty="0"/>
+          </a:p>
+          <a:p>
+            <a:endParaRPr lang="zh-CN" altLang="zh-CN" dirty="0"/>
+          </a:p>
+          <a:p>
+            <a:r>
+              <a:rPr lang="zh-CN" altLang="zh-CN" dirty="0"/>
+              <a:t>But the interesting part is Wealth.</a:t>
+            </a:r>
+          </a:p>
+          <a:p>
+            <a:r>
+              <a:rPr lang="zh-CN" altLang="zh-CN" dirty="0"/>
+              <a:t>Wealth flips the least. And that sounds a little counterintuitive at first, because low flip rate sounds like the model is stable. But here, it is stable in a bad way.</a:t>
+            </a:r>
+          </a:p>
+          <a:p>
+            <a:r>
+              <a:rPr lang="zh-CN" altLang="zh-CN" dirty="0"/>
+              <a:t>For Wealth items, the model is often locked into the wrong prototypical choice across languages. So it is not randomly changing its mind. It is consistently biased.</a:t>
+            </a:r>
+          </a:p>
+          <a:p>
+            <a:r>
+              <a:rPr lang="zh-CN" altLang="zh-CN" dirty="0"/>
+              <a:t>That is why low flip rate for Wealth is actually evidence of stable bias.</a:t>
+            </a:r>
+          </a:p>
+          <a:p>
+            <a:br>
+              <a:rPr lang="zh-CN" altLang="zh-CN" dirty="0"/>
+            </a:br>
+            <a:endParaRPr kumimoji="1" lang="zh-CN" altLang="en-US" dirty="0"/>
           </a:p>
         </p:txBody>
       </p:sp>
     </p:spTree>
-    <p:extLst>
-      <p:ext uri="{BB962C8B-B14F-4D97-AF65-F5344CB8AC3E}">
-        <p14:creationId xmlns:p14="http://schemas.microsoft.com/office/powerpoint/2010/main" val="1024086991"/>
-      </p:ext>
-    </p:extLst>
   </p:cSld>
   <p:clrMapOvr>
     <a:masterClrMapping/>
@@ -1814,19 +1771,13 @@
       </p:grpSpPr>
       <p:sp>
         <p:nvSpPr>
-          <p:cNvPr id="2" name="Slide Image Placeholder 1"/>
-          <p:cNvSpPr>
-            <a:spLocks noGrp="1" noRot="1" noChangeAspect="1"/>
-          </p:cNvSpPr>
-          <p:nvPr>
-            <p:ph type="sldImg"/>
-          </p:nvPr>
-        </p:nvSpPr>
-        <p:spPr/>
-      </p:sp>
-      <p:sp>
-        <p:nvSpPr>
-          <p:cNvPr id="3" name="Notes Placeholder 2"/>
+          <p:cNvPr id="2" name="备注占位符 1">
+            <a:extLst>
+              <a:ext uri="{FF2B5EF4-FFF2-40B4-BE49-F238E27FC236}">
+                <a16:creationId xmlns:a16="http://schemas.microsoft.com/office/drawing/2014/main" id="{A562A5A6-4AED-91F2-2F42-7F0FEC07832B}"/>
+              </a:ext>
+            </a:extLst>
+          </p:cNvPr>
           <p:cNvSpPr>
             <a:spLocks noGrp="1"/>
           </p:cNvSpPr>
@@ -1834,62 +1785,72 @@
             <p:ph type="body" idx="1"/>
           </p:nvPr>
         </p:nvSpPr>
-        <p:spPr/>
+        <p:spPr>
+          <a:xfrm>
+            <a:off x="685800" y="5867400"/>
+            <a:ext cx="5486400" cy="4800600"/>
+          </a:xfrm>
+          <a:prstGeom prst="rect">
+            <a:avLst/>
+          </a:prstGeom>
+        </p:spPr>
         <p:txBody>
           <a:bodyPr/>
           <a:lstStyle/>
           <a:p>
             <a:r>
-              <a:t>EN —</a:t>
-            </a:r>
-          </a:p>
-          <a:p>
-            <a:r>
-              <a:t>Here is a deeper check. In this dataset, the wrong image is always changed along one visual feature — its count, its color, its size, or its layout. So a fair worry is: maybe the model is not reacting to the stereotype at all, only to a low-level difference like color. We tested this by splitting the error rate by which feature was changed. The result is reassuring. Color is the LOWEST, around 0.40 — the opposite of a color artifact; if it were just color, color would be the highest. The bias is highest when the changed feature is hard to perceive, like count or size — things vision models are known to be bad at. So the model falls back on the stereotype exactly when it cannot read the fine detail. And wealth still beats morality inside every feature, so the attribute effect is not hidden in one feature.</a:t>
-            </a:r>
-          </a:p>
-          <a:p/>
-          <a:p>
-            <a:r>
-              <a:t>中文 —</a:t>
-            </a:r>
-          </a:p>
-          <a:p>
-            <a:r>
-              <a:t>这是一个更深的检查。在这个数据集里,错误的那张图总是在某一个视觉维度上被改动——数量、颜色、大小或布局。所以一个合理的担心是:模型会不会根本不是在反应刻板印象,而只是反应颜色这种低级差异?我们按"改了哪个维度"把错误率拆开。结果让人放心:颜色最低(约 0.40),这跟"颜色伪影"正好相反——如果只是颜色,颜色该最高。偏见在"难以感知"的维度上最高,比如数量、大小——这正是视觉模型出名的弱项。所以模型恰恰在"读不出细节"时退回刻板印象。而且财富在每个维度内部都高于道德,说明属性效应不是藏在某一个维度里。</a:t>
-            </a:r>
-          </a:p>
-        </p:txBody>
-      </p:sp>
-      <p:sp>
-        <p:nvSpPr>
-          <p:cNvPr id="4" name="Slide Number Placeholder 3"/>
-          <p:cNvSpPr>
-            <a:spLocks noGrp="1"/>
-          </p:cNvSpPr>
-          <p:nvPr>
-            <p:ph type="sldNum" sz="quarter" idx="10"/>
-          </p:nvPr>
-        </p:nvSpPr>
-        <p:spPr/>
-        <p:txBody>
-          <a:bodyPr/>
-          <a:lstStyle/>
-          <a:p>
-            <a:fld id="{F7021451-1387-4CA6-816F-3879F97B5CBC}" type="slidenum">
-              <a:rPr lang="en-US"/>
-              <a:t>13</a:t>
-            </a:fld>
-            <a:endParaRPr lang="en-US"/>
+              <a:rPr lang="zh-CN" altLang="zh-CN" dirty="0"/>
+              <a:t>The second metric makes that point even more directly.</a:t>
+            </a:r>
+          </a:p>
+          <a:p>
+            <a:r>
+              <a:rPr lang="zh-CN" altLang="zh-CN" dirty="0"/>
+              <a:t>Stable Bias Rate asks: does the model pick the wrong, prototypical image in all seven languages?</a:t>
+            </a:r>
+          </a:p>
+          <a:p>
+            <a:r>
+              <a:rPr lang="zh-CN" altLang="zh-CN" dirty="0"/>
+              <a:t>So this is a stricter metric than just being wrong once. An item only counts as stable bias if the model picks the prototypical-but-wrong image every single time, no matter which language we use.</a:t>
+            </a:r>
+          </a:p>
+          <a:p>
+            <a:r>
+              <a:rPr lang="zh-CN" altLang="zh-CN" dirty="0"/>
+              <a:t>And here the result is very clear: Wealth has the highest stable-bias rate in both models.</a:t>
+            </a:r>
+          </a:p>
+          <a:p>
+            <a:r>
+              <a:rPr lang="zh-CN" altLang="zh-CN" dirty="0"/>
+              <a:t>For Qwen, it is around 0.58. For InternVL, it is around 0.45. That means a large fraction of Wealth items are not just occasionally biased — they are biased everywhere.</a:t>
+            </a:r>
+          </a:p>
+          <a:p>
+            <a:r>
+              <a:rPr lang="zh-CN" altLang="zh-CN" dirty="0"/>
+              <a:t>This is important because it tells us that the Wealth effect is not just language-specific noise. It is not that the model flips around randomly depending on the prompt language.</a:t>
+            </a:r>
+          </a:p>
+          <a:p>
+            <a:r>
+              <a:rPr lang="zh-CN" altLang="zh-CN" dirty="0"/>
+              <a:t>Instead, for Wealth, there seems to be a very strong visual prototype, and both models keep falling back to it across languages.</a:t>
+            </a:r>
+          </a:p>
+          <a:p>
+            <a:r>
+              <a:rPr lang="zh-CN" altLang="zh-CN" dirty="0"/>
+              <a:t>So the takeaway here is: Wealth is not just biased. It is stably biased.</a:t>
+            </a:r>
+          </a:p>
+          <a:p>
+            <a:endParaRPr kumimoji="1" lang="zh-CN" altLang="en-US" dirty="0"/>
           </a:p>
         </p:txBody>
       </p:sp>
     </p:spTree>
-    <p:extLst>
-      <p:ext uri="{BB962C8B-B14F-4D97-AF65-F5344CB8AC3E}">
-        <p14:creationId xmlns:p14="http://schemas.microsoft.com/office/powerpoint/2010/main" val="1024086991"/>
-      </p:ext>
-    </p:extLst>
   </p:cSld>
   <p:clrMapOvr>
     <a:masterClrMapping/>
@@ -1942,24 +1903,54 @@
           <a:lstStyle/>
           <a:p>
             <a:r>
-              <a:t>EN —</a:t>
-            </a:r>
-          </a:p>
-          <a:p>
-            <a:r>
-              <a:t>Another deep check: do the two models make mistakes on the same image pairs, or different ones? Both models judged the same nine hundred pairs. Their per-item error rates are strongly correlated — the correlation is 0.68. So the same specific image pairs trap both model families. This tells us the stereotype trap is mostly a property of the image pair itself — an objective property of the data — not a private quirk of one model. The correlation is not perfect, so about half is still model-specific, but the main signal is shared. This is strong support that we are measuring something real in the data, not in one model.</a:t>
-            </a:r>
-          </a:p>
-          <a:p/>
-          <a:p>
-            <a:r>
-              <a:t>中文 —</a:t>
-            </a:r>
-          </a:p>
-          <a:p>
-            <a:r>
-              <a:t>另一个深挖:两个模型是在同一批图对上犯错,还是不同的?两个模型判断的是同样的 900 对图。它们的逐项错误率高度相关——相关系数 0.68。所以同一批具体图对会同时坑住两个模型家族。这说明刻板印象陷阱主要是图对本身的属性、是数据的客观属性,而不是某个模型的私人怪癖。相关不是完美的,所以约一半仍是模型特异的,但主信号是共享的。这有力地支持了:我们测的是数据里真实存在的东西,而不是某个模型里的东西。</a:t>
-            </a:r>
+              <a:rPr lang="zh-CN" altLang="zh-CN" dirty="0"/>
+              <a:t>Now we wanted to check another possible confound.</a:t>
+            </a:r>
+          </a:p>
+          <a:p>
+            <a:r>
+              <a:rPr lang="zh-CN" altLang="zh-CN" dirty="0"/>
+              <a:t>In this dataset, the adversarial image differs from the correct image along some visual feature — for example count, color, scale, layout, or spatial relation.</a:t>
+            </a:r>
+          </a:p>
+          <a:p>
+            <a:endParaRPr lang="en-US" altLang="zh-CN" dirty="0"/>
+          </a:p>
+          <a:p>
+            <a:r>
+              <a:rPr lang="zh-CN" altLang="zh-CN" dirty="0"/>
+              <a:t>So someone could reasonably ask: maybe the model is not reacting to a social prototype at all. Maybe it is just confused by some low-level visual feature, like color.</a:t>
+            </a:r>
+          </a:p>
+          <a:p>
+            <a:r>
+              <a:rPr lang="zh-CN" altLang="zh-CN" dirty="0"/>
+              <a:t>So we split the results by which visual knob was changed.</a:t>
+            </a:r>
+          </a:p>
+          <a:p>
+            <a:r>
+              <a:rPr lang="zh-CN" altLang="zh-CN" dirty="0"/>
+              <a:t>And the result is reassuring. If the bias were just a color artifact, then color should have the highest error rate. But actually color is the lowest, around 0.40.</a:t>
+            </a:r>
+          </a:p>
+          <a:p>
+            <a:r>
+              <a:rPr lang="zh-CN" altLang="zh-CN" dirty="0"/>
+              <a:t>The bias is highest for visual features that are harder for the model to perceive, like count and scale. And that makes sense, because vision-language models are known to struggle with precise counting and fine-grained size differences.</a:t>
+            </a:r>
+          </a:p>
+          <a:p>
+            <a:endParaRPr lang="en-US" altLang="zh-CN" dirty="0"/>
+          </a:p>
+          <a:p>
+            <a:r>
+              <a:rPr lang="zh-CN" altLang="zh-CN" dirty="0"/>
+              <a:t>So the interpretation is: when the visual evidence is weak or hard to ground, the model falls back on the prototype.</a:t>
+            </a:r>
+          </a:p>
+          <a:p>
+            <a:endParaRPr dirty="0"/>
           </a:p>
         </p:txBody>
       </p:sp>
@@ -2044,23 +2035,62 @@
           <a:lstStyle/>
           <a:p>
             <a:r>
-              <a:t>EN —</a:t>
-            </a:r>
-          </a:p>
-          <a:p>
-            <a:r>
-              <a:t>Let me put everything into one simple picture. The bias works like a fallback with two factors. The first factor is the attribute: a visual stereotype exists for wealth and status, but not for being moral or smart. This decides whether there is a shortcut to take at all, and it is the same in both models. The second factor is how weak the signal is: the model takes the shortcut more when the visual cue is hard to see, OR when the language is one it does not know well. These are two routes to the same behavior. In one sentence: the attribute decides whether a shortcut exists, and the weakness of the signal decides how much the model uses it.</a:t>
-            </a:r>
-          </a:p>
-          <a:p/>
-          <a:p>
-            <a:r>
-              <a:t>中文 —</a:t>
-            </a:r>
-          </a:p>
-          <a:p>
-            <a:r>
-              <a:t>让我把所有东西收成一张简单的图。这个偏见像一个"回退",由两个因子决定。第一个因子是属性:财富和地位有视觉刻板印象,但"有道德""聪明"没有。它决定到底有没有捷径可走,而且在两个模型里一样。第二个因子是信号有多弱:当视觉线索难看清、或语言是模型不熟悉的时候,模型就更会走捷径。这是通向同一种行为的两条路径。一句话:属性决定有没有捷径,信号的弱度决定模型用它用得多狠。</a:t>
+              <a:rPr lang="zh-CN" altLang="zh-CN" dirty="0"/>
+              <a:t>So let me put the whole story together.</a:t>
+            </a:r>
+          </a:p>
+          <a:p>
+            <a:r>
+              <a:rPr lang="zh-CN" altLang="zh-CN" dirty="0"/>
+              <a:t>I think the simplest way to understand the results is as a fallback mechanism with two factors.</a:t>
+            </a:r>
+          </a:p>
+          <a:p>
+            <a:endParaRPr lang="en-US" altLang="zh-CN" dirty="0"/>
+          </a:p>
+          <a:p>
+            <a:r>
+              <a:rPr lang="zh-CN" altLang="zh-CN" dirty="0"/>
+              <a:t>The first factor is the attribute.</a:t>
+            </a:r>
+          </a:p>
+          <a:p>
+            <a:r>
+              <a:rPr lang="zh-CN" altLang="zh-CN" dirty="0"/>
+              <a:t>Some attributes have a strong visual prototype. Wealth and Power are good examples. The web has lots of repeated visual patterns for what “rich” or “powerful” is supposed to look like. But for attributes like Morality or Intellect, there is no equally stable visual appearance.</a:t>
+            </a:r>
+          </a:p>
+          <a:p>
+            <a:r>
+              <a:rPr lang="zh-CN" altLang="zh-CN" dirty="0"/>
+              <a:t>So the attribute decides whether there is a prototype shortcut available in the first place.</a:t>
+            </a:r>
+          </a:p>
+          <a:p>
+            <a:endParaRPr lang="en-US" altLang="zh-CN" dirty="0"/>
+          </a:p>
+          <a:p>
+            <a:r>
+              <a:rPr lang="zh-CN" altLang="zh-CN" dirty="0"/>
+              <a:t>The second factor is signal weakness.</a:t>
+            </a:r>
+          </a:p>
+          <a:p>
+            <a:r>
+              <a:rPr lang="zh-CN" altLang="zh-CN" dirty="0"/>
+              <a:t>The model uses the shortcut more when the real evidence is harder to use. That can happen on the vision side, when the key difference is count or scale. And it can also happen on the language side, when the prompt is in a language where the model seems less robust, like Bengali or Greek in our results.</a:t>
+            </a:r>
+          </a:p>
+          <a:p>
+            <a:r>
+              <a:rPr lang="zh-CN" altLang="zh-CN" dirty="0"/>
+              <a:t>So these look like two different routes, but they lead to the same behavior: the model falls back on the prototype.</a:t>
+            </a:r>
+          </a:p>
+          <a:p>
+            <a:r>
+              <a:rPr lang="zh-CN" altLang="zh-CN" dirty="0"/>
+              <a:t>In one sentence: the attribute decides whether a shortcut exists, and the weakness of the visual or language signal decides how much the model takes it.</a:t>
             </a:r>
           </a:p>
         </p:txBody>
@@ -2146,23 +2176,44 @@
           <a:lstStyle/>
           <a:p>
             <a:r>
-              <a:t>EN —</a:t>
-            </a:r>
-          </a:p>
-          <a:p>
-            <a:r>
-              <a:t>We should be honest about the limits. We used one random seed and one translation tool. The changed visual feature is mixed together with the stereotype by design, so we cannot fully separate them. Some groups are small — wealth has only about thirty items per language — so those numbers are less certain. We could not run the 32-billion model; it was too slow on our GPUs. And we do not yet know WHY these specific languages — Arabic, Bengali, Greek — are the biased ones; it is not a clean low-to-high resource line, because Russian is also non-Latin but shows no effect.</a:t>
-            </a:r>
-          </a:p>
-          <a:p/>
-          <a:p>
-            <a:r>
-              <a:t>中文 —</a:t>
-            </a:r>
-          </a:p>
-          <a:p>
-            <a:r>
-              <a:t>我们要诚实地说局限。只用了一个随机种子、一个翻译工具。被改的视觉维度在设计上和刻板印象混在一起,没法完全分开。有些组样本很小——财富每种语言只有约 30 条——所以那里的数字不太确定。我们没能跑 320 亿参数的模型,在我们的 GPU 上太慢。而且我们还不知道为什么偏偏是阿拉伯语、孟加拉语、希腊语;它不是一条干净的"资源从低到高"的线,因为俄语也是非拉丁字母却没有效应。</a:t>
+              <a:rPr lang="zh-CN" altLang="zh-CN" dirty="0"/>
+              <a:t>Of course, there are several limitations.</a:t>
+            </a:r>
+          </a:p>
+          <a:p>
+            <a:r>
+              <a:rPr lang="zh-CN" altLang="zh-CN" dirty="0"/>
+              <a:t>First, we are still using a single seed and a single translation backend, so we do not want to overclaim.</a:t>
+            </a:r>
+          </a:p>
+          <a:p>
+            <a:r>
+              <a:rPr lang="zh-CN" altLang="zh-CN" dirty="0"/>
+              <a:t>Second, the adversarial visual knob is still a co-varying factor. The dataset changes things like color, scale, count, or layout, and those are not fully separable from the prototype manipulation.</a:t>
+            </a:r>
+          </a:p>
+          <a:p>
+            <a:r>
+              <a:rPr lang="zh-CN" altLang="zh-CN" dirty="0"/>
+              <a:t>Third, some of the demography cells are small. For example, Wealth has only around thirty items per language. The mixed-effects model helps by pooling information, but the power is still limited.</a:t>
+            </a:r>
+          </a:p>
+          <a:p>
+            <a:r>
+              <a:rPr lang="zh-CN" altLang="zh-CN" dirty="0"/>
+              <a:t>Fourth, we had to drop Qwen-32B because it was just too slow on the available GPUs. It was around 280 seconds per item, which was not feasible for this report.</a:t>
+            </a:r>
+          </a:p>
+          <a:p>
+            <a:r>
+              <a:rPr lang="zh-CN" altLang="zh-CN" dirty="0"/>
+              <a:t>And finally, we still do not know exactly why Arabic, Bengali, and Greek are the elevated languages. It is not a clean resource-level story, because Russian is also non-Latin and high-resource, but it is basically flat.</a:t>
+            </a:r>
+          </a:p>
+          <a:p>
+            <a:r>
+              <a:rPr lang="zh-CN" altLang="zh-CN" dirty="0"/>
+              <a:t>So the main thing we can say now is: the language effect exists, but the mechanism behind exactly these languages is still open.</a:t>
             </a:r>
           </a:p>
         </p:txBody>
@@ -2248,23 +2299,38 @@
           <a:lstStyle/>
           <a:p>
             <a:r>
-              <a:t>EN —</a:t>
-            </a:r>
-          </a:p>
-          <a:p>
-            <a:r>
-              <a:t>For next steps we have four. First, add the big 32-billion model using a smaller 4-bit version, to see if the bias gets weaker as the model gets larger. Second, add more model families like Gemma and LLaVA, to see how general the language effect is. Third, run shortcut-severing tests: remove the stereotype cue and see if the correct answers survive — this checks whether the model really understands or just guesses. Fourth, find out what drives the language effect — is it the language's resource level, its script, or its culture.</a:t>
-            </a:r>
-          </a:p>
-          <a:p/>
-          <a:p>
-            <a:r>
-              <a:t>中文 —</a:t>
-            </a:r>
-          </a:p>
-          <a:p>
-            <a:r>
-              <a:t>下一步有四件事。第一,用 4-bit 的小版本把 320 亿的大模型加进来,看偏见是否随模型变大而减弱。第二,加更多模型家族,比如 Gemma、LLaVA,看语言效应有多普遍。第三,做"切断捷径"的实验:把刻板印象线索去掉,看正确答案还在不在——检验模型是真懂还是在猜。第四,搞清楚什么在驱动语言效应——是语言的资源量、字系,还是文化。</a:t>
+              <a:rPr lang="zh-CN" altLang="zh-CN" dirty="0"/>
+              <a:t>For next steps, we have four directions.</a:t>
+            </a:r>
+          </a:p>
+          <a:p>
+            <a:r>
+              <a:rPr lang="zh-CN" altLang="zh-CN" dirty="0"/>
+              <a:t>First, we want to test model scale. The plan is to run Qwen-32B in 4-bit, so we can see whether a larger model reduces this bias or whether the same pattern stays.</a:t>
+            </a:r>
+          </a:p>
+          <a:p>
+            <a:r>
+              <a:rPr lang="zh-CN" altLang="zh-CN" dirty="0"/>
+              <a:t>Second, we want to add more model families, like Gemma and LLaVA-OneVision. That will tell us whether the language effect is really general across VLMs.</a:t>
+            </a:r>
+          </a:p>
+          <a:p>
+            <a:r>
+              <a:rPr lang="zh-CN" altLang="zh-CN" dirty="0"/>
+              <a:t>Third, we want to do shortcut-severing experiments. Basically, remove or weaken the prototype cue and see whether the model can still choose correctly. That would help us distinguish real grounding from shortcut-based guessing.</a:t>
+            </a:r>
+          </a:p>
+          <a:p>
+            <a:r>
+              <a:rPr lang="zh-CN" altLang="zh-CN" dirty="0"/>
+              <a:t>And fourth, we want to pin down the language mechanism. Right now we know Bengali, Greek, and to some extent Arabic are elevated, but we do not yet know whether that comes from resource level, script, cultural loading, or something else.</a:t>
+            </a:r>
+          </a:p>
+          <a:p>
+            <a:r>
+              <a:rPr lang="zh-CN" altLang="zh-CN" dirty="0"/>
+              <a:t>So the next stage is not just to add more data, but to explain why the language effect happens.</a:t>
             </a:r>
           </a:p>
         </p:txBody>
@@ -2350,23 +2416,69 @@
           <a:lstStyle/>
           <a:p>
             <a:r>
+              <a:rPr dirty="0"/>
               <a:t>EN —</a:t>
             </a:r>
           </a:p>
           <a:p>
             <a:r>
-              <a:t>To sum up: we built and ran the first multilingual, multi-model version of ProtoBias — seven languages and two model families. The two results both hold across families: the bias is attribute-specific, and it is modulated by language. The code is all on GitHub. Thank you, and I am happy to take questions.</a:t>
-            </a:r>
-          </a:p>
-          <a:p/>
-          <a:p>
-            <a:r>
-              <a:t>中文 —</a:t>
-            </a:r>
-          </a:p>
-          <a:p>
-            <a:r>
-              <a:t>总结一下:我们搭建并跑通了首个多语言、多模型版本的 ProtoBias——七种语言、两个模型家族。两个结果都跨家族成立:偏见是属性特异的,并且受语言调制。代码都在 GitHub 上。谢谢,欢迎提问。</a:t>
+              <a:rPr dirty="0"/>
+              <a:t>To sum up: we built and ran the first multilingual, multi-model version of </a:t>
+            </a:r>
+            <a:r>
+              <a:rPr dirty="0" err="1"/>
+              <a:t>ProtoBias</a:t>
+            </a:r>
+            <a:r>
+              <a:rPr dirty="0"/>
+              <a:t> — seven languages and two model families. The two results both hold across families: the bias is attribute-specific, and it is modulated by language. The code is all on GitHub. Thank you, and I am happy to take questions.</a:t>
+            </a:r>
+          </a:p>
+          <a:p>
+            <a:endParaRPr dirty="0"/>
+          </a:p>
+          <a:p>
+            <a:r>
+              <a:rPr dirty="0" err="1"/>
+              <a:t>中文</a:t>
+            </a:r>
+            <a:r>
+              <a:rPr dirty="0"/>
+              <a:t> —</a:t>
+            </a:r>
+          </a:p>
+          <a:p>
+            <a:r>
+              <a:rPr dirty="0" err="1"/>
+              <a:t>总结一下:我们搭建并跑通了首个多语言、多模型版本的</a:t>
+            </a:r>
+            <a:r>
+              <a:rPr dirty="0"/>
+              <a:t> </a:t>
+            </a:r>
+            <a:r>
+              <a:rPr dirty="0" err="1"/>
+              <a:t>ProtoBias</a:t>
+            </a:r>
+            <a:r>
+              <a:rPr dirty="0"/>
+              <a:t>——</a:t>
+            </a:r>
+            <a:r>
+              <a:rPr dirty="0" err="1"/>
+              <a:t>七种语言、两个模型家族。两个结果都跨家族成立:偏见是属性特异的,并且受语言调制。代码都在</a:t>
+            </a:r>
+            <a:r>
+              <a:rPr dirty="0"/>
+              <a:t> GitHub </a:t>
+            </a:r>
+            <a:r>
+              <a:rPr dirty="0" err="1"/>
+              <a:t>上。谢谢,欢迎提问</a:t>
+            </a:r>
+            <a:r>
+              <a:rPr dirty="0"/>
+              <a:t>。</a:t>
             </a:r>
           </a:p>
         </p:txBody>
@@ -2452,23 +2564,85 @@
           <a:lstStyle/>
           <a:p>
             <a:r>
+              <a:rPr dirty="0"/>
               <a:t>EN (backup — pull up if asked for exact numbers) —</a:t>
             </a:r>
           </a:p>
           <a:p>
             <a:r>
+              <a:rPr dirty="0"/>
               <a:t>This table puts both models side by side: overall error rate, the attribute and language test p-values, the wealth odds ratio, the Greek and Bengali odds ratios, the stable-bias rate, and the flip rate. The headline: the attribute p-values are tiny in both models, and the language p-values are small in both — so both effects replicate.</a:t>
             </a:r>
           </a:p>
-          <a:p/>
-          <a:p>
-            <a:r>
-              <a:t>中文(备份——要确切数字时调出)—</a:t>
-            </a:r>
-          </a:p>
-          <a:p>
-            <a:r>
-              <a:t>这张表把两个模型并排:总体错误率、属性和语言检验的 p 值、财富优势比、希腊语和孟加拉语优势比、稳定偏见率、翻转率。重点:属性 p 值在两个模型里都极小,语言 p 值也都小——两个效应都复现。</a:t>
+          <a:p>
+            <a:endParaRPr dirty="0"/>
+          </a:p>
+          <a:p>
+            <a:r>
+              <a:rPr dirty="0" err="1"/>
+              <a:t>中文</a:t>
+            </a:r>
+            <a:r>
+              <a:rPr dirty="0"/>
+              <a:t>(</a:t>
+            </a:r>
+            <a:r>
+              <a:rPr dirty="0" err="1"/>
+              <a:t>备份</a:t>
+            </a:r>
+            <a:r>
+              <a:rPr dirty="0"/>
+              <a:t>——</a:t>
+            </a:r>
+            <a:r>
+              <a:rPr dirty="0" err="1"/>
+              <a:t>要确切数字时调出</a:t>
+            </a:r>
+            <a:r>
+              <a:rPr dirty="0"/>
+              <a:t>)—</a:t>
+            </a:r>
+          </a:p>
+          <a:p>
+            <a:r>
+              <a:rPr dirty="0" err="1"/>
+              <a:t>这张表把两个模型并排:总体错误率、属性和语言检验的</a:t>
+            </a:r>
+            <a:r>
+              <a:rPr dirty="0"/>
+              <a:t> p </a:t>
+            </a:r>
+            <a:r>
+              <a:rPr dirty="0" err="1"/>
+              <a:t>值、财富优势比、希腊语和孟加拉语优势比、稳定偏见率、翻转率。重点:属性</a:t>
+            </a:r>
+            <a:r>
+              <a:rPr dirty="0"/>
+              <a:t> p </a:t>
+            </a:r>
+            <a:r>
+              <a:rPr dirty="0" err="1"/>
+              <a:t>值在两个模型里都极小,语言</a:t>
+            </a:r>
+            <a:r>
+              <a:rPr dirty="0"/>
+              <a:t> p </a:t>
+            </a:r>
+            <a:r>
+              <a:rPr dirty="0" err="1"/>
+              <a:t>值也都小</a:t>
+            </a:r>
+            <a:r>
+              <a:rPr dirty="0"/>
+              <a:t>——</a:t>
+            </a:r>
+            <a:r>
+              <a:rPr dirty="0" err="1"/>
+              <a:t>两个效应都复现</a:t>
+            </a:r>
+            <a:r>
+              <a:rPr dirty="0"/>
+              <a:t>。</a:t>
             </a:r>
           </a:p>
         </p:txBody>
@@ -2638,23 +2812,85 @@
           <a:lstStyle/>
           <a:p>
             <a:r>
+              <a:rPr dirty="0"/>
               <a:t>EN (backup — why the second model) —</a:t>
             </a:r>
           </a:p>
           <a:p>
             <a:r>
+              <a:rPr dirty="0"/>
               <a:t>The main reason is to rule out that the finding is just a Qwen quirk; an independent second family tests whether it generalizes. We picked InternVL3-8B for four reasons: it is a different family from a different lab; it is about the same size as Qwen, so size is controlled; it is a strong, standard baseline used in papers; and it fit our pipeline because it handles multiple images and loads with the standard tools.</a:t>
             </a:r>
           </a:p>
-          <a:p/>
-          <a:p>
-            <a:r>
-              <a:t>中文(备份——为什么选第二个模型)—</a:t>
-            </a:r>
-          </a:p>
-          <a:p>
-            <a:r>
-              <a:t>主要原因是排除"这只是 Qwen 的怪癖";一个独立的第二家族能检验它是否普遍。选 InternVL3-8B 有四个理由:来自另一个实验室的不同家族;和 Qwen 体量相当,控制了规模;是论文常用的强基线;支持多图、能用标准工具加载,适配我们的流程。</a:t>
+          <a:p>
+            <a:endParaRPr dirty="0"/>
+          </a:p>
+          <a:p>
+            <a:r>
+              <a:rPr dirty="0" err="1"/>
+              <a:t>中文</a:t>
+            </a:r>
+            <a:r>
+              <a:rPr dirty="0"/>
+              <a:t>(</a:t>
+            </a:r>
+            <a:r>
+              <a:rPr dirty="0" err="1"/>
+              <a:t>备份</a:t>
+            </a:r>
+            <a:r>
+              <a:rPr dirty="0"/>
+              <a:t>——</a:t>
+            </a:r>
+            <a:r>
+              <a:rPr dirty="0" err="1"/>
+              <a:t>为什么选第二个模型</a:t>
+            </a:r>
+            <a:r>
+              <a:rPr dirty="0"/>
+              <a:t>)—</a:t>
+            </a:r>
+          </a:p>
+          <a:p>
+            <a:r>
+              <a:rPr dirty="0" err="1"/>
+              <a:t>主要原因是排除"这只是</a:t>
+            </a:r>
+            <a:r>
+              <a:rPr dirty="0"/>
+              <a:t> Qwen </a:t>
+            </a:r>
+            <a:r>
+              <a:rPr dirty="0" err="1"/>
+              <a:t>的怪癖</a:t>
+            </a:r>
+            <a:r>
+              <a:rPr dirty="0"/>
+              <a:t>";</a:t>
+            </a:r>
+            <a:r>
+              <a:rPr dirty="0" err="1"/>
+              <a:t>一个独立的第二家族能检验它是否普遍。选</a:t>
+            </a:r>
+            <a:r>
+              <a:rPr dirty="0"/>
+              <a:t> InternVL3-8B </a:t>
+            </a:r>
+            <a:r>
+              <a:rPr dirty="0" err="1"/>
+              <a:t>有四个理由:来自另一个实验室的不同家族;和</a:t>
+            </a:r>
+            <a:r>
+              <a:rPr dirty="0"/>
+              <a:t> Qwen </a:t>
+            </a:r>
+            <a:r>
+              <a:rPr dirty="0" err="1"/>
+              <a:t>体量相当,控制了规模;是论文常用的强基线;支持多图、能用标准工具加载,适配我们的流程</a:t>
+            </a:r>
+            <a:r>
+              <a:rPr dirty="0"/>
+              <a:t>。</a:t>
             </a:r>
           </a:p>
         </p:txBody>
@@ -2740,23 +2976,77 @@
           <a:lstStyle/>
           <a:p>
             <a:r>
+              <a:rPr dirty="0"/>
               <a:t>EN (backup — the statistics) —</a:t>
             </a:r>
           </a:p>
           <a:p>
             <a:r>
+              <a:rPr dirty="0"/>
               <a:t>We used a logistic regression because the outcome is yes/no (did it pick the stereotype); its coefficients become odds ratios. We made it "mixed-effects" by giving each image pair its own baseline, because the same pair appears in seven languages, so those seven are not independent. To test a whole factor like language, we use a likelihood-ratio test: fit the model with and without that factor and check if it fits significantly better, giving one p-value per factor. The table: attribute is very strong, language is significant, no interaction.</a:t>
             </a:r>
           </a:p>
-          <a:p/>
-          <a:p>
-            <a:r>
-              <a:t>中文(备份——统计方法)—</a:t>
-            </a:r>
-          </a:p>
-          <a:p>
-            <a:r>
-              <a:t>我们用逻辑回归,因为结果是是/否(有没有选刻板印象那张),系数转成优势比。做成"混合效应"是给每对图自己的基线,因为同一对图出现在七种语言里,这七个不独立。要检验"语言"这样一整个因素,用似然比检验:拟合带和不带该因素的两个模型,看带上后是否显著更好,每个因素一个 p 值。表里:属性非常强,语言显著,无交互。</a:t>
+          <a:p>
+            <a:endParaRPr dirty="0"/>
+          </a:p>
+          <a:p>
+            <a:r>
+              <a:rPr dirty="0" err="1"/>
+              <a:t>中文</a:t>
+            </a:r>
+            <a:r>
+              <a:rPr dirty="0"/>
+              <a:t>(</a:t>
+            </a:r>
+            <a:r>
+              <a:rPr dirty="0" err="1"/>
+              <a:t>备份</a:t>
+            </a:r>
+            <a:r>
+              <a:rPr dirty="0"/>
+              <a:t>——</a:t>
+            </a:r>
+            <a:r>
+              <a:rPr dirty="0" err="1"/>
+              <a:t>统计方法</a:t>
+            </a:r>
+            <a:r>
+              <a:rPr dirty="0"/>
+              <a:t>)—</a:t>
+            </a:r>
+          </a:p>
+          <a:p>
+            <a:r>
+              <a:rPr dirty="0" err="1"/>
+              <a:t>我们用逻辑回归,因为结果是是</a:t>
+            </a:r>
+            <a:r>
+              <a:rPr dirty="0"/>
+              <a:t>/</a:t>
+            </a:r>
+            <a:r>
+              <a:rPr dirty="0" err="1"/>
+              <a:t>否</a:t>
+            </a:r>
+            <a:r>
+              <a:rPr dirty="0"/>
+              <a:t>(</a:t>
+            </a:r>
+            <a:r>
+              <a:rPr dirty="0" err="1"/>
+              <a:t>有没有选刻板印象那张</a:t>
+            </a:r>
+            <a:r>
+              <a:rPr dirty="0"/>
+              <a:t>),系数转成优势比。做成"混合效应"是给每对图自己的基线,因为同一对图出现在七种语言里,这七个不独立。要检验"语言"这样一整个因素,用似然比检验:拟合带和不带该因素的两个模型,看带上后是否显著更好,每个因素一个 p </a:t>
+            </a:r>
+            <a:r>
+              <a:rPr dirty="0" err="1"/>
+              <a:t>值。表里:属性非常强,语言显著,无交互</a:t>
+            </a:r>
+            <a:r>
+              <a:rPr dirty="0"/>
+              <a:t>。</a:t>
             </a:r>
           </a:p>
         </p:txBody>
@@ -2842,23 +3132,69 @@
           <a:lstStyle/>
           <a:p>
             <a:r>
+              <a:rPr dirty="0"/>
               <a:t>EN (backup — the translation check) —</a:t>
             </a:r>
           </a:p>
           <a:p>
             <a:r>
+              <a:rPr dirty="0"/>
               <a:t>We take the English prompt, translate it into, say, Greek (this is what the model sees), then translate that Greek back into English, and compare the two English versions. If they are close, the translation kept the meaning; we score closeness with a simple word-overlap measure. The key result again: the most-biased languages have the closest back-translations — so the bias is not from bad translation.</a:t>
             </a:r>
           </a:p>
-          <a:p/>
-          <a:p>
-            <a:r>
-              <a:t>中文(备份——翻译检查)—</a:t>
-            </a:r>
-          </a:p>
-          <a:p>
-            <a:r>
-              <a:t>拿英文提示,翻成比如希腊语(模型看到的就是它),再把希腊语翻回英文,比较前后两个英文版本。接近就说明翻译保住了意思;接近程度用一个简单的词重叠分数量。关键结果还是那句:最偏的语言回译最接近——所以偏见不是来自烂翻译。</a:t>
+          <a:p>
+            <a:endParaRPr dirty="0"/>
+          </a:p>
+          <a:p>
+            <a:r>
+              <a:rPr dirty="0" err="1"/>
+              <a:t>中文</a:t>
+            </a:r>
+            <a:r>
+              <a:rPr dirty="0"/>
+              <a:t>(</a:t>
+            </a:r>
+            <a:r>
+              <a:rPr dirty="0" err="1"/>
+              <a:t>备份</a:t>
+            </a:r>
+            <a:r>
+              <a:rPr dirty="0"/>
+              <a:t>——</a:t>
+            </a:r>
+            <a:r>
+              <a:rPr dirty="0" err="1"/>
+              <a:t>翻译检查</a:t>
+            </a:r>
+            <a:r>
+              <a:rPr dirty="0"/>
+              <a:t>)—</a:t>
+            </a:r>
+          </a:p>
+          <a:p>
+            <a:r>
+              <a:rPr dirty="0" err="1"/>
+              <a:t>拿英文提示,翻成比如希腊语</a:t>
+            </a:r>
+            <a:r>
+              <a:rPr dirty="0"/>
+              <a:t>(</a:t>
+            </a:r>
+            <a:r>
+              <a:rPr dirty="0" err="1"/>
+              <a:t>模型看到的就是它</a:t>
+            </a:r>
+            <a:r>
+              <a:rPr dirty="0"/>
+              <a:t>),再把希腊语翻回英文,比较前后两个英文版本。接近就说明翻译保住了意思;接近程度用一个简单的词重叠分数量。关键结果还是那句:最偏的语言回译最接近——</a:t>
+            </a:r>
+            <a:r>
+              <a:rPr dirty="0" err="1"/>
+              <a:t>所以偏见不是来自烂翻译</a:t>
+            </a:r>
+            <a:r>
+              <a:rPr dirty="0"/>
+              <a:t>。</a:t>
             </a:r>
           </a:p>
         </p:txBody>
@@ -2944,23 +3280,85 @@
           <a:lstStyle/>
           <a:p>
             <a:r>
+              <a:rPr dirty="0"/>
               <a:t>EN (backup — exact metric definitions) —</a:t>
             </a:r>
           </a:p>
           <a:p>
             <a:r>
+              <a:rPr dirty="0"/>
               <a:t>For each image pair, look at its answers across all its languages. Wrong in all of them = stable bias. Right in all of them = stable correct. Mixed = a flip. These three add up to one. The important point: these are measured per image-pair across languages, not per single judgment — which is why the average error rate can look flat while many items are actually flipping underneath.</a:t>
             </a:r>
           </a:p>
-          <a:p/>
-          <a:p>
-            <a:r>
-              <a:t>中文(备份——指标精确定义)—</a:t>
-            </a:r>
-          </a:p>
-          <a:p>
-            <a:r>
-              <a:t>对每对图,看它在所有语言下的答案。全错 = 稳定偏见;全对 = 稳定正确;有对有错 = 翻转。三者加起来等于一。重点:它们是"按图对、跨语言"量的,不是"按单次判断"量的——这就是为什么平均错误率看着平,底下其实很多图对在翻转。</a:t>
+          <a:p>
+            <a:endParaRPr dirty="0"/>
+          </a:p>
+          <a:p>
+            <a:r>
+              <a:rPr dirty="0" err="1"/>
+              <a:t>中文</a:t>
+            </a:r>
+            <a:r>
+              <a:rPr dirty="0"/>
+              <a:t>(</a:t>
+            </a:r>
+            <a:r>
+              <a:rPr dirty="0" err="1"/>
+              <a:t>备份</a:t>
+            </a:r>
+            <a:r>
+              <a:rPr dirty="0"/>
+              <a:t>——</a:t>
+            </a:r>
+            <a:r>
+              <a:rPr dirty="0" err="1"/>
+              <a:t>指标精确定义</a:t>
+            </a:r>
+            <a:r>
+              <a:rPr dirty="0"/>
+              <a:t>)—</a:t>
+            </a:r>
+          </a:p>
+          <a:p>
+            <a:r>
+              <a:rPr dirty="0" err="1"/>
+              <a:t>对每对图,看它在所有语言下的答案。全错</a:t>
+            </a:r>
+            <a:r>
+              <a:rPr dirty="0"/>
+              <a:t> = </a:t>
+            </a:r>
+            <a:r>
+              <a:rPr dirty="0" err="1"/>
+              <a:t>稳定偏见;全对</a:t>
+            </a:r>
+            <a:r>
+              <a:rPr dirty="0"/>
+              <a:t> = </a:t>
+            </a:r>
+            <a:r>
+              <a:rPr dirty="0" err="1"/>
+              <a:t>稳定正确;有对有错</a:t>
+            </a:r>
+            <a:r>
+              <a:rPr dirty="0"/>
+              <a:t> = </a:t>
+            </a:r>
+            <a:r>
+              <a:rPr dirty="0" err="1"/>
+              <a:t>翻转。三者加起来等于一。重点:它们是"按图对、跨语言"量的,不是"按单次判断"量的</a:t>
+            </a:r>
+            <a:r>
+              <a:rPr dirty="0"/>
+              <a:t>——</a:t>
+            </a:r>
+            <a:r>
+              <a:rPr dirty="0" err="1"/>
+              <a:t>这就是为什么平均错误率看着平,底下其实很多图对在翻转</a:t>
+            </a:r>
+            <a:r>
+              <a:rPr dirty="0"/>
+              <a:t>。</a:t>
             </a:r>
           </a:p>
         </p:txBody>
@@ -3046,23 +3444,85 @@
           <a:lstStyle/>
           <a:p>
             <a:r>
+              <a:rPr dirty="0"/>
               <a:t>EN (interactive backup) —</a:t>
             </a:r>
           </a:p>
           <a:p>
             <a:r>
-              <a:t>These three slides act as one panel: the buttons at the bottom are clickable in slideshow mode. Click "InternVL" or "Both" to switch which model's chart is shown — use this if someone doubts the result holds across models, and switch live in front of them. Navigate with the buttons, not the arrow keys.</a:t>
-            </a:r>
-          </a:p>
-          <a:p/>
-          <a:p>
-            <a:r>
-              <a:t>中文(交互备份)—</a:t>
-            </a:r>
-          </a:p>
-          <a:p>
-            <a:r>
-              <a:t>这三页其实是一个面板:底部按钮在放映模式下可点。点 "InternVL" 或 "Both" 切换显示哪个模型的图——有人怀疑结果跨模型是否成立时,当场切给他看。用按钮导航,别用方向键。</a:t>
+              <a:rPr dirty="0"/>
+              <a:t>These three slides act as one panel: the buttons at the bottom are clickable in slideshow mode. Click "</a:t>
+            </a:r>
+            <a:r>
+              <a:rPr dirty="0" err="1"/>
+              <a:t>InternVL</a:t>
+            </a:r>
+            <a:r>
+              <a:rPr dirty="0"/>
+              <a:t>" or "Both" to switch which model's chart is shown — use this if someone doubts the result holds across models, and switch live in front of them. Navigate with the buttons, not the arrow keys.</a:t>
+            </a:r>
+          </a:p>
+          <a:p>
+            <a:endParaRPr dirty="0"/>
+          </a:p>
+          <a:p>
+            <a:r>
+              <a:rPr dirty="0" err="1"/>
+              <a:t>中文</a:t>
+            </a:r>
+            <a:r>
+              <a:rPr dirty="0"/>
+              <a:t>(</a:t>
+            </a:r>
+            <a:r>
+              <a:rPr dirty="0" err="1"/>
+              <a:t>交互备份</a:t>
+            </a:r>
+            <a:r>
+              <a:rPr dirty="0"/>
+              <a:t>)—</a:t>
+            </a:r>
+          </a:p>
+          <a:p>
+            <a:r>
+              <a:rPr dirty="0" err="1"/>
+              <a:t>这三页其实是一个面板:底部按钮在放映模式下可点。点</a:t>
+            </a:r>
+            <a:r>
+              <a:rPr dirty="0"/>
+              <a:t> "</a:t>
+            </a:r>
+            <a:r>
+              <a:rPr dirty="0" err="1"/>
+              <a:t>InternVL</a:t>
+            </a:r>
+            <a:r>
+              <a:rPr dirty="0"/>
+              <a:t>" </a:t>
+            </a:r>
+            <a:r>
+              <a:rPr dirty="0" err="1"/>
+              <a:t>或</a:t>
+            </a:r>
+            <a:r>
+              <a:rPr dirty="0"/>
+              <a:t> "Both" </a:t>
+            </a:r>
+            <a:r>
+              <a:rPr dirty="0" err="1"/>
+              <a:t>切换显示哪个模型的图</a:t>
+            </a:r>
+            <a:r>
+              <a:rPr dirty="0"/>
+              <a:t>——</a:t>
+            </a:r>
+            <a:r>
+              <a:rPr dirty="0" err="1"/>
+              <a:t>有人怀疑结果跨模型是否成立时,当场切给他看。用按钮导航,别用方向键</a:t>
+            </a:r>
+            <a:r>
+              <a:rPr dirty="0"/>
+              <a:t>。</a:t>
             </a:r>
           </a:p>
         </p:txBody>
@@ -3148,12 +3608,42 @@
           <a:lstStyle/>
           <a:p>
             <a:r>
+              <a:rPr dirty="0"/>
               <a:t>EN — Same panel, now showing InternVL3. Click "Qwen-7B" or "Both" to switch.</a:t>
             </a:r>
           </a:p>
           <a:p>
             <a:r>
-              <a:t>中文 — 同一面板,现在显示 InternVL3。点 "Qwen-7B" 或 "Both" 切换。</a:t>
+              <a:rPr dirty="0" err="1"/>
+              <a:t>中文</a:t>
+            </a:r>
+            <a:r>
+              <a:rPr dirty="0"/>
+              <a:t> — </a:t>
+            </a:r>
+            <a:r>
+              <a:rPr dirty="0" err="1"/>
+              <a:t>同一面板,现在显示</a:t>
+            </a:r>
+            <a:r>
+              <a:rPr dirty="0"/>
+              <a:t> InternVL3。点 "Qwen-7B" </a:t>
+            </a:r>
+            <a:r>
+              <a:rPr dirty="0" err="1"/>
+              <a:t>或</a:t>
+            </a:r>
+            <a:r>
+              <a:rPr dirty="0"/>
+              <a:t> "Both" </a:t>
+            </a:r>
+            <a:r>
+              <a:rPr dirty="0" err="1"/>
+              <a:t>切换</a:t>
+            </a:r>
+            <a:r>
+              <a:rPr dirty="0"/>
+              <a:t>。</a:t>
             </a:r>
           </a:p>
         </p:txBody>
@@ -3239,12 +3729,26 @@
           <a:lstStyle/>
           <a:p>
             <a:r>
+              <a:rPr dirty="0"/>
               <a:t>EN — Same panel, showing both models overlaid. Click a button to switch back.</a:t>
             </a:r>
           </a:p>
           <a:p>
             <a:r>
-              <a:t>中文 — 同一面板,两个模型叠加显示。点按钮切回。</a:t>
+              <a:rPr dirty="0" err="1"/>
+              <a:t>中文</a:t>
+            </a:r>
+            <a:r>
+              <a:rPr dirty="0"/>
+              <a:t> — </a:t>
+            </a:r>
+            <a:r>
+              <a:rPr dirty="0" err="1"/>
+              <a:t>同一面板,两个模型叠加显示。点按钮切回</a:t>
+            </a:r>
+            <a:r>
+              <a:rPr dirty="0"/>
+              <a:t>。</a:t>
             </a:r>
           </a:p>
         </p:txBody>
@@ -3278,56 +3782,6 @@
         <p14:creationId xmlns:p14="http://schemas.microsoft.com/office/powerpoint/2010/main" val="1024086991"/>
       </p:ext>
     </p:extLst>
-  </p:cSld>
-  <p:clrMapOvr>
-    <a:masterClrMapping/>
-  </p:clrMapOvr>
-</p:notes>
-</file>
-
-<file path=ppt/notesSlides/notesSlide27.xml><?xml version="1.0" encoding="utf-8"?>
-<p:notes xmlns:a="http://schemas.openxmlformats.org/drawingml/2006/main" xmlns:p="http://schemas.openxmlformats.org/presentationml/2006/main" xmlns:r="http://schemas.openxmlformats.org/officeDocument/2006/relationships">
-  <p:cSld>
-    <p:spTree>
-      <p:nvGrpSpPr>
-        <p:cNvPr id="1" name=""/>
-        <p:cNvGrpSpPr/>
-        <p:nvPr/>
-      </p:nvGrpSpPr>
-      <p:grpSpPr>
-        <a:xfrm>
-          <a:off x="0" y="0"/>
-          <a:ext cx="0" cy="0"/>
-          <a:chOff x="0" y="0"/>
-          <a:chExt cx="0" cy="0"/>
-        </a:xfrm>
-      </p:grpSpPr>
-    </p:spTree>
-  </p:cSld>
-  <p:clrMapOvr>
-    <a:masterClrMapping/>
-  </p:clrMapOvr>
-</p:notes>
-</file>
-
-<file path=ppt/notesSlides/notesSlide28.xml><?xml version="1.0" encoding="utf-8"?>
-<p:notes xmlns:a="http://schemas.openxmlformats.org/drawingml/2006/main" xmlns:p="http://schemas.openxmlformats.org/presentationml/2006/main" xmlns:r="http://schemas.openxmlformats.org/officeDocument/2006/relationships">
-  <p:cSld>
-    <p:spTree>
-      <p:nvGrpSpPr>
-        <p:cNvPr id="1" name=""/>
-        <p:cNvGrpSpPr/>
-        <p:nvPr/>
-      </p:nvGrpSpPr>
-      <p:grpSpPr>
-        <a:xfrm>
-          <a:off x="0" y="0"/>
-          <a:ext cx="0" cy="0"/>
-          <a:chOff x="0" y="0"/>
-          <a:chExt cx="0" cy="0"/>
-        </a:xfrm>
-      </p:grpSpPr>
-    </p:spTree>
   </p:cSld>
   <p:clrMapOvr>
     <a:masterClrMapping/>
@@ -4754,10 +5208,70 @@
       </p:sp>
       <p:sp>
         <p:nvSpPr>
-          <p:cNvPr id="7" name="椭圆 6">
+          <p:cNvPr id="9" name="文本框 8">
             <a:extLst>
               <a:ext uri="{FF2B5EF4-FFF2-40B4-BE49-F238E27FC236}">
-                <a16:creationId xmlns:a16="http://schemas.microsoft.com/office/drawing/2014/main" id="{D2EE14F0-9B3D-176F-7F11-811655CDC7B5}"/>
+                <a16:creationId xmlns:a16="http://schemas.microsoft.com/office/drawing/2014/main" id="{57EAF298-B028-65F4-E58F-20728796535C}"/>
+              </a:ext>
+            </a:extLst>
+          </p:cNvPr>
+          <p:cNvSpPr txBox="1"/>
+          <p:nvPr/>
+        </p:nvSpPr>
+        <p:spPr>
+          <a:xfrm>
+            <a:off x="579120" y="3608754"/>
+            <a:ext cx="5029200" cy="646331"/>
+          </a:xfrm>
+          <a:prstGeom prst="rect">
+            <a:avLst/>
+          </a:prstGeom>
+          <a:noFill/>
+        </p:spPr>
+        <p:txBody>
+          <a:bodyPr wrap="square">
+            <a:spAutoFit/>
+          </a:bodyPr>
+          <a:lstStyle/>
+          <a:p>
+            <a:pPr>
+              <a:lnSpc>
+                <a:spcPct val="100000"/>
+              </a:lnSpc>
+              <a:spcAft>
+                <a:spcPts val="1100"/>
+              </a:spcAft>
+              <a:buSzPct val="100000"/>
+            </a:pPr>
+            <a:r>
+              <a:rPr lang="en-US" altLang="zh-CN" sz="1800" b="1" dirty="0">
+                <a:solidFill>
+                  <a:schemeClr val="accent1">
+                    <a:lumMod val="75000"/>
+                  </a:schemeClr>
+                </a:solidFill>
+                <a:latin typeface="Calibri" pitchFamily="34" charset="0"/>
+                <a:ea typeface="Calibri" pitchFamily="34" charset="-122"/>
+                <a:cs typeface="Calibri" pitchFamily="34" charset="-120"/>
+              </a:rPr>
+              <a:t>Bengali and Greek prompts → significantly more bias than English, in both models.</a:t>
+            </a:r>
+            <a:endParaRPr lang="en-US" altLang="zh-CN" sz="1800" b="1" dirty="0">
+              <a:solidFill>
+                <a:schemeClr val="accent1">
+                  <a:lumMod val="75000"/>
+                </a:schemeClr>
+              </a:solidFill>
+            </a:endParaRPr>
+          </a:p>
+        </p:txBody>
+      </p:sp>
+      <p:sp>
+        <p:nvSpPr>
+          <p:cNvPr id="8" name="矩形 7">
+            <a:extLst>
+              <a:ext uri="{FF2B5EF4-FFF2-40B4-BE49-F238E27FC236}">
+                <a16:creationId xmlns:a16="http://schemas.microsoft.com/office/drawing/2014/main" id="{8FA9A62B-DF94-9B50-3BA5-43316021435F}"/>
               </a:ext>
             </a:extLst>
           </p:cNvPr>
@@ -4766,14 +5280,14 @@
         </p:nvSpPr>
         <p:spPr>
           <a:xfrm>
-            <a:off x="9601200" y="2558143"/>
-            <a:ext cx="2122714" cy="1328057"/>
-          </a:xfrm>
-          <a:prstGeom prst="ellipse">
+            <a:off x="9745579" y="2664516"/>
+            <a:ext cx="1690437" cy="3370524"/>
+          </a:xfrm>
+          <a:prstGeom prst="rect">
             <a:avLst/>
           </a:prstGeom>
           <a:noFill/>
-          <a:ln w="28575">
+          <a:ln w="19050">
             <a:solidFill>
               <a:srgbClr val="FF0000"/>
             </a:solidFill>
@@ -4801,66 +5315,6 @@
           <a:p>
             <a:pPr algn="ctr"/>
             <a:endParaRPr kumimoji="1" lang="zh-CN" altLang="en-US"/>
-          </a:p>
-        </p:txBody>
-      </p:sp>
-      <p:sp>
-        <p:nvSpPr>
-          <p:cNvPr id="9" name="文本框 8">
-            <a:extLst>
-              <a:ext uri="{FF2B5EF4-FFF2-40B4-BE49-F238E27FC236}">
-                <a16:creationId xmlns:a16="http://schemas.microsoft.com/office/drawing/2014/main" id="{57EAF298-B028-65F4-E58F-20728796535C}"/>
-              </a:ext>
-            </a:extLst>
-          </p:cNvPr>
-          <p:cNvSpPr txBox="1"/>
-          <p:nvPr/>
-        </p:nvSpPr>
-        <p:spPr>
-          <a:xfrm>
-            <a:off x="579120" y="3608754"/>
-            <a:ext cx="5029200" cy="646331"/>
-          </a:xfrm>
-          <a:prstGeom prst="rect">
-            <a:avLst/>
-          </a:prstGeom>
-          <a:noFill/>
-        </p:spPr>
-        <p:txBody>
-          <a:bodyPr wrap="square">
-            <a:spAutoFit/>
-          </a:bodyPr>
-          <a:lstStyle/>
-          <a:p>
-            <a:pPr>
-              <a:lnSpc>
-                <a:spcPct val="100000"/>
-              </a:lnSpc>
-              <a:spcAft>
-                <a:spcPts val="1100"/>
-              </a:spcAft>
-              <a:buSzPct val="100000"/>
-            </a:pPr>
-            <a:r>
-              <a:rPr lang="en-US" altLang="zh-CN" sz="1800" b="1" dirty="0">
-                <a:solidFill>
-                  <a:schemeClr val="accent1">
-                    <a:lumMod val="75000"/>
-                  </a:schemeClr>
-                </a:solidFill>
-                <a:latin typeface="Calibri" pitchFamily="34" charset="0"/>
-                <a:ea typeface="Calibri" pitchFamily="34" charset="-122"/>
-                <a:cs typeface="Calibri" pitchFamily="34" charset="-120"/>
-              </a:rPr>
-              <a:t>Bengali and Greek prompts → significantly more bias than English, in both models.</a:t>
-            </a:r>
-            <a:endParaRPr lang="en-US" altLang="zh-CN" sz="1800" b="1" dirty="0">
-              <a:solidFill>
-                <a:schemeClr val="accent1">
-                  <a:lumMod val="75000"/>
-                </a:schemeClr>
-              </a:solidFill>
-            </a:endParaRPr>
           </a:p>
         </p:txBody>
       </p:sp>
@@ -4881,6 +5335,9 @@
                     <p:cTn id="3" fill="hold">
                       <p:stCondLst>
                         <p:cond delay="indefinite"/>
+                        <p:cond evt="onBegin" delay="0">
+                          <p:tn val="2"/>
+                        </p:cond>
                       </p:stCondLst>
                       <p:childTnLst>
                         <p:par>
@@ -4890,7 +5347,7 @@
                             </p:stCondLst>
                             <p:childTnLst>
                               <p:par>
-                                <p:cTn id="5" presetID="1" presetClass="entr" presetSubtype="0" fill="hold" grpId="0" nodeType="clickEffect">
+                                <p:cTn id="5" presetID="1" presetClass="entr" presetSubtype="0" fill="hold" grpId="0" nodeType="withEffect">
                                   <p:stCondLst>
                                     <p:cond delay="0"/>
                                   </p:stCondLst>
@@ -4903,7 +5360,7 @@
                                           </p:stCondLst>
                                         </p:cTn>
                                         <p:tgtEl>
-                                          <p:spTgt spid="7"/>
+                                          <p:spTgt spid="9"/>
                                         </p:tgtEl>
                                         <p:attrNameLst>
                                           <p:attrName>style.visibility</p:attrName>
@@ -4916,21 +5373,39 @@
                                   </p:childTnLst>
                                 </p:cTn>
                               </p:par>
+                            </p:childTnLst>
+                          </p:cTn>
+                        </p:par>
+                      </p:childTnLst>
+                    </p:cTn>
+                  </p:par>
+                  <p:par>
+                    <p:cTn id="7" fill="hold">
+                      <p:stCondLst>
+                        <p:cond delay="indefinite"/>
+                      </p:stCondLst>
+                      <p:childTnLst>
+                        <p:par>
+                          <p:cTn id="8" fill="hold">
+                            <p:stCondLst>
+                              <p:cond delay="0"/>
+                            </p:stCondLst>
+                            <p:childTnLst>
                               <p:par>
-                                <p:cTn id="7" presetID="1" presetClass="entr" presetSubtype="0" fill="hold" grpId="0" nodeType="withEffect">
+                                <p:cTn id="9" presetID="1" presetClass="entr" presetSubtype="0" fill="hold" grpId="0" nodeType="clickEffect">
                                   <p:stCondLst>
                                     <p:cond delay="0"/>
                                   </p:stCondLst>
                                   <p:childTnLst>
                                     <p:set>
                                       <p:cBhvr>
-                                        <p:cTn id="8" dur="1" fill="hold">
+                                        <p:cTn id="10" dur="1" fill="hold">
                                           <p:stCondLst>
                                             <p:cond delay="0"/>
                                           </p:stCondLst>
                                         </p:cTn>
                                         <p:tgtEl>
-                                          <p:spTgt spid="9"/>
+                                          <p:spTgt spid="8"/>
                                         </p:tgtEl>
                                         <p:attrNameLst>
                                           <p:attrName>style.visibility</p:attrName>
@@ -4971,8 +5446,8 @@
       </p:par>
     </p:tnLst>
     <p:bldLst>
-      <p:bldP spid="7" grpId="0" animBg="1"/>
       <p:bldP spid="9" grpId="0"/>
+      <p:bldP spid="8" grpId="0" animBg="1"/>
     </p:bldLst>
   </p:timing>
 </p:sld>
@@ -6699,7 +7174,7 @@
 
 <file path=ppt/slides/slide12.xml><?xml version="1.0" encoding="utf-8"?>
 <p:sld xmlns:a="http://schemas.openxmlformats.org/drawingml/2006/main" xmlns:r="http://schemas.openxmlformats.org/officeDocument/2006/relationships" xmlns:p="http://schemas.openxmlformats.org/presentationml/2006/main">
-  <p:cSld name="Slide 12">
+  <p:cSld>
     <p:bg>
       <p:bgPr>
         <a:solidFill>
@@ -6724,186 +7199,217 @@
       </p:grpSpPr>
       <p:sp>
         <p:nvSpPr>
-          <p:cNvPr id="2" name="Text 0"/>
-          <p:cNvSpPr/>
-          <p:nvPr/>
-        </p:nvSpPr>
-        <p:spPr>
-          <a:xfrm>
-            <a:off x="685800" y="502920"/>
-            <a:ext cx="10820095" cy="274320"/>
+          <p:cNvPr id="2" name="TextBox 1"/>
+          <p:cNvSpPr txBox="1"/>
+          <p:nvPr/>
+        </p:nvSpPr>
+        <p:spPr>
+          <a:xfrm>
+            <a:off x="685800" y="457200"/>
+            <a:ext cx="8229600" cy="320040"/>
           </a:xfrm>
           <a:prstGeom prst="rect">
             <a:avLst/>
           </a:prstGeom>
           <a:noFill/>
-          <a:ln/>
-        </p:spPr>
-        <p:txBody>
-          <a:bodyPr wrap="square" lIns="0" tIns="0" rIns="0" bIns="0" rtlCol="0" anchor="ctr"/>
-          <a:lstStyle/>
-          <a:p>
-            <a:pPr marL="0" indent="0">
-              <a:buNone/>
+        </p:spPr>
+        <p:txBody>
+          <a:bodyPr wrap="square" anchor="t">
+            <a:spAutoFit/>
+          </a:bodyPr>
+          <a:lstStyle/>
+          <a:p>
+            <a:pPr algn="l">
+              <a:spcAft>
+                <a:spcPts val="800"/>
+              </a:spcAft>
             </a:pPr>
             <a:r>
-              <a:rPr lang="en-US" sz="1200" b="1" kern="0" spc="300" dirty="0">
+              <a:rPr sz="1200" b="1" i="0">
                 <a:solidFill>
                   <a:srgbClr val="C44E52"/>
                 </a:solidFill>
-                <a:latin typeface="Calibri" pitchFamily="34" charset="0"/>
-                <a:ea typeface="Calibri" pitchFamily="34" charset="-122"/>
-                <a:cs typeface="Calibri" pitchFamily="34" charset="-120"/>
+                <a:latin typeface="Calibri"/>
               </a:rPr>
-              <a:t>NEW BEHAVIOURAL METRICS</a:t>
-            </a:r>
-            <a:endParaRPr lang="en-US" sz="1200" dirty="0"/>
-          </a:p>
-        </p:txBody>
-      </p:sp>
-      <p:sp>
-        <p:nvSpPr>
-          <p:cNvPr id="3" name="Text 1"/>
-          <p:cNvSpPr/>
-          <p:nvPr/>
-        </p:nvSpPr>
-        <p:spPr>
-          <a:xfrm>
-            <a:off x="685800" y="841248"/>
-            <a:ext cx="10820095" cy="868680"/>
+              <a:t>NEW BEHAVIOURAL METRIC · 1 OF 2</a:t>
+            </a:r>
+          </a:p>
+        </p:txBody>
+      </p:sp>
+      <p:sp>
+        <p:nvSpPr>
+          <p:cNvPr id="3" name="TextBox 2"/>
+          <p:cNvSpPr txBox="1"/>
+          <p:nvPr/>
+        </p:nvSpPr>
+        <p:spPr>
+          <a:xfrm>
+            <a:off x="658368" y="822960"/>
+            <a:ext cx="10789920" cy="914400"/>
           </a:xfrm>
           <a:prstGeom prst="rect">
             <a:avLst/>
           </a:prstGeom>
           <a:noFill/>
-          <a:ln/>
-        </p:spPr>
-        <p:txBody>
-          <a:bodyPr wrap="square" lIns="0" tIns="0" rIns="0" bIns="0" rtlCol="0" anchor="ctr"/>
-          <a:lstStyle/>
-          <a:p>
-            <a:pPr marL="0" indent="0">
-              <a:lnSpc>
-                <a:spcPts val="3456"/>
-              </a:lnSpc>
-              <a:buNone/>
+        </p:spPr>
+        <p:txBody>
+          <a:bodyPr wrap="square" anchor="t">
+            <a:spAutoFit/>
+          </a:bodyPr>
+          <a:lstStyle/>
+          <a:p>
+            <a:pPr algn="l">
+              <a:spcAft>
+                <a:spcPts val="800"/>
+              </a:spcAft>
             </a:pPr>
             <a:r>
-              <a:rPr lang="en-US" sz="3200" b="1" dirty="0">
+              <a:rPr sz="3000" b="1" i="0">
                 <a:solidFill>
                   <a:srgbClr val="23262F"/>
                 </a:solidFill>
-                <a:latin typeface="Georgia" pitchFamily="34" charset="0"/>
-                <a:ea typeface="Georgia" pitchFamily="34" charset="-122"/>
-                <a:cs typeface="Georgia" pitchFamily="34" charset="-120"/>
+                <a:latin typeface="Georgia"/>
               </a:rPr>
-              <a:t>Stable bias tracks the attribute</a:t>
-            </a:r>
-            <a:endParaRPr lang="en-US" sz="3200" dirty="0"/>
-          </a:p>
-        </p:txBody>
-      </p:sp>
-      <p:sp>
-        <p:nvSpPr>
-          <p:cNvPr id="4" name="Text 2"/>
-          <p:cNvSpPr/>
-          <p:nvPr/>
-        </p:nvSpPr>
-        <p:spPr>
-          <a:xfrm>
-            <a:off x="685800" y="1920240"/>
-            <a:ext cx="5029200" cy="1508760"/>
+              <a:t>Cross-lingual Flip Rate (CFR)</a:t>
+            </a:r>
+          </a:p>
+        </p:txBody>
+      </p:sp>
+      <p:sp>
+        <p:nvSpPr>
+          <p:cNvPr id="4" name="TextBox 3"/>
+          <p:cNvSpPr txBox="1"/>
+          <p:nvPr/>
+        </p:nvSpPr>
+        <p:spPr>
+          <a:xfrm>
+            <a:off x="685800" y="1965960"/>
+            <a:ext cx="5120640" cy="2194560"/>
           </a:xfrm>
           <a:prstGeom prst="rect">
             <a:avLst/>
           </a:prstGeom>
           <a:noFill/>
-          <a:ln/>
-        </p:spPr>
-        <p:txBody>
-          <a:bodyPr wrap="square" lIns="0" tIns="0" rIns="0" bIns="0" rtlCol="0" anchor="t"/>
-          <a:lstStyle/>
-          <a:p>
-            <a:pPr marL="203200" indent="-203200">
-              <a:lnSpc>
-                <a:spcPct val="100000"/>
-              </a:lnSpc>
+        </p:spPr>
+        <p:txBody>
+          <a:bodyPr wrap="square" anchor="t">
+            <a:spAutoFit/>
+          </a:bodyPr>
+          <a:lstStyle/>
+          <a:p>
+            <a:pPr algn="l">
               <a:spcAft>
-                <a:spcPts val="1100"/>
+                <a:spcPts val="800"/>
               </a:spcAft>
-              <a:buSzPct val="100000"/>
-              <a:buChar char="•"/>
             </a:pPr>
             <a:r>
-              <a:rPr lang="en-US" sz="1650" b="1" dirty="0">
+              <a:rPr sz="1650" b="0" i="0">
                 <a:solidFill>
                   <a:srgbClr val="23262F"/>
                 </a:solidFill>
-                <a:latin typeface="Calibri" pitchFamily="34" charset="0"/>
-                <a:ea typeface="Calibri" pitchFamily="34" charset="-122"/>
-                <a:cs typeface="Calibri" pitchFamily="34" charset="-120"/>
+                <a:latin typeface="Calibri"/>
               </a:rPr>
-              <a:t>Cross-lingual Flip Rate </a:t>
-            </a:r>
-            <a:r>
-              <a:rPr lang="en-US" sz="1650" dirty="0">
+              <a:t>Does the model's choice change when only the language changes?</a:t>
+            </a:r>
+          </a:p>
+          <a:p>
+            <a:pPr algn="l">
+              <a:spcAft>
+                <a:spcPts val="800"/>
+              </a:spcAft>
+            </a:pPr>
+            <a:r>
+              <a:rPr sz="1650" b="0" i="0">
                 <a:solidFill>
                   <a:srgbClr val="23262F"/>
                 </a:solidFill>
-                <a:latin typeface="Calibri" pitchFamily="34" charset="0"/>
-                <a:ea typeface="Calibri" pitchFamily="34" charset="-122"/>
-                <a:cs typeface="Calibri" pitchFamily="34" charset="-120"/>
+                <a:latin typeface="Calibri"/>
               </a:rPr>
-              <a:t>— does the choice change across languages?</a:t>
-            </a:r>
-            <a:endParaRPr lang="en-US" sz="1650" dirty="0"/>
-          </a:p>
-          <a:p>
-            <a:pPr marL="203200" indent="-203200">
-              <a:lnSpc>
-                <a:spcPct val="100000"/>
-              </a:lnSpc>
+              <a:t>Overall CFR ≈ 0.65 — about two-thirds of image-pairs flip at least once.</a:t>
+            </a:r>
+          </a:p>
+          <a:p>
+            <a:pPr algn="l">
               <a:spcAft>
-                <a:spcPts val="1100"/>
+                <a:spcPts val="800"/>
               </a:spcAft>
-              <a:buSzPct val="100000"/>
-              <a:buChar char="•"/>
             </a:pPr>
             <a:r>
-              <a:rPr lang="en-US" sz="1650" b="1" dirty="0">
+              <a:rPr sz="1650" b="0" i="0">
                 <a:solidFill>
                   <a:srgbClr val="23262F"/>
                 </a:solidFill>
-                <a:latin typeface="Calibri" pitchFamily="34" charset="0"/>
-                <a:ea typeface="Calibri" pitchFamily="34" charset="-122"/>
-                <a:cs typeface="Calibri" pitchFamily="34" charset="-120"/>
+                <a:latin typeface="Calibri"/>
               </a:rPr>
-              <a:t>Stable Bias Rate </a:t>
-            </a:r>
-            <a:r>
-              <a:rPr lang="en-US" sz="1650" dirty="0">
+              <a:t>Wealth flips the LEAST — it is locked in (low flip = high stable bias).</a:t>
+            </a:r>
+          </a:p>
+        </p:txBody>
+      </p:sp>
+      <p:sp>
+        <p:nvSpPr>
+          <p:cNvPr id="5" name="Rounded Rectangle 4"/>
+          <p:cNvSpPr/>
+          <p:nvPr/>
+        </p:nvSpPr>
+        <p:spPr>
+          <a:xfrm>
+            <a:off x="685800" y="4297680"/>
+            <a:ext cx="5120640" cy="777240"/>
+          </a:xfrm>
+          <a:prstGeom prst="roundRect">
+            <a:avLst/>
+          </a:prstGeom>
+          <a:solidFill>
+            <a:srgbClr val="1B1F3B"/>
+          </a:solidFill>
+          <a:ln>
+            <a:noFill/>
+          </a:ln>
+          <a:effectLst/>
+        </p:spPr>
+        <p:style>
+          <a:lnRef idx="1">
+            <a:schemeClr val="accent1"/>
+          </a:lnRef>
+          <a:fillRef idx="3">
+            <a:schemeClr val="accent1"/>
+          </a:fillRef>
+          <a:effectRef idx="2">
+            <a:schemeClr val="accent1"/>
+          </a:effectRef>
+          <a:fontRef idx="minor">
+            <a:schemeClr val="lt1"/>
+          </a:fontRef>
+        </p:style>
+        <p:txBody>
+          <a:bodyPr wrap="square" rtlCol="0" anchor="ctr"/>
+          <a:lstStyle/>
+          <a:p>
+            <a:pPr algn="ctr"/>
+            <a:r>
+              <a:rPr sz="1300" b="0">
                 <a:solidFill>
-                  <a:srgbClr val="23262F"/>
+                  <a:srgbClr val="FFFFFF"/>
                 </a:solidFill>
-                <a:latin typeface="Calibri" pitchFamily="34" charset="0"/>
-                <a:ea typeface="Calibri" pitchFamily="34" charset="-122"/>
-                <a:cs typeface="Calibri" pitchFamily="34" charset="-120"/>
+                <a:latin typeface="Courier New"/>
               </a:rPr>
-              <a:t>— does the model pick the wrong image in ALL languages?</a:t>
-            </a:r>
-            <a:endParaRPr lang="en-US" sz="1650" dirty="0"/>
+              <a:t>CFR  =  #(items whose answer differs across languages)  /  #(items)</a:t>
+            </a:r>
           </a:p>
         </p:txBody>
       </p:sp>
       <p:graphicFrame>
         <p:nvGraphicFramePr>
-          <p:cNvPr id="5" name="Chart 0"/>
-          <p:cNvGraphicFramePr/>
+          <p:cNvPr id="6" name="Chart 5"/>
+          <p:cNvGraphicFramePr>
+            <a:graphicFrameLocks noGrp="1"/>
+          </p:cNvGraphicFramePr>
           <p:nvPr/>
         </p:nvGraphicFramePr>
         <p:xfrm>
-          <a:off x="5943600" y="1828800"/>
-          <a:ext cx="5669280" cy="4206240"/>
+          <a:off x="6126480" y="1737360"/>
+          <a:ext cx="5486400" cy="4297680"/>
         </p:xfrm>
         <a:graphic>
           <a:graphicData uri="http://schemas.openxmlformats.org/drawingml/2006/chart">
@@ -6913,96 +7419,53 @@
       </p:graphicFrame>
       <p:sp>
         <p:nvSpPr>
-          <p:cNvPr id="6" name="Text 3"/>
-          <p:cNvSpPr/>
-          <p:nvPr/>
-        </p:nvSpPr>
-        <p:spPr>
-          <a:xfrm>
-            <a:off x="11551615" y="6400800"/>
-            <a:ext cx="365760" cy="274320"/>
-          </a:xfrm>
-          <a:prstGeom prst="rect">
-            <a:avLst/>
-          </a:prstGeom>
-          <a:noFill/>
-          <a:ln/>
-        </p:spPr>
-        <p:txBody>
-          <a:bodyPr wrap="square" lIns="0" tIns="0" rIns="0" bIns="0" rtlCol="0" anchor="ctr"/>
-          <a:lstStyle/>
-          <a:p>
-            <a:pPr marL="0" indent="0" algn="r">
-              <a:buNone/>
-            </a:pPr>
-            <a:r>
-              <a:rPr lang="en-US" sz="1000" dirty="0">
-                <a:solidFill>
-                  <a:srgbClr val="9AA0B0"/>
-                </a:solidFill>
-                <a:latin typeface="Calibri" pitchFamily="34" charset="0"/>
-                <a:ea typeface="Calibri" pitchFamily="34" charset="-122"/>
-                <a:cs typeface="Calibri" pitchFamily="34" charset="-120"/>
-              </a:rPr>
-              <a:t>12</a:t>
-            </a:r>
-            <a:endParaRPr lang="en-US" sz="1000" dirty="0"/>
-          </a:p>
-        </p:txBody>
-      </p:sp>
-      <p:sp>
-        <p:nvSpPr>
-          <p:cNvPr id="8" name="文本框 7">
+          <p:cNvPr id="8" name="矩形 7">
             <a:extLst>
               <a:ext uri="{FF2B5EF4-FFF2-40B4-BE49-F238E27FC236}">
-                <a16:creationId xmlns:a16="http://schemas.microsoft.com/office/drawing/2014/main" id="{B220E43F-3916-0639-77A3-B617F2EB5834}"/>
+                <a16:creationId xmlns:a16="http://schemas.microsoft.com/office/drawing/2014/main" id="{C868A0CA-7AF7-F6F3-5B52-1B43ABCD1933}"/>
               </a:ext>
             </a:extLst>
           </p:cNvPr>
-          <p:cNvSpPr txBox="1"/>
-          <p:nvPr/>
-        </p:nvSpPr>
-        <p:spPr>
-          <a:xfrm>
-            <a:off x="685800" y="4313200"/>
-            <a:ext cx="5029200" cy="646331"/>
+          <p:cNvSpPr/>
+          <p:nvPr/>
+        </p:nvSpPr>
+        <p:spPr>
+          <a:xfrm>
+            <a:off x="6503068" y="3429000"/>
+            <a:ext cx="1235241" cy="2606040"/>
           </a:xfrm>
           <a:prstGeom prst="rect">
             <a:avLst/>
           </a:prstGeom>
           <a:noFill/>
-        </p:spPr>
-        <p:txBody>
-          <a:bodyPr wrap="square">
-            <a:spAutoFit/>
-          </a:bodyPr>
-          <a:lstStyle/>
-          <a:p>
-            <a:pPr>
-              <a:lnSpc>
-                <a:spcPct val="100000"/>
-              </a:lnSpc>
-              <a:spcAft>
-                <a:spcPts val="1100"/>
-              </a:spcAft>
-              <a:buSzPct val="100000"/>
-            </a:pPr>
-            <a:r>
-              <a:rPr lang="en-US" altLang="zh-CN" b="1" dirty="0">
-                <a:solidFill>
-                  <a:srgbClr val="FF0000"/>
-                </a:solidFill>
-                <a:latin typeface="Calibri" pitchFamily="34" charset="0"/>
-                <a:ea typeface="Calibri" pitchFamily="34" charset="-122"/>
-                <a:cs typeface="Calibri" pitchFamily="34" charset="-120"/>
-              </a:rPr>
-              <a:t>Wealth has the highest stable-bias rate in both models — it is biased everywhere, not flip-flopping.</a:t>
-            </a:r>
-            <a:endParaRPr lang="en-US" altLang="zh-CN" b="1" dirty="0">
-              <a:solidFill>
-                <a:srgbClr val="FF0000"/>
-              </a:solidFill>
-            </a:endParaRPr>
+          <a:ln w="19050">
+            <a:solidFill>
+              <a:srgbClr val="FF0000"/>
+            </a:solidFill>
+          </a:ln>
+        </p:spPr>
+        <p:style>
+          <a:lnRef idx="2">
+            <a:schemeClr val="accent1">
+              <a:shade val="15000"/>
+            </a:schemeClr>
+          </a:lnRef>
+          <a:fillRef idx="1">
+            <a:schemeClr val="accent1"/>
+          </a:fillRef>
+          <a:effectRef idx="0">
+            <a:schemeClr val="accent1"/>
+          </a:effectRef>
+          <a:fontRef idx="minor">
+            <a:schemeClr val="lt1"/>
+          </a:fontRef>
+        </p:style>
+        <p:txBody>
+          <a:bodyPr rtlCol="0" anchor="ctr"/>
+          <a:lstStyle/>
+          <a:p>
+            <a:pPr algn="ctr"/>
+            <a:endParaRPr kumimoji="1" lang="zh-CN" altLang="en-US"/>
           </a:p>
         </p:txBody>
       </p:sp>
@@ -7086,13 +7549,250 @@
       </p:par>
     </p:tnLst>
     <p:bldLst>
-      <p:bldP spid="8" grpId="0"/>
+      <p:bldP spid="8" grpId="0" animBg="1"/>
     </p:bldLst>
   </p:timing>
 </p:sld>
 </file>
 
 <file path=ppt/slides/slide13.xml><?xml version="1.0" encoding="utf-8"?>
+<p:sld xmlns:a="http://schemas.openxmlformats.org/drawingml/2006/main" xmlns:r="http://schemas.openxmlformats.org/officeDocument/2006/relationships" xmlns:p="http://schemas.openxmlformats.org/presentationml/2006/main">
+  <p:cSld>
+    <p:bg>
+      <p:bgPr>
+        <a:solidFill>
+          <a:srgbClr val="FFFFFF"/>
+        </a:solidFill>
+        <a:effectLst/>
+      </p:bgPr>
+    </p:bg>
+    <p:spTree>
+      <p:nvGrpSpPr>
+        <p:cNvPr id="1" name=""/>
+        <p:cNvGrpSpPr/>
+        <p:nvPr/>
+      </p:nvGrpSpPr>
+      <p:grpSpPr>
+        <a:xfrm>
+          <a:off x="0" y="0"/>
+          <a:ext cx="0" cy="0"/>
+          <a:chOff x="0" y="0"/>
+          <a:chExt cx="0" cy="0"/>
+        </a:xfrm>
+      </p:grpSpPr>
+      <p:sp>
+        <p:nvSpPr>
+          <p:cNvPr id="2" name="TextBox 1"/>
+          <p:cNvSpPr txBox="1"/>
+          <p:nvPr/>
+        </p:nvSpPr>
+        <p:spPr>
+          <a:xfrm>
+            <a:off x="685800" y="457200"/>
+            <a:ext cx="8229600" cy="320040"/>
+          </a:xfrm>
+          <a:prstGeom prst="rect">
+            <a:avLst/>
+          </a:prstGeom>
+          <a:noFill/>
+        </p:spPr>
+        <p:txBody>
+          <a:bodyPr wrap="square" anchor="t">
+            <a:spAutoFit/>
+          </a:bodyPr>
+          <a:lstStyle/>
+          <a:p>
+            <a:pPr algn="l">
+              <a:spcAft>
+                <a:spcPts val="800"/>
+              </a:spcAft>
+            </a:pPr>
+            <a:r>
+              <a:rPr sz="1200" b="1" i="0">
+                <a:solidFill>
+                  <a:srgbClr val="C44E52"/>
+                </a:solidFill>
+                <a:latin typeface="Calibri"/>
+              </a:rPr>
+              <a:t>NEW BEHAVIOURAL METRIC · 2 OF 2</a:t>
+            </a:r>
+          </a:p>
+        </p:txBody>
+      </p:sp>
+      <p:sp>
+        <p:nvSpPr>
+          <p:cNvPr id="3" name="TextBox 2"/>
+          <p:cNvSpPr txBox="1"/>
+          <p:nvPr/>
+        </p:nvSpPr>
+        <p:spPr>
+          <a:xfrm>
+            <a:off x="658368" y="822960"/>
+            <a:ext cx="10789920" cy="914400"/>
+          </a:xfrm>
+          <a:prstGeom prst="rect">
+            <a:avLst/>
+          </a:prstGeom>
+          <a:noFill/>
+        </p:spPr>
+        <p:txBody>
+          <a:bodyPr wrap="square" anchor="t">
+            <a:spAutoFit/>
+          </a:bodyPr>
+          <a:lstStyle/>
+          <a:p>
+            <a:pPr algn="l">
+              <a:spcAft>
+                <a:spcPts val="800"/>
+              </a:spcAft>
+            </a:pPr>
+            <a:r>
+              <a:rPr sz="3000" b="1" i="0">
+                <a:solidFill>
+                  <a:srgbClr val="23262F"/>
+                </a:solidFill>
+                <a:latin typeface="Georgia"/>
+              </a:rPr>
+              <a:t>Stable Bias Rate (SBR)</a:t>
+            </a:r>
+          </a:p>
+        </p:txBody>
+      </p:sp>
+      <p:sp>
+        <p:nvSpPr>
+          <p:cNvPr id="4" name="TextBox 3"/>
+          <p:cNvSpPr txBox="1"/>
+          <p:nvPr/>
+        </p:nvSpPr>
+        <p:spPr>
+          <a:xfrm>
+            <a:off x="685800" y="1965960"/>
+            <a:ext cx="5120640" cy="1828800"/>
+          </a:xfrm>
+          <a:prstGeom prst="rect">
+            <a:avLst/>
+          </a:prstGeom>
+          <a:noFill/>
+        </p:spPr>
+        <p:txBody>
+          <a:bodyPr wrap="square" anchor="t">
+            <a:spAutoFit/>
+          </a:bodyPr>
+          <a:lstStyle/>
+          <a:p>
+            <a:pPr algn="l">
+              <a:spcAft>
+                <a:spcPts val="800"/>
+              </a:spcAft>
+            </a:pPr>
+            <a:r>
+              <a:rPr sz="1650" b="0" i="0">
+                <a:solidFill>
+                  <a:srgbClr val="23262F"/>
+                </a:solidFill>
+                <a:latin typeface="Calibri"/>
+              </a:rPr>
+              <a:t>Does the model pick the wrong (prototypical) image in ALL seven languages?</a:t>
+            </a:r>
+          </a:p>
+          <a:p>
+            <a:pPr algn="l">
+              <a:spcAft>
+                <a:spcPts val="800"/>
+              </a:spcAft>
+            </a:pPr>
+            <a:r>
+              <a:rPr sz="1650" b="1" i="0">
+                <a:solidFill>
+                  <a:srgbClr val="C44E52"/>
+                </a:solidFill>
+                <a:latin typeface="Calibri"/>
+              </a:rPr>
+              <a:t>Wealth has the highest SBR in both models — biased everywhere, not flip-flopping.</a:t>
+            </a:r>
+          </a:p>
+        </p:txBody>
+      </p:sp>
+      <p:sp>
+        <p:nvSpPr>
+          <p:cNvPr id="5" name="Rounded Rectangle 4"/>
+          <p:cNvSpPr/>
+          <p:nvPr/>
+        </p:nvSpPr>
+        <p:spPr>
+          <a:xfrm>
+            <a:off x="685800" y="4297680"/>
+            <a:ext cx="5120640" cy="777240"/>
+          </a:xfrm>
+          <a:prstGeom prst="roundRect">
+            <a:avLst/>
+          </a:prstGeom>
+          <a:solidFill>
+            <a:srgbClr val="1B1F3B"/>
+          </a:solidFill>
+          <a:ln>
+            <a:noFill/>
+          </a:ln>
+          <a:effectLst/>
+        </p:spPr>
+        <p:style>
+          <a:lnRef idx="1">
+            <a:schemeClr val="accent1"/>
+          </a:lnRef>
+          <a:fillRef idx="3">
+            <a:schemeClr val="accent1"/>
+          </a:fillRef>
+          <a:effectRef idx="2">
+            <a:schemeClr val="accent1"/>
+          </a:effectRef>
+          <a:fontRef idx="minor">
+            <a:schemeClr val="lt1"/>
+          </a:fontRef>
+        </p:style>
+        <p:txBody>
+          <a:bodyPr wrap="square" rtlCol="0" anchor="ctr"/>
+          <a:lstStyle/>
+          <a:p>
+            <a:pPr algn="ctr"/>
+            <a:r>
+              <a:rPr sz="1300" b="0">
+                <a:solidFill>
+                  <a:srgbClr val="FFFFFF"/>
+                </a:solidFill>
+                <a:latin typeface="Courier New"/>
+              </a:rPr>
+              <a:t>SBR  =  #(items with the prototype chosen in every language)  /  #(items)</a:t>
+            </a:r>
+          </a:p>
+        </p:txBody>
+      </p:sp>
+      <p:graphicFrame>
+        <p:nvGraphicFramePr>
+          <p:cNvPr id="6" name="Chart 5"/>
+          <p:cNvGraphicFramePr>
+            <a:graphicFrameLocks noGrp="1"/>
+          </p:cNvGraphicFramePr>
+          <p:nvPr/>
+        </p:nvGraphicFramePr>
+        <p:xfrm>
+          <a:off x="6126480" y="1737360"/>
+          <a:ext cx="5486400" cy="4297680"/>
+        </p:xfrm>
+        <a:graphic>
+          <a:graphicData uri="http://schemas.openxmlformats.org/drawingml/2006/chart">
+            <c:chart xmlns:c="http://schemas.openxmlformats.org/drawingml/2006/chart" xmlns:r="http://schemas.openxmlformats.org/officeDocument/2006/relationships" r:id="rId3"/>
+          </a:graphicData>
+        </a:graphic>
+      </p:graphicFrame>
+    </p:spTree>
+  </p:cSld>
+  <p:clrMapOvr>
+    <a:masterClrMapping/>
+  </p:clrMapOvr>
+</p:sld>
+</file>
+
+<file path=ppt/slides/slide14.xml><?xml version="1.0" encoding="utf-8"?>
 <p:sld xmlns:a="http://schemas.openxmlformats.org/drawingml/2006/main" xmlns:r="http://schemas.openxmlformats.org/officeDocument/2006/relationships" xmlns:p="http://schemas.openxmlformats.org/presentationml/2006/main">
   <p:cSld name="Slide 13">
     <p:bg>
@@ -7290,30 +7990,6 @@
             </a:r>
             <a:endParaRPr lang="en-US" sz="1600" dirty="0"/>
           </a:p>
-          <a:p>
-            <a:pPr marL="203200" indent="-203200">
-              <a:lnSpc>
-                <a:spcPct val="100000"/>
-              </a:lnSpc>
-              <a:spcAft>
-                <a:spcPts val="1100"/>
-              </a:spcAft>
-              <a:buSzPct val="100000"/>
-              <a:buChar char="•"/>
-            </a:pPr>
-            <a:r>
-              <a:rPr lang="en-US" sz="1600" dirty="0">
-                <a:solidFill>
-                  <a:srgbClr val="23262F"/>
-                </a:solidFill>
-                <a:latin typeface="Calibri" pitchFamily="34" charset="0"/>
-                <a:ea typeface="Calibri" pitchFamily="34" charset="-122"/>
-                <a:cs typeface="Calibri" pitchFamily="34" charset="-120"/>
-              </a:rPr>
-              <a:t>Wealth &gt; morality holds within every knob — the attribute effect is not a knob artifact.</a:t>
-            </a:r>
-            <a:endParaRPr lang="en-US" sz="1600" dirty="0"/>
-          </a:p>
         </p:txBody>
       </p:sp>
       <p:pic>
@@ -7379,306 +8055,141 @@
           </a:p>
         </p:txBody>
       </p:sp>
+      <p:sp>
+        <p:nvSpPr>
+          <p:cNvPr id="13" name="矩形 12">
+            <a:extLst>
+              <a:ext uri="{FF2B5EF4-FFF2-40B4-BE49-F238E27FC236}">
+                <a16:creationId xmlns:a16="http://schemas.microsoft.com/office/drawing/2014/main" id="{9B1B5029-A256-7265-95A9-9548729D3B2C}"/>
+              </a:ext>
+            </a:extLst>
+          </p:cNvPr>
+          <p:cNvSpPr/>
+          <p:nvPr/>
+        </p:nvSpPr>
+        <p:spPr>
+          <a:xfrm>
+            <a:off x="7686675" y="3244691"/>
+            <a:ext cx="857249" cy="2041683"/>
+          </a:xfrm>
+          <a:prstGeom prst="rect">
+            <a:avLst/>
+          </a:prstGeom>
+          <a:noFill/>
+          <a:ln w="19050">
+            <a:solidFill>
+              <a:srgbClr val="FF0000"/>
+            </a:solidFill>
+          </a:ln>
+        </p:spPr>
+        <p:style>
+          <a:lnRef idx="2">
+            <a:schemeClr val="accent1">
+              <a:shade val="15000"/>
+            </a:schemeClr>
+          </a:lnRef>
+          <a:fillRef idx="1">
+            <a:schemeClr val="accent1"/>
+          </a:fillRef>
+          <a:effectRef idx="0">
+            <a:schemeClr val="accent1"/>
+          </a:effectRef>
+          <a:fontRef idx="minor">
+            <a:schemeClr val="lt1"/>
+          </a:fontRef>
+        </p:style>
+        <p:txBody>
+          <a:bodyPr rtlCol="0" anchor="ctr"/>
+          <a:lstStyle/>
+          <a:p>
+            <a:pPr algn="ctr"/>
+            <a:endParaRPr kumimoji="1" lang="zh-CN" altLang="en-US"/>
+          </a:p>
+        </p:txBody>
+      </p:sp>
     </p:spTree>
   </p:cSld>
   <p:clrMapOvr>
     <a:masterClrMapping/>
   </p:clrMapOvr>
-</p:sld>
-</file>
-
-<file path=ppt/slides/slide14.xml><?xml version="1.0" encoding="utf-8"?>
-<p:sld xmlns:a="http://schemas.openxmlformats.org/drawingml/2006/main" xmlns:r="http://schemas.openxmlformats.org/officeDocument/2006/relationships" xmlns:p="http://schemas.openxmlformats.org/presentationml/2006/main">
-  <p:cSld name="Slide 14">
-    <p:bg>
-      <p:bgPr>
-        <a:solidFill>
-          <a:srgbClr val="FFFFFF"/>
-        </a:solidFill>
-        <a:effectLst/>
-      </p:bgPr>
-    </p:bg>
-    <p:spTree>
-      <p:nvGrpSpPr>
-        <p:cNvPr id="1" name=""/>
-        <p:cNvGrpSpPr/>
-        <p:nvPr/>
-      </p:nvGrpSpPr>
-      <p:grpSpPr>
-        <a:xfrm>
-          <a:off x="0" y="0"/>
-          <a:ext cx="0" cy="0"/>
-          <a:chOff x="0" y="0"/>
-          <a:chExt cx="0" cy="0"/>
-        </a:xfrm>
-      </p:grpSpPr>
-      <p:sp>
-        <p:nvSpPr>
-          <p:cNvPr id="2" name="Text 0"/>
-          <p:cNvSpPr/>
-          <p:nvPr/>
-        </p:nvSpPr>
-        <p:spPr>
-          <a:xfrm>
-            <a:off x="685800" y="502920"/>
-            <a:ext cx="10820095" cy="274320"/>
-          </a:xfrm>
-          <a:prstGeom prst="rect">
-            <a:avLst/>
-          </a:prstGeom>
-          <a:noFill/>
-          <a:ln/>
-        </p:spPr>
-        <p:txBody>
-          <a:bodyPr wrap="square" lIns="0" tIns="0" rIns="0" bIns="0" rtlCol="0" anchor="ctr"/>
-          <a:lstStyle/>
-          <a:p>
-            <a:pPr marL="0" indent="0">
-              <a:buNone/>
-            </a:pPr>
-            <a:r>
-              <a:rPr lang="en-US" sz="1200" b="1" kern="0" spc="300" dirty="0">
-                <a:solidFill>
-                  <a:srgbClr val="C44E52"/>
-                </a:solidFill>
-                <a:latin typeface="Calibri" pitchFamily="34" charset="0"/>
-                <a:ea typeface="Calibri" pitchFamily="34" charset="-122"/>
-                <a:cs typeface="Calibri" pitchFamily="34" charset="-120"/>
-              </a:rPr>
-              <a:t>GOING DEEPER · IS THE TRAP OBJECTIVE?</a:t>
-            </a:r>
-            <a:endParaRPr lang="en-US" sz="1200" dirty="0"/>
-          </a:p>
-        </p:txBody>
-      </p:sp>
-      <p:sp>
-        <p:nvSpPr>
-          <p:cNvPr id="3" name="Text 1"/>
-          <p:cNvSpPr/>
-          <p:nvPr/>
-        </p:nvSpPr>
-        <p:spPr>
-          <a:xfrm>
-            <a:off x="685800" y="841248"/>
-            <a:ext cx="10820095" cy="868680"/>
-          </a:xfrm>
-          <a:prstGeom prst="rect">
-            <a:avLst/>
-          </a:prstGeom>
-          <a:noFill/>
-          <a:ln/>
-        </p:spPr>
-        <p:txBody>
-          <a:bodyPr wrap="square" lIns="0" tIns="0" rIns="0" bIns="0" rtlCol="0" anchor="ctr"/>
-          <a:lstStyle/>
-          <a:p>
-            <a:pPr marL="0" indent="0">
-              <a:lnSpc>
-                <a:spcPts val="3456"/>
-              </a:lnSpc>
-              <a:buNone/>
-            </a:pPr>
-            <a:r>
-              <a:rPr lang="en-US" sz="3200" b="1" dirty="0">
-                <a:solidFill>
-                  <a:srgbClr val="23262F"/>
-                </a:solidFill>
-                <a:latin typeface="Georgia" pitchFamily="34" charset="0"/>
-                <a:ea typeface="Georgia" pitchFamily="34" charset="-122"/>
-                <a:cs typeface="Georgia" pitchFamily="34" charset="-120"/>
-              </a:rPr>
-              <a:t>The same items fool both model families</a:t>
-            </a:r>
-            <a:endParaRPr lang="en-US" sz="3200" dirty="0"/>
-          </a:p>
-        </p:txBody>
-      </p:sp>
-      <p:sp>
-        <p:nvSpPr>
-          <p:cNvPr id="4" name="Text 2"/>
-          <p:cNvSpPr/>
-          <p:nvPr/>
-        </p:nvSpPr>
-        <p:spPr>
-          <a:xfrm>
-            <a:off x="685800" y="1920240"/>
-            <a:ext cx="5486400" cy="4206240"/>
-          </a:xfrm>
-          <a:prstGeom prst="rect">
-            <a:avLst/>
-          </a:prstGeom>
-          <a:noFill/>
-          <a:ln/>
-        </p:spPr>
-        <p:txBody>
-          <a:bodyPr wrap="square" lIns="0" tIns="0" rIns="0" bIns="0" rtlCol="0" anchor="t"/>
-          <a:lstStyle/>
-          <a:p>
-            <a:pPr marL="203200" indent="-203200">
-              <a:lnSpc>
-                <a:spcPct val="100000"/>
-              </a:lnSpc>
-              <a:spcAft>
-                <a:spcPts val="1100"/>
-              </a:spcAft>
-              <a:buSzPct val="100000"/>
-              <a:buChar char="•"/>
-            </a:pPr>
-            <a:r>
-              <a:rPr lang="en-US" sz="1600" dirty="0">
-                <a:solidFill>
-                  <a:srgbClr val="23262F"/>
-                </a:solidFill>
-                <a:latin typeface="Calibri" pitchFamily="34" charset="0"/>
-                <a:ea typeface="Calibri" pitchFamily="34" charset="-122"/>
-                <a:cs typeface="Calibri" pitchFamily="34" charset="-120"/>
-              </a:rPr>
-              <a:t>Two families judge the same 900 image pairs — do they err on the SAME ones?</a:t>
-            </a:r>
-            <a:endParaRPr lang="en-US" sz="1600" dirty="0"/>
-          </a:p>
-          <a:p>
-            <a:pPr marL="203200" indent="-203200">
-              <a:lnSpc>
-                <a:spcPct val="100000"/>
-              </a:lnSpc>
-              <a:spcAft>
-                <a:spcPts val="1100"/>
-              </a:spcAft>
-              <a:buSzPct val="100000"/>
-              <a:buChar char="•"/>
-            </a:pPr>
-            <a:r>
-              <a:rPr lang="en-US" sz="1600" dirty="0">
-                <a:solidFill>
-                  <a:srgbClr val="23262F"/>
-                </a:solidFill>
-                <a:latin typeface="Calibri" pitchFamily="34" charset="0"/>
-                <a:ea typeface="Calibri" pitchFamily="34" charset="-122"/>
-                <a:cs typeface="Calibri" pitchFamily="34" charset="-120"/>
-              </a:rPr>
-              <a:t>Per-item error rates correlate at r = 0.68 (Cohen's κ = 0.39).</a:t>
-            </a:r>
-            <a:endParaRPr lang="en-US" sz="1600" dirty="0"/>
-          </a:p>
-          <a:p>
-            <a:pPr marL="203200" indent="-203200">
-              <a:lnSpc>
-                <a:spcPct val="100000"/>
-              </a:lnSpc>
-              <a:spcAft>
-                <a:spcPts val="1100"/>
-              </a:spcAft>
-              <a:buSzPct val="100000"/>
-              <a:buChar char="•"/>
-            </a:pPr>
-            <a:r>
-              <a:rPr lang="en-US" sz="1600" dirty="0">
-                <a:solidFill>
-                  <a:srgbClr val="23262F"/>
-                </a:solidFill>
-                <a:latin typeface="Calibri" pitchFamily="34" charset="0"/>
-                <a:ea typeface="Calibri" pitchFamily="34" charset="-122"/>
-                <a:cs typeface="Calibri" pitchFamily="34" charset="-120"/>
-              </a:rPr>
-              <a:t>So the prototype trap is largely item-intrinsic — an objective property of the image pair, not a model quirk.</a:t>
-            </a:r>
-            <a:endParaRPr lang="en-US" sz="1600" dirty="0"/>
-          </a:p>
-          <a:p>
-            <a:pPr marL="203200" indent="-203200">
-              <a:lnSpc>
-                <a:spcPct val="100000"/>
-              </a:lnSpc>
-              <a:spcAft>
-                <a:spcPts val="1100"/>
-              </a:spcAft>
-              <a:buSzPct val="100000"/>
-              <a:buChar char="•"/>
-            </a:pPr>
-            <a:r>
-              <a:rPr lang="en-US" sz="1600" dirty="0">
-                <a:solidFill>
-                  <a:srgbClr val="23262F"/>
-                </a:solidFill>
-                <a:latin typeface="Calibri" pitchFamily="34" charset="0"/>
-                <a:ea typeface="Calibri" pitchFamily="34" charset="-122"/>
-                <a:cs typeface="Calibri" pitchFamily="34" charset="-120"/>
-              </a:rPr>
-              <a:t>(r is not 1.0: about half is still model-specific — strongest agreement on demography, weakest on objects.)</a:t>
-            </a:r>
-            <a:endParaRPr lang="en-US" sz="1600" dirty="0"/>
-          </a:p>
-        </p:txBody>
-      </p:sp>
-      <p:pic>
-        <p:nvPicPr>
-          <p:cNvPr id="5" name="Image 0" descr="/Users/xiaochuan/Desktop/Projects/P5_Multi_linguistic_histoBias/v3/experiments/exp3f_cross_model_agreement/figures/figG_item_agreement.png"/>
-          <p:cNvPicPr>
-            <a:picLocks noChangeAspect="1"/>
-          </p:cNvPicPr>
-          <p:nvPr/>
-        </p:nvPicPr>
-        <p:blipFill>
-          <a:blip r:embed="rId3"/>
-          <a:stretch>
-            <a:fillRect/>
-          </a:stretch>
-        </p:blipFill>
-        <p:spPr>
-          <a:xfrm>
-            <a:off x="7315200" y="1874520"/>
-            <a:ext cx="4114800" cy="3964162"/>
-          </a:xfrm>
-          <a:prstGeom prst="rect">
-            <a:avLst/>
-          </a:prstGeom>
-        </p:spPr>
-      </p:pic>
-      <p:sp>
-        <p:nvSpPr>
-          <p:cNvPr id="6" name="Text 3"/>
-          <p:cNvSpPr/>
-          <p:nvPr/>
-        </p:nvSpPr>
-        <p:spPr>
-          <a:xfrm>
-            <a:off x="11551615" y="6400800"/>
-            <a:ext cx="365760" cy="274320"/>
-          </a:xfrm>
-          <a:prstGeom prst="rect">
-            <a:avLst/>
-          </a:prstGeom>
-          <a:noFill/>
-          <a:ln/>
-        </p:spPr>
-        <p:txBody>
-          <a:bodyPr wrap="square" lIns="0" tIns="0" rIns="0" bIns="0" rtlCol="0" anchor="ctr"/>
-          <a:lstStyle/>
-          <a:p>
-            <a:pPr marL="0" indent="0" algn="r">
-              <a:buNone/>
-            </a:pPr>
-            <a:r>
-              <a:rPr lang="en-US" sz="1000" dirty="0">
-                <a:solidFill>
-                  <a:srgbClr val="9AA0B0"/>
-                </a:solidFill>
-                <a:latin typeface="Calibri" pitchFamily="34" charset="0"/>
-                <a:ea typeface="Calibri" pitchFamily="34" charset="-122"/>
-                <a:cs typeface="Calibri" pitchFamily="34" charset="-120"/>
-              </a:rPr>
-              <a:t>14</a:t>
-            </a:r>
-            <a:endParaRPr lang="en-US" sz="1000" dirty="0"/>
-          </a:p>
-        </p:txBody>
-      </p:sp>
-    </p:spTree>
-  </p:cSld>
-  <p:clrMapOvr>
-    <a:masterClrMapping/>
-  </p:clrMapOvr>
+  <p:timing>
+    <p:tnLst>
+      <p:par>
+        <p:cTn id="1" dur="indefinite" restart="never" nodeType="tmRoot">
+          <p:childTnLst>
+            <p:seq concurrent="1" nextAc="seek">
+              <p:cTn id="2" dur="indefinite" nodeType="mainSeq">
+                <p:childTnLst>
+                  <p:par>
+                    <p:cTn id="3" fill="hold">
+                      <p:stCondLst>
+                        <p:cond delay="indefinite"/>
+                      </p:stCondLst>
+                      <p:childTnLst>
+                        <p:par>
+                          <p:cTn id="4" fill="hold">
+                            <p:stCondLst>
+                              <p:cond delay="0"/>
+                            </p:stCondLst>
+                            <p:childTnLst>
+                              <p:par>
+                                <p:cTn id="5" presetID="1" presetClass="entr" presetSubtype="0" fill="hold" grpId="0" nodeType="clickEffect">
+                                  <p:stCondLst>
+                                    <p:cond delay="0"/>
+                                  </p:stCondLst>
+                                  <p:childTnLst>
+                                    <p:set>
+                                      <p:cBhvr>
+                                        <p:cTn id="6" dur="1" fill="hold">
+                                          <p:stCondLst>
+                                            <p:cond delay="0"/>
+                                          </p:stCondLst>
+                                        </p:cTn>
+                                        <p:tgtEl>
+                                          <p:spTgt spid="13"/>
+                                        </p:tgtEl>
+                                        <p:attrNameLst>
+                                          <p:attrName>style.visibility</p:attrName>
+                                        </p:attrNameLst>
+                                      </p:cBhvr>
+                                      <p:to>
+                                        <p:strVal val="visible"/>
+                                      </p:to>
+                                    </p:set>
+                                  </p:childTnLst>
+                                </p:cTn>
+                              </p:par>
+                            </p:childTnLst>
+                          </p:cTn>
+                        </p:par>
+                      </p:childTnLst>
+                    </p:cTn>
+                  </p:par>
+                </p:childTnLst>
+              </p:cTn>
+              <p:prevCondLst>
+                <p:cond evt="onPrev" delay="0">
+                  <p:tgtEl>
+                    <p:sldTgt/>
+                  </p:tgtEl>
+                </p:cond>
+              </p:prevCondLst>
+              <p:nextCondLst>
+                <p:cond evt="onNext" delay="0">
+                  <p:tgtEl>
+                    <p:sldTgt/>
+                  </p:tgtEl>
+                </p:cond>
+              </p:nextCondLst>
+            </p:seq>
+          </p:childTnLst>
+        </p:cTn>
+      </p:par>
+    </p:tnLst>
+    <p:bldLst>
+      <p:bldP spid="13" grpId="0" animBg="1"/>
+    </p:bldLst>
+  </p:timing>
 </p:sld>
 </file>
 
@@ -8595,7 +9106,7 @@
         </p:nvSpPr>
         <p:spPr>
           <a:xfrm>
-            <a:off x="4343400" y="2039112"/>
+            <a:off x="4343400" y="2155023"/>
             <a:ext cx="7772400" cy="640080"/>
           </a:xfrm>
           <a:prstGeom prst="rect">
@@ -8739,7 +9250,7 @@
         </p:nvSpPr>
         <p:spPr>
           <a:xfrm>
-            <a:off x="4343400" y="3063240"/>
+            <a:off x="4343400" y="3179151"/>
             <a:ext cx="7772400" cy="640080"/>
           </a:xfrm>
           <a:prstGeom prst="rect">
@@ -8871,6 +9382,17 @@
               </a:rPr>
               <a:t>Shortcut-severing</a:t>
             </a:r>
+            <a:r>
+              <a:rPr lang="zh-CN" altLang="en-US" sz="1700" b="1" dirty="0">
+                <a:solidFill>
+                  <a:srgbClr val="C44E52"/>
+                </a:solidFill>
+                <a:latin typeface="Georgia" pitchFamily="34" charset="0"/>
+                <a:ea typeface="Georgia" pitchFamily="34" charset="-122"/>
+                <a:cs typeface="Georgia" pitchFamily="34" charset="-120"/>
+              </a:rPr>
+              <a:t>*</a:t>
+            </a:r>
             <a:endParaRPr lang="en-US" sz="1700" dirty="0"/>
           </a:p>
         </p:txBody>
@@ -8883,7 +9405,7 @@
         </p:nvSpPr>
         <p:spPr>
           <a:xfrm>
-            <a:off x="4343400" y="4087368"/>
+            <a:off x="4343400" y="4203279"/>
             <a:ext cx="7772400" cy="640080"/>
           </a:xfrm>
           <a:prstGeom prst="rect">
@@ -9027,7 +9549,7 @@
         </p:nvSpPr>
         <p:spPr>
           <a:xfrm>
-            <a:off x="4343400" y="5111496"/>
+            <a:off x="4343400" y="5227407"/>
             <a:ext cx="7772400" cy="640080"/>
           </a:xfrm>
           <a:prstGeom prst="rect">
@@ -9244,7 +9766,7 @@
                 <a:ea typeface="Georgia" pitchFamily="34" charset="-122"/>
                 <a:cs typeface="Georgia" pitchFamily="34" charset="-120"/>
               </a:rPr>
-              <a:t>Thank you — questions?</a:t>
+              <a:t>Thank you</a:t>
             </a:r>
             <a:endParaRPr lang="en-US" sz="4000" dirty="0"/>
           </a:p>
@@ -9481,7 +10003,7 @@
         </p:nvGraphicFramePr>
         <p:xfrm>
           <a:off x="2011680" y="1920240"/>
-          <a:ext cx="8138160" cy="914400"/>
+          <a:ext cx="8138160" cy="3657600"/>
         </p:xfrm>
         <a:graphic>
           <a:graphicData uri="http://schemas.openxmlformats.org/drawingml/2006/table">
@@ -12748,7 +13270,7 @@
         </p:nvGraphicFramePr>
         <p:xfrm>
           <a:off x="6583680" y="3794760"/>
-          <a:ext cx="4937760" cy="914400"/>
+          <a:ext cx="4937760" cy="1682496"/>
         </p:xfrm>
         <a:graphic>
           <a:graphicData uri="http://schemas.openxmlformats.org/drawingml/2006/table">
@@ -16470,482 +16992,6 @@
           </a:p>
         </p:txBody>
       </p:sp>
-    </p:spTree>
-  </p:cSld>
-  <p:clrMapOvr>
-    <a:masterClrMapping/>
-  </p:clrMapOvr>
-</p:sld>
-</file>
-
-<file path=ppt/slides/slide27.xml><?xml version="1.0" encoding="utf-8"?>
-<p:sld xmlns:a="http://schemas.openxmlformats.org/drawingml/2006/main" xmlns:p="http://schemas.openxmlformats.org/presentationml/2006/main" xmlns:r="http://schemas.openxmlformats.org/officeDocument/2006/relationships">
-  <p:cSld>
-    <p:bg>
-      <p:bgPr>
-        <a:solidFill>
-          <a:srgbClr val="FFFFFF"/>
-        </a:solidFill>
-        <a:effectLst/>
-      </p:bgPr>
-    </p:bg>
-    <p:spTree>
-      <p:nvGrpSpPr>
-        <p:cNvPr id="1" name=""/>
-        <p:cNvGrpSpPr/>
-        <p:nvPr/>
-      </p:nvGrpSpPr>
-      <p:grpSpPr/>
-      <p:sp>
-        <p:nvSpPr>
-          <p:cNvPr id="2" name="TextBox 1"/>
-          <p:cNvSpPr txBox="1"/>
-          <p:nvPr/>
-        </p:nvSpPr>
-        <p:spPr>
-          <a:xfrm>
-            <a:off x="685800" y="457200"/>
-            <a:ext cx="8229600" cy="320040"/>
-          </a:xfrm>
-          <a:prstGeom prst="rect">
-            <a:avLst/>
-          </a:prstGeom>
-          <a:noFill/>
-        </p:spPr>
-        <p:txBody>
-          <a:bodyPr wrap="square" anchor="t">
-            <a:spAutoFit/>
-          </a:bodyPr>
-          <a:lstStyle/>
-          <a:p>
-            <a:pPr algn="l">
-              <a:spcAft>
-                <a:spcPts val="800"/>
-              </a:spcAft>
-            </a:pPr>
-            <a:r>
-              <a:rPr sz="1200" b="1" i="0">
-                <a:solidFill>
-                  <a:srgbClr val="C44E52"/>
-                </a:solidFill>
-                <a:latin typeface="Calibri"/>
-              </a:rPr>
-              <a:t>NEW BEHAVIOURAL METRIC · 1 OF 2</a:t>
-            </a:r>
-          </a:p>
-        </p:txBody>
-      </p:sp>
-      <p:sp>
-        <p:nvSpPr>
-          <p:cNvPr id="3" name="TextBox 2"/>
-          <p:cNvSpPr txBox="1"/>
-          <p:nvPr/>
-        </p:nvSpPr>
-        <p:spPr>
-          <a:xfrm>
-            <a:off x="658368" y="822960"/>
-            <a:ext cx="10789920" cy="914400"/>
-          </a:xfrm>
-          <a:prstGeom prst="rect">
-            <a:avLst/>
-          </a:prstGeom>
-          <a:noFill/>
-        </p:spPr>
-        <p:txBody>
-          <a:bodyPr wrap="square" anchor="t">
-            <a:spAutoFit/>
-          </a:bodyPr>
-          <a:lstStyle/>
-          <a:p>
-            <a:pPr algn="l">
-              <a:spcAft>
-                <a:spcPts val="800"/>
-              </a:spcAft>
-            </a:pPr>
-            <a:r>
-              <a:rPr sz="3000" b="1" i="0">
-                <a:solidFill>
-                  <a:srgbClr val="23262F"/>
-                </a:solidFill>
-                <a:latin typeface="Georgia"/>
-              </a:rPr>
-              <a:t>Cross-lingual Flip Rate (CFR)</a:t>
-            </a:r>
-          </a:p>
-        </p:txBody>
-      </p:sp>
-      <p:sp>
-        <p:nvSpPr>
-          <p:cNvPr id="4" name="TextBox 3"/>
-          <p:cNvSpPr txBox="1"/>
-          <p:nvPr/>
-        </p:nvSpPr>
-        <p:spPr>
-          <a:xfrm>
-            <a:off x="685800" y="1965960"/>
-            <a:ext cx="5120640" cy="2194560"/>
-          </a:xfrm>
-          <a:prstGeom prst="rect">
-            <a:avLst/>
-          </a:prstGeom>
-          <a:noFill/>
-        </p:spPr>
-        <p:txBody>
-          <a:bodyPr wrap="square" anchor="t">
-            <a:spAutoFit/>
-          </a:bodyPr>
-          <a:lstStyle/>
-          <a:p>
-            <a:pPr algn="l">
-              <a:spcAft>
-                <a:spcPts val="800"/>
-              </a:spcAft>
-            </a:pPr>
-            <a:r>
-              <a:rPr sz="1650" b="0" i="0">
-                <a:solidFill>
-                  <a:srgbClr val="23262F"/>
-                </a:solidFill>
-                <a:latin typeface="Calibri"/>
-              </a:rPr>
-              <a:t>Does the model's choice change when only the language changes?</a:t>
-            </a:r>
-          </a:p>
-          <a:p>
-            <a:pPr algn="l">
-              <a:spcAft>
-                <a:spcPts val="800"/>
-              </a:spcAft>
-            </a:pPr>
-            <a:r>
-              <a:rPr sz="1650" b="0" i="0">
-                <a:solidFill>
-                  <a:srgbClr val="23262F"/>
-                </a:solidFill>
-                <a:latin typeface="Calibri"/>
-              </a:rPr>
-              <a:t>Overall CFR ≈ 0.65 — about two-thirds of image-pairs flip at least once.</a:t>
-            </a:r>
-          </a:p>
-          <a:p>
-            <a:pPr algn="l">
-              <a:spcAft>
-                <a:spcPts val="800"/>
-              </a:spcAft>
-            </a:pPr>
-            <a:r>
-              <a:rPr sz="1650" b="0" i="0">
-                <a:solidFill>
-                  <a:srgbClr val="23262F"/>
-                </a:solidFill>
-                <a:latin typeface="Calibri"/>
-              </a:rPr>
-              <a:t>Wealth flips the LEAST — it is locked in (low flip = high stable bias).</a:t>
-            </a:r>
-          </a:p>
-        </p:txBody>
-      </p:sp>
-      <p:sp>
-        <p:nvSpPr>
-          <p:cNvPr id="5" name="Rounded Rectangle 4"/>
-          <p:cNvSpPr/>
-          <p:nvPr/>
-        </p:nvSpPr>
-        <p:spPr>
-          <a:xfrm>
-            <a:off x="685800" y="4297680"/>
-            <a:ext cx="5120640" cy="777240"/>
-          </a:xfrm>
-          <a:prstGeom prst="roundRect">
-            <a:avLst/>
-          </a:prstGeom>
-          <a:solidFill>
-            <a:srgbClr val="1B1F3B"/>
-          </a:solidFill>
-          <a:ln>
-            <a:noFill/>
-          </a:ln>
-          <a:effectLst/>
-        </p:spPr>
-        <p:style>
-          <a:lnRef idx="1">
-            <a:schemeClr val="accent1"/>
-          </a:lnRef>
-          <a:fillRef idx="3">
-            <a:schemeClr val="accent1"/>
-          </a:fillRef>
-          <a:effectRef idx="2">
-            <a:schemeClr val="accent1"/>
-          </a:effectRef>
-          <a:fontRef idx="minor">
-            <a:schemeClr val="lt1"/>
-          </a:fontRef>
-        </p:style>
-        <p:txBody>
-          <a:bodyPr rtlCol="0" anchor="ctr" wrap="square"/>
-          <a:lstStyle/>
-          <a:p>
-            <a:pPr algn="ctr"/>
-            <a:r>
-              <a:rPr sz="1300" b="0">
-                <a:solidFill>
-                  <a:srgbClr val="FFFFFF"/>
-                </a:solidFill>
-                <a:latin typeface="Courier New"/>
-              </a:rPr>
-              <a:t>CFR  =  #(items whose answer differs across languages)  /  #(items)</a:t>
-            </a:r>
-          </a:p>
-        </p:txBody>
-      </p:sp>
-      <p:graphicFrame>
-        <p:nvGraphicFramePr>
-          <p:cNvPr id="6" name="Chart 5"/>
-          <p:cNvGraphicFramePr>
-            <a:graphicFrameLocks noGrp="1"/>
-          </p:cNvGraphicFramePr>
-          <p:nvPr/>
-        </p:nvGraphicFramePr>
-        <p:xfrm>
-          <a:off x="6126480" y="1737360"/>
-          <a:ext cx="5486400" cy="4297680"/>
-        </p:xfrm>
-        <a:graphic>
-          <a:graphicData uri="http://schemas.openxmlformats.org/drawingml/2006/chart">
-            <c:chart xmlns:c="http://schemas.openxmlformats.org/drawingml/2006/chart" r:id="rId2"/>
-          </a:graphicData>
-        </a:graphic>
-      </p:graphicFrame>
-    </p:spTree>
-  </p:cSld>
-  <p:clrMapOvr>
-    <a:masterClrMapping/>
-  </p:clrMapOvr>
-</p:sld>
-</file>
-
-<file path=ppt/slides/slide28.xml><?xml version="1.0" encoding="utf-8"?>
-<p:sld xmlns:a="http://schemas.openxmlformats.org/drawingml/2006/main" xmlns:p="http://schemas.openxmlformats.org/presentationml/2006/main" xmlns:r="http://schemas.openxmlformats.org/officeDocument/2006/relationships">
-  <p:cSld>
-    <p:bg>
-      <p:bgPr>
-        <a:solidFill>
-          <a:srgbClr val="FFFFFF"/>
-        </a:solidFill>
-        <a:effectLst/>
-      </p:bgPr>
-    </p:bg>
-    <p:spTree>
-      <p:nvGrpSpPr>
-        <p:cNvPr id="1" name=""/>
-        <p:cNvGrpSpPr/>
-        <p:nvPr/>
-      </p:nvGrpSpPr>
-      <p:grpSpPr/>
-      <p:sp>
-        <p:nvSpPr>
-          <p:cNvPr id="2" name="TextBox 1"/>
-          <p:cNvSpPr txBox="1"/>
-          <p:nvPr/>
-        </p:nvSpPr>
-        <p:spPr>
-          <a:xfrm>
-            <a:off x="685800" y="457200"/>
-            <a:ext cx="8229600" cy="320040"/>
-          </a:xfrm>
-          <a:prstGeom prst="rect">
-            <a:avLst/>
-          </a:prstGeom>
-          <a:noFill/>
-        </p:spPr>
-        <p:txBody>
-          <a:bodyPr wrap="square" anchor="t">
-            <a:spAutoFit/>
-          </a:bodyPr>
-          <a:lstStyle/>
-          <a:p>
-            <a:pPr algn="l">
-              <a:spcAft>
-                <a:spcPts val="800"/>
-              </a:spcAft>
-            </a:pPr>
-            <a:r>
-              <a:rPr sz="1200" b="1" i="0">
-                <a:solidFill>
-                  <a:srgbClr val="C44E52"/>
-                </a:solidFill>
-                <a:latin typeface="Calibri"/>
-              </a:rPr>
-              <a:t>NEW BEHAVIOURAL METRIC · 2 OF 2</a:t>
-            </a:r>
-          </a:p>
-        </p:txBody>
-      </p:sp>
-      <p:sp>
-        <p:nvSpPr>
-          <p:cNvPr id="3" name="TextBox 2"/>
-          <p:cNvSpPr txBox="1"/>
-          <p:nvPr/>
-        </p:nvSpPr>
-        <p:spPr>
-          <a:xfrm>
-            <a:off x="658368" y="822960"/>
-            <a:ext cx="10789920" cy="914400"/>
-          </a:xfrm>
-          <a:prstGeom prst="rect">
-            <a:avLst/>
-          </a:prstGeom>
-          <a:noFill/>
-        </p:spPr>
-        <p:txBody>
-          <a:bodyPr wrap="square" anchor="t">
-            <a:spAutoFit/>
-          </a:bodyPr>
-          <a:lstStyle/>
-          <a:p>
-            <a:pPr algn="l">
-              <a:spcAft>
-                <a:spcPts val="800"/>
-              </a:spcAft>
-            </a:pPr>
-            <a:r>
-              <a:rPr sz="3000" b="1" i="0">
-                <a:solidFill>
-                  <a:srgbClr val="23262F"/>
-                </a:solidFill>
-                <a:latin typeface="Georgia"/>
-              </a:rPr>
-              <a:t>Stable Bias Rate (SBR)</a:t>
-            </a:r>
-          </a:p>
-        </p:txBody>
-      </p:sp>
-      <p:sp>
-        <p:nvSpPr>
-          <p:cNvPr id="4" name="TextBox 3"/>
-          <p:cNvSpPr txBox="1"/>
-          <p:nvPr/>
-        </p:nvSpPr>
-        <p:spPr>
-          <a:xfrm>
-            <a:off x="685800" y="1965960"/>
-            <a:ext cx="5120640" cy="1828800"/>
-          </a:xfrm>
-          <a:prstGeom prst="rect">
-            <a:avLst/>
-          </a:prstGeom>
-          <a:noFill/>
-        </p:spPr>
-        <p:txBody>
-          <a:bodyPr wrap="square" anchor="t">
-            <a:spAutoFit/>
-          </a:bodyPr>
-          <a:lstStyle/>
-          <a:p>
-            <a:pPr algn="l">
-              <a:spcAft>
-                <a:spcPts val="800"/>
-              </a:spcAft>
-            </a:pPr>
-            <a:r>
-              <a:rPr sz="1650" b="0" i="0">
-                <a:solidFill>
-                  <a:srgbClr val="23262F"/>
-                </a:solidFill>
-                <a:latin typeface="Calibri"/>
-              </a:rPr>
-              <a:t>Does the model pick the wrong (prototypical) image in ALL seven languages?</a:t>
-            </a:r>
-          </a:p>
-          <a:p>
-            <a:pPr algn="l">
-              <a:spcAft>
-                <a:spcPts val="800"/>
-              </a:spcAft>
-            </a:pPr>
-            <a:r>
-              <a:rPr sz="1650" b="1" i="0">
-                <a:solidFill>
-                  <a:srgbClr val="C44E52"/>
-                </a:solidFill>
-                <a:latin typeface="Calibri"/>
-              </a:rPr>
-              <a:t>Wealth has the highest SBR in both models — biased everywhere, not flip-flopping.</a:t>
-            </a:r>
-          </a:p>
-        </p:txBody>
-      </p:sp>
-      <p:sp>
-        <p:nvSpPr>
-          <p:cNvPr id="5" name="Rounded Rectangle 4"/>
-          <p:cNvSpPr/>
-          <p:nvPr/>
-        </p:nvSpPr>
-        <p:spPr>
-          <a:xfrm>
-            <a:off x="685800" y="4297680"/>
-            <a:ext cx="5120640" cy="777240"/>
-          </a:xfrm>
-          <a:prstGeom prst="roundRect">
-            <a:avLst/>
-          </a:prstGeom>
-          <a:solidFill>
-            <a:srgbClr val="1B1F3B"/>
-          </a:solidFill>
-          <a:ln>
-            <a:noFill/>
-          </a:ln>
-          <a:effectLst/>
-        </p:spPr>
-        <p:style>
-          <a:lnRef idx="1">
-            <a:schemeClr val="accent1"/>
-          </a:lnRef>
-          <a:fillRef idx="3">
-            <a:schemeClr val="accent1"/>
-          </a:fillRef>
-          <a:effectRef idx="2">
-            <a:schemeClr val="accent1"/>
-          </a:effectRef>
-          <a:fontRef idx="minor">
-            <a:schemeClr val="lt1"/>
-          </a:fontRef>
-        </p:style>
-        <p:txBody>
-          <a:bodyPr rtlCol="0" anchor="ctr" wrap="square"/>
-          <a:lstStyle/>
-          <a:p>
-            <a:pPr algn="ctr"/>
-            <a:r>
-              <a:rPr sz="1300" b="0">
-                <a:solidFill>
-                  <a:srgbClr val="FFFFFF"/>
-                </a:solidFill>
-                <a:latin typeface="Courier New"/>
-              </a:rPr>
-              <a:t>SBR  =  #(items with the prototype chosen in every language)  /  #(items)</a:t>
-            </a:r>
-          </a:p>
-        </p:txBody>
-      </p:sp>
-      <p:graphicFrame>
-        <p:nvGraphicFramePr>
-          <p:cNvPr id="6" name="Chart 5"/>
-          <p:cNvGraphicFramePr>
-            <a:graphicFrameLocks noGrp="1"/>
-          </p:cNvGraphicFramePr>
-          <p:nvPr/>
-        </p:nvGraphicFramePr>
-        <p:xfrm>
-          <a:off x="6126480" y="1737360"/>
-          <a:ext cx="5486400" cy="4297680"/>
-        </p:xfrm>
-        <a:graphic>
-          <a:graphicData uri="http://schemas.openxmlformats.org/drawingml/2006/chart">
-            <c:chart xmlns:c="http://schemas.openxmlformats.org/drawingml/2006/chart" r:id="rId2"/>
-          </a:graphicData>
-        </a:graphic>
-      </p:graphicFrame>
     </p:spTree>
   </p:cSld>
   <p:clrMapOvr>
@@ -22597,11 +22643,221 @@
           </a:p>
         </p:txBody>
       </p:sp>
+      <p:sp>
+        <p:nvSpPr>
+          <p:cNvPr id="12" name="矩形 11">
+            <a:extLst>
+              <a:ext uri="{FF2B5EF4-FFF2-40B4-BE49-F238E27FC236}">
+                <a16:creationId xmlns:a16="http://schemas.microsoft.com/office/drawing/2014/main" id="{C88B6C26-EBA7-D79F-9DF1-247064FCB0AB}"/>
+              </a:ext>
+            </a:extLst>
+          </p:cNvPr>
+          <p:cNvSpPr/>
+          <p:nvPr/>
+        </p:nvSpPr>
+        <p:spPr>
+          <a:xfrm>
+            <a:off x="3122195" y="2207795"/>
+            <a:ext cx="3062037" cy="385010"/>
+          </a:xfrm>
+          <a:prstGeom prst="rect">
+            <a:avLst/>
+          </a:prstGeom>
+          <a:noFill/>
+          <a:ln w="19050">
+            <a:solidFill>
+              <a:srgbClr val="FF0000"/>
+            </a:solidFill>
+          </a:ln>
+        </p:spPr>
+        <p:style>
+          <a:lnRef idx="2">
+            <a:schemeClr val="accent1">
+              <a:shade val="15000"/>
+            </a:schemeClr>
+          </a:lnRef>
+          <a:fillRef idx="1">
+            <a:schemeClr val="accent1"/>
+          </a:fillRef>
+          <a:effectRef idx="0">
+            <a:schemeClr val="accent1"/>
+          </a:effectRef>
+          <a:fontRef idx="minor">
+            <a:schemeClr val="lt1"/>
+          </a:fontRef>
+        </p:style>
+        <p:txBody>
+          <a:bodyPr rtlCol="0" anchor="ctr"/>
+          <a:lstStyle/>
+          <a:p>
+            <a:pPr algn="ctr"/>
+            <a:endParaRPr kumimoji="1" lang="zh-CN" altLang="en-US"/>
+          </a:p>
+        </p:txBody>
+      </p:sp>
+      <p:sp>
+        <p:nvSpPr>
+          <p:cNvPr id="14" name="矩形 13">
+            <a:extLst>
+              <a:ext uri="{FF2B5EF4-FFF2-40B4-BE49-F238E27FC236}">
+                <a16:creationId xmlns:a16="http://schemas.microsoft.com/office/drawing/2014/main" id="{15916838-D3A3-11DE-64BB-D3EFBFBCA798}"/>
+              </a:ext>
+            </a:extLst>
+          </p:cNvPr>
+          <p:cNvSpPr/>
+          <p:nvPr/>
+        </p:nvSpPr>
+        <p:spPr>
+          <a:xfrm>
+            <a:off x="8915400" y="2069431"/>
+            <a:ext cx="1235241" cy="914400"/>
+          </a:xfrm>
+          <a:prstGeom prst="rect">
+            <a:avLst/>
+          </a:prstGeom>
+          <a:noFill/>
+          <a:ln w="19050">
+            <a:solidFill>
+              <a:srgbClr val="FF0000"/>
+            </a:solidFill>
+          </a:ln>
+        </p:spPr>
+        <p:style>
+          <a:lnRef idx="2">
+            <a:schemeClr val="accent1">
+              <a:shade val="15000"/>
+            </a:schemeClr>
+          </a:lnRef>
+          <a:fillRef idx="1">
+            <a:schemeClr val="accent1"/>
+          </a:fillRef>
+          <a:effectRef idx="0">
+            <a:schemeClr val="accent1"/>
+          </a:effectRef>
+          <a:fontRef idx="minor">
+            <a:schemeClr val="lt1"/>
+          </a:fontRef>
+        </p:style>
+        <p:txBody>
+          <a:bodyPr rtlCol="0" anchor="ctr"/>
+          <a:lstStyle/>
+          <a:p>
+            <a:pPr algn="ctr"/>
+            <a:endParaRPr kumimoji="1" lang="zh-CN" altLang="en-US"/>
+          </a:p>
+        </p:txBody>
+      </p:sp>
     </p:spTree>
   </p:cSld>
   <p:clrMapOvr>
     <a:masterClrMapping/>
   </p:clrMapOvr>
+  <p:timing>
+    <p:tnLst>
+      <p:par>
+        <p:cTn id="1" dur="indefinite" restart="never" nodeType="tmRoot">
+          <p:childTnLst>
+            <p:seq concurrent="1" nextAc="seek">
+              <p:cTn id="2" dur="indefinite" nodeType="mainSeq">
+                <p:childTnLst>
+                  <p:par>
+                    <p:cTn id="3" fill="hold">
+                      <p:stCondLst>
+                        <p:cond delay="indefinite"/>
+                      </p:stCondLst>
+                      <p:childTnLst>
+                        <p:par>
+                          <p:cTn id="4" fill="hold">
+                            <p:stCondLst>
+                              <p:cond delay="0"/>
+                            </p:stCondLst>
+                            <p:childTnLst>
+                              <p:par>
+                                <p:cTn id="5" presetID="1" presetClass="entr" presetSubtype="0" fill="hold" grpId="0" nodeType="clickEffect">
+                                  <p:stCondLst>
+                                    <p:cond delay="0"/>
+                                  </p:stCondLst>
+                                  <p:childTnLst>
+                                    <p:set>
+                                      <p:cBhvr>
+                                        <p:cTn id="6" dur="1" fill="hold">
+                                          <p:stCondLst>
+                                            <p:cond delay="0"/>
+                                          </p:stCondLst>
+                                        </p:cTn>
+                                        <p:tgtEl>
+                                          <p:spTgt spid="14"/>
+                                        </p:tgtEl>
+                                        <p:attrNameLst>
+                                          <p:attrName>style.visibility</p:attrName>
+                                        </p:attrNameLst>
+                                      </p:cBhvr>
+                                      <p:to>
+                                        <p:strVal val="visible"/>
+                                      </p:to>
+                                    </p:set>
+                                  </p:childTnLst>
+                                </p:cTn>
+                              </p:par>
+                              <p:par>
+                                <p:cTn id="7" presetID="1" presetClass="entr" presetSubtype="0" fill="hold" grpId="0" nodeType="withEffect">
+                                  <p:stCondLst>
+                                    <p:cond delay="0"/>
+                                  </p:stCondLst>
+                                  <p:childTnLst>
+                                    <p:set>
+                                      <p:cBhvr>
+                                        <p:cTn id="8" dur="1" fill="hold">
+                                          <p:stCondLst>
+                                            <p:cond delay="0"/>
+                                          </p:stCondLst>
+                                        </p:cTn>
+                                        <p:tgtEl>
+                                          <p:spTgt spid="12"/>
+                                        </p:tgtEl>
+                                        <p:attrNameLst>
+                                          <p:attrName>style.visibility</p:attrName>
+                                        </p:attrNameLst>
+                                      </p:cBhvr>
+                                      <p:to>
+                                        <p:strVal val="visible"/>
+                                      </p:to>
+                                    </p:set>
+                                  </p:childTnLst>
+                                </p:cTn>
+                              </p:par>
+                            </p:childTnLst>
+                          </p:cTn>
+                        </p:par>
+                      </p:childTnLst>
+                    </p:cTn>
+                  </p:par>
+                </p:childTnLst>
+              </p:cTn>
+              <p:prevCondLst>
+                <p:cond evt="onPrev" delay="0">
+                  <p:tgtEl>
+                    <p:sldTgt/>
+                  </p:tgtEl>
+                </p:cond>
+              </p:prevCondLst>
+              <p:nextCondLst>
+                <p:cond evt="onNext" delay="0">
+                  <p:tgtEl>
+                    <p:sldTgt/>
+                  </p:tgtEl>
+                </p:cond>
+              </p:nextCondLst>
+            </p:seq>
+          </p:childTnLst>
+        </p:cTn>
+      </p:par>
+    </p:tnLst>
+    <p:bldLst>
+      <p:bldP spid="12" grpId="0" animBg="1"/>
+      <p:bldP spid="14" grpId="0" animBg="1"/>
+    </p:bldLst>
+  </p:timing>
 </p:sld>
 </file>
 

</xml_diff>